<commit_message>
feat(grading): update rubric to 10/30/40/20 with QR checkin, GitHub autograding, and secondary email support
</commit_message>
<xml_diff>
--- a/Jave1_Hyrje_Nextjs_PWA_Copilot_2026.pptx
+++ b/Jave1_Hyrje_Nextjs_PWA_Copilot_2026.pptx
@@ -23,6 +23,7 @@
     <p:sldId id="271" r:id="rId22"/>
     <p:sldId id="272" r:id="rId23"/>
     <p:sldId id="273" r:id="rId24"/>
+    <p:sldId id="274" r:id="rId25"/>
   </p:sldIdLst>
   <p:sldSz cx="12191695" cy="6858000" type="screen4x3"/>
   <p:notesSz cx="6858000" cy="9144000"/>
@@ -4659,7 +4660,7 @@
               </a:defRPr>
             </a:pPr>
             <a:r>
-              <a:t>Formula e Notimit: 40% / 40% / 20%</a:t>
+              <a:t>Formula e Notimit: 10% / 30% / 40% / 20%</a:t>
             </a:r>
           </a:p>
         </p:txBody>
@@ -4695,7 +4696,7 @@
               </a:defRPr>
             </a:pPr>
             <a:r>
-              <a:t>Llogaridhënie e qartë — secili student vlerësohet për punën dhe kodin e tij.</a:t>
+              <a:t>Llogaridhënie e qartë — diferencojmë vijueshmërinë nga ata që kërkojnë vetëm një notë.</a:t>
             </a:r>
           </a:p>
         </p:txBody>
@@ -4709,7 +4710,152 @@
         <p:spPr>
           <a:xfrm>
             <a:off x="731520" y="2011680"/>
-            <a:ext cx="3383280" cy="4389120"/>
+            <a:ext cx="2514600" cy="4389120"/>
+          </a:xfrm>
+          <a:prstGeom prst="roundRect">
+            <a:avLst/>
+          </a:prstGeom>
+          <a:solidFill>
+            <a:srgbClr val="141E34"/>
+          </a:solidFill>
+          <a:ln w="31750">
+            <a:solidFill>
+              <a:srgbClr val="10B981"/>
+            </a:solidFill>
+          </a:ln>
+        </p:spPr>
+        <p:style>
+          <a:lnRef idx="1">
+            <a:schemeClr val="accent1"/>
+          </a:lnRef>
+          <a:fillRef idx="3">
+            <a:schemeClr val="accent1"/>
+          </a:fillRef>
+          <a:effectRef idx="2">
+            <a:schemeClr val="accent1"/>
+          </a:effectRef>
+          <a:fontRef idx="minor">
+            <a:schemeClr val="lt1"/>
+          </a:fontRef>
+        </p:style>
+        <p:txBody>
+          <a:bodyPr rtlCol="0" anchor="ctr"/>
+          <a:lstStyle/>
+          <a:p>
+            <a:pPr algn="ctr"/>
+          </a:p>
+        </p:txBody>
+      </p:sp>
+      <p:sp>
+        <p:nvSpPr>
+          <p:cNvPr id="7" name="TextBox 6"/>
+          <p:cNvSpPr txBox="1"/>
+          <p:nvPr/>
+        </p:nvSpPr>
+        <p:spPr>
+          <a:xfrm>
+            <a:off x="914400" y="2194560"/>
+            <a:ext cx="3017520" cy="4023360"/>
+          </a:xfrm>
+          <a:prstGeom prst="rect">
+            <a:avLst/>
+          </a:prstGeom>
+          <a:noFill/>
+        </p:spPr>
+        <p:txBody>
+          <a:bodyPr wrap="square">
+            <a:spAutoFit/>
+          </a:bodyPr>
+          <a:lstStyle/>
+          <a:p>
+            <a:pPr>
+              <a:defRPr sz="5400" b="1">
+                <a:solidFill>
+                  <a:srgbClr val="10B981"/>
+                </a:solidFill>
+                <a:latin typeface="Inter"/>
+              </a:defRPr>
+            </a:pPr>
+            <a:r>
+              <a:t>10%</a:t>
+            </a:r>
+          </a:p>
+          <a:p>
+            <a:pPr>
+              <a:spcAft>
+                <a:spcPts val="1400"/>
+              </a:spcAft>
+              <a:defRPr sz="2400" b="1">
+                <a:solidFill>
+                  <a:srgbClr val="FFFFFF"/>
+                </a:solidFill>
+                <a:latin typeface="Inter"/>
+              </a:defRPr>
+            </a:pPr>
+            <a:r>
+              <a:t>📡 Vijueshmëria &amp; QR</a:t>
+            </a:r>
+          </a:p>
+          <a:p>
+            <a:pPr>
+              <a:spcAft>
+                <a:spcPts val="1000"/>
+              </a:spcAft>
+              <a:defRPr sz="2000">
+                <a:solidFill>
+                  <a:srgbClr val="E2E8F0"/>
+                </a:solidFill>
+                <a:latin typeface="Inter"/>
+              </a:defRPr>
+            </a:pPr>
+            <a:r>
+              <a:t>• Check-In me QR në çdo ligjëratë/lab</a:t>
+            </a:r>
+          </a:p>
+          <a:p>
+            <a:pPr>
+              <a:spcAft>
+                <a:spcPts val="1000"/>
+              </a:spcAft>
+              <a:defRPr sz="2000">
+                <a:solidFill>
+                  <a:srgbClr val="E2E8F0"/>
+                </a:solidFill>
+                <a:latin typeface="Inter"/>
+              </a:defRPr>
+            </a:pPr>
+            <a:r>
+              <a:t>• Diferencon vijuesit nga pasivët</a:t>
+            </a:r>
+          </a:p>
+          <a:p>
+            <a:pPr>
+              <a:spcAft>
+                <a:spcPts val="1000"/>
+              </a:spcAft>
+              <a:defRPr sz="2000">
+                <a:solidFill>
+                  <a:srgbClr val="E2E8F0"/>
+                </a:solidFill>
+                <a:latin typeface="Inter"/>
+              </a:defRPr>
+            </a:pPr>
+            <a:r>
+              <a:t>• Pragu 70% minimal: Eliminues!</a:t>
+            </a:r>
+          </a:p>
+        </p:txBody>
+      </p:sp>
+      <p:sp>
+        <p:nvSpPr>
+          <p:cNvPr id="8" name="Rounded Rectangle 7"/>
+          <p:cNvSpPr/>
+          <p:nvPr/>
+        </p:nvSpPr>
+        <p:spPr>
+          <a:xfrm>
+            <a:off x="3465576" y="2011680"/>
+            <a:ext cx="2514600" cy="4389120"/>
           </a:xfrm>
           <a:prstGeom prst="roundRect">
             <a:avLst/>
@@ -4747,13 +4893,13 @@
       </p:sp>
       <p:sp>
         <p:nvSpPr>
-          <p:cNvPr id="7" name="TextBox 6"/>
+          <p:cNvPr id="9" name="TextBox 8"/>
           <p:cNvSpPr txBox="1"/>
           <p:nvPr/>
         </p:nvSpPr>
         <p:spPr>
           <a:xfrm>
-            <a:off x="914400" y="2194560"/>
+            <a:off x="3648456" y="2194560"/>
             <a:ext cx="3017520" cy="4023360"/>
           </a:xfrm>
           <a:prstGeom prst="rect">
@@ -4776,7 +4922,7 @@
               </a:defRPr>
             </a:pPr>
             <a:r>
-              <a:t>40%</a:t>
+              <a:t>30%</a:t>
             </a:r>
           </a:p>
           <a:p>
@@ -4792,7 +4938,7 @@
               </a:defRPr>
             </a:pPr>
             <a:r>
-              <a:t>🧪 Ushtrimet Lab</a:t>
+              <a:t>⚡ GitHub Autograding</a:t>
             </a:r>
           </a:p>
           <a:p>
@@ -4824,7 +4970,7 @@
               </a:defRPr>
             </a:pPr>
             <a:r>
-              <a:t>• Pjesëmarrje dhe kodim aktiv në sallë</a:t>
+              <a:t>• Vlerësim automatik me GitHub Actions</a:t>
             </a:r>
           </a:p>
           <a:p>
@@ -4840,21 +4986,21 @@
               </a:defRPr>
             </a:pPr>
             <a:r>
-              <a:t>• Dëshmi e punës me git commits</a:t>
-            </a:r>
-          </a:p>
-        </p:txBody>
-      </p:sp>
-      <p:sp>
-        <p:nvSpPr>
-          <p:cNvPr id="8" name="Rounded Rectangle 7"/>
+              <a:t>• Feedback i menjëhershëm në git push</a:t>
+            </a:r>
+          </a:p>
+        </p:txBody>
+      </p:sp>
+      <p:sp>
+        <p:nvSpPr>
+          <p:cNvPr id="10" name="Rounded Rectangle 9"/>
           <p:cNvSpPr/>
           <p:nvPr/>
         </p:nvSpPr>
         <p:spPr>
           <a:xfrm>
-            <a:off x="4389120" y="2011680"/>
-            <a:ext cx="3383280" cy="4389120"/>
+            <a:off x="6199632" y="2011680"/>
+            <a:ext cx="2514600" cy="4389120"/>
           </a:xfrm>
           <a:prstGeom prst="roundRect">
             <a:avLst/>
@@ -4864,7 +5010,7 @@
           </a:solidFill>
           <a:ln w="31750">
             <a:solidFill>
-              <a:srgbClr val="10B981"/>
+              <a:srgbClr val="F59E0B"/>
             </a:solidFill>
           </a:ln>
         </p:spPr>
@@ -4892,13 +5038,13 @@
       </p:sp>
       <p:sp>
         <p:nvSpPr>
-          <p:cNvPr id="9" name="TextBox 8"/>
+          <p:cNvPr id="11" name="TextBox 10"/>
           <p:cNvSpPr txBox="1"/>
           <p:nvPr/>
         </p:nvSpPr>
         <p:spPr>
           <a:xfrm>
-            <a:off x="4572000" y="2194560"/>
+            <a:off x="6382512" y="2194560"/>
             <a:ext cx="3017520" cy="4023360"/>
           </a:xfrm>
           <a:prstGeom prst="rect">
@@ -4915,7 +5061,7 @@
             <a:pPr>
               <a:defRPr sz="5400" b="1">
                 <a:solidFill>
-                  <a:srgbClr val="10B981"/>
+                  <a:srgbClr val="F59E0B"/>
                 </a:solidFill>
                 <a:latin typeface="Inter"/>
               </a:defRPr>
@@ -4937,7 +5083,7 @@
               </a:defRPr>
             </a:pPr>
             <a:r>
-              <a:t>📱 Projekti Final</a:t>
+              <a:t>📱 Projekti PWA</a:t>
             </a:r>
           </a:p>
           <a:p>
@@ -4953,7 +5099,7 @@
               </a:defRPr>
             </a:pPr>
             <a:r>
-              <a:t>• Aplikacioni PWA për biznesin tuaj</a:t>
+              <a:t>• PWA mobile për biznes real familjar</a:t>
             </a:r>
           </a:p>
           <a:p>
@@ -4969,7 +5115,7 @@
               </a:defRPr>
             </a:pPr>
             <a:r>
-              <a:t>• Supabase DB + Autentikimi i plotë</a:t>
+              <a:t>• Supabase DB + Auth + RLS e plotë</a:t>
             </a:r>
           </a:p>
           <a:p>
@@ -4992,14 +5138,14 @@
       </p:sp>
       <p:sp>
         <p:nvSpPr>
-          <p:cNvPr id="10" name="Rounded Rectangle 9"/>
+          <p:cNvPr id="12" name="Rounded Rectangle 11"/>
           <p:cNvSpPr/>
           <p:nvPr/>
         </p:nvSpPr>
         <p:spPr>
           <a:xfrm>
-            <a:off x="8046720" y="2011680"/>
-            <a:ext cx="3383280" cy="4389120"/>
+            <a:off x="8933688" y="2011680"/>
+            <a:ext cx="2514600" cy="4389120"/>
           </a:xfrm>
           <a:prstGeom prst="roundRect">
             <a:avLst/>
@@ -5037,13 +5183,13 @@
       </p:sp>
       <p:sp>
         <p:nvSpPr>
-          <p:cNvPr id="11" name="TextBox 10"/>
+          <p:cNvPr id="13" name="TextBox 12"/>
           <p:cNvSpPr txBox="1"/>
           <p:nvPr/>
         </p:nvSpPr>
         <p:spPr>
           <a:xfrm>
-            <a:off x="8229600" y="2194560"/>
+            <a:off x="9116568" y="2194560"/>
             <a:ext cx="3017520" cy="4023360"/>
           </a:xfrm>
           <a:prstGeom prst="rect">
@@ -5114,7 +5260,7 @@
               </a:defRPr>
             </a:pPr>
             <a:r>
-              <a:t>• Demo live nga telefoni juaj celular</a:t>
+              <a:t>• Demo live nga telefoni në auditor</a:t>
             </a:r>
           </a:p>
           <a:p>
@@ -5130,7 +5276,7 @@
               </a:defRPr>
             </a:pPr>
             <a:r>
-              <a:t>• Mbrojtje teknike individuale e kodit</a:t>
+              <a:t>• Mbrojtje teknike e thellë e kodit</a:t>
             </a:r>
           </a:p>
         </p:txBody>
@@ -5227,7 +5373,7 @@
               </a:defRPr>
             </a:pPr>
             <a:r>
-              <a:t>KULMI I SEMESTRIT</a:t>
+              <a:t>EFIKASITET &amp; SHPEJTËSI</a:t>
             </a:r>
           </a:p>
         </p:txBody>
@@ -5263,7 +5409,7 @@
               </a:defRPr>
             </a:pPr>
             <a:r>
-              <a:t>Demo Day në Javën 15: Vizioni i Suksesit!</a:t>
+              <a:t>Automatizimi i Detyrave Javore: GitHub Autograding</a:t>
             </a:r>
           </a:p>
         </p:txBody>
@@ -5299,7 +5445,7 @@
               </a:defRPr>
             </a:pPr>
             <a:r>
-              <a:t>Dita kur telefoni juaj kthehet në dëshminë e arritjes suaj profesionale.</a:t>
+              <a:t>Zero vonesa në korrigjim — çdo 'git push' testohet dhe vlerësohet menjëherë përmes CI/CD.</a:t>
             </a:r>
           </a:p>
         </p:txBody>
@@ -5323,7 +5469,7 @@
           </a:solidFill>
           <a:ln w="31750">
             <a:solidFill>
-              <a:srgbClr val="38BDF8"/>
+              <a:srgbClr val="6366F1"/>
             </a:solidFill>
           </a:ln>
         </p:spPr>
@@ -5377,21 +5523,21 @@
               </a:spcAft>
               <a:defRPr sz="2500" b="1">
                 <a:solidFill>
-                  <a:srgbClr val="38BDF8"/>
-                </a:solidFill>
-                <a:latin typeface="Inter"/>
-              </a:defRPr>
-            </a:pPr>
-            <a:r>
-              <a:t>🎤 Formati i Prezantimit</a:t>
-            </a:r>
-          </a:p>
-          <a:p>
-            <a:pPr>
-              <a:spcAft>
-                <a:spcPts val="1400"/>
-              </a:spcAft>
-              <a:defRPr sz="2000">
+                  <a:srgbClr val="FFFFFF"/>
+                </a:solidFill>
+                <a:latin typeface="Inter"/>
+              </a:defRPr>
+            </a:pPr>
+            <a:r>
+              <a:t>💻 Fluksi i Studentit në Çdo Javë</a:t>
+            </a:r>
+          </a:p>
+          <a:p>
+            <a:pPr>
+              <a:spcAft>
+                <a:spcPts val="1200"/>
+              </a:spcAft>
+              <a:defRPr sz="1900">
                 <a:solidFill>
                   <a:srgbClr val="E2E8F0"/>
                 </a:solidFill>
@@ -5399,15 +5545,15 @@
               </a:defRPr>
             </a:pPr>
             <a:r>
-              <a:t>• 5 Minuta Prezantim Live: Çdo student prezanton me telefonin e vet.</a:t>
-            </a:r>
-          </a:p>
-          <a:p>
-            <a:pPr>
-              <a:spcAft>
-                <a:spcPts val="1400"/>
-              </a:spcAft>
-              <a:defRPr sz="2000">
+              <a:t>1. Prano Detyrën: Klikoni ftesën në GitHub Classroom për të hapur depon tuaj private.</a:t>
+            </a:r>
+          </a:p>
+          <a:p>
+            <a:pPr>
+              <a:spcAft>
+                <a:spcPts val="1200"/>
+              </a:spcAft>
+              <a:defRPr sz="1900">
                 <a:solidFill>
                   <a:srgbClr val="E2E8F0"/>
                 </a:solidFill>
@@ -5415,15 +5561,15 @@
               </a:defRPr>
             </a:pPr>
             <a:r>
-              <a:t>• Projektori i Madh: Ekrani i celularit pasqyrohet para gjithë sallës.</a:t>
-            </a:r>
-          </a:p>
-          <a:p>
-            <a:pPr>
-              <a:spcAft>
-                <a:spcPts val="1400"/>
-              </a:spcAft>
-              <a:defRPr sz="2000">
+              <a:t>2. Kodo me Copilot: Zgjidhni kërkesat e ushtrimit (komponentët, logjikën, lidhjen me DB).</a:t>
+            </a:r>
+          </a:p>
+          <a:p>
+            <a:pPr>
+              <a:spcAft>
+                <a:spcPts val="1200"/>
+              </a:spcAft>
+              <a:defRPr sz="1900">
                 <a:solidFill>
                   <a:srgbClr val="E2E8F0"/>
                 </a:solidFill>
@@ -5431,23 +5577,7 @@
               </a:defRPr>
             </a:pPr>
             <a:r>
-              <a:t>• Simulim i Porosisë: Kryeni një porosi ose veprim live në kohë reale.</a:t>
-            </a:r>
-          </a:p>
-          <a:p>
-            <a:pPr>
-              <a:spcAft>
-                <a:spcPts val="1400"/>
-              </a:spcAft>
-              <a:defRPr sz="2000">
-                <a:solidFill>
-                  <a:srgbClr val="E2E8F0"/>
-                </a:solidFill>
-                <a:latin typeface="Inter"/>
-              </a:defRPr>
-            </a:pPr>
-            <a:r>
-              <a:t>• Pyetje Teknike: Shpjegoni arkitekturën e kodit para profesorit!</a:t>
+              <a:t>3. Git Push: Ekzekutoni 'git push origin main' drejt depos suaj zyrtare në GitHub.</a:t>
             </a:r>
           </a:p>
         </p:txBody>
@@ -5525,21 +5655,21 @@
               </a:spcAft>
               <a:defRPr sz="2500" b="1">
                 <a:solidFill>
-                  <a:srgbClr val="10B981"/>
-                </a:solidFill>
-                <a:latin typeface="Inter"/>
-              </a:defRPr>
-            </a:pPr>
-            <a:r>
-              <a:t>🌟 Çfarë Fitoni në Fund?</a:t>
-            </a:r>
-          </a:p>
-          <a:p>
-            <a:pPr>
-              <a:spcAft>
-                <a:spcPts val="1400"/>
-              </a:spcAft>
-              <a:defRPr sz="2000">
+                  <a:srgbClr val="FFFFFF"/>
+                </a:solidFill>
+                <a:latin typeface="Inter"/>
+              </a:defRPr>
+            </a:pPr>
+            <a:r>
+              <a:t>🤖 Vlerësimi Automat me GitHub Actions</a:t>
+            </a:r>
+          </a:p>
+          <a:p>
+            <a:pPr>
+              <a:spcAft>
+                <a:spcPts val="1200"/>
+              </a:spcAft>
+              <a:defRPr sz="1900">
                 <a:solidFill>
                   <a:srgbClr val="E2E8F0"/>
                 </a:solidFill>
@@ -5547,15 +5677,15 @@
               </a:defRPr>
             </a:pPr>
             <a:r>
-              <a:t>• Notë Maksimale: Vlerësim i merituar për kodin dhe punën tuaj reale.</a:t>
-            </a:r>
-          </a:p>
-          <a:p>
-            <a:pPr>
-              <a:spcAft>
-                <a:spcPts val="1400"/>
-              </a:spcAft>
-              <a:defRPr sz="2000">
+              <a:t>• Teste Automatike: Workflow CI/CD verifikon linter-in, tipet dhe funksionalitetin e kodit.</a:t>
+            </a:r>
+          </a:p>
+          <a:p>
+            <a:pPr>
+              <a:spcAft>
+                <a:spcPts val="1200"/>
+              </a:spcAft>
+              <a:defRPr sz="1900">
                 <a:solidFill>
                   <a:srgbClr val="E2E8F0"/>
                 </a:solidFill>
@@ -5563,15 +5693,15 @@
               </a:defRPr>
             </a:pPr>
             <a:r>
-              <a:t>• Zgjidhje për Biznesin: Biznesi familjar/lokal fiton një sistem funksional.</a:t>
-            </a:r>
-          </a:p>
-          <a:p>
-            <a:pPr>
-              <a:spcAft>
-                <a:spcPts val="1400"/>
-              </a:spcAft>
-              <a:defRPr sz="2000">
+              <a:t>• Rezultat i Menjëhershëm: Pikët (p.sh. 10/10) shfaqen te badge në README brenda 60 sekondave.</a:t>
+            </a:r>
+          </a:p>
+          <a:p>
+            <a:pPr>
+              <a:spcAft>
+                <a:spcPts val="1200"/>
+              </a:spcAft>
+              <a:defRPr sz="1900">
                 <a:solidFill>
                   <a:srgbClr val="E2E8F0"/>
                 </a:solidFill>
@@ -5579,23 +5709,7 @@
               </a:defRPr>
             </a:pPr>
             <a:r>
-              <a:t>• Portofol Digjital: Një link publik në internet për rezymenë tuaj.</a:t>
-            </a:r>
-          </a:p>
-          <a:p>
-            <a:pPr>
-              <a:spcAft>
-                <a:spcPts val="1400"/>
-              </a:spcAft>
-              <a:defRPr sz="2000">
-                <a:solidFill>
-                  <a:srgbClr val="E2E8F0"/>
-                </a:solidFill>
-                <a:latin typeface="Inter"/>
-              </a:defRPr>
-            </a:pPr>
-            <a:r>
-              <a:t>• Besim i Plotë: Bindja se mund të ndërtoni çdo softuer nga fillimi!</a:t>
+              <a:t>• Zero Pritje / Pa Ngarkesë: Notat sinkronizohen në Gradebook CSV të profesorit pa asnjë gabim njerëzor!</a:t>
             </a:r>
           </a:p>
         </p:txBody>
@@ -5692,7 +5806,7 @@
               </a:defRPr>
             </a:pPr>
             <a:r>
-              <a:t>EVIDENCA ZYRTARE E ORËS</a:t>
+              <a:t>KULMI I SEMESTRIT</a:t>
             </a:r>
           </a:p>
         </p:txBody>
@@ -5728,7 +5842,7 @@
               </a:defRPr>
             </a:pPr>
             <a:r>
-              <a:t>Nxirrni Telefonat: Check-In i Pjesëmarrjes!</a:t>
+              <a:t>Demo Day në Javën 15: Vizioni i Suksesit!</a:t>
             </a:r>
           </a:p>
         </p:txBody>
@@ -5764,7 +5878,7 @@
               </a:defRPr>
             </a:pPr>
             <a:r>
-              <a:t>Regjistroni praninë tuaj në ligjëratë ose laborator brenda dritares 2-minutëshe.</a:t>
+              <a:t>Dita kur telefoni juaj kthehet në dëshminë e arritjes suaj profesionale.</a:t>
             </a:r>
           </a:p>
         </p:txBody>
@@ -5778,7 +5892,7 @@
         <p:spPr>
           <a:xfrm>
             <a:off x="731520" y="2011680"/>
-            <a:ext cx="6858000" cy="4389120"/>
+            <a:ext cx="5120640" cy="4389120"/>
           </a:xfrm>
           <a:prstGeom prst="roundRect">
             <a:avLst/>
@@ -5822,8 +5936,8 @@
         </p:nvSpPr>
         <p:spPr>
           <a:xfrm>
-            <a:off x="1005840" y="2194560"/>
-            <a:ext cx="6309360" cy="2286000"/>
+            <a:off x="1005840" y="2286000"/>
+            <a:ext cx="4572000" cy="3840480"/>
           </a:xfrm>
           <a:prstGeom prst="rect">
             <a:avLst/>
@@ -5837,7 +5951,10 @@
           <a:lstStyle/>
           <a:p>
             <a:pPr>
-              <a:defRPr sz="2100" b="1">
+              <a:spcAft>
+                <a:spcPts val="1600"/>
+              </a:spcAft>
+              <a:defRPr sz="2500" b="1">
                 <a:solidFill>
                   <a:srgbClr val="38BDF8"/>
                 </a:solidFill>
@@ -5845,15 +5962,15 @@
               </a:defRPr>
             </a:pPr>
             <a:r>
-              <a:t>1️⃣ Skanoni QR Kodin:</a:t>
-            </a:r>
-          </a:p>
-          <a:p>
-            <a:pPr>
-              <a:spcAft>
-                <a:spcPts val="800"/>
-              </a:spcAft>
-              <a:defRPr sz="1800">
+              <a:t>🎤 Formati i Prezantimit</a:t>
+            </a:r>
+          </a:p>
+          <a:p>
+            <a:pPr>
+              <a:spcAft>
+                <a:spcPts val="1400"/>
+              </a:spcAft>
+              <a:defRPr sz="2000">
                 <a:solidFill>
                   <a:srgbClr val="E2E8F0"/>
                 </a:solidFill>
@@ -5861,28 +5978,15 @@
               </a:defRPr>
             </a:pPr>
             <a:r>
-              <a:t>Hapni shfletuesin në arbenl.github.io/#checkin</a:t>
-            </a:r>
-          </a:p>
-          <a:p>
-            <a:pPr>
-              <a:defRPr sz="2100" b="1">
-                <a:solidFill>
-                  <a:srgbClr val="38BDF8"/>
-                </a:solidFill>
-                <a:latin typeface="Inter"/>
-              </a:defRPr>
-            </a:pPr>
-            <a:r>
-              <a:t>2️⃣ Zgjidhni Seancën:</a:t>
-            </a:r>
-          </a:p>
-          <a:p>
-            <a:pPr>
-              <a:spcAft>
-                <a:spcPts val="800"/>
-              </a:spcAft>
-              <a:defRPr sz="1800">
+              <a:t>• 5 Minuta Prezantim Live: Çdo student prezanton me telefonin e vet.</a:t>
+            </a:r>
+          </a:p>
+          <a:p>
+            <a:pPr>
+              <a:spcAft>
+                <a:spcPts val="1400"/>
+              </a:spcAft>
+              <a:defRPr sz="2000">
                 <a:solidFill>
                   <a:srgbClr val="E2E8F0"/>
                 </a:solidFill>
@@ -5890,28 +5994,15 @@
               </a:defRPr>
             </a:pPr>
             <a:r>
-              <a:t>Zgjidhni [ 📚 Ligjëratë ] ose [ 🧪 Ushtrime (Lab) ]</a:t>
-            </a:r>
-          </a:p>
-          <a:p>
-            <a:pPr>
-              <a:defRPr sz="2100" b="1">
-                <a:solidFill>
-                  <a:srgbClr val="38BDF8"/>
-                </a:solidFill>
-                <a:latin typeface="Inter"/>
-              </a:defRPr>
-            </a:pPr>
-            <a:r>
-              <a:t>3️⃣ Shënoni Të Dhënat &amp; PIN-in:</a:t>
-            </a:r>
-          </a:p>
-          <a:p>
-            <a:pPr>
-              <a:spcAft>
-                <a:spcPts val="800"/>
-              </a:spcAft>
-              <a:defRPr sz="1800">
+              <a:t>• Projektori i Madh: Ekrani i celularit pasqyrohet para gjithë sallës.</a:t>
+            </a:r>
+          </a:p>
+          <a:p>
+            <a:pPr>
+              <a:spcAft>
+                <a:spcPts val="1400"/>
+              </a:spcAft>
+              <a:defRPr sz="2000">
                 <a:solidFill>
                   <a:srgbClr val="E2E8F0"/>
                 </a:solidFill>
@@ -5919,7 +6010,23 @@
               </a:defRPr>
             </a:pPr>
             <a:r>
-              <a:t>ID e studentit, emri, emaili AAB dhe kodi PIN.</a:t>
+              <a:t>• Simulim i Porosisë: Kryeni një porosi ose veprim live në kohë reale.</a:t>
+            </a:r>
+          </a:p>
+          <a:p>
+            <a:pPr>
+              <a:spcAft>
+                <a:spcPts val="1400"/>
+              </a:spcAft>
+              <a:defRPr sz="2000">
+                <a:solidFill>
+                  <a:srgbClr val="E2E8F0"/>
+                </a:solidFill>
+                <a:latin typeface="Inter"/>
+              </a:defRPr>
+            </a:pPr>
+            <a:r>
+              <a:t>• Pyetje Teknike: Shpjegoni arkitekturën e kodit para profesorit!</a:t>
             </a:r>
           </a:p>
         </p:txBody>
@@ -5932,105 +6039,8 @@
         </p:nvSpPr>
         <p:spPr>
           <a:xfrm>
-            <a:off x="1005840" y="4572000"/>
-            <a:ext cx="6309360" cy="1645920"/>
-          </a:xfrm>
-          <a:prstGeom prst="roundRect">
-            <a:avLst/>
-          </a:prstGeom>
-          <a:solidFill>
-            <a:srgbClr val="0F172A"/>
-          </a:solidFill>
-          <a:ln w="31750">
-            <a:solidFill>
-              <a:srgbClr val="F59E0B"/>
-            </a:solidFill>
-          </a:ln>
-        </p:spPr>
-        <p:style>
-          <a:lnRef idx="1">
-            <a:schemeClr val="accent1"/>
-          </a:lnRef>
-          <a:fillRef idx="3">
-            <a:schemeClr val="accent1"/>
-          </a:fillRef>
-          <a:effectRef idx="2">
-            <a:schemeClr val="accent1"/>
-          </a:effectRef>
-          <a:fontRef idx="minor">
-            <a:schemeClr val="lt1"/>
-          </a:fontRef>
-        </p:style>
-        <p:txBody>
-          <a:bodyPr rtlCol="0" anchor="ctr"/>
-          <a:lstStyle/>
-          <a:p>
-            <a:pPr algn="ctr"/>
-          </a:p>
-        </p:txBody>
-      </p:sp>
-      <p:sp>
-        <p:nvSpPr>
-          <p:cNvPr id="9" name="TextBox 8"/>
-          <p:cNvSpPr txBox="1"/>
-          <p:nvPr/>
-        </p:nvSpPr>
-        <p:spPr>
-          <a:xfrm>
-            <a:off x="1097280" y="4663440"/>
-            <a:ext cx="6126480" cy="1463040"/>
-          </a:xfrm>
-          <a:prstGeom prst="rect">
-            <a:avLst/>
-          </a:prstGeom>
-          <a:noFill/>
-        </p:spPr>
-        <p:txBody>
-          <a:bodyPr wrap="square">
-            <a:spAutoFit/>
-          </a:bodyPr>
-          <a:lstStyle/>
-          <a:p>
-            <a:pPr algn="ctr">
-              <a:spcAft>
-                <a:spcPts val="400"/>
-              </a:spcAft>
-              <a:defRPr sz="1600" b="1">
-                <a:solidFill>
-                  <a:srgbClr val="F59E0B"/>
-                </a:solidFill>
-                <a:latin typeface="Inter"/>
-              </a:defRPr>
-            </a:pPr>
-            <a:r>
-              <a:t>🔑 KODI PIN I SEANCËS SOT (DRITARE 2 MINUTA):</a:t>
-            </a:r>
-          </a:p>
-          <a:p>
-            <a:pPr algn="ctr">
-              <a:defRPr sz="4400" b="1">
-                <a:solidFill>
-                  <a:srgbClr val="FFFFFF"/>
-                </a:solidFill>
-                <a:latin typeface="Inter"/>
-              </a:defRPr>
-            </a:pPr>
-            <a:r>
-              <a:t>8 4 9 2</a:t>
-            </a:r>
-          </a:p>
-        </p:txBody>
-      </p:sp>
-      <p:sp>
-        <p:nvSpPr>
-          <p:cNvPr id="10" name="Rounded Rectangle 9"/>
-          <p:cNvSpPr/>
-          <p:nvPr/>
-        </p:nvSpPr>
-        <p:spPr>
-          <a:xfrm>
-            <a:off x="7955279" y="2011680"/>
-            <a:ext cx="3474720" cy="4389120"/>
+            <a:off x="6309360" y="2011680"/>
+            <a:ext cx="5120640" cy="4389120"/>
           </a:xfrm>
           <a:prstGeom prst="roundRect">
             <a:avLst/>
@@ -6066,40 +6076,16 @@
           </a:p>
         </p:txBody>
       </p:sp>
-      <p:pic>
-        <p:nvPicPr>
-          <p:cNvPr id="11" name="Picture 10" descr="qr_master_checkin.png"/>
-          <p:cNvPicPr>
-            <a:picLocks noChangeAspect="1"/>
-          </p:cNvPicPr>
-          <p:nvPr/>
-        </p:nvPicPr>
-        <p:blipFill>
-          <a:blip r:embed="rId2"/>
-          <a:stretch>
-            <a:fillRect/>
-          </a:stretch>
-        </p:blipFill>
-        <p:spPr>
-          <a:xfrm>
-            <a:off x="8321040" y="2286000"/>
-            <a:ext cx="2743200" cy="2743200"/>
-          </a:xfrm>
-          <a:prstGeom prst="rect">
-            <a:avLst/>
-          </a:prstGeom>
-        </p:spPr>
-      </p:pic>
-      <p:sp>
-        <p:nvSpPr>
-          <p:cNvPr id="12" name="TextBox 11"/>
+      <p:sp>
+        <p:nvSpPr>
+          <p:cNvPr id="9" name="TextBox 8"/>
           <p:cNvSpPr txBox="1"/>
           <p:nvPr/>
         </p:nvSpPr>
         <p:spPr>
           <a:xfrm>
-            <a:off x="8046720" y="5120640"/>
-            <a:ext cx="3291840" cy="1097280"/>
+            <a:off x="6583680" y="2286000"/>
+            <a:ext cx="4572000" cy="3840480"/>
           </a:xfrm>
           <a:prstGeom prst="rect">
             <a:avLst/>
@@ -6112,8 +6098,11 @@
           </a:bodyPr>
           <a:lstStyle/>
           <a:p>
-            <a:pPr algn="ctr">
-              <a:defRPr sz="2000" b="1">
+            <a:pPr>
+              <a:spcAft>
+                <a:spcPts val="1600"/>
+              </a:spcAft>
+              <a:defRPr sz="2500" b="1">
                 <a:solidFill>
                   <a:srgbClr val="10B981"/>
                 </a:solidFill>
@@ -6121,20 +6110,71 @@
               </a:defRPr>
             </a:pPr>
             <a:r>
-              <a:t>SKANO PËR CHECK-IN</a:t>
-            </a:r>
-          </a:p>
-          <a:p>
-            <a:pPr algn="ctr">
-              <a:defRPr sz="1600">
-                <a:solidFill>
-                  <a:srgbClr val="FFFFFF"/>
-                </a:solidFill>
-                <a:latin typeface="Inter"/>
-              </a:defRPr>
-            </a:pPr>
-            <a:r>
-              <a:t>arbenl.github.io/#checkin</a:t>
+              <a:t>🌟 Çfarë Fitoni në Fund?</a:t>
+            </a:r>
+          </a:p>
+          <a:p>
+            <a:pPr>
+              <a:spcAft>
+                <a:spcPts val="1400"/>
+              </a:spcAft>
+              <a:defRPr sz="2000">
+                <a:solidFill>
+                  <a:srgbClr val="E2E8F0"/>
+                </a:solidFill>
+                <a:latin typeface="Inter"/>
+              </a:defRPr>
+            </a:pPr>
+            <a:r>
+              <a:t>• Notë Maksimale: Vlerësim i merituar për kodin dhe punën tuaj reale.</a:t>
+            </a:r>
+          </a:p>
+          <a:p>
+            <a:pPr>
+              <a:spcAft>
+                <a:spcPts val="1400"/>
+              </a:spcAft>
+              <a:defRPr sz="2000">
+                <a:solidFill>
+                  <a:srgbClr val="E2E8F0"/>
+                </a:solidFill>
+                <a:latin typeface="Inter"/>
+              </a:defRPr>
+            </a:pPr>
+            <a:r>
+              <a:t>• Zgjidhje për Biznesin: Biznesi familjar/lokal fiton një sistem funksional.</a:t>
+            </a:r>
+          </a:p>
+          <a:p>
+            <a:pPr>
+              <a:spcAft>
+                <a:spcPts val="1400"/>
+              </a:spcAft>
+              <a:defRPr sz="2000">
+                <a:solidFill>
+                  <a:srgbClr val="E2E8F0"/>
+                </a:solidFill>
+                <a:latin typeface="Inter"/>
+              </a:defRPr>
+            </a:pPr>
+            <a:r>
+              <a:t>• Portofol Digjital: Një link publik në internet për rezymenë tuaj.</a:t>
+            </a:r>
+          </a:p>
+          <a:p>
+            <a:pPr>
+              <a:spcAft>
+                <a:spcPts val="1400"/>
+              </a:spcAft>
+              <a:defRPr sz="2000">
+                <a:solidFill>
+                  <a:srgbClr val="E2E8F0"/>
+                </a:solidFill>
+                <a:latin typeface="Inter"/>
+              </a:defRPr>
+            </a:pPr>
+            <a:r>
+              <a:t>• Besim i Plotë: Bindja se mund të ndërtoni çdo softuer nga fillimi!</a:t>
             </a:r>
           </a:p>
         </p:txBody>
@@ -6231,7 +6271,7 @@
               </a:defRPr>
             </a:pPr>
             <a:r>
-              <a:t>AKSIONI FILLON TANI</a:t>
+              <a:t>EVIDENCA ZYRTARE E ORËS</a:t>
             </a:r>
           </a:p>
         </p:txBody>
@@ -6267,7 +6307,7 @@
               </a:defRPr>
             </a:pPr>
             <a:r>
-              <a:t>Sprinti Praktik: Gati për Semestrin!</a:t>
+              <a:t>Nxirrni Telefonat: Check-In i Pjesëmarrjes!</a:t>
             </a:r>
           </a:p>
         </p:txBody>
@@ -6303,7 +6343,7 @@
               </a:defRPr>
             </a:pPr>
             <a:r>
-              <a:t>Në 15 minutat e ardhshme lidhim të gjitha platformat zhvillimore në telefon.</a:t>
+              <a:t>Regjistroni praninë tuaj në ligjëratë ose laborator brenda dritares 2-minutëshe.</a:t>
             </a:r>
           </a:p>
         </p:txBody>
@@ -6362,7 +6402,7 @@
         <p:spPr>
           <a:xfrm>
             <a:off x="1005840" y="2194560"/>
-            <a:ext cx="6309360" cy="4023360"/>
+            <a:ext cx="6309360" cy="2286000"/>
           </a:xfrm>
           <a:prstGeom prst="rect">
             <a:avLst/>
@@ -6376,7 +6416,7 @@
           <a:lstStyle/>
           <a:p>
             <a:pPr>
-              <a:defRPr sz="2300" b="1">
+              <a:defRPr sz="2100" b="1">
                 <a:solidFill>
                   <a:srgbClr val="38BDF8"/>
                 </a:solidFill>
@@ -6384,15 +6424,15 @@
               </a:defRPr>
             </a:pPr>
             <a:r>
-              <a:t>1️⃣ GitHub Student Pack:</a:t>
-            </a:r>
-          </a:p>
-          <a:p>
-            <a:pPr>
-              <a:spcAft>
-                <a:spcPts val="1400"/>
-              </a:spcAft>
-              <a:defRPr sz="2000">
+              <a:t>1️⃣ Skanoni QR Kodin:</a:t>
+            </a:r>
+          </a:p>
+          <a:p>
+            <a:pPr>
+              <a:spcAft>
+                <a:spcPts val="800"/>
+              </a:spcAft>
+              <a:defRPr sz="1800">
                 <a:solidFill>
                   <a:srgbClr val="E2E8F0"/>
                 </a:solidFill>
@@ -6400,12 +6440,12 @@
               </a:defRPr>
             </a:pPr>
             <a:r>
-              <a:t>Përfitoni Copilot Pro Falas me emailin AAB</a:t>
-            </a:r>
-          </a:p>
-          <a:p>
-            <a:pPr>
-              <a:defRPr sz="2300" b="1">
+              <a:t>Hapni shfletuesin në arbenl.github.io/#checkin</a:t>
+            </a:r>
+          </a:p>
+          <a:p>
+            <a:pPr>
+              <a:defRPr sz="2100" b="1">
                 <a:solidFill>
                   <a:srgbClr val="38BDF8"/>
                 </a:solidFill>
@@ -6413,15 +6453,15 @@
               </a:defRPr>
             </a:pPr>
             <a:r>
-              <a:t>2️⃣ Supabase Cloud:</a:t>
-            </a:r>
-          </a:p>
-          <a:p>
-            <a:pPr>
-              <a:spcAft>
-                <a:spcPts val="1400"/>
-              </a:spcAft>
-              <a:defRPr sz="2000">
+              <a:t>2️⃣ Zgjidhni Seancën:</a:t>
+            </a:r>
+          </a:p>
+          <a:p>
+            <a:pPr>
+              <a:spcAft>
+                <a:spcPts val="800"/>
+              </a:spcAft>
+              <a:defRPr sz="1800">
                 <a:solidFill>
                   <a:srgbClr val="E2E8F0"/>
                 </a:solidFill>
@@ -6429,12 +6469,12 @@
               </a:defRPr>
             </a:pPr>
             <a:r>
-              <a:t>Kyçuni me 1 klik (Sign in with GitHub)</a:t>
-            </a:r>
-          </a:p>
-          <a:p>
-            <a:pPr>
-              <a:defRPr sz="2300" b="1">
+              <a:t>Zgjidhni [ 📚 Ligjëratë ] ose [ 🧪 Ushtrime (Lab) ]</a:t>
+            </a:r>
+          </a:p>
+          <a:p>
+            <a:pPr>
+              <a:defRPr sz="2100" b="1">
                 <a:solidFill>
                   <a:srgbClr val="38BDF8"/>
                 </a:solidFill>
@@ -6442,15 +6482,15 @@
               </a:defRPr>
             </a:pPr>
             <a:r>
-              <a:t>3️⃣ Vercel Deployment:</a:t>
-            </a:r>
-          </a:p>
-          <a:p>
-            <a:pPr>
-              <a:spcAft>
-                <a:spcPts val="1400"/>
-              </a:spcAft>
-              <a:defRPr sz="2000">
+              <a:t>3️⃣ Shënoni Të Dhënat &amp; PIN-in:</a:t>
+            </a:r>
+          </a:p>
+          <a:p>
+            <a:pPr>
+              <a:spcAft>
+                <a:spcPts val="800"/>
+              </a:spcAft>
+              <a:defRPr sz="1800">
                 <a:solidFill>
                   <a:srgbClr val="E2E8F0"/>
                 </a:solidFill>
@@ -6458,36 +6498,7 @@
               </a:defRPr>
             </a:pPr>
             <a:r>
-              <a:t>Lidhni llogarinë për deploy live me git push</a:t>
-            </a:r>
-          </a:p>
-          <a:p>
-            <a:pPr>
-              <a:defRPr sz="2300" b="1">
-                <a:solidFill>
-                  <a:srgbClr val="38BDF8"/>
-                </a:solidFill>
-                <a:latin typeface="Inter"/>
-              </a:defRPr>
-            </a:pPr>
-            <a:r>
-              <a:t>🌐 Ruani Portalin:</a:t>
-            </a:r>
-          </a:p>
-          <a:p>
-            <a:pPr>
-              <a:spcAft>
-                <a:spcPts val="1400"/>
-              </a:spcAft>
-              <a:defRPr sz="2000">
-                <a:solidFill>
-                  <a:srgbClr val="E2E8F0"/>
-                </a:solidFill>
-                <a:latin typeface="Inter"/>
-              </a:defRPr>
-            </a:pPr>
-            <a:r>
-              <a:t>Shtoni arbenl.github.io në Homescreen të telefonit!</a:t>
+              <a:t>ID e studentit, emri, emaili AAB dhe kodi PIN.</a:t>
             </a:r>
           </a:p>
         </p:txBody>
@@ -6495,6 +6506,103 @@
       <p:sp>
         <p:nvSpPr>
           <p:cNvPr id="8" name="Rounded Rectangle 7"/>
+          <p:cNvSpPr/>
+          <p:nvPr/>
+        </p:nvSpPr>
+        <p:spPr>
+          <a:xfrm>
+            <a:off x="1005840" y="4572000"/>
+            <a:ext cx="6309360" cy="1645920"/>
+          </a:xfrm>
+          <a:prstGeom prst="roundRect">
+            <a:avLst/>
+          </a:prstGeom>
+          <a:solidFill>
+            <a:srgbClr val="0F172A"/>
+          </a:solidFill>
+          <a:ln w="31750">
+            <a:solidFill>
+              <a:srgbClr val="F59E0B"/>
+            </a:solidFill>
+          </a:ln>
+        </p:spPr>
+        <p:style>
+          <a:lnRef idx="1">
+            <a:schemeClr val="accent1"/>
+          </a:lnRef>
+          <a:fillRef idx="3">
+            <a:schemeClr val="accent1"/>
+          </a:fillRef>
+          <a:effectRef idx="2">
+            <a:schemeClr val="accent1"/>
+          </a:effectRef>
+          <a:fontRef idx="minor">
+            <a:schemeClr val="lt1"/>
+          </a:fontRef>
+        </p:style>
+        <p:txBody>
+          <a:bodyPr rtlCol="0" anchor="ctr"/>
+          <a:lstStyle/>
+          <a:p>
+            <a:pPr algn="ctr"/>
+          </a:p>
+        </p:txBody>
+      </p:sp>
+      <p:sp>
+        <p:nvSpPr>
+          <p:cNvPr id="9" name="TextBox 8"/>
+          <p:cNvSpPr txBox="1"/>
+          <p:nvPr/>
+        </p:nvSpPr>
+        <p:spPr>
+          <a:xfrm>
+            <a:off x="1097280" y="4663440"/>
+            <a:ext cx="6126480" cy="1463040"/>
+          </a:xfrm>
+          <a:prstGeom prst="rect">
+            <a:avLst/>
+          </a:prstGeom>
+          <a:noFill/>
+        </p:spPr>
+        <p:txBody>
+          <a:bodyPr wrap="square">
+            <a:spAutoFit/>
+          </a:bodyPr>
+          <a:lstStyle/>
+          <a:p>
+            <a:pPr algn="ctr">
+              <a:spcAft>
+                <a:spcPts val="400"/>
+              </a:spcAft>
+              <a:defRPr sz="1600" b="1">
+                <a:solidFill>
+                  <a:srgbClr val="F59E0B"/>
+                </a:solidFill>
+                <a:latin typeface="Inter"/>
+              </a:defRPr>
+            </a:pPr>
+            <a:r>
+              <a:t>🔑 KODI PIN I SEANCËS SOT (DRITARE 2 MINUTA):</a:t>
+            </a:r>
+          </a:p>
+          <a:p>
+            <a:pPr algn="ctr">
+              <a:defRPr sz="4400" b="1">
+                <a:solidFill>
+                  <a:srgbClr val="FFFFFF"/>
+                </a:solidFill>
+                <a:latin typeface="Inter"/>
+              </a:defRPr>
+            </a:pPr>
+            <a:r>
+              <a:t>8 4 9 2</a:t>
+            </a:r>
+          </a:p>
+        </p:txBody>
+      </p:sp>
+      <p:sp>
+        <p:nvSpPr>
+          <p:cNvPr id="10" name="Rounded Rectangle 9"/>
           <p:cNvSpPr/>
           <p:nvPr/>
         </p:nvSpPr>
@@ -6539,7 +6647,7 @@
       </p:sp>
       <p:pic>
         <p:nvPicPr>
-          <p:cNvPr id="9" name="Picture 8" descr="qr_master_portal.png"/>
+          <p:cNvPr id="11" name="Picture 10" descr="qr_master_checkin.png"/>
           <p:cNvPicPr>
             <a:picLocks noChangeAspect="1"/>
           </p:cNvPicPr>
@@ -6553,8 +6661,8 @@
         </p:blipFill>
         <p:spPr>
           <a:xfrm>
-            <a:off x="8412480" y="2286000"/>
-            <a:ext cx="2560320" cy="2560320"/>
+            <a:off x="8321040" y="2286000"/>
+            <a:ext cx="2743200" cy="2743200"/>
           </a:xfrm>
           <a:prstGeom prst="rect">
             <a:avLst/>
@@ -6563,14 +6671,14 @@
       </p:pic>
       <p:sp>
         <p:nvSpPr>
-          <p:cNvPr id="10" name="TextBox 9"/>
+          <p:cNvPr id="12" name="TextBox 11"/>
           <p:cNvSpPr txBox="1"/>
           <p:nvPr/>
         </p:nvSpPr>
         <p:spPr>
           <a:xfrm>
-            <a:off x="8046720" y="4937760"/>
-            <a:ext cx="3291840" cy="1280160"/>
+            <a:off x="8046720" y="5120640"/>
+            <a:ext cx="3291840" cy="1097280"/>
           </a:xfrm>
           <a:prstGeom prst="rect">
             <a:avLst/>
@@ -6592,12 +6700,12 @@
               </a:defRPr>
             </a:pPr>
             <a:r>
-              <a:t>SKANO PORTALIN</a:t>
+              <a:t>SKANO PËR CHECK-IN</a:t>
             </a:r>
           </a:p>
           <a:p>
             <a:pPr algn="ctr">
-              <a:defRPr sz="1700">
+              <a:defRPr sz="1600">
                 <a:solidFill>
                   <a:srgbClr val="FFFFFF"/>
                 </a:solidFill>
@@ -6605,11 +6713,7 @@
               </a:defRPr>
             </a:pPr>
             <a:r>
-              <a:t>Hapni portalin e kursit</a:t>
-            </a:r>
-            <a:br/>
-            <a:r>
-              <a:t>arbenl.github.io</a:t>
+              <a:t>arbenl.github.io/#checkin</a:t>
             </a:r>
           </a:p>
         </p:txBody>
@@ -6706,7 +6810,7 @@
               </a:defRPr>
             </a:pPr>
             <a:r>
-              <a:t>HAPI 1 • PAKOJA E STUDENTIT</a:t>
+              <a:t>AKSIONI FILLON TANI</a:t>
             </a:r>
           </a:p>
         </p:txBody>
@@ -6742,7 +6846,7 @@
               </a:defRPr>
             </a:pPr>
             <a:r>
-              <a:t>Aktivizoni GitHub Copilot Pro Falas</a:t>
+              <a:t>Sprinti Praktik: Gati për Semestrin!</a:t>
             </a:r>
           </a:p>
         </p:txBody>
@@ -6778,7 +6882,7 @@
               </a:defRPr>
             </a:pPr>
             <a:r>
-              <a:t>Përfitoni paketën me vlerë 100$/vit pa pagesë përmes Kolegjit AAB.</a:t>
+              <a:t>Në 15 minutat e ardhshme lidhim të gjitha platformat zhvillimore në telefon.</a:t>
             </a:r>
           </a:p>
         </p:txBody>
@@ -6802,7 +6906,7 @@
           </a:solidFill>
           <a:ln w="31750">
             <a:solidFill>
-              <a:srgbClr val="6366F1"/>
+              <a:srgbClr val="38BDF8"/>
             </a:solidFill>
           </a:ln>
         </p:spPr>
@@ -6853,19 +6957,19 @@
             <a:pPr>
               <a:defRPr sz="2300" b="1">
                 <a:solidFill>
-                  <a:srgbClr val="FFFFFF"/>
-                </a:solidFill>
-                <a:latin typeface="Inter"/>
-              </a:defRPr>
-            </a:pPr>
-            <a:r>
-              <a:t>✉️ Përdorni Emailin Zyrtar AAB:</a:t>
-            </a:r>
-          </a:p>
-          <a:p>
-            <a:pPr>
-              <a:spcAft>
-                <a:spcPts val="1800"/>
+                  <a:srgbClr val="38BDF8"/>
+                </a:solidFill>
+                <a:latin typeface="Inter"/>
+              </a:defRPr>
+            </a:pPr>
+            <a:r>
+              <a:t>1️⃣ GitHub Student Pack:</a:t>
+            </a:r>
+          </a:p>
+          <a:p>
+            <a:pPr>
+              <a:spcAft>
+                <a:spcPts val="1400"/>
               </a:spcAft>
               <a:defRPr sz="2000">
                 <a:solidFill>
@@ -6875,26 +6979,26 @@
               </a:defRPr>
             </a:pPr>
             <a:r>
-              <a:t>Format: emri.mbiemri@universitetiaab.com në llogarinë tuaj GitHub.</a:t>
+              <a:t>Përfitoni Copilot Pro Falas me emailin AAB</a:t>
             </a:r>
           </a:p>
           <a:p>
             <a:pPr>
               <a:defRPr sz="2300" b="1">
                 <a:solidFill>
-                  <a:srgbClr val="FFFFFF"/>
-                </a:solidFill>
-                <a:latin typeface="Inter"/>
-              </a:defRPr>
-            </a:pPr>
-            <a:r>
-              <a:t>🎓 Klikoni 'Get Student Benefits':</a:t>
-            </a:r>
-          </a:p>
-          <a:p>
-            <a:pPr>
-              <a:spcAft>
-                <a:spcPts val="1800"/>
+                  <a:srgbClr val="38BDF8"/>
+                </a:solidFill>
+                <a:latin typeface="Inter"/>
+              </a:defRPr>
+            </a:pPr>
+            <a:r>
+              <a:t>2️⃣ Supabase Cloud:</a:t>
+            </a:r>
+          </a:p>
+          <a:p>
+            <a:pPr>
+              <a:spcAft>
+                <a:spcPts val="1400"/>
               </a:spcAft>
               <a:defRPr sz="2000">
                 <a:solidFill>
@@ -6904,26 +7008,26 @@
               </a:defRPr>
             </a:pPr>
             <a:r>
-              <a:t>Ngarkoni foton e kartelës studentore ose vërtetimin e vitit.</a:t>
+              <a:t>Kyçuni me 1 klik (Sign in with GitHub)</a:t>
             </a:r>
           </a:p>
           <a:p>
             <a:pPr>
               <a:defRPr sz="2300" b="1">
                 <a:solidFill>
-                  <a:srgbClr val="FFFFFF"/>
-                </a:solidFill>
-                <a:latin typeface="Inter"/>
-              </a:defRPr>
-            </a:pPr>
-            <a:r>
-              <a:t>🤖 Copilot Aktivizohet Menjëherë:</a:t>
-            </a:r>
-          </a:p>
-          <a:p>
-            <a:pPr>
-              <a:spcAft>
-                <a:spcPts val="1800"/>
+                  <a:srgbClr val="38BDF8"/>
+                </a:solidFill>
+                <a:latin typeface="Inter"/>
+              </a:defRPr>
+            </a:pPr>
+            <a:r>
+              <a:t>3️⃣ Vercel Deployment:</a:t>
+            </a:r>
+          </a:p>
+          <a:p>
+            <a:pPr>
+              <a:spcAft>
+                <a:spcPts val="1400"/>
               </a:spcAft>
               <a:defRPr sz="2000">
                 <a:solidFill>
@@ -6933,7 +7037,36 @@
               </a:defRPr>
             </a:pPr>
             <a:r>
-              <a:t>Akses falas i pakufizuar në VS Code për gjatë gjithë studimeve!</a:t>
+              <a:t>Lidhni llogarinë për deploy live me git push</a:t>
+            </a:r>
+          </a:p>
+          <a:p>
+            <a:pPr>
+              <a:defRPr sz="2300" b="1">
+                <a:solidFill>
+                  <a:srgbClr val="38BDF8"/>
+                </a:solidFill>
+                <a:latin typeface="Inter"/>
+              </a:defRPr>
+            </a:pPr>
+            <a:r>
+              <a:t>🌐 Ruani Portalin:</a:t>
+            </a:r>
+          </a:p>
+          <a:p>
+            <a:pPr>
+              <a:spcAft>
+                <a:spcPts val="1400"/>
+              </a:spcAft>
+              <a:defRPr sz="2000">
+                <a:solidFill>
+                  <a:srgbClr val="E2E8F0"/>
+                </a:solidFill>
+                <a:latin typeface="Inter"/>
+              </a:defRPr>
+            </a:pPr>
+            <a:r>
+              <a:t>Shtoni arbenl.github.io në Homescreen të telefonit!</a:t>
             </a:r>
           </a:p>
         </p:txBody>
@@ -6985,7 +7118,7 @@
       </p:sp>
       <p:pic>
         <p:nvPicPr>
-          <p:cNvPr id="9" name="Picture 8" descr="qr_master_github_pack.png"/>
+          <p:cNvPr id="9" name="Picture 8" descr="qr_master_portal.png"/>
           <p:cNvPicPr>
             <a:picLocks noChangeAspect="1"/>
           </p:cNvPicPr>
@@ -6999,8 +7132,8 @@
         </p:blipFill>
         <p:spPr>
           <a:xfrm>
-            <a:off x="8321040" y="2286000"/>
-            <a:ext cx="2743200" cy="2743200"/>
+            <a:off x="8412480" y="2286000"/>
+            <a:ext cx="2560320" cy="2560320"/>
           </a:xfrm>
           <a:prstGeom prst="rect">
             <a:avLst/>
@@ -7015,8 +7148,8 @@
         </p:nvSpPr>
         <p:spPr>
           <a:xfrm>
-            <a:off x="8046720" y="5120640"/>
-            <a:ext cx="3291840" cy="1097280"/>
+            <a:off x="8046720" y="4937760"/>
+            <a:ext cx="3291840" cy="1280160"/>
           </a:xfrm>
           <a:prstGeom prst="rect">
             <a:avLst/>
@@ -7038,7 +7171,24 @@
               </a:defRPr>
             </a:pPr>
             <a:r>
-              <a:t>SKANO PËR COPILOT</a:t>
+              <a:t>SKANO PORTALIN</a:t>
+            </a:r>
+          </a:p>
+          <a:p>
+            <a:pPr algn="ctr">
+              <a:defRPr sz="1700">
+                <a:solidFill>
+                  <a:srgbClr val="FFFFFF"/>
+                </a:solidFill>
+                <a:latin typeface="Inter"/>
+              </a:defRPr>
+            </a:pPr>
+            <a:r>
+              <a:t>Hapni portalin e kursit</a:t>
+            </a:r>
+            <a:br/>
+            <a:r>
+              <a:t>arbenl.github.io</a:t>
             </a:r>
           </a:p>
         </p:txBody>
@@ -7135,7 +7285,7 @@
               </a:defRPr>
             </a:pPr>
             <a:r>
-              <a:t>HAPAT 2 &amp; 3 • INFRASTRUKTURA CLOUD</a:t>
+              <a:t>HAPI 1 • PAKOJA E STUDENTIT</a:t>
             </a:r>
           </a:p>
         </p:txBody>
@@ -7171,7 +7321,7 @@
               </a:defRPr>
             </a:pPr>
             <a:r>
-              <a:t>Supabase &amp; Vercel: Kyçja me 1-Kliko</a:t>
+              <a:t>Aktivizoni GitHub Copilot Pro Falas</a:t>
             </a:r>
           </a:p>
         </p:txBody>
@@ -7207,7 +7357,7 @@
               </a:defRPr>
             </a:pPr>
             <a:r>
-              <a:t>Nuk keni nevojë për fjalëkalime të reja — zgjidhni 'Continue with GitHub'.</a:t>
+              <a:t>Përfitoni paketën me vlerë 100$/vit pa pagesë përmes Kolegjit AAB.</a:t>
             </a:r>
           </a:p>
         </p:txBody>
@@ -7221,7 +7371,162 @@
         <p:spPr>
           <a:xfrm>
             <a:off x="731520" y="2011680"/>
-            <a:ext cx="5120640" cy="4389120"/>
+            <a:ext cx="6858000" cy="4389120"/>
+          </a:xfrm>
+          <a:prstGeom prst="roundRect">
+            <a:avLst/>
+          </a:prstGeom>
+          <a:solidFill>
+            <a:srgbClr val="141E34"/>
+          </a:solidFill>
+          <a:ln w="31750">
+            <a:solidFill>
+              <a:srgbClr val="6366F1"/>
+            </a:solidFill>
+          </a:ln>
+        </p:spPr>
+        <p:style>
+          <a:lnRef idx="1">
+            <a:schemeClr val="accent1"/>
+          </a:lnRef>
+          <a:fillRef idx="3">
+            <a:schemeClr val="accent1"/>
+          </a:fillRef>
+          <a:effectRef idx="2">
+            <a:schemeClr val="accent1"/>
+          </a:effectRef>
+          <a:fontRef idx="minor">
+            <a:schemeClr val="lt1"/>
+          </a:fontRef>
+        </p:style>
+        <p:txBody>
+          <a:bodyPr rtlCol="0" anchor="ctr"/>
+          <a:lstStyle/>
+          <a:p>
+            <a:pPr algn="ctr"/>
+          </a:p>
+        </p:txBody>
+      </p:sp>
+      <p:sp>
+        <p:nvSpPr>
+          <p:cNvPr id="7" name="TextBox 6"/>
+          <p:cNvSpPr txBox="1"/>
+          <p:nvPr/>
+        </p:nvSpPr>
+        <p:spPr>
+          <a:xfrm>
+            <a:off x="1005840" y="2194560"/>
+            <a:ext cx="6309360" cy="4023360"/>
+          </a:xfrm>
+          <a:prstGeom prst="rect">
+            <a:avLst/>
+          </a:prstGeom>
+          <a:noFill/>
+        </p:spPr>
+        <p:txBody>
+          <a:bodyPr wrap="square">
+            <a:spAutoFit/>
+          </a:bodyPr>
+          <a:lstStyle/>
+          <a:p>
+            <a:pPr>
+              <a:defRPr sz="2300" b="1">
+                <a:solidFill>
+                  <a:srgbClr val="FFFFFF"/>
+                </a:solidFill>
+                <a:latin typeface="Inter"/>
+              </a:defRPr>
+            </a:pPr>
+            <a:r>
+              <a:t>✉️ Përdorni Emailin Zyrtar AAB:</a:t>
+            </a:r>
+          </a:p>
+          <a:p>
+            <a:pPr>
+              <a:spcAft>
+                <a:spcPts val="1800"/>
+              </a:spcAft>
+              <a:defRPr sz="2000">
+                <a:solidFill>
+                  <a:srgbClr val="E2E8F0"/>
+                </a:solidFill>
+                <a:latin typeface="Inter"/>
+              </a:defRPr>
+            </a:pPr>
+            <a:r>
+              <a:t>Format: emri.mbiemri@universitetiaab.com në llogarinë tuaj GitHub.</a:t>
+            </a:r>
+          </a:p>
+          <a:p>
+            <a:pPr>
+              <a:defRPr sz="2300" b="1">
+                <a:solidFill>
+                  <a:srgbClr val="FFFFFF"/>
+                </a:solidFill>
+                <a:latin typeface="Inter"/>
+              </a:defRPr>
+            </a:pPr>
+            <a:r>
+              <a:t>🎓 Klikoni 'Get Student Benefits':</a:t>
+            </a:r>
+          </a:p>
+          <a:p>
+            <a:pPr>
+              <a:spcAft>
+                <a:spcPts val="1800"/>
+              </a:spcAft>
+              <a:defRPr sz="2000">
+                <a:solidFill>
+                  <a:srgbClr val="E2E8F0"/>
+                </a:solidFill>
+                <a:latin typeface="Inter"/>
+              </a:defRPr>
+            </a:pPr>
+            <a:r>
+              <a:t>Ngarkoni foton e kartelës studentore ose vërtetimin e vitit.</a:t>
+            </a:r>
+          </a:p>
+          <a:p>
+            <a:pPr>
+              <a:defRPr sz="2300" b="1">
+                <a:solidFill>
+                  <a:srgbClr val="FFFFFF"/>
+                </a:solidFill>
+                <a:latin typeface="Inter"/>
+              </a:defRPr>
+            </a:pPr>
+            <a:r>
+              <a:t>🤖 Copilot Aktivizohet Menjëherë:</a:t>
+            </a:r>
+          </a:p>
+          <a:p>
+            <a:pPr>
+              <a:spcAft>
+                <a:spcPts val="1800"/>
+              </a:spcAft>
+              <a:defRPr sz="2000">
+                <a:solidFill>
+                  <a:srgbClr val="E2E8F0"/>
+                </a:solidFill>
+                <a:latin typeface="Inter"/>
+              </a:defRPr>
+            </a:pPr>
+            <a:r>
+              <a:t>Akses falas i pakufizuar në VS Code për gjatë gjithë studimeve!</a:t>
+            </a:r>
+          </a:p>
+        </p:txBody>
+      </p:sp>
+      <p:sp>
+        <p:nvSpPr>
+          <p:cNvPr id="8" name="Rounded Rectangle 7"/>
+          <p:cNvSpPr/>
+          <p:nvPr/>
+        </p:nvSpPr>
+        <p:spPr>
+          <a:xfrm>
+            <a:off x="7955279" y="2011680"/>
+            <a:ext cx="3474720" cy="4389120"/>
           </a:xfrm>
           <a:prstGeom prst="roundRect">
             <a:avLst/>
@@ -7259,7 +7564,7 @@
       </p:sp>
       <p:pic>
         <p:nvPicPr>
-          <p:cNvPr id="7" name="Picture 6" descr="qr_master_supabase.png"/>
+          <p:cNvPr id="9" name="Picture 8" descr="qr_master_github_pack.png"/>
           <p:cNvPicPr>
             <a:picLocks noChangeAspect="1"/>
           </p:cNvPicPr>
@@ -7273,8 +7578,8 @@
         </p:blipFill>
         <p:spPr>
           <a:xfrm>
-            <a:off x="1005840" y="2286000"/>
-            <a:ext cx="2194560" cy="2194560"/>
+            <a:off x="8321040" y="2286000"/>
+            <a:ext cx="2743200" cy="2743200"/>
           </a:xfrm>
           <a:prstGeom prst="rect">
             <a:avLst/>
@@ -7283,14 +7588,14 @@
       </p:pic>
       <p:sp>
         <p:nvSpPr>
-          <p:cNvPr id="8" name="TextBox 7"/>
+          <p:cNvPr id="10" name="TextBox 9"/>
           <p:cNvSpPr txBox="1"/>
           <p:nvPr/>
         </p:nvSpPr>
         <p:spPr>
           <a:xfrm>
-            <a:off x="3383280" y="2194560"/>
-            <a:ext cx="2286000" cy="4023360"/>
+            <a:off x="8046720" y="5120640"/>
+            <a:ext cx="3291840" cy="1097280"/>
           </a:xfrm>
           <a:prstGeom prst="rect">
             <a:avLst/>
@@ -7303,11 +7608,8 @@
           </a:bodyPr>
           <a:lstStyle/>
           <a:p>
-            <a:pPr>
-              <a:spcAft>
-                <a:spcPts val="1200"/>
-              </a:spcAft>
-              <a:defRPr sz="2400" b="1">
+            <a:pPr algn="ctr">
+              <a:defRPr sz="2000" b="1">
                 <a:solidFill>
                   <a:srgbClr val="10B981"/>
                 </a:solidFill>
@@ -7315,157 +7617,7 @@
               </a:defRPr>
             </a:pPr>
             <a:r>
-              <a:t>🗄️ SUPABASE</a:t>
-            </a:r>
-          </a:p>
-          <a:p>
-            <a:pPr>
-              <a:defRPr sz="1900">
-                <a:solidFill>
-                  <a:srgbClr val="E2E8F0"/>
-                </a:solidFill>
-                <a:latin typeface="Inter"/>
-              </a:defRPr>
-            </a:pPr>
-            <a:r>
-              <a:t>• Skanoni QR kodin</a:t>
-            </a:r>
-            <a:br/>
-            <a:r>
-              <a:t>• 'Sign in with GitHub'</a:t>
-            </a:r>
-            <a:br/>
-            <a:r>
-              <a:t>• Databaza PostgreSQL &amp; Auth gati për aplikacionin tuaj!</a:t>
-            </a:r>
-          </a:p>
-        </p:txBody>
-      </p:sp>
-      <p:sp>
-        <p:nvSpPr>
-          <p:cNvPr id="9" name="Rounded Rectangle 8"/>
-          <p:cNvSpPr/>
-          <p:nvPr/>
-        </p:nvSpPr>
-        <p:spPr>
-          <a:xfrm>
-            <a:off x="6309360" y="2011680"/>
-            <a:ext cx="5120640" cy="4389120"/>
-          </a:xfrm>
-          <a:prstGeom prst="roundRect">
-            <a:avLst/>
-          </a:prstGeom>
-          <a:solidFill>
-            <a:srgbClr val="141E34"/>
-          </a:solidFill>
-          <a:ln w="31750">
-            <a:solidFill>
-              <a:srgbClr val="38BDF8"/>
-            </a:solidFill>
-          </a:ln>
-        </p:spPr>
-        <p:style>
-          <a:lnRef idx="1">
-            <a:schemeClr val="accent1"/>
-          </a:lnRef>
-          <a:fillRef idx="3">
-            <a:schemeClr val="accent1"/>
-          </a:fillRef>
-          <a:effectRef idx="2">
-            <a:schemeClr val="accent1"/>
-          </a:effectRef>
-          <a:fontRef idx="minor">
-            <a:schemeClr val="lt1"/>
-          </a:fontRef>
-        </p:style>
-        <p:txBody>
-          <a:bodyPr rtlCol="0" anchor="ctr"/>
-          <a:lstStyle/>
-          <a:p>
-            <a:pPr algn="ctr"/>
-          </a:p>
-        </p:txBody>
-      </p:sp>
-      <p:pic>
-        <p:nvPicPr>
-          <p:cNvPr id="10" name="Picture 9" descr="qr_master_vercel.png"/>
-          <p:cNvPicPr>
-            <a:picLocks noChangeAspect="1"/>
-          </p:cNvPicPr>
-          <p:nvPr/>
-        </p:nvPicPr>
-        <p:blipFill>
-          <a:blip r:embed="rId3"/>
-          <a:stretch>
-            <a:fillRect/>
-          </a:stretch>
-        </p:blipFill>
-        <p:spPr>
-          <a:xfrm>
-            <a:off x="6583680" y="2286000"/>
-            <a:ext cx="2194560" cy="2194560"/>
-          </a:xfrm>
-          <a:prstGeom prst="rect">
-            <a:avLst/>
-          </a:prstGeom>
-        </p:spPr>
-      </p:pic>
-      <p:sp>
-        <p:nvSpPr>
-          <p:cNvPr id="11" name="TextBox 10"/>
-          <p:cNvSpPr txBox="1"/>
-          <p:nvPr/>
-        </p:nvSpPr>
-        <p:spPr>
-          <a:xfrm>
-            <a:off x="8961120" y="2194560"/>
-            <a:ext cx="2286000" cy="4023360"/>
-          </a:xfrm>
-          <a:prstGeom prst="rect">
-            <a:avLst/>
-          </a:prstGeom>
-          <a:noFill/>
-        </p:spPr>
-        <p:txBody>
-          <a:bodyPr wrap="square">
-            <a:spAutoFit/>
-          </a:bodyPr>
-          <a:lstStyle/>
-          <a:p>
-            <a:pPr>
-              <a:spcAft>
-                <a:spcPts val="1200"/>
-              </a:spcAft>
-              <a:defRPr sz="2400" b="1">
-                <a:solidFill>
-                  <a:srgbClr val="38BDF8"/>
-                </a:solidFill>
-                <a:latin typeface="Inter"/>
-              </a:defRPr>
-            </a:pPr>
-            <a:r>
-              <a:t>🚀 VERCEL</a:t>
-            </a:r>
-          </a:p>
-          <a:p>
-            <a:pPr>
-              <a:defRPr sz="1900">
-                <a:solidFill>
-                  <a:srgbClr val="E2E8F0"/>
-                </a:solidFill>
-                <a:latin typeface="Inter"/>
-              </a:defRPr>
-            </a:pPr>
-            <a:r>
-              <a:t>• Skanoni QR kodin</a:t>
-            </a:r>
-            <a:br/>
-            <a:r>
-              <a:t>• 'Continue with GitHub'</a:t>
-            </a:r>
-            <a:br/>
-            <a:r>
-              <a:t>• Publikimi live bëhet automatik me çdo git push!</a:t>
+              <a:t>SKANO PËR COPILOT</a:t>
             </a:r>
           </a:p>
         </p:txBody>
@@ -7479,6 +7631,433 @@
 </file>
 
 <file path=ppt/slides/slide18.xml><?xml version="1.0" encoding="utf-8"?>
+<p:sld xmlns:a="http://schemas.openxmlformats.org/drawingml/2006/main" xmlns:p="http://schemas.openxmlformats.org/presentationml/2006/main" xmlns:r="http://schemas.openxmlformats.org/officeDocument/2006/relationships">
+  <p:cSld>
+    <p:spTree>
+      <p:nvGrpSpPr>
+        <p:cNvPr id="1" name=""/>
+        <p:cNvGrpSpPr/>
+        <p:nvPr/>
+      </p:nvGrpSpPr>
+      <p:grpSpPr/>
+      <p:sp>
+        <p:nvSpPr>
+          <p:cNvPr id="2" name="Rectangle 1"/>
+          <p:cNvSpPr/>
+          <p:nvPr/>
+        </p:nvSpPr>
+        <p:spPr>
+          <a:xfrm>
+            <a:off x="0" y="0"/>
+            <a:ext cx="12191695" cy="6858000"/>
+          </a:xfrm>
+          <a:prstGeom prst="rect">
+            <a:avLst/>
+          </a:prstGeom>
+          <a:solidFill>
+            <a:srgbClr val="0B1120"/>
+          </a:solidFill>
+          <a:ln>
+            <a:noFill/>
+          </a:ln>
+        </p:spPr>
+        <p:style>
+          <a:lnRef idx="1">
+            <a:schemeClr val="accent1"/>
+          </a:lnRef>
+          <a:fillRef idx="3">
+            <a:schemeClr val="accent1"/>
+          </a:fillRef>
+          <a:effectRef idx="2">
+            <a:schemeClr val="accent1"/>
+          </a:effectRef>
+          <a:fontRef idx="minor">
+            <a:schemeClr val="lt1"/>
+          </a:fontRef>
+        </p:style>
+        <p:txBody>
+          <a:bodyPr rtlCol="0" anchor="ctr"/>
+          <a:lstStyle/>
+          <a:p>
+            <a:pPr algn="ctr"/>
+          </a:p>
+        </p:txBody>
+      </p:sp>
+      <p:sp>
+        <p:nvSpPr>
+          <p:cNvPr id="3" name="TextBox 2"/>
+          <p:cNvSpPr txBox="1"/>
+          <p:nvPr/>
+        </p:nvSpPr>
+        <p:spPr>
+          <a:xfrm>
+            <a:off x="731520" y="365760"/>
+            <a:ext cx="10698480" cy="320040"/>
+          </a:xfrm>
+          <a:prstGeom prst="rect">
+            <a:avLst/>
+          </a:prstGeom>
+          <a:noFill/>
+        </p:spPr>
+        <p:txBody>
+          <a:bodyPr wrap="square">
+            <a:spAutoFit/>
+          </a:bodyPr>
+          <a:lstStyle/>
+          <a:p>
+            <a:pPr>
+              <a:defRPr sz="1500" b="1">
+                <a:solidFill>
+                  <a:srgbClr val="38BDF8"/>
+                </a:solidFill>
+                <a:latin typeface="Inter"/>
+              </a:defRPr>
+            </a:pPr>
+            <a:r>
+              <a:t>HAPAT 2 &amp; 3 • INFRASTRUKTURA CLOUD</a:t>
+            </a:r>
+          </a:p>
+        </p:txBody>
+      </p:sp>
+      <p:sp>
+        <p:nvSpPr>
+          <p:cNvPr id="4" name="TextBox 3"/>
+          <p:cNvSpPr txBox="1"/>
+          <p:nvPr/>
+        </p:nvSpPr>
+        <p:spPr>
+          <a:xfrm>
+            <a:off x="731520" y="685800"/>
+            <a:ext cx="10698480" cy="777240"/>
+          </a:xfrm>
+          <a:prstGeom prst="rect">
+            <a:avLst/>
+          </a:prstGeom>
+          <a:noFill/>
+        </p:spPr>
+        <p:txBody>
+          <a:bodyPr wrap="square">
+            <a:spAutoFit/>
+          </a:bodyPr>
+          <a:lstStyle/>
+          <a:p>
+            <a:pPr>
+              <a:defRPr sz="3800" b="1">
+                <a:solidFill>
+                  <a:srgbClr val="FFFFFF"/>
+                </a:solidFill>
+                <a:latin typeface="Inter"/>
+              </a:defRPr>
+            </a:pPr>
+            <a:r>
+              <a:t>Supabase &amp; Vercel: Kyçja me 1-Kliko</a:t>
+            </a:r>
+          </a:p>
+        </p:txBody>
+      </p:sp>
+      <p:sp>
+        <p:nvSpPr>
+          <p:cNvPr id="5" name="TextBox 4"/>
+          <p:cNvSpPr txBox="1"/>
+          <p:nvPr/>
+        </p:nvSpPr>
+        <p:spPr>
+          <a:xfrm>
+            <a:off x="731520" y="1444752"/>
+            <a:ext cx="10698480" cy="502920"/>
+          </a:xfrm>
+          <a:prstGeom prst="rect">
+            <a:avLst/>
+          </a:prstGeom>
+          <a:noFill/>
+        </p:spPr>
+        <p:txBody>
+          <a:bodyPr wrap="square">
+            <a:spAutoFit/>
+          </a:bodyPr>
+          <a:lstStyle/>
+          <a:p>
+            <a:pPr>
+              <a:defRPr sz="2200">
+                <a:solidFill>
+                  <a:srgbClr val="E2E8F0"/>
+                </a:solidFill>
+                <a:latin typeface="Inter"/>
+              </a:defRPr>
+            </a:pPr>
+            <a:r>
+              <a:t>Nuk keni nevojë për fjalëkalime të reja — zgjidhni 'Continue with GitHub'.</a:t>
+            </a:r>
+          </a:p>
+        </p:txBody>
+      </p:sp>
+      <p:sp>
+        <p:nvSpPr>
+          <p:cNvPr id="6" name="Rounded Rectangle 5"/>
+          <p:cNvSpPr/>
+          <p:nvPr/>
+        </p:nvSpPr>
+        <p:spPr>
+          <a:xfrm>
+            <a:off x="731520" y="2011680"/>
+            <a:ext cx="5120640" cy="4389120"/>
+          </a:xfrm>
+          <a:prstGeom prst="roundRect">
+            <a:avLst/>
+          </a:prstGeom>
+          <a:solidFill>
+            <a:srgbClr val="141E34"/>
+          </a:solidFill>
+          <a:ln w="31750">
+            <a:solidFill>
+              <a:srgbClr val="10B981"/>
+            </a:solidFill>
+          </a:ln>
+        </p:spPr>
+        <p:style>
+          <a:lnRef idx="1">
+            <a:schemeClr val="accent1"/>
+          </a:lnRef>
+          <a:fillRef idx="3">
+            <a:schemeClr val="accent1"/>
+          </a:fillRef>
+          <a:effectRef idx="2">
+            <a:schemeClr val="accent1"/>
+          </a:effectRef>
+          <a:fontRef idx="minor">
+            <a:schemeClr val="lt1"/>
+          </a:fontRef>
+        </p:style>
+        <p:txBody>
+          <a:bodyPr rtlCol="0" anchor="ctr"/>
+          <a:lstStyle/>
+          <a:p>
+            <a:pPr algn="ctr"/>
+          </a:p>
+        </p:txBody>
+      </p:sp>
+      <p:pic>
+        <p:nvPicPr>
+          <p:cNvPr id="7" name="Picture 6" descr="qr_master_supabase.png"/>
+          <p:cNvPicPr>
+            <a:picLocks noChangeAspect="1"/>
+          </p:cNvPicPr>
+          <p:nvPr/>
+        </p:nvPicPr>
+        <p:blipFill>
+          <a:blip r:embed="rId2"/>
+          <a:stretch>
+            <a:fillRect/>
+          </a:stretch>
+        </p:blipFill>
+        <p:spPr>
+          <a:xfrm>
+            <a:off x="1005840" y="2286000"/>
+            <a:ext cx="2194560" cy="2194560"/>
+          </a:xfrm>
+          <a:prstGeom prst="rect">
+            <a:avLst/>
+          </a:prstGeom>
+        </p:spPr>
+      </p:pic>
+      <p:sp>
+        <p:nvSpPr>
+          <p:cNvPr id="8" name="TextBox 7"/>
+          <p:cNvSpPr txBox="1"/>
+          <p:nvPr/>
+        </p:nvSpPr>
+        <p:spPr>
+          <a:xfrm>
+            <a:off x="3383280" y="2194560"/>
+            <a:ext cx="2286000" cy="4023360"/>
+          </a:xfrm>
+          <a:prstGeom prst="rect">
+            <a:avLst/>
+          </a:prstGeom>
+          <a:noFill/>
+        </p:spPr>
+        <p:txBody>
+          <a:bodyPr wrap="square">
+            <a:spAutoFit/>
+          </a:bodyPr>
+          <a:lstStyle/>
+          <a:p>
+            <a:pPr>
+              <a:spcAft>
+                <a:spcPts val="1200"/>
+              </a:spcAft>
+              <a:defRPr sz="2400" b="1">
+                <a:solidFill>
+                  <a:srgbClr val="10B981"/>
+                </a:solidFill>
+                <a:latin typeface="Inter"/>
+              </a:defRPr>
+            </a:pPr>
+            <a:r>
+              <a:t>🗄️ SUPABASE</a:t>
+            </a:r>
+          </a:p>
+          <a:p>
+            <a:pPr>
+              <a:defRPr sz="1900">
+                <a:solidFill>
+                  <a:srgbClr val="E2E8F0"/>
+                </a:solidFill>
+                <a:latin typeface="Inter"/>
+              </a:defRPr>
+            </a:pPr>
+            <a:r>
+              <a:t>• Skanoni QR kodin</a:t>
+            </a:r>
+            <a:br/>
+            <a:r>
+              <a:t>• 'Sign in with GitHub'</a:t>
+            </a:r>
+            <a:br/>
+            <a:r>
+              <a:t>• Databaza PostgreSQL &amp; Auth gati për aplikacionin tuaj!</a:t>
+            </a:r>
+          </a:p>
+        </p:txBody>
+      </p:sp>
+      <p:sp>
+        <p:nvSpPr>
+          <p:cNvPr id="9" name="Rounded Rectangle 8"/>
+          <p:cNvSpPr/>
+          <p:nvPr/>
+        </p:nvSpPr>
+        <p:spPr>
+          <a:xfrm>
+            <a:off x="6309360" y="2011680"/>
+            <a:ext cx="5120640" cy="4389120"/>
+          </a:xfrm>
+          <a:prstGeom prst="roundRect">
+            <a:avLst/>
+          </a:prstGeom>
+          <a:solidFill>
+            <a:srgbClr val="141E34"/>
+          </a:solidFill>
+          <a:ln w="31750">
+            <a:solidFill>
+              <a:srgbClr val="38BDF8"/>
+            </a:solidFill>
+          </a:ln>
+        </p:spPr>
+        <p:style>
+          <a:lnRef idx="1">
+            <a:schemeClr val="accent1"/>
+          </a:lnRef>
+          <a:fillRef idx="3">
+            <a:schemeClr val="accent1"/>
+          </a:fillRef>
+          <a:effectRef idx="2">
+            <a:schemeClr val="accent1"/>
+          </a:effectRef>
+          <a:fontRef idx="minor">
+            <a:schemeClr val="lt1"/>
+          </a:fontRef>
+        </p:style>
+        <p:txBody>
+          <a:bodyPr rtlCol="0" anchor="ctr"/>
+          <a:lstStyle/>
+          <a:p>
+            <a:pPr algn="ctr"/>
+          </a:p>
+        </p:txBody>
+      </p:sp>
+      <p:pic>
+        <p:nvPicPr>
+          <p:cNvPr id="10" name="Picture 9" descr="qr_master_vercel.png"/>
+          <p:cNvPicPr>
+            <a:picLocks noChangeAspect="1"/>
+          </p:cNvPicPr>
+          <p:nvPr/>
+        </p:nvPicPr>
+        <p:blipFill>
+          <a:blip r:embed="rId3"/>
+          <a:stretch>
+            <a:fillRect/>
+          </a:stretch>
+        </p:blipFill>
+        <p:spPr>
+          <a:xfrm>
+            <a:off x="6583680" y="2286000"/>
+            <a:ext cx="2194560" cy="2194560"/>
+          </a:xfrm>
+          <a:prstGeom prst="rect">
+            <a:avLst/>
+          </a:prstGeom>
+        </p:spPr>
+      </p:pic>
+      <p:sp>
+        <p:nvSpPr>
+          <p:cNvPr id="11" name="TextBox 10"/>
+          <p:cNvSpPr txBox="1"/>
+          <p:nvPr/>
+        </p:nvSpPr>
+        <p:spPr>
+          <a:xfrm>
+            <a:off x="8961120" y="2194560"/>
+            <a:ext cx="2286000" cy="4023360"/>
+          </a:xfrm>
+          <a:prstGeom prst="rect">
+            <a:avLst/>
+          </a:prstGeom>
+          <a:noFill/>
+        </p:spPr>
+        <p:txBody>
+          <a:bodyPr wrap="square">
+            <a:spAutoFit/>
+          </a:bodyPr>
+          <a:lstStyle/>
+          <a:p>
+            <a:pPr>
+              <a:spcAft>
+                <a:spcPts val="1200"/>
+              </a:spcAft>
+              <a:defRPr sz="2400" b="1">
+                <a:solidFill>
+                  <a:srgbClr val="38BDF8"/>
+                </a:solidFill>
+                <a:latin typeface="Inter"/>
+              </a:defRPr>
+            </a:pPr>
+            <a:r>
+              <a:t>🚀 VERCEL</a:t>
+            </a:r>
+          </a:p>
+          <a:p>
+            <a:pPr>
+              <a:defRPr sz="1900">
+                <a:solidFill>
+                  <a:srgbClr val="E2E8F0"/>
+                </a:solidFill>
+                <a:latin typeface="Inter"/>
+              </a:defRPr>
+            </a:pPr>
+            <a:r>
+              <a:t>• Skanoni QR kodin</a:t>
+            </a:r>
+            <a:br/>
+            <a:r>
+              <a:t>• 'Continue with GitHub'</a:t>
+            </a:r>
+            <a:br/>
+            <a:r>
+              <a:t>• Publikimi live bëhet automatik me çdo git push!</a:t>
+            </a:r>
+          </a:p>
+        </p:txBody>
+      </p:sp>
+    </p:spTree>
+  </p:cSld>
+  <p:clrMapOvr>
+    <a:masterClrMapping/>
+  </p:clrMapOvr>
+</p:sld>
+</file>
+
+<file path=ppt/slides/slide19.xml><?xml version="1.0" encoding="utf-8"?>
 <p:sld xmlns:a="http://schemas.openxmlformats.org/drawingml/2006/main" xmlns:p="http://schemas.openxmlformats.org/presentationml/2006/main" xmlns:r="http://schemas.openxmlformats.org/officeDocument/2006/relationships">
   <p:cSld>
     <p:spTree>

</xml_diff>

<commit_message>
feat(presentation): adopt AAB RideShare theme with clean line sketch and student carpooling story in Albanian
</commit_message>
<xml_diff>
--- a/Jave1_Hyrje_Nextjs_PWA_Copilot_2026.pptx
+++ b/Jave1_Hyrje_Nextjs_PWA_Copilot_2026.pptx
@@ -3723,7 +3723,7 @@
               </a:defRPr>
             </a:pPr>
             <a:r>
-              <a:t>• Server Components për shpejtësi maksimale</a:t>
+              <a:t>• Server Components për shpejtësi</a:t>
             </a:r>
           </a:p>
           <a:p>
@@ -3755,7 +3755,7 @@
               </a:defRPr>
             </a:pPr>
             <a:r>
-              <a:t>• Optimizim Touch-First me Tailwind</a:t>
+              <a:t>• Dizajn Touch-First me Tailwind</a:t>
             </a:r>
           </a:p>
         </p:txBody>
@@ -3900,7 +3900,7 @@
               </a:defRPr>
             </a:pPr>
             <a:r>
-              <a:t>• Autentikim i plotë (Email, Google, Phone)</a:t>
+              <a:t>• Auth i dedikuar me email @universitetiaab.com</a:t>
             </a:r>
           </a:p>
           <a:p>
@@ -3916,7 +3916,7 @@
               </a:defRPr>
             </a:pPr>
             <a:r>
-              <a:t>• Realtime Subscriptions për porositë</a:t>
+              <a:t>• Realtime Subscriptions për vendet e lira</a:t>
             </a:r>
           </a:p>
         </p:txBody>
@@ -4045,7 +4045,7 @@
               </a:defRPr>
             </a:pPr>
             <a:r>
-              <a:t>• Gjenerim i skemave SQL dhe testeve</a:t>
+              <a:t>• Gjenerim i shpejtë i skemave SQL dhe testeve</a:t>
             </a:r>
           </a:p>
           <a:p>
@@ -4061,7 +4061,7 @@
               </a:defRPr>
             </a:pPr>
             <a:r>
-              <a:t>• Përshpejton zhvillimin e veçorive 3x</a:t>
+              <a:t>• Përshpejton zhvillimin 3x më shpejt</a:t>
             </a:r>
           </a:p>
           <a:p>
@@ -4077,7 +4077,7 @@
               </a:defRPr>
             </a:pPr>
             <a:r>
-              <a:t>• Mjet profesional i industrisë globale</a:t>
+              <a:t>• Mjet profesional i standardeve globale</a:t>
             </a:r>
           </a:p>
         </p:txBody>
@@ -4238,7 +4238,7 @@
               </a:defRPr>
             </a:pPr>
             <a:r>
-              <a:t>• Lighthouse Score 100/100</a:t>
+              <a:t>• Shpejtësi maksimale në çdo celular</a:t>
             </a:r>
           </a:p>
         </p:txBody>
@@ -4507,7 +4507,7 @@
               </a:defRPr>
             </a:pPr>
             <a:r>
-              <a:t>• Gjenerim Komponentësh: Përshkruani UI-në në koment dhe lini Copilot të gjenerojë skeleton-in me Tailwind.</a:t>
+              <a:t>• Gjenerim Komponentësh: Përshkruani kartelën e udhëtimit në koment dhe lini Copilot të gjenerojë kodin Tailwind.</a:t>
             </a:r>
           </a:p>
           <a:p>
@@ -4523,7 +4523,7 @@
               </a:defRPr>
             </a:pPr>
             <a:r>
-              <a:t>• Skema dhe Query SQL: Ndihmon në shkrimin e query-ve komplekse për Supabase.</a:t>
+              <a:t>• Skema dhe Query SQL: Ndihmon në shkrimin e query-ve për filtrimin e vendeve të lira sipas orës.</a:t>
             </a:r>
           </a:p>
           <a:p>
@@ -4703,7 +4703,7 @@
               </a:defRPr>
             </a:pPr>
             <a:r>
-              <a:t>• Ju Jeni Inxhinieri: Copilot është thjesht një kalkulator i avancuar. Inxhinieri i vërtetë jeni JU!</a:t>
+              <a:t>• Ju Jeni Inxhinieri: Copilot është thjesht një asistent i avancuar. Inxhinieri i vërtetë jeni JU!</a:t>
             </a:r>
           </a:p>
         </p:txBody>
@@ -5275,7 +5275,7 @@
               </a:defRPr>
             </a:pPr>
             <a:r>
-              <a:t>• PWA mobile për biznes real familjar</a:t>
+              <a:t>• PWA mobile për një rast real (si RideShare)</a:t>
             </a:r>
           </a:p>
           <a:p>
@@ -6170,7 +6170,7 @@
               </a:defRPr>
             </a:pPr>
             <a:r>
-              <a:t>• Biznesi Real: Tregoni biznesin që keni zgjedhur dhe problemin kryesor që zgjidh aplikacioni.</a:t>
+              <a:t>• Problemi Real: Tregoni problemin që keni zgjedhur (p.sh. transporti me AAB RideShare ose biznesi lokal).</a:t>
             </a:r>
           </a:p>
           <a:p>
@@ -6186,7 +6186,7 @@
               </a:defRPr>
             </a:pPr>
             <a:r>
-              <a:t>• Demonstrim i Veçorive: Kryeni një porosi me 'Click &amp; Collect' live, tregoni modin offline dhe RLS në Supabase.</a:t>
+              <a:t>• Demonstrim i Veçorive: Kryeni një rezervim live, tregoni modin offline dhe RLS në Supabase.</a:t>
             </a:r>
           </a:p>
           <a:p>
@@ -6318,7 +6318,7 @@
               </a:defRPr>
             </a:pPr>
             <a:r>
-              <a:t>• Zgjidhje për Familjen: Biznesi i prindërve ose të afërmve tuaj merr një vegël digjitale që kursen para çdo ditë.</a:t>
+              <a:t>• Zgjidhje për Komunitetin: Një vegël digjitale që zgjidh një problem të prekshëm për kolegët ose bizneset tona.</a:t>
             </a:r>
           </a:p>
           <a:p>
@@ -6334,7 +6334,7 @@
               </a:defRPr>
             </a:pPr>
             <a:r>
-              <a:t>• Gati për Tregun e Punës: Përvojë praktike me teknologjitë më të kërkuara në kompanitë ndërkombëtare.</a:t>
+              <a:t>• Gati për Tregun e Punës: Përvojë praktike me teknologjitë më të kërkuara në kompanitë moderne globale.</a:t>
             </a:r>
           </a:p>
           <a:p>
@@ -8645,7 +8645,7 @@
               </a:defRPr>
             </a:pPr>
             <a:r>
-              <a:t>Zgjidhni Biznesin</a:t>
+              <a:t>Përzgjidhni Temën</a:t>
             </a:r>
           </a:p>
           <a:p>
@@ -8661,7 +8661,7 @@
               </a:defRPr>
             </a:pPr>
             <a:r>
-              <a:t>• Flisni me një biznes familjar, punishte mobiliesh, kafene apo servis lokal.</a:t>
+              <a:t>• Zgjidhni një problem real studentor ose biznes lokal (si AAB RideShare ose shërbim lokal).</a:t>
             </a:r>
           </a:p>
           <a:p>
@@ -8677,7 +8677,7 @@
               </a:defRPr>
             </a:pPr>
             <a:r>
-              <a:t>• Zbuloni problemin e tyre kryesor ditor (inventari, porositë, mungesa e pjesëve).</a:t>
+              <a:t>• Përcaktoni cili është problemi kryesor që zgjidh aplikacioni juaj.</a:t>
             </a:r>
           </a:p>
           <a:p>
@@ -8809,7 +8809,7 @@
               </a:defRPr>
             </a:pPr>
             <a:r>
-              <a:t>• Merrni një fletë të bardhë dhe skiconi 3 ekranet kryesore të aplikacionit.</a:t>
+              <a:t>• Merrni një fletë të bardhë dhe skiconi me dorë 3 ekranet kryesore të aplikacionit.</a:t>
             </a:r>
           </a:p>
           <a:p>
@@ -8825,7 +8825,7 @@
               </a:defRPr>
             </a:pPr>
             <a:r>
-              <a:t>• Identifikoni 3 pjesët kryesore të inventarit që duhen skanuar.</a:t>
+              <a:t>• Përcaktoni butonin kryesor që do të klikojë përdoruesi (p.sh. 'Rezervo Vendin').</a:t>
             </a:r>
           </a:p>
           <a:p>
@@ -8841,7 +8841,7 @@
               </a:defRPr>
             </a:pPr>
             <a:r>
-              <a:t>• Përcaktoni butonin kryesor që do të përdorë klienti ose punëtori.</a:t>
+              <a:t>• Bëni një foto skicës suaj për ta pasur udhërrëfyes gjatë kodimit.</a:t>
             </a:r>
           </a:p>
         </p:txBody>
@@ -8989,7 +8989,7 @@
               </a:defRPr>
             </a:pPr>
             <a:r>
-              <a:t>• Bëni push-in e parë për të verifikuar pikët e autograding!</a:t>
+              <a:t>• Bëni push-in e parë me 'git push' për të testuar pikët e para të autograding!</a:t>
             </a:r>
           </a:p>
         </p:txBody>
@@ -9158,7 +9158,7 @@
               </a:defRPr>
             </a:pPr>
             <a:r>
-              <a:t>Si lindi ideja e një studenti për të modernizuar punishtën e karrigeve me celular.</a:t>
+              <a:t>Si lindi ideja e një studenti për të zgjidhur problemin e transportit për në Kolegjin AAB.</a:t>
             </a:r>
           </a:p>
         </p:txBody>
@@ -9210,7 +9210,7 @@
       </p:sp>
       <p:pic>
         <p:nvPicPr>
-          <p:cNvPr id="7" name="Picture 6" descr="chair_business_sketch_dream.jpg"/>
+          <p:cNvPr id="7" name="Picture 6" descr="aab_rideshare_sketch_dream.png"/>
           <p:cNvPicPr>
             <a:picLocks noChangeAspect="1"/>
           </p:cNvPicPr>
@@ -9311,7 +9311,7 @@
               </a:defRPr>
             </a:pPr>
             <a:r>
-              <a:t>🪵 Ëndrra e Një Inxhinieri të Ri</a:t>
+              <a:t>🚗 Tregimi Real i Studentit</a:t>
             </a:r>
           </a:p>
           <a:p>
@@ -9327,7 +9327,7 @@
               </a:defRPr>
             </a:pPr>
             <a:r>
-              <a:t>• Realiteti në Punishte: Prindërit punojnë me pasion duke prodhuar karrige cilësore, por stoqet shënohen me laps në fletore dhe porositë humbasin në thirrje telefonike.</a:t>
+              <a:t>• Realiteti i Mëngjesit: Në orën 07:30, qindra studentë nisen për në AAB nga Ferizaji, Gjilani, Podujeva, Mitrovica e Peja.</a:t>
             </a:r>
           </a:p>
           <a:p>
@@ -9343,7 +9343,7 @@
               </a:defRPr>
             </a:pPr>
             <a:r>
-              <a:t>• Skica e Parë: Studenti ulet me një fletë të bardhë dhe skicon karrigen, pjesët e saj (druri, këmbët metalike, vidat) dhe një ndërfaqe të thjeshtë telefoni.</a:t>
+              <a:t>• Paradoksi në Rrugë: Dhjetëra studentë shkojnë me makinë me 3 vende krejt të zbrazëta duke paguar 10€ naftë vetëm. Ndërkohë, shokët e tyre presin autobusin në shi ose vonohen në ligjëratë.</a:t>
             </a:r>
           </a:p>
           <a:p>
@@ -9359,7 +9359,7 @@
               </a:defRPr>
             </a:pPr>
             <a:r>
-              <a:t>• Pyetja Visionare: 'Po sikur punëtori të skanojë pjesët me telefon, baza të alarmojë kur mbarojnë vidat, dhe klienti të porosisë karrigen e personalizuar online?'</a:t>
+              <a:t>• Skica e Parë: Një student merr një fletë të bardhë dhe vizaton skicën: 'Po sikur të lidhim shoferin me studentët e së njëjtës rrugë përmes një aplikacioni të thjeshtë në celular?'</a:t>
             </a:r>
           </a:p>
           <a:p>
@@ -9708,7 +9708,7 @@
               </a:defRPr>
             </a:pPr>
             <a:r>
-              <a:t>• Rezultati: Shumica e bizneseve lokale mbeteshin me fletore!</a:t>
+              <a:t>• Rezultati: Shumica e ideve të mira mbeteshin vetëm në letër!</a:t>
             </a:r>
           </a:p>
         </p:txBody>
@@ -9808,7 +9808,7 @@
               </a:defRPr>
             </a:pPr>
             <a:r>
-              <a:t>• Next.js 15 PWA: Një kod i vetëm për çdo celular, tablet e PC.</a:t>
+              <a:t>• Next.js 15 PWA: Një kod i vetëm për çdo celular (iOS &amp; Android).</a:t>
             </a:r>
           </a:p>
           <a:p>
@@ -9840,7 +9840,7 @@
               </a:defRPr>
             </a:pPr>
             <a:r>
-              <a:t>• Supabase Cloud: Baza e të dhënave, auth dhe RLS me 0€ kosto fillestare.</a:t>
+              <a:t>• Supabase Cloud: Baza e të dhënave dhe Auth me email AAB falas.</a:t>
             </a:r>
           </a:p>
           <a:p>
@@ -9969,7 +9969,7 @@
               </a:defRPr>
             </a:pPr>
             <a:r>
-              <a:t>RASTI I STUDIMIT</a:t>
+              <a:t>RASTI KONKRET I STUDIMIT</a:t>
             </a:r>
           </a:p>
         </p:txBody>
@@ -10005,7 +10005,7 @@
               </a:defRPr>
             </a:pPr>
             <a:r>
-              <a:t>Zgjidhja Softuerike: Fabrika e Karrigeve 'WoodCraft'</a:t>
+              <a:t>Zgjidhja Softuerike: 'AAB RideShare' me 3 Ekrane</a:t>
             </a:r>
           </a:p>
         </p:txBody>
@@ -10041,7 +10041,7 @@
               </a:defRPr>
             </a:pPr>
             <a:r>
-              <a:t>3 shtyllat kryesore që automatizojnë punishtën nga lënda e parë te klienti.</a:t>
+              <a:t>Arkitekturë e pastër dhe e thjeshtë që çdo student mund ta ndërtojë dhe zotërojë lehtë.</a:t>
             </a:r>
           </a:p>
         </p:txBody>
@@ -10125,7 +10125,7 @@
               </a:defRPr>
             </a:pPr>
             <a:r>
-              <a:t>🪵 1. Inventari i Pjesëve</a:t>
+              <a:t>🔍 1. Kërkimi i Udhëtimit</a:t>
             </a:r>
           </a:p>
           <a:p>
@@ -10141,7 +10141,7 @@
               </a:defRPr>
             </a:pPr>
             <a:r>
-              <a:t>• Skanim me telefon në punishte</a:t>
+              <a:t>• Zgjedh qytetin e nisjes (p.sh. Gjilan)</a:t>
             </a:r>
           </a:p>
           <a:p>
@@ -10157,7 +10157,7 @@
               </a:defRPr>
             </a:pPr>
             <a:r>
-              <a:t>• Evidentim i drurit, këmbëve &amp; vidave</a:t>
+              <a:t>• Destinacioni automatik: Kampusi AAB</a:t>
             </a:r>
           </a:p>
           <a:p>
@@ -10173,7 +10173,7 @@
               </a:defRPr>
             </a:pPr>
             <a:r>
-              <a:t>• Pjesët zbriten automatikisht gjatë montimit</a:t>
+              <a:t>• Përzgjedh orën e dëshiruar (p.sh. 08:00)</a:t>
             </a:r>
           </a:p>
           <a:p>
@@ -10189,7 +10189,7 @@
               </a:defRPr>
             </a:pPr>
             <a:r>
-              <a:t>• Zero fletore dhe zero gabime njerëzore</a:t>
+              <a:t>• Filtër i shpejtë me 1 prekje në ekran</a:t>
             </a:r>
           </a:p>
         </p:txBody>
@@ -10273,7 +10273,7 @@
               </a:defRPr>
             </a:pPr>
             <a:r>
-              <a:t>🔄 2. Porositja e Furnizimeve</a:t>
+              <a:t>📋 2. Lista e Veturave të Lira</a:t>
             </a:r>
           </a:p>
           <a:p>
@@ -10289,7 +10289,7 @@
               </a:defRPr>
             </a:pPr>
             <a:r>
-              <a:t>• Alarme kur stoku bie nën minimum (p.sh. &lt;20 këmbë)</a:t>
+              <a:t>• Sheh studentin shofer &amp; vitin e studimit</a:t>
             </a:r>
           </a:p>
           <a:p>
@@ -10305,7 +10305,7 @@
               </a:defRPr>
             </a:pPr>
             <a:r>
-              <a:t>• Gjenerim i fletës së porosisë me 1-klik</a:t>
+              <a:t>• Modelin e makinës (p.sh. Golf 7, Audi A3)</a:t>
             </a:r>
           </a:p>
           <a:p>
@@ -10321,7 +10321,7 @@
               </a:defRPr>
             </a:pPr>
             <a:r>
-              <a:t>• Lidhje direkte me furnitorët lokalë</a:t>
+              <a:t>• Numrin e vendeve të lira (p.sh. 2 vende)</a:t>
             </a:r>
           </a:p>
           <a:p>
@@ -10337,7 +10337,7 @@
               </a:defRPr>
             </a:pPr>
             <a:r>
-              <a:t>• Punishtja nuk bllokohet kurrë nga mungesa e pjesëve</a:t>
+              <a:t>• Kontributin për karburant (p.sh. 1.50€)</a:t>
             </a:r>
           </a:p>
         </p:txBody>
@@ -10421,7 +10421,7 @@
               </a:defRPr>
             </a:pPr>
             <a:r>
-              <a:t>🛒 3. Shitjet &amp; Porositë B2B</a:t>
+              <a:t>📲 3. Rezervo &amp; Lidhja</a:t>
             </a:r>
           </a:p>
           <a:p>
@@ -10437,7 +10437,7 @@
               </a:defRPr>
             </a:pPr>
             <a:r>
-              <a:t>• Katalog mobil për restorante e klientë</a:t>
+              <a:t>• Rezervim i menjëhershëm me 1-klik</a:t>
             </a:r>
           </a:p>
           <a:p>
@@ -10453,7 +10453,7 @@
               </a:defRPr>
             </a:pPr>
             <a:r>
-              <a:t>• Zgjedhja e modelit, llojit të drurit dhe pëlhurës</a:t>
+              <a:t>• Shoferi merr njoftim live në telefon</a:t>
             </a:r>
           </a:p>
           <a:p>
@@ -10469,7 +10469,7 @@
               </a:defRPr>
             </a:pPr>
             <a:r>
-              <a:t>• Llogaritje e menjëhershme e çmimit &amp; afatit</a:t>
+              <a:t>• Lidhje direkte në WhatsApp për vendin e takimit</a:t>
             </a:r>
           </a:p>
           <a:p>
@@ -10485,7 +10485,7 @@
               </a:defRPr>
             </a:pPr>
             <a:r>
-              <a:t>• Statusi live: [Në Prerje] ➔ [Montim] ➔ [Gati]</a:t>
+              <a:t>• Statusi: [I Rezervuar] ➔ [Gati për Nisje]</a:t>
             </a:r>
           </a:p>
         </p:txBody>
@@ -10618,7 +10618,7 @@
               </a:defRPr>
             </a:pPr>
             <a:r>
-              <a:t>Anatomia e një Biznesi Prodhes: Nga Dhimbja te Vlera</a:t>
+              <a:t>Nga Dhimbja te Vlera: Pse Ka Sukses 'AAB RideShare'?</a:t>
             </a:r>
           </a:p>
         </p:txBody>
@@ -10654,7 +10654,7 @@
               </a:defRPr>
             </a:pPr>
             <a:r>
-              <a:t>Lidhja mes problemeve të punishtes dhe zgjidhjes softuerike që ndërtoni ju.</a:t>
+              <a:t>Lidhja mes problemit të përditshëm të studentëve dhe zgjidhjes softuerike.</a:t>
             </a:r>
           </a:p>
         </p:txBody>
@@ -10754,7 +10754,7 @@
               </a:defRPr>
             </a:pPr>
             <a:r>
-              <a:t>Kaosi në Montim &amp; Pjesët që Mungojnë</a:t>
+              <a:t>Kosto e Lartë &amp; Humbje Kohe</a:t>
             </a:r>
           </a:p>
           <a:p>
@@ -10770,7 +10770,7 @@
               </a:defRPr>
             </a:pPr>
             <a:r>
-              <a:t>• Punëtori nis montimin e 40 karrigeve dhe zbulon se mungojnë vidat speciale.</a:t>
+              <a:t>• Shoferi paguan 100% të naftës i vetëm (10€-15€ në ditë).</a:t>
             </a:r>
           </a:p>
           <a:p>
@@ -10786,7 +10786,7 @@
               </a:defRPr>
             </a:pPr>
             <a:r>
-              <a:t>• Porositë e restoranteve regjistrohen në copa letre dhe ngatërrohen ngjyrat.</a:t>
+              <a:t>• Studentët pa makinë presin autobusin në shi dhe në të ftohtë.</a:t>
             </a:r>
           </a:p>
           <a:p>
@@ -10802,7 +10802,7 @@
               </a:defRPr>
             </a:pPr>
             <a:r>
-              <a:t>• Humbje direkte: ~25% e kohës dhe materialit të shkuar dëm.</a:t>
+              <a:t>• Udhëtimi me autobus merr shpesh 1 orë e gjysmë në trafik.</a:t>
             </a:r>
           </a:p>
           <a:p>
@@ -10818,7 +10818,7 @@
               </a:defRPr>
             </a:pPr>
             <a:r>
-              <a:t>• Klientët e pakënaqur telefonojnë vazhdimisht: 'A janë bërë gati karriget?'</a:t>
+              <a:t>• Vonesa të shpeshta në ligjëratën e orës 09:00 në fakultet.</a:t>
             </a:r>
           </a:p>
         </p:txBody>
@@ -10918,7 +10918,7 @@
               </a:defRPr>
             </a:pPr>
             <a:r>
-              <a:t>PWA Mobile: Punishtja e Dixhitalizuar</a:t>
+              <a:t>Udhëtim i Shpejtë, i Lirë &amp; Social</a:t>
             </a:r>
           </a:p>
           <a:p>
@@ -10934,7 +10934,7 @@
               </a:defRPr>
             </a:pPr>
             <a:r>
-              <a:t>• Punëtori skanon me telefon barkodin e pakos me pjesë brenda 1 sekonde.</a:t>
+              <a:t>• Studenti arrin në AAB 45 minuta më shpejt se me autobus.</a:t>
             </a:r>
           </a:p>
           <a:p>
@@ -10950,7 +10950,7 @@
               </a:defRPr>
             </a:pPr>
             <a:r>
-              <a:t>• Klienti konfigurues karrigen e tij (ngjyrën, drurin) nga celulari.</a:t>
+              <a:t>• Kosto e ndarë dhe minimale: vetëm 1.00€ — 1.50€ për rrugë.</a:t>
             </a:r>
           </a:p>
           <a:p>
@@ -10966,7 +10966,7 @@
               </a:defRPr>
             </a:pPr>
             <a:r>
-              <a:t>• Përcjellje transparente e statusit: [Prerje] ➔ [Montim] ➔ [Gati].</a:t>
+              <a:t>• Përvojë sociale: shoqërohesh me kolegë të fakultetit gjatë rrugës.</a:t>
             </a:r>
           </a:p>
           <a:p>
@@ -10982,7 +10982,7 @@
               </a:defRPr>
             </a:pPr>
             <a:r>
-              <a:t>• Zero fërkim: Pa shkarkuar asnjë aplikacion të rëndë nga App Store.</a:t>
+              <a:t>• Zero fërkim: PWA hapet me link pa shkarkuar 150MB nga App Store.</a:t>
             </a:r>
           </a:p>
         </p:txBody>
@@ -11066,7 +11066,7 @@
               </a:defRPr>
             </a:pPr>
             <a:r>
-              <a:t>💰 Ekonomia e Njësisë (Economics)</a:t>
+              <a:t>💰 Siguria &amp; Modeli (Economics &amp; Trust)</a:t>
             </a:r>
           </a:p>
           <a:p>
@@ -11082,7 +11082,7 @@
               </a:defRPr>
             </a:pPr>
             <a:r>
-              <a:t>Margjinë e Lartë &amp; Zero Komisione</a:t>
+              <a:t>Komunitet i Besueshëm me Email AAB</a:t>
             </a:r>
           </a:p>
           <a:p>
@@ -11098,7 +11098,7 @@
               </a:defRPr>
             </a:pPr>
             <a:r>
-              <a:t>• Pa licenca të shtrenjta ERP: 0€ me Vercel &amp; Supabase Free Tier.</a:t>
+              <a:t>• Kyçje e sigurt: lejohen vetëm studentët me email zyrtar AAB.</a:t>
             </a:r>
           </a:p>
           <a:p>
@@ -11114,7 +11114,7 @@
               </a:defRPr>
             </a:pPr>
             <a:r>
-              <a:t>• Zvogëlimi i stoqeve të fjetura dhe dorëzim 2x më i shpejtë te klientët.</a:t>
+              <a:t>• Zero komisione: kursimi shkon 100% për xhepin e studentëve.</a:t>
             </a:r>
           </a:p>
           <a:p>
@@ -11130,7 +11130,7 @@
               </a:defRPr>
             </a:pPr>
             <a:r>
-              <a:t>• Porositë automatike parandalojnë ndaljen e prodhimit në fabrikë.</a:t>
+              <a:t>• Zvogëlim i trafikut në hyrje të Prishtinës dhe më pak ndotje.</a:t>
             </a:r>
           </a:p>
           <a:p>
@@ -11146,7 +11146,7 @@
               </a:defRPr>
             </a:pPr>
             <a:r>
-              <a:t>• Fitimi mbetet 100% brenda biznesit prodhues lokal!</a:t>
+              <a:t>• Infrastruktura softuerike: 0€ kosto me Supabase &amp; Vercel Free Tier!</a:t>
             </a:r>
           </a:p>
         </p:txBody>
@@ -11279,7 +11279,7 @@
               </a:defRPr>
             </a:pPr>
             <a:r>
-              <a:t>Arkitektura në Veprim: Skica Vektoriale e Fluksit të të Dhënave</a:t>
+              <a:t>Arkitektura në Veprim: Skica Teknike e Të Dhënave</a:t>
             </a:r>
           </a:p>
         </p:txBody>
@@ -11315,7 +11315,7 @@
               </a:defRPr>
             </a:pPr>
             <a:r>
-              <a:t>Skicë e pastër teknike me vija dhe kuti: Nga punishtja fizike te cloud-i dhe klienti.</a:t>
+              <a:t>Skicë e pastër me vija dhe kuti: Nga celulari i studentit te cloud-i dhe lidhja live.</a:t>
             </a:r>
           </a:p>
         </p:txBody>
@@ -11399,7 +11399,7 @@
               </a:defRPr>
             </a:pPr>
             <a:r>
-              <a:t>🏭 1. Punishtja &amp; Skanimi me Telefon</a:t>
+              <a:t>📱 1. Ndërfaqja Mobile PWA (Frontend)</a:t>
             </a:r>
           </a:p>
           <a:p>
@@ -11415,7 +11415,7 @@
               </a:defRPr>
             </a:pPr>
             <a:r>
-              <a:t>• Skanim me Kamerë (PWA): Punëtori përdor celularin e tij për të skanuar barkodin e drurit, këmbëve ose vidave gjatë montimit të karriges.</a:t>
+              <a:t>• Moduli i Shoferit: Formë 1-faqëshe me 3 fusha: Qyteti i nisjes, ora dhe numri i vendeve të lira (p.sh. 3 vende).</a:t>
             </a:r>
           </a:p>
           <a:p>
@@ -11431,7 +11431,7 @@
               </a:defRPr>
             </a:pPr>
             <a:r>
-              <a:t>• Regjistrim Offline: Nëse punishtja ka sinjal të dobët, Service Worker ruan veprimin lokalisht dhe e sinkronizon sapo lidhet me WiFi.</a:t>
+              <a:t>• Moduli i Udhëtarit: Kërkim i menjëhershëm sipas qytetit dhe lista me kartela të qarta me çmimin dhe vendet.</a:t>
             </a:r>
           </a:p>
           <a:p>
@@ -11447,7 +11447,23 @@
               </a:defRPr>
             </a:pPr>
             <a:r>
-              <a:t>• Ndryshimi i Statusit: Me 1 prekje në ekran punëtori kalon karrigen nga [Në Prerje] në [Në Montim] dhe [Në Tapiceri].</a:t>
+              <a:t>• Touch-First me Tailwind: Butona të mëdhenj (48px) që klikohen lehtë me gisht gjatë lëvizjes.</a:t>
+            </a:r>
+          </a:p>
+          <a:p>
+            <a:pPr>
+              <a:spcAft>
+                <a:spcPts val="1000"/>
+              </a:spcAft>
+              <a:defRPr sz="1700">
+                <a:solidFill>
+                  <a:srgbClr val="E2E8F0"/>
+                </a:solidFill>
+                <a:latin typeface="Inter"/>
+              </a:defRPr>
+            </a:pPr>
+            <a:r>
+              <a:t>• Instalueshmëria PWA: Ruhet në Home Screen me ikonën zyrtare të Kolegjit AAB pa kaluar nga App Store.</a:t>
             </a:r>
           </a:p>
         </p:txBody>
@@ -11531,7 +11547,7 @@
               </a:defRPr>
             </a:pPr>
             <a:r>
-              <a:t>☁️ 2. Supabase Cloud, Furnizimi &amp; Klienti</a:t>
+              <a:t>☁️ 2. Supabase Cloud DB &amp; Auth (Backend)</a:t>
             </a:r>
           </a:p>
           <a:p>
@@ -11547,7 +11563,7 @@
               </a:defRPr>
             </a:pPr>
             <a:r>
-              <a:t>• Sinkronizim në Çast (0.2s): Supabase PostgreSQL përditëson stoqet me Row-Level Security (punëtorët shohin punishten, menaxheri gjithçka).</a:t>
+              <a:t>• Autentikimi me Email AAB: Lejohen vetëm regjistrimet me prapashtesën @universitetiaab.com për siguri maksimale.</a:t>
             </a:r>
           </a:p>
           <a:p>
@@ -11563,7 +11579,7 @@
               </a:defRPr>
             </a:pPr>
             <a:r>
-              <a:t>• Alarmi i Auto-Porosisë: Kur stoku i këmbëve metalike bie nën 20 copë, sistemi dërgon automatikisht kërkesën për furnizim te furnitori.</a:t>
+              <a:t>• Tabela 'rides' (PostgreSQL): Ruan: shoferin, qytetin, orën, vendet e lira dhe çmimin e karburantit.</a:t>
             </a:r>
           </a:p>
           <a:p>
@@ -11579,7 +11595,23 @@
               </a:defRPr>
             </a:pPr>
             <a:r>
-              <a:t>• Portali i Klientit (B2B): Restoranti që ka porositur 50 karrige sheh në telefon përparimin në kohë reale pa telefonuar asnjëherë menaxherin.</a:t>
+              <a:t>• Realtime Subscriptions: Sapo një student rezervon vendin, numri i vendeve të lira bie në çast për të gjithë përdoruesit!</a:t>
+            </a:r>
+          </a:p>
+          <a:p>
+            <a:pPr>
+              <a:spcAft>
+                <a:spcPts val="1000"/>
+              </a:spcAft>
+              <a:defRPr sz="1700">
+                <a:solidFill>
+                  <a:srgbClr val="E2E8F0"/>
+                </a:solidFill>
+                <a:latin typeface="Inter"/>
+              </a:defRPr>
+            </a:pPr>
+            <a:r>
+              <a:t>• Row-Level Security (RLS): Shoferi mund të modifikojë ose fshijë vetëm udhëtimet e tij personale.</a:t>
             </a:r>
           </a:p>
         </p:txBody>
@@ -11873,7 +11905,7 @@
               </a:defRPr>
             </a:pPr>
             <a:r>
-              <a:t>Bisedoni me biznesin/punishten: Cilat pjesë vonohen më shumë? Skiconi modelin në letër.</a:t>
+              <a:t>Bisedoni me kolegët: Nga cili qytet udhëtoni? Sa vende ka makina? Skiconi idenë në letër.</a:t>
             </a:r>
           </a:p>
         </p:txBody>
@@ -11998,7 +12030,7 @@
               </a:defRPr>
             </a:pPr>
             <a:r>
-              <a:t>Ndërtoni ndërfaqen mobile me Tailwind CSS. Butona Touch-First (48px) të përshtatshëm për punishte.</a:t>
+              <a:t>Ndërtoni ndërfaqen mobile me Tailwind CSS. Krijoni kartelat e makinave dhe butonat e kërkimit.</a:t>
             </a:r>
           </a:p>
         </p:txBody>
@@ -12123,7 +12155,7 @@
               </a:defRPr>
             </a:pPr>
             <a:r>
-              <a:t>Krijoni tabelat (karriget, pjesët, furnitorët, porositë). Mbroni të dhënat me siguri të plotë (RLS).</a:t>
+              <a:t>Krijoni tabelat 'rides' dhe 'bookings'. Mbroni të dhënat me siguri të plotë (RLS) dhe email AAB.</a:t>
             </a:r>
           </a:p>
         </p:txBody>
@@ -12231,11 +12263,11 @@
               </a:defRPr>
             </a:pPr>
             <a:r>
-              <a:t>Skanimi &amp;</a:t>
+              <a:t>Realtime &amp;</a:t>
             </a:r>
             <a:br/>
             <a:r>
-              <a:t>Testimi</a:t>
+              <a:t>Njoftimet</a:t>
             </a:r>
           </a:p>
           <a:p>
@@ -12248,7 +12280,7 @@
               </a:defRPr>
             </a:pPr>
             <a:r>
-              <a:t>Integroni kamerën e telefonit për leximin e barkodeve/QR dhe testimin e auto-porosive.</a:t>
+              <a:t>Lidhni përditësimin live të vendeve të lira dhe njoftimet push kur studenti konfirmon vendin.</a:t>
             </a:r>
           </a:p>
         </p:txBody>
@@ -12642,7 +12674,7 @@
               </a:defRPr>
             </a:pPr>
             <a:r>
-              <a:t>• Klienti ose punëtori hap vetëm një link ose skanon QR.</a:t>
+              <a:t>• Studenti hap vetëm linkun në shfletues.</a:t>
             </a:r>
           </a:p>
           <a:p>
@@ -12674,7 +12706,7 @@
               </a:defRPr>
             </a:pPr>
             <a:r>
-              <a:t>• Zë më pak se 2MB memorie në pajisje (krahasuar me 150MB të app-eve native).</a:t>
+              <a:t>• Zë më pak se 2MB memorie në telefon (krahasuar me 150MB të app-eve native).</a:t>
             </a:r>
           </a:p>
         </p:txBody>
@@ -12758,7 +12790,7 @@
               </a:defRPr>
             </a:pPr>
             <a:r>
-              <a:t>📶 Funksionon Edhe Offline</a:t>
+              <a:t>📶 Funksionon Edhe me Rrjet të Dobët</a:t>
             </a:r>
           </a:p>
           <a:p>
@@ -12774,7 +12806,7 @@
               </a:defRPr>
             </a:pPr>
             <a:r>
-              <a:t>• Punishtja e drurit mund të mos ketë WiFi në çdo cep.</a:t>
+              <a:t>• Rruga mes qyteteve shpesh ka zona me mbulim të dobët interneti.</a:t>
             </a:r>
           </a:p>
           <a:p>
@@ -12790,7 +12822,7 @@
               </a:defRPr>
             </a:pPr>
             <a:r>
-              <a:t>• Service Worker ruan të dhënat dhe mundëson skanim të pandërprerë.</a:t>
+              <a:t>• Service Worker ruan të dhënat e fundit lokalisht në telefon.</a:t>
             </a:r>
           </a:p>
           <a:p>
@@ -12806,7 +12838,7 @@
               </a:defRPr>
             </a:pPr>
             <a:r>
-              <a:t>• Sinkronizim automatik në sfond sapo rikthehet lidhja në internet.</a:t>
+              <a:t>• Sinkronizohet automatikisht sapo rifitohet lidhja 4G/5G.</a:t>
             </a:r>
           </a:p>
         </p:txBody>
@@ -12890,7 +12922,7 @@
               </a:defRPr>
             </a:pPr>
             <a:r>
-              <a:t>📱 Qasje në Hardware të Telefonit</a:t>
+              <a:t>📱 Qasje në Karakteristikat Celulare</a:t>
             </a:r>
           </a:p>
           <a:p>
@@ -12906,7 +12938,7 @@
               </a:defRPr>
             </a:pPr>
             <a:r>
-              <a:t>• Kamera përdoret për skanimin e barkodeve të pjesëve të karrigeve.</a:t>
+              <a:t>• Njoftime Push sapo shoferi të konfirmojë rezervimin tuaj.</a:t>
             </a:r>
           </a:p>
           <a:p>
@@ -12922,7 +12954,7 @@
               </a:defRPr>
             </a:pPr>
             <a:r>
-              <a:t>• Njoftimet Push paralajmërojnë stafin kur mungojnë vidat apo këmbët.</a:t>
+              <a:t>• Gjeolokacion për të parë distancën deri te pika e takimit.</a:t>
             </a:r>
           </a:p>
           <a:p>
@@ -12938,7 +12970,7 @@
               </a:defRPr>
             </a:pPr>
             <a:r>
-              <a:t>• Gjeolokacioni ndihmon shoferin e furgonit për dorëzimin e porosive.</a:t>
+              <a:t>• Telefonatë ose mesazh direkt me 1-prekje nga ekrani.</a:t>
             </a:r>
           </a:p>
         </p:txBody>
@@ -13107,7 +13139,7 @@
               </a:defRPr>
             </a:pPr>
             <a:r>
-              <a:t>Pse teknologjia PWA është zgjedhja ideale për tregun e Kosovës dhe SME-të.</a:t>
+              <a:t>Pse teknologjia PWA është zgjedhja ideale për tregun e Kosovës dhe projektet studentore.</a:t>
             </a:r>
           </a:p>
         </p:txBody>
@@ -13255,7 +13287,7 @@
               </a:defRPr>
             </a:pPr>
             <a:r>
-              <a:t>Madhësia e Aplikacionit    | 100MB — 250MB (Pengesë për shkarkim nga klienti) | &lt; 2MB (Hapet me 1 klikim pa zënë memorien)</a:t>
+              <a:t>Madhësia e Aplikacionit    | 100MB — 250MB (Pengesë për shkarkim nga studenti) | &lt; 2MB (Hapet me 1 klikim pa zënë memorien)</a:t>
             </a:r>
           </a:p>
           <a:p>
@@ -13287,7 +13319,7 @@
               </a:defRPr>
             </a:pPr>
             <a:r>
-              <a:t>E Përshtatshme për Biznese | E papërballueshme për shumicën e bizneseve tona  | Zgjidhja ideale me kosto zero dhe efikasitet maksimal</a:t>
+              <a:t>E Përshtatshme për Ne      | E papërballueshme për shumicën e ideve fillestare | Zgjidhja ideale me kosto zero dhe efikasitet maksimal</a:t>
             </a:r>
           </a:p>
         </p:txBody>

</xml_diff>

<commit_message>
feat(curriculum): align Week 1 Lab toolchain and Week 2 Startup Ideation & Architecture
</commit_message>
<xml_diff>
--- a/Jave1_Hyrje_Nextjs_PWA_Copilot_2026.pptx
+++ b/Jave1_Hyrje_Nextjs_PWA_Copilot_2026.pptx
@@ -25,6 +25,7 @@
     <p:sldId id="273" r:id="rId24"/>
     <p:sldId id="274" r:id="rId25"/>
     <p:sldId id="275" r:id="rId26"/>
+    <p:sldId id="276" r:id="rId27"/>
   </p:sldIdLst>
   <p:sldSz cx="12191695" cy="6858000" type="screen4x3"/>
   <p:notesSz cx="6858000" cy="9144000"/>
@@ -7223,7 +7224,7 @@
               </a:defRPr>
             </a:pPr>
             <a:r>
-              <a:t>AKSIONI NË SALLË</a:t>
+              <a:t>LABORATORI PRAKTIK 1 (USHTRIMET)</a:t>
             </a:r>
           </a:p>
         </p:txBody>
@@ -7259,7 +7260,7 @@
               </a:defRPr>
             </a:pPr>
             <a:r>
-              <a:t>Sprinti Praktik: Nxirrni Telefonat Celularë!</a:t>
+              <a:t>Ora 1 e Ushtrimeve: Toolchain-i i Themeluesit (How to Start a Startup 🚀)</a:t>
             </a:r>
           </a:p>
         </p:txBody>
@@ -7295,7 +7296,7 @@
               </a:defRPr>
             </a:pPr>
             <a:r>
-              <a:t>10 minuta punë aktive në auditor për konfigurimin e mjedisit tuaj të punës.</a:t>
+              <a:t>Pajisja e çdo studenti me veglat moderne: Git, VS Code, GitHub Copilot, Supabase &amp; Vercel.</a:t>
             </a:r>
           </a:p>
         </p:txBody>
@@ -7379,7 +7380,7 @@
               </a:defRPr>
             </a:pPr>
             <a:r>
-              <a:t>1️⃣ Hapi 1 (Min 0–3)</a:t>
+              <a:t>1️⃣ Veglat Lokale</a:t>
             </a:r>
           </a:p>
           <a:p>
@@ -7395,7 +7396,7 @@
               </a:defRPr>
             </a:pPr>
             <a:r>
-              <a:t>Skanoni dhe Hyni</a:t>
+              <a:t>VS Code &amp; Git i Konfiguruar</a:t>
             </a:r>
           </a:p>
           <a:p>
@@ -7403,15 +7404,15 @@
               <a:spcAft>
                 <a:spcPts val="1000"/>
               </a:spcAft>
-              <a:defRPr sz="1800">
-                <a:solidFill>
-                  <a:srgbClr val="E2E8F0"/>
-                </a:solidFill>
-                <a:latin typeface="Inter"/>
-              </a:defRPr>
-            </a:pPr>
-            <a:r>
-              <a:t>• Hapni kamerën e telefonit</a:t>
+              <a:defRPr sz="1700">
+                <a:solidFill>
+                  <a:srgbClr val="E2E8F0"/>
+                </a:solidFill>
+                <a:latin typeface="Inter"/>
+              </a:defRPr>
+            </a:pPr>
+            <a:r>
+              <a:t>• Instalimi dhe konfigurimi i VS Code me shtojcat thelbësore.</a:t>
             </a:r>
           </a:p>
           <a:p>
@@ -7419,15 +7420,15 @@
               <a:spcAft>
                 <a:spcPts val="1000"/>
               </a:spcAft>
-              <a:defRPr sz="1800">
-                <a:solidFill>
-                  <a:srgbClr val="E2E8F0"/>
-                </a:solidFill>
-                <a:latin typeface="Inter"/>
-              </a:defRPr>
-            </a:pPr>
-            <a:r>
-              <a:t>• Skanoni kodin QR në ekran</a:t>
+              <a:defRPr sz="1700">
+                <a:solidFill>
+                  <a:srgbClr val="E2E8F0"/>
+                </a:solidFill>
+                <a:latin typeface="Inter"/>
+              </a:defRPr>
+            </a:pPr>
+            <a:r>
+              <a:t>• Lidhja e llogarisë zyrtare të GitHub dhe vendosja e çelësave SSH.</a:t>
             </a:r>
           </a:p>
           <a:p>
@@ -7435,15 +7436,15 @@
               <a:spcAft>
                 <a:spcPts val="1000"/>
               </a:spcAft>
-              <a:defRPr sz="1800">
-                <a:solidFill>
-                  <a:srgbClr val="E2E8F0"/>
-                </a:solidFill>
-                <a:latin typeface="Inter"/>
-              </a:defRPr>
-            </a:pPr>
-            <a:r>
-              <a:t>• Regjistroni praninë me PIN-in e ditës</a:t>
+              <a:defRPr sz="1700">
+                <a:solidFill>
+                  <a:srgbClr val="E2E8F0"/>
+                </a:solidFill>
+                <a:latin typeface="Inter"/>
+              </a:defRPr>
+            </a:pPr>
+            <a:r>
+              <a:t>• Klonimi i repos fillestare nga GitHub Classroom.</a:t>
             </a:r>
           </a:p>
           <a:p>
@@ -7451,15 +7452,15 @@
               <a:spcAft>
                 <a:spcPts val="1000"/>
               </a:spcAft>
-              <a:defRPr sz="1800">
-                <a:solidFill>
-                  <a:srgbClr val="E2E8F0"/>
-                </a:solidFill>
-                <a:latin typeface="Inter"/>
-              </a:defRPr>
-            </a:pPr>
-            <a:r>
-              <a:t>• Ruani faqen në 'Home Screen'</a:t>
+              <a:defRPr sz="1700">
+                <a:solidFill>
+                  <a:srgbClr val="E2E8F0"/>
+                </a:solidFill>
+                <a:latin typeface="Inter"/>
+              </a:defRPr>
+            </a:pPr>
+            <a:r>
+              <a:t>• Verifikimi që terminali dhe Git funksionojnë 100% lokalisht.</a:t>
             </a:r>
           </a:p>
         </p:txBody>
@@ -7543,7 +7544,7 @@
               </a:defRPr>
             </a:pPr>
             <a:r>
-              <a:t>2️⃣ Hapi 2 (Min 3–7)</a:t>
+              <a:t>2️⃣ AI &amp; Cloud Falas</a:t>
             </a:r>
           </a:p>
           <a:p>
@@ -7559,7 +7560,7 @@
               </a:defRPr>
             </a:pPr>
             <a:r>
-              <a:t>Aktivizoni GitHub Pack</a:t>
+              <a:t>Copilot Pro, Supabase &amp; Vercel</a:t>
             </a:r>
           </a:p>
           <a:p>
@@ -7567,15 +7568,15 @@
               <a:spcAft>
                 <a:spcPts val="1000"/>
               </a:spcAft>
-              <a:defRPr sz="1800">
-                <a:solidFill>
-                  <a:srgbClr val="E2E8F0"/>
-                </a:solidFill>
-                <a:latin typeface="Inter"/>
-              </a:defRPr>
-            </a:pPr>
-            <a:r>
-              <a:t>• Kyçuni me emailin studentor AAB</a:t>
+              <a:defRPr sz="1700">
+                <a:solidFill>
+                  <a:srgbClr val="E2E8F0"/>
+                </a:solidFill>
+                <a:latin typeface="Inter"/>
+              </a:defRPr>
+            </a:pPr>
+            <a:r>
+              <a:t>• Aktivizimi i GitHub Student Developer Pack me email AAB.</a:t>
             </a:r>
           </a:p>
           <a:p>
@@ -7583,15 +7584,15 @@
               <a:spcAft>
                 <a:spcPts val="1000"/>
               </a:spcAft>
-              <a:defRPr sz="1800">
-                <a:solidFill>
-                  <a:srgbClr val="E2E8F0"/>
-                </a:solidFill>
-                <a:latin typeface="Inter"/>
-              </a:defRPr>
-            </a:pPr>
-            <a:r>
-              <a:t>• Përfitoni GitHub Copilot Pro falas</a:t>
+              <a:defRPr sz="1700">
+                <a:solidFill>
+                  <a:srgbClr val="E2E8F0"/>
+                </a:solidFill>
+                <a:latin typeface="Inter"/>
+              </a:defRPr>
+            </a:pPr>
+            <a:r>
+              <a:t>• GitHub Copilot Pro aktiv falas (kursen 120$/vit për studentët).</a:t>
             </a:r>
           </a:p>
           <a:p>
@@ -7599,15 +7600,15 @@
               <a:spcAft>
                 <a:spcPts val="1000"/>
               </a:spcAft>
-              <a:defRPr sz="1800">
-                <a:solidFill>
-                  <a:srgbClr val="E2E8F0"/>
-                </a:solidFill>
-                <a:latin typeface="Inter"/>
-              </a:defRPr>
-            </a:pPr>
-            <a:r>
-              <a:t>• Verifikoni statusin në llogarinë tuaj</a:t>
+              <a:defRPr sz="1700">
+                <a:solidFill>
+                  <a:srgbClr val="E2E8F0"/>
+                </a:solidFill>
+                <a:latin typeface="Inter"/>
+              </a:defRPr>
+            </a:pPr>
+            <a:r>
+              <a:t>• Hapja e llogarisë në Supabase Cloud (PostgreSQL falas).</a:t>
             </a:r>
           </a:p>
           <a:p>
@@ -7615,15 +7616,15 @@
               <a:spcAft>
                 <a:spcPts val="1000"/>
               </a:spcAft>
-              <a:defRPr sz="1800">
-                <a:solidFill>
-                  <a:srgbClr val="E2E8F0"/>
-                </a:solidFill>
-                <a:latin typeface="Inter"/>
-              </a:defRPr>
-            </a:pPr>
-            <a:r>
-              <a:t>• Kjo ju kursen 120$/vit!</a:t>
+              <a:defRPr sz="1700">
+                <a:solidFill>
+                  <a:srgbClr val="E2E8F0"/>
+                </a:solidFill>
+                <a:latin typeface="Inter"/>
+              </a:defRPr>
+            </a:pPr>
+            <a:r>
+              <a:t>• Lidhja e Vercel me GitHub për deploy me 1-klik.</a:t>
             </a:r>
           </a:p>
         </p:txBody>
@@ -7707,7 +7708,7 @@
               </a:defRPr>
             </a:pPr>
             <a:r>
-              <a:t>3️⃣ Hapi 3 (Min 7–10)</a:t>
+              <a:t>3️⃣ Startup Mindset</a:t>
             </a:r>
           </a:p>
           <a:p>
@@ -7723,7 +7724,7 @@
               </a:defRPr>
             </a:pPr>
             <a:r>
-              <a:t>Hapni Supabase &amp; Vercel</a:t>
+              <a:t>Si Fillon një Startup Sot?</a:t>
             </a:r>
           </a:p>
           <a:p>
@@ -7731,15 +7732,15 @@
               <a:spcAft>
                 <a:spcPts val="1000"/>
               </a:spcAft>
-              <a:defRPr sz="1800">
-                <a:solidFill>
-                  <a:srgbClr val="E2E8F0"/>
-                </a:solidFill>
-                <a:latin typeface="Inter"/>
-              </a:defRPr>
-            </a:pPr>
-            <a:r>
-              <a:t>• Kyçje me 1-klik përmes GitHub</a:t>
+              <a:defRPr sz="1700">
+                <a:solidFill>
+                  <a:srgbClr val="E2E8F0"/>
+                </a:solidFill>
+                <a:latin typeface="Inter"/>
+              </a:defRPr>
+            </a:pPr>
+            <a:r>
+              <a:t>• Nuk blejmë servera fizikë: Përdorim infrastrukturë globale cloud.</a:t>
             </a:r>
           </a:p>
           <a:p>
@@ -7747,15 +7748,15 @@
               <a:spcAft>
                 <a:spcPts val="1000"/>
               </a:spcAft>
-              <a:defRPr sz="1800">
-                <a:solidFill>
-                  <a:srgbClr val="E2E8F0"/>
-                </a:solidFill>
-                <a:latin typeface="Inter"/>
-              </a:defRPr>
-            </a:pPr>
-            <a:r>
-              <a:t>• Krijoni projektin e parë në Supabase</a:t>
+              <a:defRPr sz="1700">
+                <a:solidFill>
+                  <a:srgbClr val="E2E8F0"/>
+                </a:solidFill>
+                <a:latin typeface="Inter"/>
+              </a:defRPr>
+            </a:pPr>
+            <a:r>
+              <a:t>• Kosto operative 0 EUR gjatë fazës së zhvillimit dhe testimit.</a:t>
             </a:r>
           </a:p>
           <a:p>
@@ -7763,15 +7764,15 @@
               <a:spcAft>
                 <a:spcPts val="1000"/>
               </a:spcAft>
-              <a:defRPr sz="1800">
-                <a:solidFill>
-                  <a:srgbClr val="E2E8F0"/>
-                </a:solidFill>
-                <a:latin typeface="Inter"/>
-              </a:defRPr>
-            </a:pPr>
-            <a:r>
-              <a:t>• Lidhni profilin në Vercel</a:t>
+              <a:defRPr sz="1700">
+                <a:solidFill>
+                  <a:srgbClr val="E2E8F0"/>
+                </a:solidFill>
+                <a:latin typeface="Inter"/>
+              </a:defRPr>
+            </a:pPr>
+            <a:r>
+              <a:t>• Ekzekutimi i 'git push' të parë që shkon live në Vercel.</a:t>
             </a:r>
           </a:p>
           <a:p>
@@ -7779,15 +7780,15 @@
               <a:spcAft>
                 <a:spcPts val="1000"/>
               </a:spcAft>
-              <a:defRPr sz="1800">
-                <a:solidFill>
-                  <a:srgbClr val="E2E8F0"/>
-                </a:solidFill>
-                <a:latin typeface="Inter"/>
-              </a:defRPr>
-            </a:pPr>
-            <a:r>
-              <a:t>• Mjedisi juaj cloud është gati!</a:t>
+              <a:defRPr sz="1700">
+                <a:solidFill>
+                  <a:srgbClr val="E2E8F0"/>
+                </a:solidFill>
+                <a:latin typeface="Inter"/>
+              </a:defRPr>
+            </a:pPr>
+            <a:r>
+              <a:t>• Çdo student largohet nga laboratori me mjedis të plotë gati!</a:t>
             </a:r>
           </a:p>
         </p:txBody>
@@ -8978,6 +8979,667 @@
 </file>
 
 <file path=ppt/slides/slide20.xml><?xml version="1.0" encoding="utf-8"?>
+<p:sld xmlns:a="http://schemas.openxmlformats.org/drawingml/2006/main" xmlns:p="http://schemas.openxmlformats.org/presentationml/2006/main" xmlns:r="http://schemas.openxmlformats.org/officeDocument/2006/relationships">
+  <p:cSld>
+    <p:spTree>
+      <p:nvGrpSpPr>
+        <p:cNvPr id="1" name=""/>
+        <p:cNvGrpSpPr/>
+        <p:nvPr/>
+      </p:nvGrpSpPr>
+      <p:grpSpPr/>
+      <p:sp>
+        <p:nvSpPr>
+          <p:cNvPr id="2" name="Rectangle 1"/>
+          <p:cNvSpPr/>
+          <p:nvPr/>
+        </p:nvSpPr>
+        <p:spPr>
+          <a:xfrm>
+            <a:off x="0" y="0"/>
+            <a:ext cx="12191695" cy="6858000"/>
+          </a:xfrm>
+          <a:prstGeom prst="rect">
+            <a:avLst/>
+          </a:prstGeom>
+          <a:solidFill>
+            <a:srgbClr val="0B1120"/>
+          </a:solidFill>
+          <a:ln>
+            <a:noFill/>
+          </a:ln>
+        </p:spPr>
+        <p:style>
+          <a:lnRef idx="1">
+            <a:schemeClr val="accent1"/>
+          </a:lnRef>
+          <a:fillRef idx="3">
+            <a:schemeClr val="accent1"/>
+          </a:fillRef>
+          <a:effectRef idx="2">
+            <a:schemeClr val="accent1"/>
+          </a:effectRef>
+          <a:fontRef idx="minor">
+            <a:schemeClr val="lt1"/>
+          </a:fontRef>
+        </p:style>
+        <p:txBody>
+          <a:bodyPr rtlCol="0" anchor="ctr"/>
+          <a:lstStyle/>
+          <a:p>
+            <a:pPr algn="ctr"/>
+          </a:p>
+        </p:txBody>
+      </p:sp>
+      <p:sp>
+        <p:nvSpPr>
+          <p:cNvPr id="3" name="TextBox 2"/>
+          <p:cNvSpPr txBox="1"/>
+          <p:nvPr/>
+        </p:nvSpPr>
+        <p:spPr>
+          <a:xfrm>
+            <a:off x="731520" y="365760"/>
+            <a:ext cx="10698480" cy="320040"/>
+          </a:xfrm>
+          <a:prstGeom prst="rect">
+            <a:avLst/>
+          </a:prstGeom>
+          <a:noFill/>
+        </p:spPr>
+        <p:txBody>
+          <a:bodyPr wrap="square">
+            <a:spAutoFit/>
+          </a:bodyPr>
+          <a:lstStyle/>
+          <a:p>
+            <a:pPr>
+              <a:defRPr sz="1500" b="1">
+                <a:solidFill>
+                  <a:srgbClr val="38BDF8"/>
+                </a:solidFill>
+                <a:latin typeface="Inter"/>
+              </a:defRPr>
+            </a:pPr>
+            <a:r>
+              <a:t>PLANI PËR LIGJËRATËN 2</a:t>
+            </a:r>
+          </a:p>
+        </p:txBody>
+      </p:sp>
+      <p:sp>
+        <p:nvSpPr>
+          <p:cNvPr id="4" name="TextBox 3"/>
+          <p:cNvSpPr txBox="1"/>
+          <p:nvPr/>
+        </p:nvSpPr>
+        <p:spPr>
+          <a:xfrm>
+            <a:off x="731520" y="685800"/>
+            <a:ext cx="10698480" cy="777240"/>
+          </a:xfrm>
+          <a:prstGeom prst="rect">
+            <a:avLst/>
+          </a:prstGeom>
+          <a:noFill/>
+        </p:spPr>
+        <p:txBody>
+          <a:bodyPr wrap="square">
+            <a:spAutoFit/>
+          </a:bodyPr>
+          <a:lstStyle/>
+          <a:p>
+            <a:pPr>
+              <a:defRPr sz="3600" b="1">
+                <a:solidFill>
+                  <a:srgbClr val="FFFFFF"/>
+                </a:solidFill>
+                <a:latin typeface="Inter"/>
+              </a:defRPr>
+            </a:pPr>
+            <a:r>
+              <a:t>Ligjërata 2: Si të Ndërtojmë Idenë, Specifikat &amp; Arkitekturën?</a:t>
+            </a:r>
+          </a:p>
+        </p:txBody>
+      </p:sp>
+      <p:sp>
+        <p:nvSpPr>
+          <p:cNvPr id="5" name="TextBox 4"/>
+          <p:cNvSpPr txBox="1"/>
+          <p:nvPr/>
+        </p:nvSpPr>
+        <p:spPr>
+          <a:xfrm>
+            <a:off x="731520" y="1444752"/>
+            <a:ext cx="10698480" cy="502920"/>
+          </a:xfrm>
+          <a:prstGeom prst="rect">
+            <a:avLst/>
+          </a:prstGeom>
+          <a:noFill/>
+        </p:spPr>
+        <p:txBody>
+          <a:bodyPr wrap="square">
+            <a:spAutoFit/>
+          </a:bodyPr>
+          <a:lstStyle/>
+          <a:p>
+            <a:pPr>
+              <a:defRPr sz="2100">
+                <a:solidFill>
+                  <a:srgbClr val="E2E8F0"/>
+                </a:solidFill>
+                <a:latin typeface="Inter"/>
+              </a:defRPr>
+            </a:pPr>
+            <a:r>
+              <a:t>Jo menjëherë në zhvillim! Secili zgjedh një problem real dhe ndërton arkitekturën para kodit.</a:t>
+            </a:r>
+          </a:p>
+        </p:txBody>
+      </p:sp>
+      <p:sp>
+        <p:nvSpPr>
+          <p:cNvPr id="6" name="Rounded Rectangle 5"/>
+          <p:cNvSpPr/>
+          <p:nvPr/>
+        </p:nvSpPr>
+        <p:spPr>
+          <a:xfrm>
+            <a:off x="731520" y="2011680"/>
+            <a:ext cx="3383280" cy="4389120"/>
+          </a:xfrm>
+          <a:prstGeom prst="roundRect">
+            <a:avLst/>
+          </a:prstGeom>
+          <a:solidFill>
+            <a:srgbClr val="141E34"/>
+          </a:solidFill>
+          <a:ln w="31750">
+            <a:solidFill>
+              <a:srgbClr val="38BDF8"/>
+            </a:solidFill>
+          </a:ln>
+        </p:spPr>
+        <p:style>
+          <a:lnRef idx="1">
+            <a:schemeClr val="accent1"/>
+          </a:lnRef>
+          <a:fillRef idx="3">
+            <a:schemeClr val="accent1"/>
+          </a:fillRef>
+          <a:effectRef idx="2">
+            <a:schemeClr val="accent1"/>
+          </a:effectRef>
+          <a:fontRef idx="minor">
+            <a:schemeClr val="lt1"/>
+          </a:fontRef>
+        </p:style>
+        <p:txBody>
+          <a:bodyPr rtlCol="0" anchor="ctr"/>
+          <a:lstStyle/>
+          <a:p>
+            <a:pPr algn="ctr"/>
+          </a:p>
+        </p:txBody>
+      </p:sp>
+      <p:sp>
+        <p:nvSpPr>
+          <p:cNvPr id="7" name="TextBox 6"/>
+          <p:cNvSpPr txBox="1"/>
+          <p:nvPr/>
+        </p:nvSpPr>
+        <p:spPr>
+          <a:xfrm>
+            <a:off x="914400" y="2194560"/>
+            <a:ext cx="3017520" cy="4023360"/>
+          </a:xfrm>
+          <a:prstGeom prst="rect">
+            <a:avLst/>
+          </a:prstGeom>
+          <a:noFill/>
+        </p:spPr>
+        <p:txBody>
+          <a:bodyPr wrap="square">
+            <a:spAutoFit/>
+          </a:bodyPr>
+          <a:lstStyle/>
+          <a:p>
+            <a:pPr>
+              <a:spcAft>
+                <a:spcPts val="600"/>
+              </a:spcAft>
+              <a:defRPr sz="1400" b="1">
+                <a:solidFill>
+                  <a:srgbClr val="38BDF8"/>
+                </a:solidFill>
+                <a:latin typeface="Inter"/>
+              </a:defRPr>
+            </a:pPr>
+            <a:r>
+              <a:t>💡 1. Përzgjedhja e Idesë</a:t>
+            </a:r>
+          </a:p>
+          <a:p>
+            <a:pPr>
+              <a:spcAft>
+                <a:spcPts val="1400"/>
+              </a:spcAft>
+              <a:defRPr sz="2200" b="1">
+                <a:solidFill>
+                  <a:srgbClr val="FFFFFF"/>
+                </a:solidFill>
+                <a:latin typeface="Inter"/>
+              </a:defRPr>
+            </a:pPr>
+            <a:r>
+              <a:t>Biznesi / Problemi Real</a:t>
+            </a:r>
+          </a:p>
+          <a:p>
+            <a:pPr>
+              <a:spcAft>
+                <a:spcPts val="1000"/>
+              </a:spcAft>
+              <a:defRPr sz="1700">
+                <a:solidFill>
+                  <a:srgbClr val="E2E8F0"/>
+                </a:solidFill>
+                <a:latin typeface="Inter"/>
+              </a:defRPr>
+            </a:pPr>
+            <a:r>
+              <a:t>• Çdo student ose grup përzgjedh një SME lokale ose nevojë reale.</a:t>
+            </a:r>
+          </a:p>
+          <a:p>
+            <a:pPr>
+              <a:spcAft>
+                <a:spcPts val="1000"/>
+              </a:spcAft>
+              <a:defRPr sz="1700">
+                <a:solidFill>
+                  <a:srgbClr val="E2E8F0"/>
+                </a:solidFill>
+                <a:latin typeface="Inter"/>
+              </a:defRPr>
+            </a:pPr>
+            <a:r>
+              <a:t>• Shembuj: RideShare, Furrë buke, Mobileri, Porosi studentore, Servis.</a:t>
+            </a:r>
+          </a:p>
+          <a:p>
+            <a:pPr>
+              <a:spcAft>
+                <a:spcPts val="1000"/>
+              </a:spcAft>
+              <a:defRPr sz="1700">
+                <a:solidFill>
+                  <a:srgbClr val="E2E8F0"/>
+                </a:solidFill>
+                <a:latin typeface="Inter"/>
+              </a:defRPr>
+            </a:pPr>
+            <a:r>
+              <a:t>• Formulimi i saktë i 'Dhimbjes' (Pain) dhe 'Përfitimit' (Value).</a:t>
+            </a:r>
+          </a:p>
+          <a:p>
+            <a:pPr>
+              <a:spcAft>
+                <a:spcPts val="1000"/>
+              </a:spcAft>
+              <a:defRPr sz="1700">
+                <a:solidFill>
+                  <a:srgbClr val="E2E8F0"/>
+                </a:solidFill>
+                <a:latin typeface="Inter"/>
+              </a:defRPr>
+            </a:pPr>
+            <a:r>
+              <a:t>• Pse zgjidhja me celular sjell efiçiencë dhe fitim të matshëm.</a:t>
+            </a:r>
+          </a:p>
+        </p:txBody>
+      </p:sp>
+      <p:sp>
+        <p:nvSpPr>
+          <p:cNvPr id="8" name="Rounded Rectangle 7"/>
+          <p:cNvSpPr/>
+          <p:nvPr/>
+        </p:nvSpPr>
+        <p:spPr>
+          <a:xfrm>
+            <a:off x="4389120" y="2011680"/>
+            <a:ext cx="3383280" cy="4389120"/>
+          </a:xfrm>
+          <a:prstGeom prst="roundRect">
+            <a:avLst/>
+          </a:prstGeom>
+          <a:solidFill>
+            <a:srgbClr val="141E34"/>
+          </a:solidFill>
+          <a:ln w="31750">
+            <a:solidFill>
+              <a:srgbClr val="10B981"/>
+            </a:solidFill>
+          </a:ln>
+        </p:spPr>
+        <p:style>
+          <a:lnRef idx="1">
+            <a:schemeClr val="accent1"/>
+          </a:lnRef>
+          <a:fillRef idx="3">
+            <a:schemeClr val="accent1"/>
+          </a:fillRef>
+          <a:effectRef idx="2">
+            <a:schemeClr val="accent1"/>
+          </a:effectRef>
+          <a:fontRef idx="minor">
+            <a:schemeClr val="lt1"/>
+          </a:fontRef>
+        </p:style>
+        <p:txBody>
+          <a:bodyPr rtlCol="0" anchor="ctr"/>
+          <a:lstStyle/>
+          <a:p>
+            <a:pPr algn="ctr"/>
+          </a:p>
+        </p:txBody>
+      </p:sp>
+      <p:sp>
+        <p:nvSpPr>
+          <p:cNvPr id="9" name="TextBox 8"/>
+          <p:cNvSpPr txBox="1"/>
+          <p:nvPr/>
+        </p:nvSpPr>
+        <p:spPr>
+          <a:xfrm>
+            <a:off x="4572000" y="2194560"/>
+            <a:ext cx="3017520" cy="4023360"/>
+          </a:xfrm>
+          <a:prstGeom prst="rect">
+            <a:avLst/>
+          </a:prstGeom>
+          <a:noFill/>
+        </p:spPr>
+        <p:txBody>
+          <a:bodyPr wrap="square">
+            <a:spAutoFit/>
+          </a:bodyPr>
+          <a:lstStyle/>
+          <a:p>
+            <a:pPr>
+              <a:spcAft>
+                <a:spcPts val="600"/>
+              </a:spcAft>
+              <a:defRPr sz="1400" b="1">
+                <a:solidFill>
+                  <a:srgbClr val="10B981"/>
+                </a:solidFill>
+                <a:latin typeface="Inter"/>
+              </a:defRPr>
+            </a:pPr>
+            <a:r>
+              <a:t>📋 2. Hartimi i Specifikave</a:t>
+            </a:r>
+          </a:p>
+          <a:p>
+            <a:pPr>
+              <a:spcAft>
+                <a:spcPts val="1400"/>
+              </a:spcAft>
+              <a:defRPr sz="2200" b="1">
+                <a:solidFill>
+                  <a:srgbClr val="FFFFFF"/>
+                </a:solidFill>
+                <a:latin typeface="Inter"/>
+              </a:defRPr>
+            </a:pPr>
+            <a:r>
+              <a:t>Kërkesat &amp; Kufijtë (PRD)</a:t>
+            </a:r>
+          </a:p>
+          <a:p>
+            <a:pPr>
+              <a:spcAft>
+                <a:spcPts val="1000"/>
+              </a:spcAft>
+              <a:defRPr sz="1700">
+                <a:solidFill>
+                  <a:srgbClr val="E2E8F0"/>
+                </a:solidFill>
+                <a:latin typeface="Inter"/>
+              </a:defRPr>
+            </a:pPr>
+            <a:r>
+              <a:t>• Përcaktimi i saktë i aktorëve (kush e përdor dhe pse).</a:t>
+            </a:r>
+          </a:p>
+          <a:p>
+            <a:pPr>
+              <a:spcAft>
+                <a:spcPts val="1000"/>
+              </a:spcAft>
+              <a:defRPr sz="1700">
+                <a:solidFill>
+                  <a:srgbClr val="E2E8F0"/>
+                </a:solidFill>
+                <a:latin typeface="Inter"/>
+              </a:defRPr>
+            </a:pPr>
+            <a:r>
+              <a:t>• Features Must-Have (funksionalitetet thelbësore të MVP-së).</a:t>
+            </a:r>
+          </a:p>
+          <a:p>
+            <a:pPr>
+              <a:spcAft>
+                <a:spcPts val="1000"/>
+              </a:spcAft>
+              <a:defRPr sz="1700">
+                <a:solidFill>
+                  <a:srgbClr val="E2E8F0"/>
+                </a:solidFill>
+                <a:latin typeface="Inter"/>
+              </a:defRPr>
+            </a:pPr>
+            <a:r>
+              <a:t>• Përjashtimet Out-of-Scope (çfarë NUK bëjmë për të shmangur dështimin).</a:t>
+            </a:r>
+          </a:p>
+          <a:p>
+            <a:pPr>
+              <a:spcAft>
+                <a:spcPts val="1000"/>
+              </a:spcAft>
+              <a:defRPr sz="1700">
+                <a:solidFill>
+                  <a:srgbClr val="E2E8F0"/>
+                </a:solidFill>
+                <a:latin typeface="Inter"/>
+              </a:defRPr>
+            </a:pPr>
+            <a:r>
+              <a:t>• Rregulli: 80% e projekteve dështojnë nga fryrja e kërkesave!</a:t>
+            </a:r>
+          </a:p>
+        </p:txBody>
+      </p:sp>
+      <p:sp>
+        <p:nvSpPr>
+          <p:cNvPr id="10" name="Rounded Rectangle 9"/>
+          <p:cNvSpPr/>
+          <p:nvPr/>
+        </p:nvSpPr>
+        <p:spPr>
+          <a:xfrm>
+            <a:off x="8046720" y="2011680"/>
+            <a:ext cx="3383280" cy="4389120"/>
+          </a:xfrm>
+          <a:prstGeom prst="roundRect">
+            <a:avLst/>
+          </a:prstGeom>
+          <a:solidFill>
+            <a:srgbClr val="141E34"/>
+          </a:solidFill>
+          <a:ln w="31750">
+            <a:solidFill>
+              <a:srgbClr val="F59E0B"/>
+            </a:solidFill>
+          </a:ln>
+        </p:spPr>
+        <p:style>
+          <a:lnRef idx="1">
+            <a:schemeClr val="accent1"/>
+          </a:lnRef>
+          <a:fillRef idx="3">
+            <a:schemeClr val="accent1"/>
+          </a:fillRef>
+          <a:effectRef idx="2">
+            <a:schemeClr val="accent1"/>
+          </a:effectRef>
+          <a:fontRef idx="minor">
+            <a:schemeClr val="lt1"/>
+          </a:fontRef>
+        </p:style>
+        <p:txBody>
+          <a:bodyPr rtlCol="0" anchor="ctr"/>
+          <a:lstStyle/>
+          <a:p>
+            <a:pPr algn="ctr"/>
+          </a:p>
+        </p:txBody>
+      </p:sp>
+      <p:sp>
+        <p:nvSpPr>
+          <p:cNvPr id="11" name="TextBox 10"/>
+          <p:cNvSpPr txBox="1"/>
+          <p:nvPr/>
+        </p:nvSpPr>
+        <p:spPr>
+          <a:xfrm>
+            <a:off x="8229600" y="2194560"/>
+            <a:ext cx="3017520" cy="4023360"/>
+          </a:xfrm>
+          <a:prstGeom prst="rect">
+            <a:avLst/>
+          </a:prstGeom>
+          <a:noFill/>
+        </p:spPr>
+        <p:txBody>
+          <a:bodyPr wrap="square">
+            <a:spAutoFit/>
+          </a:bodyPr>
+          <a:lstStyle/>
+          <a:p>
+            <a:pPr>
+              <a:spcAft>
+                <a:spcPts val="600"/>
+              </a:spcAft>
+              <a:defRPr sz="1400" b="1">
+                <a:solidFill>
+                  <a:srgbClr val="F59E0B"/>
+                </a:solidFill>
+                <a:latin typeface="Inter"/>
+              </a:defRPr>
+            </a:pPr>
+            <a:r>
+              <a:t>📐 3. Arkitektura &amp; Skica</a:t>
+            </a:r>
+          </a:p>
+          <a:p>
+            <a:pPr>
+              <a:spcAft>
+                <a:spcPts val="1400"/>
+              </a:spcAft>
+              <a:defRPr sz="2200" b="1">
+                <a:solidFill>
+                  <a:srgbClr val="FFFFFF"/>
+                </a:solidFill>
+                <a:latin typeface="Inter"/>
+              </a:defRPr>
+            </a:pPr>
+            <a:r>
+              <a:t>Kutitë &amp; Komponentët</a:t>
+            </a:r>
+          </a:p>
+          <a:p>
+            <a:pPr>
+              <a:spcAft>
+                <a:spcPts val="1000"/>
+              </a:spcAft>
+              <a:defRPr sz="1700">
+                <a:solidFill>
+                  <a:srgbClr val="E2E8F0"/>
+                </a:solidFill>
+                <a:latin typeface="Inter"/>
+              </a:defRPr>
+            </a:pPr>
+            <a:r>
+              <a:t>• Skicimi i kutive dhe shigjetave: Klienti PWA, Supabase DB, Auth.</a:t>
+            </a:r>
+          </a:p>
+          <a:p>
+            <a:pPr>
+              <a:spcAft>
+                <a:spcPts val="1000"/>
+              </a:spcAft>
+              <a:defRPr sz="1700">
+                <a:solidFill>
+                  <a:srgbClr val="E2E8F0"/>
+                </a:solidFill>
+                <a:latin typeface="Inter"/>
+              </a:defRPr>
+            </a:pPr>
+            <a:r>
+              <a:t>• Modelimi i tabelave kryesore (p.sh. tabelat 'rides', 'orders').</a:t>
+            </a:r>
+          </a:p>
+          <a:p>
+            <a:pPr>
+              <a:spcAft>
+                <a:spcPts val="1000"/>
+              </a:spcAft>
+              <a:defRPr sz="1700">
+                <a:solidFill>
+                  <a:srgbClr val="E2E8F0"/>
+                </a:solidFill>
+                <a:latin typeface="Inter"/>
+              </a:defRPr>
+            </a:pPr>
+            <a:r>
+              <a:t>• Vizatimi i ekraneve me dorë në letër (Wireframing).</a:t>
+            </a:r>
+          </a:p>
+          <a:p>
+            <a:pPr>
+              <a:spcAft>
+                <a:spcPts val="1000"/>
+              </a:spcAft>
+              <a:defRPr sz="1700">
+                <a:solidFill>
+                  <a:srgbClr val="E2E8F0"/>
+                </a:solidFill>
+                <a:latin typeface="Inter"/>
+              </a:defRPr>
+            </a:pPr>
+            <a:r>
+              <a:t>• Parimi i Hekurt: Asnjë rresht kod pa arkitekturë të miratuar!</a:t>
+            </a:r>
+          </a:p>
+        </p:txBody>
+      </p:sp>
+    </p:spTree>
+  </p:cSld>
+  <p:clrMapOvr>
+    <a:masterClrMapping/>
+  </p:clrMapOvr>
+</p:sld>
+</file>
+
+<file path=ppt/slides/slide21.xml><?xml version="1.0" encoding="utf-8"?>
 <p:sld xmlns:a="http://schemas.openxmlformats.org/drawingml/2006/main" xmlns:p="http://schemas.openxmlformats.org/presentationml/2006/main" xmlns:r="http://schemas.openxmlformats.org/officeDocument/2006/relationships">
   <p:cSld>
     <p:spTree>

</xml_diff>

<commit_message>
feat(slides): embed tailored visual sketches for each architectural progression slide
</commit_message>
<xml_diff>
--- a/Jave1_Hyrje_Nextjs_PWA_Copilot_2026.pptx
+++ b/Jave1_Hyrje_Nextjs_PWA_Copilot_2026.pptx
@@ -10421,8 +10421,8 @@
         </p:nvSpPr>
         <p:spPr>
           <a:xfrm>
-            <a:off x="731520" y="2011680"/>
-            <a:ext cx="5852160" cy="4389120"/>
+            <a:off x="731520" y="1965960"/>
+            <a:ext cx="5303520" cy="4480560"/>
           </a:xfrm>
           <a:prstGeom prst="roundRect">
             <a:avLst/>
@@ -10460,7 +10460,7 @@
       </p:sp>
       <p:pic>
         <p:nvPicPr>
-          <p:cNvPr id="7" name="Picture 6" descr="aab_rideshare_grand_architecture_sketch.png"/>
+          <p:cNvPr id="7" name="Picture 6" descr="slide3_sketch_ideja_problemi.png"/>
           <p:cNvPicPr>
             <a:picLocks noChangeAspect="1"/>
           </p:cNvPicPr>
@@ -10474,8 +10474,8 @@
         </p:blipFill>
         <p:spPr>
           <a:xfrm>
-            <a:off x="777240" y="2057400"/>
-            <a:ext cx="5760720" cy="4297680"/>
+            <a:off x="777240" y="2011680"/>
+            <a:ext cx="5212080" cy="4389120"/>
           </a:xfrm>
           <a:prstGeom prst="rect">
             <a:avLst/>
@@ -10490,8 +10490,8 @@
         </p:nvSpPr>
         <p:spPr>
           <a:xfrm>
-            <a:off x="6858000" y="2011680"/>
-            <a:ext cx="4572000" cy="4389120"/>
+            <a:off x="6217920" y="1965960"/>
+            <a:ext cx="5303520" cy="4480560"/>
           </a:xfrm>
           <a:prstGeom prst="roundRect">
             <a:avLst/>
@@ -10535,8 +10535,8 @@
         </p:nvSpPr>
         <p:spPr>
           <a:xfrm>
-            <a:off x="7040880" y="2194560"/>
-            <a:ext cx="4206240" cy="4023360"/>
+            <a:off x="6400800" y="2148840"/>
+            <a:ext cx="4937760" cy="4114800"/>
           </a:xfrm>
           <a:prstGeom prst="rect">
             <a:avLst/>
@@ -10609,7 +10609,7 @@
               </a:defRPr>
             </a:pPr>
             <a:r>
-              <a:t>• Skica e Parë: Një student merr një fletë të bardhë dhe vizaton skicën me laps: '1 Makinë me 3 vende të lira + 3 shokë që ndajnë rrugën.'</a:t>
+              <a:t>• Skica e Parë në Letër: Një student merr një fletë dhe vizaton skicën me laps: '1 Makinë me 3 vende të lira + 3 shokë që ndajnë rrugën.'</a:t>
             </a:r>
           </a:p>
           <a:p>
@@ -10625,7 +10625,7 @@
               </a:defRPr>
             </a:pPr>
             <a:r>
-              <a:t>• Përfundimi Inxhinierik: Nuk nisim me kod të gatshëm. Nisim me të kuptuarit e thellë të problemit!</a:t>
+              <a:t>• Përfundimi Inxhinierik: Nuk nisim me kod të gatshëm! Nisim me të kuptuarit e thellë të problemit dhe zgjidhjen që krijon vlerë.</a:t>
             </a:r>
           </a:p>
         </p:txBody>
@@ -10807,18 +10807,18 @@
         </p:nvSpPr>
         <p:spPr>
           <a:xfrm>
-            <a:off x="731520" y="2011680"/>
-            <a:ext cx="3383280" cy="4389120"/>
+            <a:off x="731520" y="1965960"/>
+            <a:ext cx="5303520" cy="4480560"/>
           </a:xfrm>
           <a:prstGeom prst="roundRect">
             <a:avLst/>
           </a:prstGeom>
           <a:solidFill>
-            <a:srgbClr val="141E34"/>
+            <a:srgbClr val="FFFFFF"/>
           </a:solidFill>
           <a:ln w="31750">
             <a:solidFill>
-              <a:srgbClr val="6366F1"/>
+              <a:srgbClr val="38BDF8"/>
             </a:solidFill>
           </a:ln>
         </p:spPr>
@@ -10844,109 +10844,30 @@
           </a:p>
         </p:txBody>
       </p:sp>
-      <p:sp>
-        <p:nvSpPr>
-          <p:cNvPr id="7" name="TextBox 6"/>
-          <p:cNvSpPr txBox="1"/>
-          <p:nvPr/>
-        </p:nvSpPr>
-        <p:spPr>
-          <a:xfrm>
-            <a:off x="914400" y="2194560"/>
-            <a:ext cx="3017520" cy="4023360"/>
-          </a:xfrm>
-          <a:prstGeom prst="rect">
-            <a:avLst/>
-          </a:prstGeom>
-          <a:noFill/>
-        </p:spPr>
-        <p:txBody>
-          <a:bodyPr wrap="square">
-            <a:spAutoFit/>
-          </a:bodyPr>
-          <a:lstStyle/>
-          <a:p>
-            <a:pPr>
-              <a:spcAft>
-                <a:spcPts val="1400"/>
-              </a:spcAft>
-              <a:defRPr sz="2100" b="1">
-                <a:solidFill>
-                  <a:srgbClr val="FFFFFF"/>
-                </a:solidFill>
-                <a:latin typeface="Inter"/>
-              </a:defRPr>
-            </a:pPr>
-            <a:r>
-              <a:t>👥 1. Përdoruesit (Aktorët)</a:t>
-            </a:r>
-          </a:p>
-          <a:p>
-            <a:pPr>
-              <a:spcAft>
-                <a:spcPts val="1000"/>
-              </a:spcAft>
-              <a:defRPr sz="1700">
-                <a:solidFill>
-                  <a:srgbClr val="E2E8F0"/>
-                </a:solidFill>
-                <a:latin typeface="Inter"/>
-              </a:defRPr>
-            </a:pPr>
-            <a:r>
-              <a:t>• Shoferi (Studenti):</a:t>
-            </a:r>
-          </a:p>
-          <a:p>
-            <a:pPr>
-              <a:spcAft>
-                <a:spcPts val="1000"/>
-              </a:spcAft>
-              <a:defRPr sz="1700">
-                <a:solidFill>
-                  <a:srgbClr val="E2E8F0"/>
-                </a:solidFill>
-                <a:latin typeface="Inter"/>
-              </a:defRPr>
-            </a:pPr>
-            <a:r>
-              <a:t>• Ka veturë, udhëton përditë, kërkon të ndajë koston e karburantit.</a:t>
-            </a:r>
-          </a:p>
-          <a:p>
-            <a:pPr>
-              <a:spcAft>
-                <a:spcPts val="1000"/>
-              </a:spcAft>
-              <a:defRPr sz="1700">
-                <a:solidFill>
-                  <a:srgbClr val="E2E8F0"/>
-                </a:solidFill>
-                <a:latin typeface="Inter"/>
-              </a:defRPr>
-            </a:pPr>
-            <a:r>
-              <a:t>• Udhëtari (Kolegu):</a:t>
-            </a:r>
-          </a:p>
-          <a:p>
-            <a:pPr>
-              <a:spcAft>
-                <a:spcPts val="1000"/>
-              </a:spcAft>
-              <a:defRPr sz="1700">
-                <a:solidFill>
-                  <a:srgbClr val="E2E8F0"/>
-                </a:solidFill>
-                <a:latin typeface="Inter"/>
-              </a:defRPr>
-            </a:pPr>
-            <a:r>
-              <a:t>• Nuk ka veturë, kërkon udhëtim më të shpejtë e të rehatshëm se autobusi.</a:t>
-            </a:r>
-          </a:p>
-        </p:txBody>
-      </p:sp>
+      <p:pic>
+        <p:nvPicPr>
+          <p:cNvPr id="7" name="Picture 6" descr="slide4_sketch_specifikat_prd.png"/>
+          <p:cNvPicPr>
+            <a:picLocks noChangeAspect="1"/>
+          </p:cNvPicPr>
+          <p:nvPr/>
+        </p:nvPicPr>
+        <p:blipFill>
+          <a:blip r:embed="rId2"/>
+          <a:stretch>
+            <a:fillRect/>
+          </a:stretch>
+        </p:blipFill>
+        <p:spPr>
+          <a:xfrm>
+            <a:off x="777240" y="2011680"/>
+            <a:ext cx="5212080" cy="4389120"/>
+          </a:xfrm>
+          <a:prstGeom prst="rect">
+            <a:avLst/>
+          </a:prstGeom>
+        </p:spPr>
+      </p:pic>
       <p:sp>
         <p:nvSpPr>
           <p:cNvPr id="8" name="Rounded Rectangle 7"/>
@@ -10955,8 +10876,8 @@
         </p:nvSpPr>
         <p:spPr>
           <a:xfrm>
-            <a:off x="4389120" y="2011680"/>
-            <a:ext cx="3383280" cy="4389120"/>
+            <a:off x="6217920" y="1965960"/>
+            <a:ext cx="5303520" cy="4480560"/>
           </a:xfrm>
           <a:prstGeom prst="roundRect">
             <a:avLst/>
@@ -11000,8 +10921,8 @@
         </p:nvSpPr>
         <p:spPr>
           <a:xfrm>
-            <a:off x="4572000" y="2194560"/>
-            <a:ext cx="3017520" cy="4023360"/>
+            <a:off x="6400800" y="2148840"/>
+            <a:ext cx="4937760" cy="4114800"/>
           </a:xfrm>
           <a:prstGeom prst="rect">
             <a:avLst/>
@@ -11016,17 +10937,17 @@
           <a:p>
             <a:pPr>
               <a:spcAft>
-                <a:spcPts val="1400"/>
-              </a:spcAft>
-              <a:defRPr sz="2100" b="1">
-                <a:solidFill>
-                  <a:srgbClr val="FFFFFF"/>
-                </a:solidFill>
-                <a:latin typeface="Inter"/>
-              </a:defRPr>
-            </a:pPr>
-            <a:r>
-              <a:t>📋 2. Kërkesat Kyçe (Must-Have)</a:t>
+                <a:spcPts val="1200"/>
+              </a:spcAft>
+              <a:defRPr sz="2300" b="1">
+                <a:solidFill>
+                  <a:srgbClr val="10B981"/>
+                </a:solidFill>
+                <a:latin typeface="Inter"/>
+              </a:defRPr>
+            </a:pPr>
+            <a:r>
+              <a:t>📋 Disiplina e Kufijve të Projektit (Scope)</a:t>
             </a:r>
           </a:p>
           <a:p>
@@ -11042,7 +10963,7 @@
               </a:defRPr>
             </a:pPr>
             <a:r>
-              <a:t>• Specifika 1: Shoferi poston rrugën, orën dhe vendet e lira (p.sh. 3 vende).</a:t>
+              <a:t>• Aktorët e Qartë: Shoferi që poston udhëtimin dhe Udhëtari që rezervon vendin.</a:t>
             </a:r>
           </a:p>
           <a:p>
@@ -11058,7 +10979,7 @@
               </a:defRPr>
             </a:pPr>
             <a:r>
-              <a:t>• Specifika 2: Udhëtari kërkon sipas qytetit dhe rezervon me 1-klik.</a:t>
+              <a:t>• Kërkesat Must-Have (MVP): Postimi me 3 fusha, filtrimi sipas qytetit, rezervimi me 1-prekje, koordinimi në WhatsApp, dhe kyçja me @universitetiaab.com.</a:t>
             </a:r>
           </a:p>
           <a:p>
@@ -11074,91 +10995,7 @@
               </a:defRPr>
             </a:pPr>
             <a:r>
-              <a:t>• Specifika 3: Lidhje direkte në WhatsApp me numrin e telefonit për pikën e takimit.</a:t>
-            </a:r>
-          </a:p>
-        </p:txBody>
-      </p:sp>
-      <p:sp>
-        <p:nvSpPr>
-          <p:cNvPr id="10" name="Rounded Rectangle 9"/>
-          <p:cNvSpPr/>
-          <p:nvPr/>
-        </p:nvSpPr>
-        <p:spPr>
-          <a:xfrm>
-            <a:off x="8046720" y="2011680"/>
-            <a:ext cx="3383280" cy="4389120"/>
-          </a:xfrm>
-          <a:prstGeom prst="roundRect">
-            <a:avLst/>
-          </a:prstGeom>
-          <a:solidFill>
-            <a:srgbClr val="141E34"/>
-          </a:solidFill>
-          <a:ln w="31750">
-            <a:solidFill>
-              <a:srgbClr val="F59E0B"/>
-            </a:solidFill>
-          </a:ln>
-        </p:spPr>
-        <p:style>
-          <a:lnRef idx="1">
-            <a:schemeClr val="accent1"/>
-          </a:lnRef>
-          <a:fillRef idx="3">
-            <a:schemeClr val="accent1"/>
-          </a:fillRef>
-          <a:effectRef idx="2">
-            <a:schemeClr val="accent1"/>
-          </a:effectRef>
-          <a:fontRef idx="minor">
-            <a:schemeClr val="lt1"/>
-          </a:fontRef>
-        </p:style>
-        <p:txBody>
-          <a:bodyPr rtlCol="0" anchor="ctr"/>
-          <a:lstStyle/>
-          <a:p>
-            <a:pPr algn="ctr"/>
-          </a:p>
-        </p:txBody>
-      </p:sp>
-      <p:sp>
-        <p:nvSpPr>
-          <p:cNvPr id="11" name="TextBox 10"/>
-          <p:cNvSpPr txBox="1"/>
-          <p:nvPr/>
-        </p:nvSpPr>
-        <p:spPr>
-          <a:xfrm>
-            <a:off x="8229600" y="2194560"/>
-            <a:ext cx="3017520" cy="4023360"/>
-          </a:xfrm>
-          <a:prstGeom prst="rect">
-            <a:avLst/>
-          </a:prstGeom>
-          <a:noFill/>
-        </p:spPr>
-        <p:txBody>
-          <a:bodyPr wrap="square">
-            <a:spAutoFit/>
-          </a:bodyPr>
-          <a:lstStyle/>
-          <a:p>
-            <a:pPr>
-              <a:spcAft>
-                <a:spcPts val="1400"/>
-              </a:spcAft>
-              <a:defRPr sz="2100" b="1">
-                <a:solidFill>
-                  <a:srgbClr val="FFFFFF"/>
-                </a:solidFill>
-                <a:latin typeface="Inter"/>
-              </a:defRPr>
-            </a:pPr>
-            <a:r>
-              <a:t>🚫 3. Jashtë Kufijve (Out-of-Scope)</a:t>
+              <a:t>• Kufijtë Out-of-Scope (Çfarë NUK Bëjmë): JO pagesa me kartela (ndarja e parave bëhet kesh në makinë), JO GPS tracking kompleks satelitor.</a:t>
             </a:r>
           </a:p>
           <a:p>
@@ -11174,39 +11011,7 @@
               </a:defRPr>
             </a:pPr>
             <a:r>
-              <a:t>• JO pagesa me kartela bankare (ndarja e parave bëhet kesh në makinë).</a:t>
-            </a:r>
-          </a:p>
-          <a:p>
-            <a:pPr>
-              <a:spcAft>
-                <a:spcPts val="1000"/>
-              </a:spcAft>
-              <a:defRPr sz="1700">
-                <a:solidFill>
-                  <a:srgbClr val="E2E8F0"/>
-                </a:solidFill>
-                <a:latin typeface="Inter"/>
-              </a:defRPr>
-            </a:pPr>
-            <a:r>
-              <a:t>• JO navigim kompleks satelitor me GPS (kursen kohë zhvillimi).</a:t>
-            </a:r>
-          </a:p>
-          <a:p>
-            <a:pPr>
-              <a:spcAft>
-                <a:spcPts val="1000"/>
-              </a:spcAft>
-              <a:defRPr sz="1700">
-                <a:solidFill>
-                  <a:srgbClr val="E2E8F0"/>
-                </a:solidFill>
-                <a:latin typeface="Inter"/>
-              </a:defRPr>
-            </a:pPr>
-            <a:r>
-              <a:t>• Rregulli i Artë: Fillojmë të thjeshtë, funksional dhe të realizueshëm brenda semestrit!</a:t>
+              <a:t>• Mësimi për Themeluesit: 80% e projekteve studentore dështojnë nga 'Scope Creep' (fryrja e kërkesave). Ne ndërtojmë një bërthamë të hekurt që funksionon 100%!</a:t>
             </a:r>
           </a:p>
         </p:txBody>
@@ -11388,8 +11193,77 @@
         </p:nvSpPr>
         <p:spPr>
           <a:xfrm>
-            <a:off x="731520" y="2011680"/>
-            <a:ext cx="5120640" cy="4389120"/>
+            <a:off x="731520" y="1965960"/>
+            <a:ext cx="5303520" cy="4480560"/>
+          </a:xfrm>
+          <a:prstGeom prst="roundRect">
+            <a:avLst/>
+          </a:prstGeom>
+          <a:solidFill>
+            <a:srgbClr val="FFFFFF"/>
+          </a:solidFill>
+          <a:ln w="31750">
+            <a:solidFill>
+              <a:srgbClr val="38BDF8"/>
+            </a:solidFill>
+          </a:ln>
+        </p:spPr>
+        <p:style>
+          <a:lnRef idx="1">
+            <a:schemeClr val="accent1"/>
+          </a:lnRef>
+          <a:fillRef idx="3">
+            <a:schemeClr val="accent1"/>
+          </a:fillRef>
+          <a:effectRef idx="2">
+            <a:schemeClr val="accent1"/>
+          </a:effectRef>
+          <a:fontRef idx="minor">
+            <a:schemeClr val="lt1"/>
+          </a:fontRef>
+        </p:style>
+        <p:txBody>
+          <a:bodyPr rtlCol="0" anchor="ctr"/>
+          <a:lstStyle/>
+          <a:p>
+            <a:pPr algn="ctr"/>
+          </a:p>
+        </p:txBody>
+      </p:sp>
+      <p:pic>
+        <p:nvPicPr>
+          <p:cNvPr id="7" name="Picture 6" descr="slide5_sketch_arkitektura_blloqet.png"/>
+          <p:cNvPicPr>
+            <a:picLocks noChangeAspect="1"/>
+          </p:cNvPicPr>
+          <p:nvPr/>
+        </p:nvPicPr>
+        <p:blipFill>
+          <a:blip r:embed="rId2"/>
+          <a:stretch>
+            <a:fillRect/>
+          </a:stretch>
+        </p:blipFill>
+        <p:spPr>
+          <a:xfrm>
+            <a:off x="777240" y="2011680"/>
+            <a:ext cx="5212080" cy="4389120"/>
+          </a:xfrm>
+          <a:prstGeom prst="rect">
+            <a:avLst/>
+          </a:prstGeom>
+        </p:spPr>
+      </p:pic>
+      <p:sp>
+        <p:nvSpPr>
+          <p:cNvPr id="8" name="Rounded Rectangle 7"/>
+          <p:cNvSpPr/>
+          <p:nvPr/>
+        </p:nvSpPr>
+        <p:spPr>
+          <a:xfrm>
+            <a:off x="6217920" y="1965960"/>
+            <a:ext cx="5303520" cy="4480560"/>
           </a:xfrm>
           <a:prstGeom prst="roundRect">
             <a:avLst/>
@@ -11427,14 +11301,14 @@
       </p:sp>
       <p:sp>
         <p:nvSpPr>
-          <p:cNvPr id="7" name="TextBox 6"/>
+          <p:cNvPr id="9" name="TextBox 8"/>
           <p:cNvSpPr txBox="1"/>
           <p:nvPr/>
         </p:nvSpPr>
         <p:spPr>
           <a:xfrm>
-            <a:off x="1005840" y="2286000"/>
-            <a:ext cx="4572000" cy="3840480"/>
+            <a:off x="6400800" y="2148840"/>
+            <a:ext cx="4937760" cy="4114800"/>
           </a:xfrm>
           <a:prstGeom prst="rect">
             <a:avLst/>
@@ -11449,9 +11323,9 @@
           <a:p>
             <a:pPr>
               <a:spcAft>
-                <a:spcPts val="1600"/>
-              </a:spcAft>
-              <a:defRPr sz="2400" b="1">
+                <a:spcPts val="1200"/>
+              </a:spcAft>
+              <a:defRPr sz="2300" b="1">
                 <a:solidFill>
                   <a:srgbClr val="38BDF8"/>
                 </a:solidFill>
@@ -11459,219 +11333,71 @@
               </a:defRPr>
             </a:pPr>
             <a:r>
-              <a:t>📱 Ndërfaqja Mobile (Next.js PWA)</a:t>
-            </a:r>
-          </a:p>
-          <a:p>
-            <a:pPr>
-              <a:spcAft>
-                <a:spcPts val="1200"/>
-              </a:spcAft>
-              <a:defRPr sz="1800">
-                <a:solidFill>
-                  <a:srgbClr val="E2E8F0"/>
-                </a:solidFill>
-                <a:latin typeface="Inter"/>
-              </a:defRPr>
-            </a:pPr>
-            <a:r>
-              <a:t>• Ekrani 1: Kërko Udhëtim: Zgjedhja e qytetit dhe orës nga udhëtari.</a:t>
-            </a:r>
-          </a:p>
-          <a:p>
-            <a:pPr>
-              <a:spcAft>
-                <a:spcPts val="1200"/>
-              </a:spcAft>
-              <a:defRPr sz="1800">
-                <a:solidFill>
-                  <a:srgbClr val="E2E8F0"/>
-                </a:solidFill>
-                <a:latin typeface="Inter"/>
-              </a:defRPr>
-            </a:pPr>
-            <a:r>
-              <a:t>• Ekrani 2: Lista e Veturave: Kartelat e shoferëve me vendet e lira dhe çmimin.</a:t>
-            </a:r>
-          </a:p>
-          <a:p>
-            <a:pPr>
-              <a:spcAft>
-                <a:spcPts val="1200"/>
-              </a:spcAft>
-              <a:defRPr sz="1800">
-                <a:solidFill>
-                  <a:srgbClr val="E2E8F0"/>
-                </a:solidFill>
-                <a:latin typeface="Inter"/>
-              </a:defRPr>
-            </a:pPr>
-            <a:r>
-              <a:t>• Ekrani 3: Posto Rrugën: Formë e shpejtë për shoferin me 3 fusha.</a:t>
-            </a:r>
-          </a:p>
-          <a:p>
-            <a:pPr>
-              <a:spcAft>
-                <a:spcPts val="1200"/>
-              </a:spcAft>
-              <a:defRPr sz="1800">
-                <a:solidFill>
-                  <a:srgbClr val="E2E8F0"/>
-                </a:solidFill>
-                <a:latin typeface="Inter"/>
-              </a:defRPr>
-            </a:pPr>
-            <a:r>
-              <a:t>• Teknologjia:: Next.js 15 App Router + Tailwind CSS (Touch-First 48px).</a:t>
-            </a:r>
-          </a:p>
-        </p:txBody>
-      </p:sp>
-      <p:sp>
-        <p:nvSpPr>
-          <p:cNvPr id="8" name="Rounded Rectangle 7"/>
-          <p:cNvSpPr/>
-          <p:nvPr/>
-        </p:nvSpPr>
-        <p:spPr>
-          <a:xfrm>
-            <a:off x="6309360" y="2011680"/>
-            <a:ext cx="5120640" cy="4389120"/>
-          </a:xfrm>
-          <a:prstGeom prst="roundRect">
-            <a:avLst/>
-          </a:prstGeom>
-          <a:solidFill>
-            <a:srgbClr val="141E34"/>
-          </a:solidFill>
-          <a:ln w="31750">
-            <a:solidFill>
-              <a:srgbClr val="10B981"/>
-            </a:solidFill>
-          </a:ln>
-        </p:spPr>
-        <p:style>
-          <a:lnRef idx="1">
-            <a:schemeClr val="accent1"/>
-          </a:lnRef>
-          <a:fillRef idx="3">
-            <a:schemeClr val="accent1"/>
-          </a:fillRef>
-          <a:effectRef idx="2">
-            <a:schemeClr val="accent1"/>
-          </a:effectRef>
-          <a:fontRef idx="minor">
-            <a:schemeClr val="lt1"/>
-          </a:fontRef>
-        </p:style>
-        <p:txBody>
-          <a:bodyPr rtlCol="0" anchor="ctr"/>
-          <a:lstStyle/>
-          <a:p>
-            <a:pPr algn="ctr"/>
-          </a:p>
-        </p:txBody>
-      </p:sp>
-      <p:sp>
-        <p:nvSpPr>
-          <p:cNvPr id="9" name="TextBox 8"/>
-          <p:cNvSpPr txBox="1"/>
-          <p:nvPr/>
-        </p:nvSpPr>
-        <p:spPr>
-          <a:xfrm>
-            <a:off x="6583680" y="2286000"/>
-            <a:ext cx="4572000" cy="3840480"/>
-          </a:xfrm>
-          <a:prstGeom prst="rect">
-            <a:avLst/>
-          </a:prstGeom>
-          <a:noFill/>
-        </p:spPr>
-        <p:txBody>
-          <a:bodyPr wrap="square">
-            <a:spAutoFit/>
-          </a:bodyPr>
-          <a:lstStyle/>
-          <a:p>
-            <a:pPr>
-              <a:spcAft>
-                <a:spcPts val="1600"/>
-              </a:spcAft>
-              <a:defRPr sz="2400" b="1">
-                <a:solidFill>
-                  <a:srgbClr val="10B981"/>
-                </a:solidFill>
-                <a:latin typeface="Inter"/>
-              </a:defRPr>
-            </a:pPr>
-            <a:r>
-              <a:t>☁️ Baza &amp; Siguria (Supabase Cloud)</a:t>
-            </a:r>
-          </a:p>
-          <a:p>
-            <a:pPr>
-              <a:spcAft>
-                <a:spcPts val="1200"/>
-              </a:spcAft>
-              <a:defRPr sz="1800">
-                <a:solidFill>
-                  <a:srgbClr val="E2E8F0"/>
-                </a:solidFill>
-                <a:latin typeface="Inter"/>
-              </a:defRPr>
-            </a:pPr>
-            <a:r>
-              <a:t>• Tabela 'rides': id, driver_id, origin, departure_time, seats_available, price.</a:t>
-            </a:r>
-          </a:p>
-          <a:p>
-            <a:pPr>
-              <a:spcAft>
-                <a:spcPts val="1200"/>
-              </a:spcAft>
-              <a:defRPr sz="1800">
-                <a:solidFill>
-                  <a:srgbClr val="E2E8F0"/>
-                </a:solidFill>
-                <a:latin typeface="Inter"/>
-              </a:defRPr>
-            </a:pPr>
-            <a:r>
-              <a:t>• Tabela 'bookings': id, ride_id, passenger_id, status (konfirmuar/anuluar).</a:t>
-            </a:r>
-          </a:p>
-          <a:p>
-            <a:pPr>
-              <a:spcAft>
-                <a:spcPts val="1200"/>
-              </a:spcAft>
-              <a:defRPr sz="1800">
-                <a:solidFill>
-                  <a:srgbClr val="E2E8F0"/>
-                </a:solidFill>
-                <a:latin typeface="Inter"/>
-              </a:defRPr>
-            </a:pPr>
-            <a:r>
-              <a:t>• Siguria me Email AAB: Kyçje vetëm me @universitetiaab.com.</a:t>
-            </a:r>
-          </a:p>
-          <a:p>
-            <a:pPr>
-              <a:spcAft>
-                <a:spcPts val="1200"/>
-              </a:spcAft>
-              <a:defRPr sz="1800">
-                <a:solidFill>
-                  <a:srgbClr val="E2E8F0"/>
-                </a:solidFill>
-                <a:latin typeface="Inter"/>
-              </a:defRPr>
-            </a:pPr>
-            <a:r>
-              <a:t>• Realtime Sync: Vendet e lira zbriten në çast te të gjithë përdoruesit.</a:t>
+              <a:t>🏛️ 3 Blloqet Kryesore të Arkitekturës</a:t>
+            </a:r>
+          </a:p>
+          <a:p>
+            <a:pPr>
+              <a:spcAft>
+                <a:spcPts val="1000"/>
+              </a:spcAft>
+              <a:defRPr sz="1700">
+                <a:solidFill>
+                  <a:srgbClr val="E2E8F0"/>
+                </a:solidFill>
+                <a:latin typeface="Inter"/>
+              </a:defRPr>
+            </a:pPr>
+            <a:r>
+              <a:t>• 1. Klienti Mobile (PWA): Ndërtuar me Next.js 15 dhe Tailwind CSS. Butona me sipërfaqe prekjeje 48px. Service Worker për shpejtësi dhe mbështetje offline.</a:t>
+            </a:r>
+          </a:p>
+          <a:p>
+            <a:pPr>
+              <a:spcAft>
+                <a:spcPts val="1000"/>
+              </a:spcAft>
+              <a:defRPr sz="1700">
+                <a:solidFill>
+                  <a:srgbClr val="E2E8F0"/>
+                </a:solidFill>
+                <a:latin typeface="Inter"/>
+              </a:defRPr>
+            </a:pPr>
+            <a:r>
+              <a:t>• 2. Baza &amp; Siguria (Supabase): Tabela relacionale 'rides' (shoferi, nisja, ora, vendet) dhe 'bookings'. Realtime engine që zbret vendet e lira menjëherë pa rifreskuar faqen.</a:t>
+            </a:r>
+          </a:p>
+          <a:p>
+            <a:pPr>
+              <a:spcAft>
+                <a:spcPts val="1000"/>
+              </a:spcAft>
+              <a:defRPr sz="1700">
+                <a:solidFill>
+                  <a:srgbClr val="E2E8F0"/>
+                </a:solidFill>
+                <a:latin typeface="Inter"/>
+              </a:defRPr>
+            </a:pPr>
+            <a:r>
+              <a:t>• 3. Lidhja e Jashtme (WhatsApp): Deep link 'wa.me' që lidh shoferin dhe pasagjerin për pikën e takimit.</a:t>
+            </a:r>
+          </a:p>
+          <a:p>
+            <a:pPr>
+              <a:spcAft>
+                <a:spcPts val="1000"/>
+              </a:spcAft>
+              <a:defRPr sz="1700">
+                <a:solidFill>
+                  <a:srgbClr val="E2E8F0"/>
+                </a:solidFill>
+                <a:latin typeface="Inter"/>
+              </a:defRPr>
+            </a:pPr>
+            <a:r>
+              <a:t>• Pse Kjo Arkitekturë? Ndërtim modular: PWA bën menaxhimin e të dhënave, Supabase garanton besueshmërinë, WhatsApp koordinimin live!</a:t>
             </a:r>
           </a:p>
         </p:txBody>
@@ -11853,14 +11579,14 @@
         </p:nvSpPr>
         <p:spPr>
           <a:xfrm>
-            <a:off x="731520" y="2011680"/>
-            <a:ext cx="2011680" cy="4389120"/>
+            <a:off x="731520" y="1965960"/>
+            <a:ext cx="5303520" cy="4480560"/>
           </a:xfrm>
           <a:prstGeom prst="roundRect">
             <a:avLst/>
           </a:prstGeom>
           <a:solidFill>
-            <a:srgbClr val="141E34"/>
+            <a:srgbClr val="FFFFFF"/>
           </a:solidFill>
           <a:ln w="31750">
             <a:solidFill>
@@ -11890,86 +11616,30 @@
           </a:p>
         </p:txBody>
       </p:sp>
-      <p:sp>
-        <p:nvSpPr>
-          <p:cNvPr id="7" name="TextBox 6"/>
-          <p:cNvSpPr txBox="1"/>
-          <p:nvPr/>
-        </p:nvSpPr>
-        <p:spPr>
-          <a:xfrm>
-            <a:off x="841248" y="2148840"/>
-            <a:ext cx="1792224" cy="4069080"/>
-          </a:xfrm>
-          <a:prstGeom prst="rect">
-            <a:avLst/>
-          </a:prstGeom>
-          <a:noFill/>
-        </p:spPr>
-        <p:txBody>
-          <a:bodyPr wrap="square">
-            <a:spAutoFit/>
-          </a:bodyPr>
-          <a:lstStyle/>
-          <a:p>
-            <a:pPr algn="ctr">
-              <a:defRPr sz="3600"/>
-            </a:pPr>
-            <a:r>
-              <a:t>1️⃣</a:t>
-            </a:r>
-          </a:p>
-          <a:p>
-            <a:pPr algn="ctr">
-              <a:spcAft>
-                <a:spcPts val="600"/>
-              </a:spcAft>
-              <a:defRPr sz="1300" b="1">
-                <a:solidFill>
-                  <a:srgbClr val="38BDF8"/>
-                </a:solidFill>
-                <a:latin typeface="Inter"/>
-              </a:defRPr>
-            </a:pPr>
-            <a:r>
-              <a:t>JAVËT 1–2</a:t>
-            </a:r>
-          </a:p>
-          <a:p>
-            <a:pPr algn="ctr">
-              <a:spcAft>
-                <a:spcPts val="1200"/>
-              </a:spcAft>
-              <a:defRPr sz="1900" b="1">
-                <a:solidFill>
-                  <a:srgbClr val="FFFFFF"/>
-                </a:solidFill>
-                <a:latin typeface="Inter"/>
-              </a:defRPr>
-            </a:pPr>
-            <a:r>
-              <a:t>Ideja &amp; Skica</a:t>
-            </a:r>
-            <a:br/>
-            <a:r>
-              <a:t>në Letër</a:t>
-            </a:r>
-          </a:p>
-          <a:p>
-            <a:pPr algn="l">
-              <a:defRPr sz="1600">
-                <a:solidFill>
-                  <a:srgbClr val="E2E8F0"/>
-                </a:solidFill>
-                <a:latin typeface="Inter"/>
-              </a:defRPr>
-            </a:pPr>
-            <a:r>
-              <a:t>Vëzhgimi i problemit, përcaktimi i kërkesave dhe vizatimi me dorë i ekraneve.</a:t>
-            </a:r>
-          </a:p>
-        </p:txBody>
-      </p:sp>
+      <p:pic>
+        <p:nvPicPr>
+          <p:cNvPr id="7" name="Picture 6" descr="slide6_sketch_vijueshmeria_ndertimi.png"/>
+          <p:cNvPicPr>
+            <a:picLocks noChangeAspect="1"/>
+          </p:cNvPicPr>
+          <p:nvPr/>
+        </p:nvPicPr>
+        <p:blipFill>
+          <a:blip r:embed="rId2"/>
+          <a:stretch>
+            <a:fillRect/>
+          </a:stretch>
+        </p:blipFill>
+        <p:spPr>
+          <a:xfrm>
+            <a:off x="777240" y="2011680"/>
+            <a:ext cx="5212080" cy="4389120"/>
+          </a:xfrm>
+          <a:prstGeom prst="rect">
+            <a:avLst/>
+          </a:prstGeom>
+        </p:spPr>
+      </p:pic>
       <p:sp>
         <p:nvSpPr>
           <p:cNvPr id="8" name="Rounded Rectangle 7"/>
@@ -11978,133 +11648,8 @@
         </p:nvSpPr>
         <p:spPr>
           <a:xfrm>
-            <a:off x="2907792" y="2011680"/>
-            <a:ext cx="2011680" cy="4389120"/>
-          </a:xfrm>
-          <a:prstGeom prst="roundRect">
-            <a:avLst/>
-          </a:prstGeom>
-          <a:solidFill>
-            <a:srgbClr val="141E34"/>
-          </a:solidFill>
-          <a:ln w="31750">
-            <a:solidFill>
-              <a:srgbClr val="6366F1"/>
-            </a:solidFill>
-          </a:ln>
-        </p:spPr>
-        <p:style>
-          <a:lnRef idx="1">
-            <a:schemeClr val="accent1"/>
-          </a:lnRef>
-          <a:fillRef idx="3">
-            <a:schemeClr val="accent1"/>
-          </a:fillRef>
-          <a:effectRef idx="2">
-            <a:schemeClr val="accent1"/>
-          </a:effectRef>
-          <a:fontRef idx="minor">
-            <a:schemeClr val="lt1"/>
-          </a:fontRef>
-        </p:style>
-        <p:txBody>
-          <a:bodyPr rtlCol="0" anchor="ctr"/>
-          <a:lstStyle/>
-          <a:p>
-            <a:pPr algn="ctr"/>
-          </a:p>
-        </p:txBody>
-      </p:sp>
-      <p:sp>
-        <p:nvSpPr>
-          <p:cNvPr id="9" name="TextBox 8"/>
-          <p:cNvSpPr txBox="1"/>
-          <p:nvPr/>
-        </p:nvSpPr>
-        <p:spPr>
-          <a:xfrm>
-            <a:off x="3017520" y="2148840"/>
-            <a:ext cx="1792224" cy="4069080"/>
-          </a:xfrm>
-          <a:prstGeom prst="rect">
-            <a:avLst/>
-          </a:prstGeom>
-          <a:noFill/>
-        </p:spPr>
-        <p:txBody>
-          <a:bodyPr wrap="square">
-            <a:spAutoFit/>
-          </a:bodyPr>
-          <a:lstStyle/>
-          <a:p>
-            <a:pPr algn="ctr">
-              <a:defRPr sz="3600"/>
-            </a:pPr>
-            <a:r>
-              <a:t>2️⃣</a:t>
-            </a:r>
-          </a:p>
-          <a:p>
-            <a:pPr algn="ctr">
-              <a:spcAft>
-                <a:spcPts val="600"/>
-              </a:spcAft>
-              <a:defRPr sz="1300" b="1">
-                <a:solidFill>
-                  <a:srgbClr val="6366F1"/>
-                </a:solidFill>
-                <a:latin typeface="Inter"/>
-              </a:defRPr>
-            </a:pPr>
-            <a:r>
-              <a:t>JAVËT 3–5</a:t>
-            </a:r>
-          </a:p>
-          <a:p>
-            <a:pPr algn="ctr">
-              <a:spcAft>
-                <a:spcPts val="1200"/>
-              </a:spcAft>
-              <a:defRPr sz="1900" b="1">
-                <a:solidFill>
-                  <a:srgbClr val="FFFFFF"/>
-                </a:solidFill>
-                <a:latin typeface="Inter"/>
-              </a:defRPr>
-            </a:pPr>
-            <a:r>
-              <a:t>Dizajni i UI</a:t>
-            </a:r>
-            <a:br/>
-            <a:r>
-              <a:t>me Tailwind</a:t>
-            </a:r>
-          </a:p>
-          <a:p>
-            <a:pPr algn="l">
-              <a:defRPr sz="1600">
-                <a:solidFill>
-                  <a:srgbClr val="E2E8F0"/>
-                </a:solidFill>
-                <a:latin typeface="Inter"/>
-              </a:defRPr>
-            </a:pPr>
-            <a:r>
-              <a:t>Kthimi i skicës në faqe mobile me Copilot. Krijimi i kartelave dhe butonave.</a:t>
-            </a:r>
-          </a:p>
-        </p:txBody>
-      </p:sp>
-      <p:sp>
-        <p:nvSpPr>
-          <p:cNvPr id="10" name="Rounded Rectangle 9"/>
-          <p:cNvSpPr/>
-          <p:nvPr/>
-        </p:nvSpPr>
-        <p:spPr>
-          <a:xfrm>
-            <a:off x="5084064" y="2011680"/>
-            <a:ext cx="2011680" cy="4389120"/>
+            <a:off x="6217920" y="1965960"/>
+            <a:ext cx="5303520" cy="4480560"/>
           </a:xfrm>
           <a:prstGeom prst="roundRect">
             <a:avLst/>
@@ -12142,14 +11687,14 @@
       </p:sp>
       <p:sp>
         <p:nvSpPr>
-          <p:cNvPr id="11" name="TextBox 10"/>
+          <p:cNvPr id="9" name="TextBox 8"/>
           <p:cNvSpPr txBox="1"/>
           <p:nvPr/>
         </p:nvSpPr>
         <p:spPr>
           <a:xfrm>
-            <a:off x="5193792" y="2148840"/>
-            <a:ext cx="1792224" cy="4069080"/>
+            <a:off x="6400800" y="2148840"/>
+            <a:ext cx="4937760" cy="4114800"/>
           </a:xfrm>
           <a:prstGeom prst="rect">
             <a:avLst/>
@@ -12162,19 +11707,11 @@
           </a:bodyPr>
           <a:lstStyle/>
           <a:p>
-            <a:pPr algn="ctr">
-              <a:defRPr sz="3600"/>
-            </a:pPr>
-            <a:r>
-              <a:t>3️⃣</a:t>
-            </a:r>
-          </a:p>
-          <a:p>
-            <a:pPr algn="ctr">
-              <a:spcAft>
-                <a:spcPts val="600"/>
-              </a:spcAft>
-              <a:defRPr sz="1300" b="1">
+            <a:pPr>
+              <a:spcAft>
+                <a:spcPts val="1200"/>
+              </a:spcAft>
+              <a:defRPr sz="2300" b="1">
                 <a:solidFill>
                   <a:srgbClr val="F59E0B"/>
                 </a:solidFill>
@@ -12182,290 +11719,87 @@
               </a:defRPr>
             </a:pPr>
             <a:r>
-              <a:t>JAVËT 6–9</a:t>
-            </a:r>
-          </a:p>
-          <a:p>
-            <a:pPr algn="ctr">
-              <a:spcAft>
-                <a:spcPts val="1200"/>
-              </a:spcAft>
-              <a:defRPr sz="1900" b="1">
-                <a:solidFill>
-                  <a:srgbClr val="FFFFFF"/>
-                </a:solidFill>
-                <a:latin typeface="Inter"/>
-              </a:defRPr>
-            </a:pPr>
-            <a:r>
-              <a:t>Databaza</a:t>
-            </a:r>
-            <a:br/>
-            <a:r>
-              <a:t>Supabase</a:t>
-            </a:r>
-          </a:p>
-          <a:p>
-            <a:pPr algn="l">
-              <a:defRPr sz="1600">
-                <a:solidFill>
-                  <a:srgbClr val="E2E8F0"/>
-                </a:solidFill>
-                <a:latin typeface="Inter"/>
-              </a:defRPr>
-            </a:pPr>
-            <a:r>
-              <a:t>Krijimi i tabelave në PostgreSQL, lidhja e autentikimit AAB dhe logjika e rezervimit.</a:t>
-            </a:r>
-          </a:p>
-        </p:txBody>
-      </p:sp>
-      <p:sp>
-        <p:nvSpPr>
-          <p:cNvPr id="12" name="Rounded Rectangle 11"/>
-          <p:cNvSpPr/>
-          <p:nvPr/>
-        </p:nvSpPr>
-        <p:spPr>
-          <a:xfrm>
-            <a:off x="7260336" y="2011680"/>
-            <a:ext cx="2011680" cy="4389120"/>
-          </a:xfrm>
-          <a:prstGeom prst="roundRect">
-            <a:avLst/>
-          </a:prstGeom>
-          <a:solidFill>
-            <a:srgbClr val="141E34"/>
-          </a:solidFill>
-          <a:ln w="31750">
-            <a:solidFill>
-              <a:srgbClr val="10B981"/>
-            </a:solidFill>
-          </a:ln>
-        </p:spPr>
-        <p:style>
-          <a:lnRef idx="1">
-            <a:schemeClr val="accent1"/>
-          </a:lnRef>
-          <a:fillRef idx="3">
-            <a:schemeClr val="accent1"/>
-          </a:fillRef>
-          <a:effectRef idx="2">
-            <a:schemeClr val="accent1"/>
-          </a:effectRef>
-          <a:fontRef idx="minor">
-            <a:schemeClr val="lt1"/>
-          </a:fontRef>
-        </p:style>
-        <p:txBody>
-          <a:bodyPr rtlCol="0" anchor="ctr"/>
-          <a:lstStyle/>
-          <a:p>
-            <a:pPr algn="ctr"/>
-          </a:p>
-        </p:txBody>
-      </p:sp>
-      <p:sp>
-        <p:nvSpPr>
-          <p:cNvPr id="13" name="TextBox 12"/>
-          <p:cNvSpPr txBox="1"/>
-          <p:nvPr/>
-        </p:nvSpPr>
-        <p:spPr>
-          <a:xfrm>
-            <a:off x="7370064" y="2148840"/>
-            <a:ext cx="1792224" cy="4069080"/>
-          </a:xfrm>
-          <a:prstGeom prst="rect">
-            <a:avLst/>
-          </a:prstGeom>
-          <a:noFill/>
-        </p:spPr>
-        <p:txBody>
-          <a:bodyPr wrap="square">
-            <a:spAutoFit/>
-          </a:bodyPr>
-          <a:lstStyle/>
-          <a:p>
-            <a:pPr algn="ctr">
-              <a:defRPr sz="3600"/>
-            </a:pPr>
-            <a:r>
-              <a:t>4️⃣</a:t>
-            </a:r>
-          </a:p>
-          <a:p>
-            <a:pPr algn="ctr">
-              <a:spcAft>
-                <a:spcPts val="600"/>
-              </a:spcAft>
-              <a:defRPr sz="1300" b="1">
-                <a:solidFill>
-                  <a:srgbClr val="10B981"/>
-                </a:solidFill>
-                <a:latin typeface="Inter"/>
-              </a:defRPr>
-            </a:pPr>
-            <a:r>
-              <a:t>JAVËT 10–12</a:t>
-            </a:r>
-          </a:p>
-          <a:p>
-            <a:pPr algn="ctr">
-              <a:spcAft>
-                <a:spcPts val="1200"/>
-              </a:spcAft>
-              <a:defRPr sz="1900" b="1">
-                <a:solidFill>
-                  <a:srgbClr val="FFFFFF"/>
-                </a:solidFill>
-                <a:latin typeface="Inter"/>
-              </a:defRPr>
-            </a:pPr>
-            <a:r>
-              <a:t>Realtime &amp;</a:t>
-            </a:r>
-            <a:br/>
-            <a:r>
-              <a:t>PWA Offline</a:t>
-            </a:r>
-          </a:p>
-          <a:p>
-            <a:pPr algn="l">
-              <a:defRPr sz="1600">
-                <a:solidFill>
-                  <a:srgbClr val="E2E8F0"/>
-                </a:solidFill>
-                <a:latin typeface="Inter"/>
-              </a:defRPr>
-            </a:pPr>
-            <a:r>
-              <a:t>Sinkronizimi live i vendeve të lira, njoftimet push dhe instalimi në telefon.</a:t>
-            </a:r>
-          </a:p>
-        </p:txBody>
-      </p:sp>
-      <p:sp>
-        <p:nvSpPr>
-          <p:cNvPr id="14" name="Rounded Rectangle 13"/>
-          <p:cNvSpPr/>
-          <p:nvPr/>
-        </p:nvSpPr>
-        <p:spPr>
-          <a:xfrm>
-            <a:off x="9436608" y="2011680"/>
-            <a:ext cx="2011680" cy="4389120"/>
-          </a:xfrm>
-          <a:prstGeom prst="roundRect">
-            <a:avLst/>
-          </a:prstGeom>
-          <a:solidFill>
-            <a:srgbClr val="141E34"/>
-          </a:solidFill>
-          <a:ln w="31750">
-            <a:solidFill>
-              <a:srgbClr val="EC4899"/>
-            </a:solidFill>
-          </a:ln>
-        </p:spPr>
-        <p:style>
-          <a:lnRef idx="1">
-            <a:schemeClr val="accent1"/>
-          </a:lnRef>
-          <a:fillRef idx="3">
-            <a:schemeClr val="accent1"/>
-          </a:fillRef>
-          <a:effectRef idx="2">
-            <a:schemeClr val="accent1"/>
-          </a:effectRef>
-          <a:fontRef idx="minor">
-            <a:schemeClr val="lt1"/>
-          </a:fontRef>
-        </p:style>
-        <p:txBody>
-          <a:bodyPr rtlCol="0" anchor="ctr"/>
-          <a:lstStyle/>
-          <a:p>
-            <a:pPr algn="ctr"/>
-          </a:p>
-        </p:txBody>
-      </p:sp>
-      <p:sp>
-        <p:nvSpPr>
-          <p:cNvPr id="15" name="TextBox 14"/>
-          <p:cNvSpPr txBox="1"/>
-          <p:nvPr/>
-        </p:nvSpPr>
-        <p:spPr>
-          <a:xfrm>
-            <a:off x="9546336" y="2148840"/>
-            <a:ext cx="1792224" cy="4069080"/>
-          </a:xfrm>
-          <a:prstGeom prst="rect">
-            <a:avLst/>
-          </a:prstGeom>
-          <a:noFill/>
-        </p:spPr>
-        <p:txBody>
-          <a:bodyPr wrap="square">
-            <a:spAutoFit/>
-          </a:bodyPr>
-          <a:lstStyle/>
-          <a:p>
-            <a:pPr algn="ctr">
-              <a:defRPr sz="3600"/>
-            </a:pPr>
-            <a:r>
-              <a:t>5️⃣</a:t>
-            </a:r>
-          </a:p>
-          <a:p>
-            <a:pPr algn="ctr">
-              <a:spcAft>
-                <a:spcPts val="600"/>
-              </a:spcAft>
-              <a:defRPr sz="1300" b="1">
-                <a:solidFill>
-                  <a:srgbClr val="EC4899"/>
-                </a:solidFill>
-                <a:latin typeface="Inter"/>
-              </a:defRPr>
-            </a:pPr>
-            <a:r>
-              <a:t>JAVA 15</a:t>
-            </a:r>
-          </a:p>
-          <a:p>
-            <a:pPr algn="ctr">
-              <a:spcAft>
-                <a:spcPts val="1200"/>
-              </a:spcAft>
-              <a:defRPr sz="1900" b="1">
-                <a:solidFill>
-                  <a:srgbClr val="FFFFFF"/>
-                </a:solidFill>
-                <a:latin typeface="Inter"/>
-              </a:defRPr>
-            </a:pPr>
-            <a:r>
-              <a:t>Demo Day &amp;</a:t>
-            </a:r>
-            <a:br/>
-            <a:r>
-              <a:t>Mbrojtja</a:t>
-            </a:r>
-          </a:p>
-          <a:p>
-            <a:pPr algn="l">
-              <a:defRPr sz="1600">
-                <a:solidFill>
-                  <a:srgbClr val="E2E8F0"/>
-                </a:solidFill>
-                <a:latin typeface="Inter"/>
-              </a:defRPr>
-            </a:pPr>
-            <a:r>
-              <a:t>Prezantimi live para sallës direkt nga telefoni juaj. Notë maksimale dhe festim!</a:t>
+              <a:t>⏳ 'Pastaj Më Vonë Hyjmë në Ndërtim Real!'</a:t>
+            </a:r>
+          </a:p>
+          <a:p>
+            <a:pPr>
+              <a:spcAft>
+                <a:spcPts val="1000"/>
+              </a:spcAft>
+              <a:defRPr sz="1700">
+                <a:solidFill>
+                  <a:srgbClr val="E2E8F0"/>
+                </a:solidFill>
+                <a:latin typeface="Inter"/>
+              </a:defRPr>
+            </a:pPr>
+            <a:r>
+              <a:t>• Javët 1–2 (Ideja &amp; Letra): Vëzhgimi i problemit, zgjedhja e biznesit, specifikat e qarta dhe skicimi me dorë i ekraneve pa shkruar asnjë rresht kod.</a:t>
+            </a:r>
+          </a:p>
+          <a:p>
+            <a:pPr>
+              <a:spcAft>
+                <a:spcPts val="1000"/>
+              </a:spcAft>
+              <a:defRPr sz="1700">
+                <a:solidFill>
+                  <a:srgbClr val="E2E8F0"/>
+                </a:solidFill>
+                <a:latin typeface="Inter"/>
+              </a:defRPr>
+            </a:pPr>
+            <a:r>
+              <a:t>• Javët 3–5 (Dizajni i UI me Tailwind): Kthimi i skicës në faqe mobile me Tailwind CSS dhe ndihmën e GitHub Copilot.</a:t>
+            </a:r>
+          </a:p>
+          <a:p>
+            <a:pPr>
+              <a:spcAft>
+                <a:spcPts val="1000"/>
+              </a:spcAft>
+              <a:defRPr sz="1700">
+                <a:solidFill>
+                  <a:srgbClr val="E2E8F0"/>
+                </a:solidFill>
+                <a:latin typeface="Inter"/>
+              </a:defRPr>
+            </a:pPr>
+            <a:r>
+              <a:t>• Javët 6–9 (Databaza &amp; Auth): Lidhja e Supabase, krijimi i tabelave dhe sistemi i rezervimit me siguri AAB.</a:t>
+            </a:r>
+          </a:p>
+          <a:p>
+            <a:pPr>
+              <a:spcAft>
+                <a:spcPts val="1000"/>
+              </a:spcAft>
+              <a:defRPr sz="1700">
+                <a:solidFill>
+                  <a:srgbClr val="E2E8F0"/>
+                </a:solidFill>
+                <a:latin typeface="Inter"/>
+              </a:defRPr>
+            </a:pPr>
+            <a:r>
+              <a:t>• Javët 10–12 (PWA &amp; Offline): Instalimi në ekran të telefonit, manifest.json dhe sinkronizimi live.</a:t>
+            </a:r>
+          </a:p>
+          <a:p>
+            <a:pPr>
+              <a:spcAft>
+                <a:spcPts val="1000"/>
+              </a:spcAft>
+              <a:defRPr sz="1700">
+                <a:solidFill>
+                  <a:srgbClr val="E2E8F0"/>
+                </a:solidFill>
+                <a:latin typeface="Inter"/>
+              </a:defRPr>
+            </a:pPr>
+            <a:r>
+              <a:t>• Java 15 (Demo Day &amp; Suksesi): Prezantimi live nga telefoni juaj personal para komisionit dhe sallës!</a:t>
             </a:r>
           </a:p>
         </p:txBody>

</xml_diff>

<commit_message>
feat(presentation): upgrade slides 2-6 to full-width projector-grade visual diagrams
</commit_message>
<xml_diff>
--- a/Jave1_Hyrje_Nextjs_PWA_Copilot_2026.pptx
+++ b/Jave1_Hyrje_Nextjs_PWA_Copilot_2026.pptx
@@ -10421,8 +10421,8 @@
         </p:nvSpPr>
         <p:spPr>
           <a:xfrm>
-            <a:off x="731520" y="1965960"/>
-            <a:ext cx="5303520" cy="4480560"/>
+            <a:off x="731520" y="1874519"/>
+            <a:ext cx="10728655" cy="4663440"/>
           </a:xfrm>
           <a:prstGeom prst="roundRect">
             <a:avLst/>
@@ -10460,7 +10460,7 @@
       </p:sp>
       <p:pic>
         <p:nvPicPr>
-          <p:cNvPr id="7" name="Picture 6" descr="slide3_sketch_ideja_problemi.png"/>
+          <p:cNvPr id="7" name="Picture 6" descr="slide3_sketch_car_visual_master.png"/>
           <p:cNvPicPr>
             <a:picLocks noChangeAspect="1"/>
           </p:cNvPicPr>
@@ -10474,162 +10474,14 @@
         </p:blipFill>
         <p:spPr>
           <a:xfrm>
-            <a:off x="777240" y="2011680"/>
-            <a:ext cx="5212080" cy="4389120"/>
+            <a:off x="777240" y="1920240"/>
+            <a:ext cx="10637215" cy="4572000"/>
           </a:xfrm>
           <a:prstGeom prst="rect">
             <a:avLst/>
           </a:prstGeom>
         </p:spPr>
       </p:pic>
-      <p:sp>
-        <p:nvSpPr>
-          <p:cNvPr id="8" name="Rounded Rectangle 7"/>
-          <p:cNvSpPr/>
-          <p:nvPr/>
-        </p:nvSpPr>
-        <p:spPr>
-          <a:xfrm>
-            <a:off x="6217920" y="1965960"/>
-            <a:ext cx="5303520" cy="4480560"/>
-          </a:xfrm>
-          <a:prstGeom prst="roundRect">
-            <a:avLst/>
-          </a:prstGeom>
-          <a:solidFill>
-            <a:srgbClr val="141E34"/>
-          </a:solidFill>
-          <a:ln w="31750">
-            <a:solidFill>
-              <a:srgbClr val="6366F1"/>
-            </a:solidFill>
-          </a:ln>
-        </p:spPr>
-        <p:style>
-          <a:lnRef idx="1">
-            <a:schemeClr val="accent1"/>
-          </a:lnRef>
-          <a:fillRef idx="3">
-            <a:schemeClr val="accent1"/>
-          </a:fillRef>
-          <a:effectRef idx="2">
-            <a:schemeClr val="accent1"/>
-          </a:effectRef>
-          <a:fontRef idx="minor">
-            <a:schemeClr val="lt1"/>
-          </a:fontRef>
-        </p:style>
-        <p:txBody>
-          <a:bodyPr rtlCol="0" anchor="ctr"/>
-          <a:lstStyle/>
-          <a:p>
-            <a:pPr algn="ctr"/>
-          </a:p>
-        </p:txBody>
-      </p:sp>
-      <p:sp>
-        <p:nvSpPr>
-          <p:cNvPr id="9" name="TextBox 8"/>
-          <p:cNvSpPr txBox="1"/>
-          <p:nvPr/>
-        </p:nvSpPr>
-        <p:spPr>
-          <a:xfrm>
-            <a:off x="6400800" y="2148840"/>
-            <a:ext cx="4937760" cy="4114800"/>
-          </a:xfrm>
-          <a:prstGeom prst="rect">
-            <a:avLst/>
-          </a:prstGeom>
-          <a:noFill/>
-        </p:spPr>
-        <p:txBody>
-          <a:bodyPr wrap="square">
-            <a:spAutoFit/>
-          </a:bodyPr>
-          <a:lstStyle/>
-          <a:p>
-            <a:pPr>
-              <a:spcAft>
-                <a:spcPts val="1400"/>
-              </a:spcAft>
-              <a:defRPr sz="2400" b="1">
-                <a:solidFill>
-                  <a:srgbClr val="38BDF8"/>
-                </a:solidFill>
-                <a:latin typeface="Inter"/>
-              </a:defRPr>
-            </a:pPr>
-            <a:r>
-              <a:t>💡 Si Lindi 'AAB RideShare'?</a:t>
-            </a:r>
-          </a:p>
-          <a:p>
-            <a:pPr>
-              <a:spcAft>
-                <a:spcPts val="1000"/>
-              </a:spcAft>
-              <a:defRPr sz="1700">
-                <a:solidFill>
-                  <a:srgbClr val="E2E8F0"/>
-                </a:solidFill>
-                <a:latin typeface="Inter"/>
-              </a:defRPr>
-            </a:pPr>
-            <a:r>
-              <a:t>• Vëzhgimi në Terren: Në orën 07:30, qindra studentë nisen drejt AAB-së nga Ferizaji, Gjilani, Podujeva e Mitrovica.</a:t>
-            </a:r>
-          </a:p>
-          <a:p>
-            <a:pPr>
-              <a:spcAft>
-                <a:spcPts val="1000"/>
-              </a:spcAft>
-              <a:defRPr sz="1700">
-                <a:solidFill>
-                  <a:srgbClr val="E2E8F0"/>
-                </a:solidFill>
-                <a:latin typeface="Inter"/>
-              </a:defRPr>
-            </a:pPr>
-            <a:r>
-              <a:t>• Dhimbja (The Pain): Studentët me makinë shkojnë me 3 vende të zbrazëta duke paguar 10€ naftë vetëm. Ndërkohë, shokët e tyre presin autobusin në shi dhe vonohen në ligjëratë.</a:t>
-            </a:r>
-          </a:p>
-          <a:p>
-            <a:pPr>
-              <a:spcAft>
-                <a:spcPts val="1000"/>
-              </a:spcAft>
-              <a:defRPr sz="1700">
-                <a:solidFill>
-                  <a:srgbClr val="E2E8F0"/>
-                </a:solidFill>
-                <a:latin typeface="Inter"/>
-              </a:defRPr>
-            </a:pPr>
-            <a:r>
-              <a:t>• Skica e Parë në Letër: Një student merr një fletë dhe vizaton skicën me laps: '1 Makinë me 3 vende të lira + 3 shokë që ndajnë rrugën.'</a:t>
-            </a:r>
-          </a:p>
-          <a:p>
-            <a:pPr>
-              <a:spcAft>
-                <a:spcPts val="1000"/>
-              </a:spcAft>
-              <a:defRPr sz="1700">
-                <a:solidFill>
-                  <a:srgbClr val="E2E8F0"/>
-                </a:solidFill>
-                <a:latin typeface="Inter"/>
-              </a:defRPr>
-            </a:pPr>
-            <a:r>
-              <a:t>• Përfundimi Inxhinierik: Nuk nisim me kod të gatshëm! Nisim me të kuptuarit e thellë të problemit dhe zgjidhjen që krijon vlerë.</a:t>
-            </a:r>
-          </a:p>
-        </p:txBody>
-      </p:sp>
     </p:spTree>
   </p:cSld>
   <p:clrMapOvr>
@@ -10807,8 +10659,8 @@
         </p:nvSpPr>
         <p:spPr>
           <a:xfrm>
-            <a:off x="731520" y="1965960"/>
-            <a:ext cx="5303520" cy="4480560"/>
+            <a:off x="731520" y="1874519"/>
+            <a:ext cx="10728655" cy="4663440"/>
           </a:xfrm>
           <a:prstGeom prst="roundRect">
             <a:avLst/>
@@ -10846,7 +10698,7 @@
       </p:sp>
       <p:pic>
         <p:nvPicPr>
-          <p:cNvPr id="7" name="Picture 6" descr="slide4_sketch_specifikat_prd.png"/>
+          <p:cNvPr id="7" name="Picture 6" descr="slide4_sketch_wireframe_scope_master.png"/>
           <p:cNvPicPr>
             <a:picLocks noChangeAspect="1"/>
           </p:cNvPicPr>
@@ -10860,162 +10712,14 @@
         </p:blipFill>
         <p:spPr>
           <a:xfrm>
-            <a:off x="777240" y="2011680"/>
-            <a:ext cx="5212080" cy="4389120"/>
+            <a:off x="777240" y="1920240"/>
+            <a:ext cx="10637215" cy="4572000"/>
           </a:xfrm>
           <a:prstGeom prst="rect">
             <a:avLst/>
           </a:prstGeom>
         </p:spPr>
       </p:pic>
-      <p:sp>
-        <p:nvSpPr>
-          <p:cNvPr id="8" name="Rounded Rectangle 7"/>
-          <p:cNvSpPr/>
-          <p:nvPr/>
-        </p:nvSpPr>
-        <p:spPr>
-          <a:xfrm>
-            <a:off x="6217920" y="1965960"/>
-            <a:ext cx="5303520" cy="4480560"/>
-          </a:xfrm>
-          <a:prstGeom prst="roundRect">
-            <a:avLst/>
-          </a:prstGeom>
-          <a:solidFill>
-            <a:srgbClr val="141E34"/>
-          </a:solidFill>
-          <a:ln w="31750">
-            <a:solidFill>
-              <a:srgbClr val="10B981"/>
-            </a:solidFill>
-          </a:ln>
-        </p:spPr>
-        <p:style>
-          <a:lnRef idx="1">
-            <a:schemeClr val="accent1"/>
-          </a:lnRef>
-          <a:fillRef idx="3">
-            <a:schemeClr val="accent1"/>
-          </a:fillRef>
-          <a:effectRef idx="2">
-            <a:schemeClr val="accent1"/>
-          </a:effectRef>
-          <a:fontRef idx="minor">
-            <a:schemeClr val="lt1"/>
-          </a:fontRef>
-        </p:style>
-        <p:txBody>
-          <a:bodyPr rtlCol="0" anchor="ctr"/>
-          <a:lstStyle/>
-          <a:p>
-            <a:pPr algn="ctr"/>
-          </a:p>
-        </p:txBody>
-      </p:sp>
-      <p:sp>
-        <p:nvSpPr>
-          <p:cNvPr id="9" name="TextBox 8"/>
-          <p:cNvSpPr txBox="1"/>
-          <p:nvPr/>
-        </p:nvSpPr>
-        <p:spPr>
-          <a:xfrm>
-            <a:off x="6400800" y="2148840"/>
-            <a:ext cx="4937760" cy="4114800"/>
-          </a:xfrm>
-          <a:prstGeom prst="rect">
-            <a:avLst/>
-          </a:prstGeom>
-          <a:noFill/>
-        </p:spPr>
-        <p:txBody>
-          <a:bodyPr wrap="square">
-            <a:spAutoFit/>
-          </a:bodyPr>
-          <a:lstStyle/>
-          <a:p>
-            <a:pPr>
-              <a:spcAft>
-                <a:spcPts val="1200"/>
-              </a:spcAft>
-              <a:defRPr sz="2300" b="1">
-                <a:solidFill>
-                  <a:srgbClr val="10B981"/>
-                </a:solidFill>
-                <a:latin typeface="Inter"/>
-              </a:defRPr>
-            </a:pPr>
-            <a:r>
-              <a:t>📋 Disiplina e Kufijve të Projektit (Scope)</a:t>
-            </a:r>
-          </a:p>
-          <a:p>
-            <a:pPr>
-              <a:spcAft>
-                <a:spcPts val="1000"/>
-              </a:spcAft>
-              <a:defRPr sz="1700">
-                <a:solidFill>
-                  <a:srgbClr val="E2E8F0"/>
-                </a:solidFill>
-                <a:latin typeface="Inter"/>
-              </a:defRPr>
-            </a:pPr>
-            <a:r>
-              <a:t>• Aktorët e Qartë: Shoferi që poston udhëtimin dhe Udhëtari që rezervon vendin.</a:t>
-            </a:r>
-          </a:p>
-          <a:p>
-            <a:pPr>
-              <a:spcAft>
-                <a:spcPts val="1000"/>
-              </a:spcAft>
-              <a:defRPr sz="1700">
-                <a:solidFill>
-                  <a:srgbClr val="E2E8F0"/>
-                </a:solidFill>
-                <a:latin typeface="Inter"/>
-              </a:defRPr>
-            </a:pPr>
-            <a:r>
-              <a:t>• Kërkesat Must-Have (MVP): Postimi me 3 fusha, filtrimi sipas qytetit, rezervimi me 1-prekje, koordinimi në WhatsApp, dhe kyçja me @universitetiaab.com.</a:t>
-            </a:r>
-          </a:p>
-          <a:p>
-            <a:pPr>
-              <a:spcAft>
-                <a:spcPts val="1000"/>
-              </a:spcAft>
-              <a:defRPr sz="1700">
-                <a:solidFill>
-                  <a:srgbClr val="E2E8F0"/>
-                </a:solidFill>
-                <a:latin typeface="Inter"/>
-              </a:defRPr>
-            </a:pPr>
-            <a:r>
-              <a:t>• Kufijtë Out-of-Scope (Çfarë NUK Bëjmë): JO pagesa me kartela (ndarja e parave bëhet kesh në makinë), JO GPS tracking kompleks satelitor.</a:t>
-            </a:r>
-          </a:p>
-          <a:p>
-            <a:pPr>
-              <a:spcAft>
-                <a:spcPts val="1000"/>
-              </a:spcAft>
-              <a:defRPr sz="1700">
-                <a:solidFill>
-                  <a:srgbClr val="E2E8F0"/>
-                </a:solidFill>
-                <a:latin typeface="Inter"/>
-              </a:defRPr>
-            </a:pPr>
-            <a:r>
-              <a:t>• Mësimi për Themeluesit: 80% e projekteve studentore dështojnë nga 'Scope Creep' (fryrja e kërkesave). Ne ndërtojmë një bërthamë të hekurt që funksionon 100%!</a:t>
-            </a:r>
-          </a:p>
-        </p:txBody>
-      </p:sp>
     </p:spTree>
   </p:cSld>
   <p:clrMapOvr>
@@ -11193,8 +10897,8 @@
         </p:nvSpPr>
         <p:spPr>
           <a:xfrm>
-            <a:off x="731520" y="1965960"/>
-            <a:ext cx="5303520" cy="4480560"/>
+            <a:off x="731520" y="1874519"/>
+            <a:ext cx="10728655" cy="4663440"/>
           </a:xfrm>
           <a:prstGeom prst="roundRect">
             <a:avLst/>
@@ -11232,7 +10936,7 @@
       </p:sp>
       <p:pic>
         <p:nvPicPr>
-          <p:cNvPr id="7" name="Picture 6" descr="slide5_sketch_arkitektura_blloqet.png"/>
+          <p:cNvPr id="7" name="Picture 6" descr="slide5_sketch_architecture_master.png"/>
           <p:cNvPicPr>
             <a:picLocks noChangeAspect="1"/>
           </p:cNvPicPr>
@@ -11246,162 +10950,14 @@
         </p:blipFill>
         <p:spPr>
           <a:xfrm>
-            <a:off x="777240" y="2011680"/>
-            <a:ext cx="5212080" cy="4389120"/>
+            <a:off x="777240" y="1920240"/>
+            <a:ext cx="10637215" cy="4572000"/>
           </a:xfrm>
           <a:prstGeom prst="rect">
             <a:avLst/>
           </a:prstGeom>
         </p:spPr>
       </p:pic>
-      <p:sp>
-        <p:nvSpPr>
-          <p:cNvPr id="8" name="Rounded Rectangle 7"/>
-          <p:cNvSpPr/>
-          <p:nvPr/>
-        </p:nvSpPr>
-        <p:spPr>
-          <a:xfrm>
-            <a:off x="6217920" y="1965960"/>
-            <a:ext cx="5303520" cy="4480560"/>
-          </a:xfrm>
-          <a:prstGeom prst="roundRect">
-            <a:avLst/>
-          </a:prstGeom>
-          <a:solidFill>
-            <a:srgbClr val="141E34"/>
-          </a:solidFill>
-          <a:ln w="31750">
-            <a:solidFill>
-              <a:srgbClr val="38BDF8"/>
-            </a:solidFill>
-          </a:ln>
-        </p:spPr>
-        <p:style>
-          <a:lnRef idx="1">
-            <a:schemeClr val="accent1"/>
-          </a:lnRef>
-          <a:fillRef idx="3">
-            <a:schemeClr val="accent1"/>
-          </a:fillRef>
-          <a:effectRef idx="2">
-            <a:schemeClr val="accent1"/>
-          </a:effectRef>
-          <a:fontRef idx="minor">
-            <a:schemeClr val="lt1"/>
-          </a:fontRef>
-        </p:style>
-        <p:txBody>
-          <a:bodyPr rtlCol="0" anchor="ctr"/>
-          <a:lstStyle/>
-          <a:p>
-            <a:pPr algn="ctr"/>
-          </a:p>
-        </p:txBody>
-      </p:sp>
-      <p:sp>
-        <p:nvSpPr>
-          <p:cNvPr id="9" name="TextBox 8"/>
-          <p:cNvSpPr txBox="1"/>
-          <p:nvPr/>
-        </p:nvSpPr>
-        <p:spPr>
-          <a:xfrm>
-            <a:off x="6400800" y="2148840"/>
-            <a:ext cx="4937760" cy="4114800"/>
-          </a:xfrm>
-          <a:prstGeom prst="rect">
-            <a:avLst/>
-          </a:prstGeom>
-          <a:noFill/>
-        </p:spPr>
-        <p:txBody>
-          <a:bodyPr wrap="square">
-            <a:spAutoFit/>
-          </a:bodyPr>
-          <a:lstStyle/>
-          <a:p>
-            <a:pPr>
-              <a:spcAft>
-                <a:spcPts val="1200"/>
-              </a:spcAft>
-              <a:defRPr sz="2300" b="1">
-                <a:solidFill>
-                  <a:srgbClr val="38BDF8"/>
-                </a:solidFill>
-                <a:latin typeface="Inter"/>
-              </a:defRPr>
-            </a:pPr>
-            <a:r>
-              <a:t>🏛️ 3 Blloqet Kryesore të Arkitekturës</a:t>
-            </a:r>
-          </a:p>
-          <a:p>
-            <a:pPr>
-              <a:spcAft>
-                <a:spcPts val="1000"/>
-              </a:spcAft>
-              <a:defRPr sz="1700">
-                <a:solidFill>
-                  <a:srgbClr val="E2E8F0"/>
-                </a:solidFill>
-                <a:latin typeface="Inter"/>
-              </a:defRPr>
-            </a:pPr>
-            <a:r>
-              <a:t>• 1. Klienti Mobile (PWA): Ndërtuar me Next.js 15 dhe Tailwind CSS. Butona me sipërfaqe prekjeje 48px. Service Worker për shpejtësi dhe mbështetje offline.</a:t>
-            </a:r>
-          </a:p>
-          <a:p>
-            <a:pPr>
-              <a:spcAft>
-                <a:spcPts val="1000"/>
-              </a:spcAft>
-              <a:defRPr sz="1700">
-                <a:solidFill>
-                  <a:srgbClr val="E2E8F0"/>
-                </a:solidFill>
-                <a:latin typeface="Inter"/>
-              </a:defRPr>
-            </a:pPr>
-            <a:r>
-              <a:t>• 2. Baza &amp; Siguria (Supabase): Tabela relacionale 'rides' (shoferi, nisja, ora, vendet) dhe 'bookings'. Realtime engine që zbret vendet e lira menjëherë pa rifreskuar faqen.</a:t>
-            </a:r>
-          </a:p>
-          <a:p>
-            <a:pPr>
-              <a:spcAft>
-                <a:spcPts val="1000"/>
-              </a:spcAft>
-              <a:defRPr sz="1700">
-                <a:solidFill>
-                  <a:srgbClr val="E2E8F0"/>
-                </a:solidFill>
-                <a:latin typeface="Inter"/>
-              </a:defRPr>
-            </a:pPr>
-            <a:r>
-              <a:t>• 3. Lidhja e Jashtme (WhatsApp): Deep link 'wa.me' që lidh shoferin dhe pasagjerin për pikën e takimit.</a:t>
-            </a:r>
-          </a:p>
-          <a:p>
-            <a:pPr>
-              <a:spcAft>
-                <a:spcPts val="1000"/>
-              </a:spcAft>
-              <a:defRPr sz="1700">
-                <a:solidFill>
-                  <a:srgbClr val="E2E8F0"/>
-                </a:solidFill>
-                <a:latin typeface="Inter"/>
-              </a:defRPr>
-            </a:pPr>
-            <a:r>
-              <a:t>• Pse Kjo Arkitekturë? Ndërtim modular: PWA bën menaxhimin e të dhënave, Supabase garanton besueshmërinë, WhatsApp koordinimin live!</a:t>
-            </a:r>
-          </a:p>
-        </p:txBody>
-      </p:sp>
     </p:spTree>
   </p:cSld>
   <p:clrMapOvr>
@@ -11579,8 +11135,8 @@
         </p:nvSpPr>
         <p:spPr>
           <a:xfrm>
-            <a:off x="731520" y="1965960"/>
-            <a:ext cx="5303520" cy="4480560"/>
+            <a:off x="731520" y="1874519"/>
+            <a:ext cx="10728655" cy="4663440"/>
           </a:xfrm>
           <a:prstGeom prst="roundRect">
             <a:avLst/>
@@ -11618,7 +11174,7 @@
       </p:sp>
       <p:pic>
         <p:nvPicPr>
-          <p:cNvPr id="7" name="Picture 6" descr="slide6_sketch_vijueshmeria_ndertimi.png"/>
+          <p:cNvPr id="7" name="Picture 6" descr="slide6_sketch_roadmap_master.png"/>
           <p:cNvPicPr>
             <a:picLocks noChangeAspect="1"/>
           </p:cNvPicPr>
@@ -11632,178 +11188,14 @@
         </p:blipFill>
         <p:spPr>
           <a:xfrm>
-            <a:off x="777240" y="2011680"/>
-            <a:ext cx="5212080" cy="4389120"/>
+            <a:off x="777240" y="1920240"/>
+            <a:ext cx="10637215" cy="4572000"/>
           </a:xfrm>
           <a:prstGeom prst="rect">
             <a:avLst/>
           </a:prstGeom>
         </p:spPr>
       </p:pic>
-      <p:sp>
-        <p:nvSpPr>
-          <p:cNvPr id="8" name="Rounded Rectangle 7"/>
-          <p:cNvSpPr/>
-          <p:nvPr/>
-        </p:nvSpPr>
-        <p:spPr>
-          <a:xfrm>
-            <a:off x="6217920" y="1965960"/>
-            <a:ext cx="5303520" cy="4480560"/>
-          </a:xfrm>
-          <a:prstGeom prst="roundRect">
-            <a:avLst/>
-          </a:prstGeom>
-          <a:solidFill>
-            <a:srgbClr val="141E34"/>
-          </a:solidFill>
-          <a:ln w="31750">
-            <a:solidFill>
-              <a:srgbClr val="F59E0B"/>
-            </a:solidFill>
-          </a:ln>
-        </p:spPr>
-        <p:style>
-          <a:lnRef idx="1">
-            <a:schemeClr val="accent1"/>
-          </a:lnRef>
-          <a:fillRef idx="3">
-            <a:schemeClr val="accent1"/>
-          </a:fillRef>
-          <a:effectRef idx="2">
-            <a:schemeClr val="accent1"/>
-          </a:effectRef>
-          <a:fontRef idx="minor">
-            <a:schemeClr val="lt1"/>
-          </a:fontRef>
-        </p:style>
-        <p:txBody>
-          <a:bodyPr rtlCol="0" anchor="ctr"/>
-          <a:lstStyle/>
-          <a:p>
-            <a:pPr algn="ctr"/>
-          </a:p>
-        </p:txBody>
-      </p:sp>
-      <p:sp>
-        <p:nvSpPr>
-          <p:cNvPr id="9" name="TextBox 8"/>
-          <p:cNvSpPr txBox="1"/>
-          <p:nvPr/>
-        </p:nvSpPr>
-        <p:spPr>
-          <a:xfrm>
-            <a:off x="6400800" y="2148840"/>
-            <a:ext cx="4937760" cy="4114800"/>
-          </a:xfrm>
-          <a:prstGeom prst="rect">
-            <a:avLst/>
-          </a:prstGeom>
-          <a:noFill/>
-        </p:spPr>
-        <p:txBody>
-          <a:bodyPr wrap="square">
-            <a:spAutoFit/>
-          </a:bodyPr>
-          <a:lstStyle/>
-          <a:p>
-            <a:pPr>
-              <a:spcAft>
-                <a:spcPts val="1200"/>
-              </a:spcAft>
-              <a:defRPr sz="2300" b="1">
-                <a:solidFill>
-                  <a:srgbClr val="F59E0B"/>
-                </a:solidFill>
-                <a:latin typeface="Inter"/>
-              </a:defRPr>
-            </a:pPr>
-            <a:r>
-              <a:t>⏳ 'Pastaj Më Vonë Hyjmë në Ndërtim Real!'</a:t>
-            </a:r>
-          </a:p>
-          <a:p>
-            <a:pPr>
-              <a:spcAft>
-                <a:spcPts val="1000"/>
-              </a:spcAft>
-              <a:defRPr sz="1700">
-                <a:solidFill>
-                  <a:srgbClr val="E2E8F0"/>
-                </a:solidFill>
-                <a:latin typeface="Inter"/>
-              </a:defRPr>
-            </a:pPr>
-            <a:r>
-              <a:t>• Javët 1–2 (Ideja &amp; Letra): Vëzhgimi i problemit, zgjedhja e biznesit, specifikat e qarta dhe skicimi me dorë i ekraneve pa shkruar asnjë rresht kod.</a:t>
-            </a:r>
-          </a:p>
-          <a:p>
-            <a:pPr>
-              <a:spcAft>
-                <a:spcPts val="1000"/>
-              </a:spcAft>
-              <a:defRPr sz="1700">
-                <a:solidFill>
-                  <a:srgbClr val="E2E8F0"/>
-                </a:solidFill>
-                <a:latin typeface="Inter"/>
-              </a:defRPr>
-            </a:pPr>
-            <a:r>
-              <a:t>• Javët 3–5 (Dizajni i UI me Tailwind): Kthimi i skicës në faqe mobile me Tailwind CSS dhe ndihmën e GitHub Copilot.</a:t>
-            </a:r>
-          </a:p>
-          <a:p>
-            <a:pPr>
-              <a:spcAft>
-                <a:spcPts val="1000"/>
-              </a:spcAft>
-              <a:defRPr sz="1700">
-                <a:solidFill>
-                  <a:srgbClr val="E2E8F0"/>
-                </a:solidFill>
-                <a:latin typeface="Inter"/>
-              </a:defRPr>
-            </a:pPr>
-            <a:r>
-              <a:t>• Javët 6–9 (Databaza &amp; Auth): Lidhja e Supabase, krijimi i tabelave dhe sistemi i rezervimit me siguri AAB.</a:t>
-            </a:r>
-          </a:p>
-          <a:p>
-            <a:pPr>
-              <a:spcAft>
-                <a:spcPts val="1000"/>
-              </a:spcAft>
-              <a:defRPr sz="1700">
-                <a:solidFill>
-                  <a:srgbClr val="E2E8F0"/>
-                </a:solidFill>
-                <a:latin typeface="Inter"/>
-              </a:defRPr>
-            </a:pPr>
-            <a:r>
-              <a:t>• Javët 10–12 (PWA &amp; Offline): Instalimi në ekran të telefonit, manifest.json dhe sinkronizimi live.</a:t>
-            </a:r>
-          </a:p>
-          <a:p>
-            <a:pPr>
-              <a:spcAft>
-                <a:spcPts val="1000"/>
-              </a:spcAft>
-              <a:defRPr sz="1700">
-                <a:solidFill>
-                  <a:srgbClr val="E2E8F0"/>
-                </a:solidFill>
-                <a:latin typeface="Inter"/>
-              </a:defRPr>
-            </a:pPr>
-            <a:r>
-              <a:t>• Java 15 (Demo Day &amp; Suksesi): Prezantimi live nga telefoni juaj personal para komisionit dhe sallës!</a:t>
-            </a:r>
-          </a:p>
-        </p:txBody>
-      </p:sp>
     </p:spTree>
   </p:cSld>
   <p:clrMapOvr>

</xml_diff>

<commit_message>
Update Lecture 01 restaurant story
</commit_message>
<xml_diff>
--- a/Jave1_Hyrje_Nextjs_PWA_Copilot_2026.pptx
+++ b/Jave1_Hyrje_Nextjs_PWA_Copilot_2026.pptx
@@ -2,38 +2,38 @@
 <file path=ppt/presentation.xml><?xml version="1.0" encoding="utf-8"?>
 <p:presentation xmlns:p="http://schemas.openxmlformats.org/presentationml/2006/main">
   <p:sldMasterIdLst>
-    <p:sldMasterId xmlns:r="http://schemas.openxmlformats.org/officeDocument/2006/relationships" id="2147483648" r:id="R23ed594d3c874fff"/>
+    <p:sldMasterId xmlns:r="http://schemas.openxmlformats.org/officeDocument/2006/relationships" id="2147483648" r:id="Rc99adde3bfc14622"/>
   </p:sldMasterIdLst>
   <p:sldIdLst>
-    <p:sldId xmlns:r="http://schemas.openxmlformats.org/officeDocument/2006/relationships" id="256" r:id="R680531d7c8d64170"/>
-    <p:sldId xmlns:r="http://schemas.openxmlformats.org/officeDocument/2006/relationships" id="257" r:id="Rff792a8fc6b64130"/>
-    <p:sldId xmlns:r="http://schemas.openxmlformats.org/officeDocument/2006/relationships" id="258" r:id="Rec8b5cd0ac2947a1"/>
-    <p:sldId xmlns:r="http://schemas.openxmlformats.org/officeDocument/2006/relationships" id="259" r:id="Rc976631b983c4f0d"/>
-    <p:sldId xmlns:r="http://schemas.openxmlformats.org/officeDocument/2006/relationships" id="260" r:id="R6929fd60dd9e43d1"/>
-    <p:sldId xmlns:r="http://schemas.openxmlformats.org/officeDocument/2006/relationships" id="261" r:id="R95a9336130cb4c3d"/>
-    <p:sldId xmlns:r="http://schemas.openxmlformats.org/officeDocument/2006/relationships" id="262" r:id="R3ab32a06e8354b1f"/>
-    <p:sldId xmlns:r="http://schemas.openxmlformats.org/officeDocument/2006/relationships" id="263" r:id="R6fef2d2775ca4193"/>
-    <p:sldId xmlns:r="http://schemas.openxmlformats.org/officeDocument/2006/relationships" id="264" r:id="R3e7df30a18d9477c"/>
-    <p:sldId xmlns:r="http://schemas.openxmlformats.org/officeDocument/2006/relationships" id="265" r:id="Re0e13d699e0340e8"/>
-    <p:sldId xmlns:r="http://schemas.openxmlformats.org/officeDocument/2006/relationships" id="266" r:id="R61c1f25830d0435d"/>
-    <p:sldId xmlns:r="http://schemas.openxmlformats.org/officeDocument/2006/relationships" id="267" r:id="R6119d367e4b04c54"/>
-    <p:sldId xmlns:r="http://schemas.openxmlformats.org/officeDocument/2006/relationships" id="268" r:id="R59b8de1e50604a3c"/>
-    <p:sldId xmlns:r="http://schemas.openxmlformats.org/officeDocument/2006/relationships" id="269" r:id="R7fa0640df4204a27"/>
-    <p:sldId xmlns:r="http://schemas.openxmlformats.org/officeDocument/2006/relationships" id="270" r:id="Rd9b32368748c4db5"/>
-    <p:sldId xmlns:r="http://schemas.openxmlformats.org/officeDocument/2006/relationships" id="271" r:id="R182f79178dae4434"/>
-    <p:sldId xmlns:r="http://schemas.openxmlformats.org/officeDocument/2006/relationships" id="272" r:id="Rd5de8247305f487e"/>
-    <p:sldId xmlns:r="http://schemas.openxmlformats.org/officeDocument/2006/relationships" id="273" r:id="R858f6b8de79542ac"/>
-    <p:sldId xmlns:r="http://schemas.openxmlformats.org/officeDocument/2006/relationships" id="274" r:id="Rab9e0b49b5a244ce"/>
-    <p:sldId xmlns:r="http://schemas.openxmlformats.org/officeDocument/2006/relationships" id="275" r:id="Rd7b1e3376daf4253"/>
-    <p:sldId xmlns:r="http://schemas.openxmlformats.org/officeDocument/2006/relationships" id="276" r:id="R94e51465628e403b"/>
-    <p:sldId xmlns:r="http://schemas.openxmlformats.org/officeDocument/2006/relationships" id="277" r:id="Refbbdaebd851445d"/>
-    <p:sldId xmlns:r="http://schemas.openxmlformats.org/officeDocument/2006/relationships" id="278" r:id="R7fe04622b0274ac7"/>
-    <p:sldId xmlns:r="http://schemas.openxmlformats.org/officeDocument/2006/relationships" id="279" r:id="R721e7f2c1b9a438b"/>
-    <p:sldId xmlns:r="http://schemas.openxmlformats.org/officeDocument/2006/relationships" id="280" r:id="Rb9529caa9c6c457e"/>
-    <p:sldId xmlns:r="http://schemas.openxmlformats.org/officeDocument/2006/relationships" id="281" r:id="Rffe8cf25171c4459"/>
-    <p:sldId xmlns:r="http://schemas.openxmlformats.org/officeDocument/2006/relationships" id="282" r:id="R72c4436e3bd14980"/>
-    <p:sldId xmlns:r="http://schemas.openxmlformats.org/officeDocument/2006/relationships" id="283" r:id="R9d46f5b0ad4e4755"/>
-    <p:sldId xmlns:r="http://schemas.openxmlformats.org/officeDocument/2006/relationships" id="284" r:id="R7279bdfd901941c7"/>
+    <p:sldId xmlns:r="http://schemas.openxmlformats.org/officeDocument/2006/relationships" id="256" r:id="Rb5df68abbea24449"/>
+    <p:sldId xmlns:r="http://schemas.openxmlformats.org/officeDocument/2006/relationships" id="257" r:id="R86c224ac868e48eb"/>
+    <p:sldId xmlns:r="http://schemas.openxmlformats.org/officeDocument/2006/relationships" id="258" r:id="R37209b7858ab46e6"/>
+    <p:sldId xmlns:r="http://schemas.openxmlformats.org/officeDocument/2006/relationships" id="259" r:id="Re5bd5dfdac8c455d"/>
+    <p:sldId xmlns:r="http://schemas.openxmlformats.org/officeDocument/2006/relationships" id="260" r:id="Recc37fcd10e145d6"/>
+    <p:sldId xmlns:r="http://schemas.openxmlformats.org/officeDocument/2006/relationships" id="261" r:id="R3476c86ecbe34502"/>
+    <p:sldId xmlns:r="http://schemas.openxmlformats.org/officeDocument/2006/relationships" id="262" r:id="R750be0211a7e446a"/>
+    <p:sldId xmlns:r="http://schemas.openxmlformats.org/officeDocument/2006/relationships" id="263" r:id="Rf90f3b8d0f254776"/>
+    <p:sldId xmlns:r="http://schemas.openxmlformats.org/officeDocument/2006/relationships" id="264" r:id="R7d944e5f17d1446f"/>
+    <p:sldId xmlns:r="http://schemas.openxmlformats.org/officeDocument/2006/relationships" id="265" r:id="Rad4d5a38425f4841"/>
+    <p:sldId xmlns:r="http://schemas.openxmlformats.org/officeDocument/2006/relationships" id="266" r:id="Rbd25cf0e5e7e4554"/>
+    <p:sldId xmlns:r="http://schemas.openxmlformats.org/officeDocument/2006/relationships" id="267" r:id="Rd8d1b97dad5c49ef"/>
+    <p:sldId xmlns:r="http://schemas.openxmlformats.org/officeDocument/2006/relationships" id="268" r:id="Ra737bd6e2122458e"/>
+    <p:sldId xmlns:r="http://schemas.openxmlformats.org/officeDocument/2006/relationships" id="269" r:id="Re69ec57bea594eb5"/>
+    <p:sldId xmlns:r="http://schemas.openxmlformats.org/officeDocument/2006/relationships" id="270" r:id="R8dbbc04a46934b70"/>
+    <p:sldId xmlns:r="http://schemas.openxmlformats.org/officeDocument/2006/relationships" id="271" r:id="Rbe785212417d4332"/>
+    <p:sldId xmlns:r="http://schemas.openxmlformats.org/officeDocument/2006/relationships" id="272" r:id="R30bccf968651423e"/>
+    <p:sldId xmlns:r="http://schemas.openxmlformats.org/officeDocument/2006/relationships" id="273" r:id="R603cf261503644fe"/>
+    <p:sldId xmlns:r="http://schemas.openxmlformats.org/officeDocument/2006/relationships" id="274" r:id="R94e32af86b9d4c15"/>
+    <p:sldId xmlns:r="http://schemas.openxmlformats.org/officeDocument/2006/relationships" id="275" r:id="R2caa62c305164714"/>
+    <p:sldId xmlns:r="http://schemas.openxmlformats.org/officeDocument/2006/relationships" id="276" r:id="R59146143671e4904"/>
+    <p:sldId xmlns:r="http://schemas.openxmlformats.org/officeDocument/2006/relationships" id="277" r:id="R1ad8cb1a710749d8"/>
+    <p:sldId xmlns:r="http://schemas.openxmlformats.org/officeDocument/2006/relationships" id="278" r:id="R98c64833e7f8403c"/>
+    <p:sldId xmlns:r="http://schemas.openxmlformats.org/officeDocument/2006/relationships" id="279" r:id="Rb671e5fffa54461b"/>
+    <p:sldId xmlns:r="http://schemas.openxmlformats.org/officeDocument/2006/relationships" id="280" r:id="Re1bfb3773799448a"/>
+    <p:sldId xmlns:r="http://schemas.openxmlformats.org/officeDocument/2006/relationships" id="281" r:id="Rdad9ac7bbda645b4"/>
+    <p:sldId xmlns:r="http://schemas.openxmlformats.org/officeDocument/2006/relationships" id="282" r:id="Rd5ee2c84e0c14d05"/>
+    <p:sldId xmlns:r="http://schemas.openxmlformats.org/officeDocument/2006/relationships" id="283" r:id="R0d6e04e5c347457d"/>
+    <p:sldId xmlns:r="http://schemas.openxmlformats.org/officeDocument/2006/relationships" id="284" r:id="R7248704c773b4eb4"/>
   </p:sldIdLst>
   <p:sldSz cx="12192000" cy="6858000"/>
   <p:notesSz cx="6858000" cy="9144000"/>
@@ -78,7 +78,7 @@
   </p:cSld>
   <p:clrMap bg1="lt1" tx1="dk1" bg2="lt2" tx2="dk2" accent1="accent1" accent2="accent2" accent3="accent3" accent4="accent4" accent5="accent5" accent6="accent6" hlink="hlink" folHlink="folHlink"/>
   <p:sldLayoutIdLst>
-    <p:sldLayoutId xmlns:r="http://schemas.openxmlformats.org/officeDocument/2006/relationships" id="2147483649" r:id="R0754685b2e434198"/>
+    <p:sldLayoutId xmlns:r="http://schemas.openxmlformats.org/officeDocument/2006/relationships" id="2147483649" r:id="Rfe6a5ccf7b13489a"/>
   </p:sldLayoutIdLst>
   <p:txStyles>
     <p:titleStyle>
@@ -1094,7 +1094,7 @@
                 <a:ea typeface="Helvetica Neue"/>
                 <a:cs typeface="Helvetica Neue"/>
               </a:rPr>
-              <a:t>Një aplikacion për një biznes real.</a:t>
+              <a:t>Projekti juaj: aplikacion për një biznes real.</a:t>
             </a:r>
           </a:p>
         </p:txBody>
@@ -1448,7 +1448,7 @@
                 <a:ea typeface="Helvetica Neue"/>
                 <a:cs typeface="Helvetica Neue"/>
               </a:rPr>
-              <a:t>AAB RideShare</a:t>
+              <a:t>Restoranti “Sofra”</a:t>
             </a:r>
           </a:p>
         </p:txBody>
@@ -1506,31 +1506,7 @@
                 <a:ea typeface="Helvetica Neue"/>
                 <a:cs typeface="Helvetica Neue"/>
               </a:rPr>
-              <a:t>Fushë Kosovë</a:t>
-            </a:r>
-          </a:p>
-          <a:p xmlns:a="http://schemas.openxmlformats.org/drawingml/2006/main">
-            <a:pPr algn="l">
-              <a:buNone/>
-              <a:defRPr sz="2550" b="1">
-                <a:solidFill>
-                  <a:srgbClr val="F4F2EC"/>
-                </a:solidFill>
-                <a:latin typeface="Helvetica Neue"/>
-                <a:ea typeface="Helvetica Neue"/>
-                <a:cs typeface="Helvetica Neue"/>
-              </a:defRPr>
-            </a:pPr>
-            <a:r>
-              <a:rPr sz="2550" b="1">
-                <a:solidFill>
-                  <a:srgbClr val="F4F2EC"/>
-                </a:solidFill>
-                <a:latin typeface="Helvetica Neue"/>
-                <a:ea typeface="Helvetica Neue"/>
-                <a:cs typeface="Helvetica Neue"/>
-              </a:rPr>
-              <a:t>Kampus</a:t>
+              <a:t>A mund të porosis?</a:t>
             </a:r>
           </a:p>
         </p:txBody>
@@ -1570,25 +1546,25 @@
           <a:p xmlns:a="http://schemas.openxmlformats.org/drawingml/2006/main">
             <a:pPr algn="l">
               <a:buNone/>
-              <a:defRPr sz="3450" b="1">
-                <a:solidFill>
-                  <a:srgbClr val="F4F2EC"/>
-                </a:solidFill>
-                <a:latin typeface="Helvetica Neue"/>
-                <a:ea typeface="Helvetica Neue"/>
-                <a:cs typeface="Helvetica Neue"/>
-              </a:defRPr>
-            </a:pPr>
-            <a:r>
-              <a:rPr sz="3450" b="1">
-                <a:solidFill>
-                  <a:srgbClr val="F4F2EC"/>
-                </a:solidFill>
-                <a:latin typeface="Helvetica Neue"/>
-                <a:ea typeface="Helvetica Neue"/>
-                <a:cs typeface="Helvetica Neue"/>
-              </a:rPr>
-              <a:t>07:30</a:t>
+              <a:defRPr sz="1875" b="1">
+                <a:solidFill>
+                  <a:srgbClr val="F5F7F9"/>
+                </a:solidFill>
+                <a:latin typeface="Helvetica Neue"/>
+                <a:ea typeface="Helvetica Neue"/>
+                <a:cs typeface="Helvetica Neue"/>
+              </a:defRPr>
+            </a:pPr>
+            <a:r>
+              <a:rPr sz="1875" b="1">
+                <a:solidFill>
+                  <a:srgbClr val="F5F7F9"/>
+                </a:solidFill>
+                <a:latin typeface="Helvetica Neue"/>
+                <a:ea typeface="Helvetica Neue"/>
+                <a:cs typeface="Helvetica Neue"/>
+              </a:rPr>
+              <a:t>Tavë shtëpie</a:t>
             </a:r>
           </a:p>
         </p:txBody>
@@ -1646,7 +1622,7 @@
                 <a:ea typeface="Helvetica Neue"/>
                 <a:cs typeface="Helvetica Neue"/>
               </a:rPr>
-              <a:t>1 vend i lirë</a:t>
+              <a:t>Sasia: 1</a:t>
             </a:r>
           </a:p>
         </p:txBody>
@@ -1736,7 +1712,7 @@
                 <a:ea typeface="Helvetica Neue"/>
                 <a:cs typeface="Helvetica Neue"/>
               </a:rPr>
-              <a:t>Kërko vend</a:t>
+              <a:t>Porosit</a:t>
             </a:r>
           </a:p>
         </p:txBody>
@@ -1750,7 +1726,7 @@
           <p:nvPr/>
         </p:nvPicPr>
         <p:blipFill>
-          <a:blip xmlns:r="http://schemas.openxmlformats.org/officeDocument/2006/relationships" xmlns:a="http://schemas.openxmlformats.org/drawingml/2006/main" r:embed="Ra243a7a739104693"/>
+          <a:blip xmlns:r="http://schemas.openxmlformats.org/officeDocument/2006/relationships" xmlns:a="http://schemas.openxmlformats.org/drawingml/2006/main" r:embed="R59a4256bbe014b77"/>
           <a:stretch xmlns:a="http://schemas.openxmlformats.org/drawingml/2006/main"/>
         </p:blipFill>
         <p:spPr>
@@ -1975,7 +1951,7 @@
           <p:nvPr/>
         </p:nvPicPr>
         <p:blipFill>
-          <a:blip xmlns:r="http://schemas.openxmlformats.org/officeDocument/2006/relationships" xmlns:a="http://schemas.openxmlformats.org/drawingml/2006/main" r:embed="R9774eb9d87664a5a"/>
+          <a:blip xmlns:r="http://schemas.openxmlformats.org/officeDocument/2006/relationships" xmlns:a="http://schemas.openxmlformats.org/drawingml/2006/main" r:embed="R2a57d42d75f04264"/>
           <a:stretch xmlns:a="http://schemas.openxmlformats.org/drawingml/2006/main"/>
         </p:blipFill>
         <p:spPr>
@@ -2277,7 +2253,7 @@
           <p:nvPr/>
         </p:nvPicPr>
         <p:blipFill>
-          <a:blip xmlns:r="http://schemas.openxmlformats.org/officeDocument/2006/relationships" xmlns:a="http://schemas.openxmlformats.org/drawingml/2006/main" r:embed="Rba131908bd9f48cd"/>
+          <a:blip xmlns:r="http://schemas.openxmlformats.org/officeDocument/2006/relationships" xmlns:a="http://schemas.openxmlformats.org/drawingml/2006/main" r:embed="R19f3b7d3891a4672"/>
           <a:stretch xmlns:a="http://schemas.openxmlformats.org/drawingml/2006/main"/>
         </p:blipFill>
         <p:spPr>
@@ -3624,7 +3600,7 @@
                 <a:ea typeface="Helvetica Neue"/>
                 <a:cs typeface="Helvetica Neue"/>
               </a:rPr>
-              <a:t>Çfarë prove keni përtej miratimit verbal?</a:t>
+              <a:t>Çfarë prove tregon se porosia u mor dhe nuk u dyfishua?</a:t>
             </a:r>
           </a:p>
         </p:txBody>
@@ -3638,7 +3614,7 @@
           <p:nvPr/>
         </p:nvPicPr>
         <p:blipFill>
-          <a:blip xmlns:r="http://schemas.openxmlformats.org/officeDocument/2006/relationships" xmlns:a="http://schemas.openxmlformats.org/drawingml/2006/main" r:embed="R51bef60c1719491a"/>
+          <a:blip xmlns:r="http://schemas.openxmlformats.org/officeDocument/2006/relationships" xmlns:a="http://schemas.openxmlformats.org/drawingml/2006/main" r:embed="Re39faa6fb8f0409c"/>
           <a:stretch xmlns:a="http://schemas.openxmlformats.org/drawingml/2006/main"/>
         </p:blipFill>
         <p:spPr>
@@ -3849,7 +3825,7 @@
                 <a:ea typeface="Helvetica Neue"/>
                 <a:cs typeface="Helvetica Neue"/>
               </a:rPr>
-              <a:t>07:20. Ende pa konfirmim</a:t>
+              <a:t>11:45. Ende pa konfirmim</a:t>
             </a:r>
           </a:p>
         </p:txBody>
@@ -3941,7 +3917,7 @@
                 <a:ea typeface="Helvetica Neue"/>
                 <a:cs typeface="Helvetica Neue"/>
               </a:rPr>
-              <a:t>Prishtinë</a:t>
+              <a:t>Telefoni</a:t>
             </a:r>
           </a:p>
         </p:txBody>
@@ -4033,7 +4009,7 @@
                 <a:ea typeface="Helvetica Neue"/>
                 <a:cs typeface="Helvetica Neue"/>
               </a:rPr>
-              <a:t>Fushë Kosovë</a:t>
+              <a:t>Instagram</a:t>
             </a:r>
           </a:p>
         </p:txBody>
@@ -4125,7 +4101,7 @@
                 <a:ea typeface="Helvetica Neue"/>
                 <a:cs typeface="Helvetica Neue"/>
               </a:rPr>
-              <a:t>Kampus</a:t>
+              <a:t>Restoranti</a:t>
             </a:r>
           </a:p>
         </p:txBody>
@@ -4243,7 +4219,7 @@
                 <a:ea typeface="Helvetica Neue"/>
                 <a:cs typeface="Helvetica Neue"/>
               </a:rPr>
-              <a:t>Kërkim</a:t>
+              <a:t>Konsumatori</a:t>
             </a:r>
           </a:p>
         </p:txBody>
@@ -4301,7 +4277,7 @@
                 <a:ea typeface="Helvetica Neue"/>
                 <a:cs typeface="Helvetica Neue"/>
               </a:rPr>
-              <a:t>Mesazh</a:t>
+              <a:t>Mesazhi</a:t>
             </a:r>
           </a:p>
         </p:txBody>
@@ -4359,7 +4335,7 @@
                 <a:ea typeface="Helvetica Neue"/>
                 <a:cs typeface="Helvetica Neue"/>
               </a:rPr>
-              <a:t>Pritje</a:t>
+              <a:t>Pa përgjigje</a:t>
             </a:r>
           </a:p>
         </p:txBody>
@@ -4417,7 +4393,7 @@
                 <a:ea typeface="Helvetica Neue"/>
                 <a:cs typeface="Helvetica Neue"/>
               </a:rPr>
-              <a:t>Nisje</a:t>
+              <a:t>Porosia?</a:t>
             </a:r>
           </a:p>
         </p:txBody>
@@ -4535,7 +4511,7 @@
                 <a:ea typeface="Helvetica Neue"/>
                 <a:cs typeface="Helvetica Neue"/>
               </a:rPr>
-              <a:t>Pasiguria ka kosto</a:t>
+              <a:t>A u pranua porosia?</a:t>
             </a:r>
           </a:p>
         </p:txBody>
@@ -4607,7 +4583,7 @@
           <p:nvPr/>
         </p:nvPicPr>
         <p:blipFill>
-          <a:blip xmlns:r="http://schemas.openxmlformats.org/officeDocument/2006/relationships" xmlns:a="http://schemas.openxmlformats.org/drawingml/2006/main" r:embed="R968fcfa1e2c24eaf"/>
+          <a:blip xmlns:r="http://schemas.openxmlformats.org/officeDocument/2006/relationships" xmlns:a="http://schemas.openxmlformats.org/drawingml/2006/main" r:embed="Rd238091616dc4dc1"/>
           <a:stretch xmlns:a="http://schemas.openxmlformats.org/drawingml/2006/main"/>
         </p:blipFill>
         <p:spPr>
@@ -4818,7 +4794,7 @@
                 <a:ea typeface="Helvetica Neue"/>
                 <a:cs typeface="Helvetica Neue"/>
               </a:rPr>
-              <a:t>Mesazhi nuk është rezervim</a:t>
+              <a:t>Mesazhi nuk është porosi</a:t>
             </a:r>
           </a:p>
         </p:txBody>
@@ -4966,7 +4942,7 @@
                 <a:ea typeface="Helvetica Neue"/>
                 <a:cs typeface="Helvetica Neue"/>
               </a:rPr>
-              <a:t>Kam një vend.</a:t>
+              <a:t>Dua një porosi.</a:t>
             </a:r>
           </a:p>
         </p:txBody>
@@ -5056,7 +5032,7 @@
                 <a:ea typeface="Helvetica Neue"/>
                 <a:cs typeface="Helvetica Neue"/>
               </a:rPr>
-              <a:t>Vij unë.</a:t>
+              <a:t>Cilin vakt?</a:t>
             </a:r>
           </a:p>
         </p:txBody>
@@ -5146,7 +5122,7 @@
                 <a:ea typeface="Helvetica Neue"/>
                 <a:cs typeface="Helvetica Neue"/>
               </a:rPr>
-              <a:t>A është ende?</a:t>
+              <a:t>Për katër veta.</a:t>
             </a:r>
           </a:p>
         </p:txBody>
@@ -5236,7 +5212,7 @@
                 <a:ea typeface="Helvetica Neue"/>
                 <a:cs typeface="Helvetica Neue"/>
               </a:rPr>
-              <a:t>U nisët?</a:t>
+              <a:t>Në cilën adresë?</a:t>
             </a:r>
           </a:p>
         </p:txBody>
@@ -5294,7 +5270,7 @@
                 <a:ea typeface="Helvetica Neue"/>
                 <a:cs typeface="Helvetica Neue"/>
               </a:rPr>
-              <a:t>Gjendja e kërkesës</a:t>
+              <a:t>Të dhënat që mungojnë</a:t>
             </a:r>
           </a:p>
         </p:txBody>
@@ -5410,7 +5386,7 @@
                 <a:ea typeface="Helvetica Neue"/>
                 <a:cs typeface="Helvetica Neue"/>
               </a:rPr>
-              <a:t>Kërkuar</a:t>
+              <a:t>Vakti</a:t>
             </a:r>
           </a:p>
         </p:txBody>
@@ -5526,7 +5502,7 @@
                 <a:ea typeface="Helvetica Neue"/>
                 <a:cs typeface="Helvetica Neue"/>
               </a:rPr>
-              <a:t>Pranuar</a:t>
+              <a:t>Sasia</a:t>
             </a:r>
           </a:p>
         </p:txBody>
@@ -5642,7 +5618,7 @@
                 <a:ea typeface="Helvetica Neue"/>
                 <a:cs typeface="Helvetica Neue"/>
               </a:rPr>
-              <a:t>Refuzuar</a:t>
+              <a:t>Adresa</a:t>
             </a:r>
           </a:p>
         </p:txBody>
@@ -5700,7 +5676,7 @@
                 <a:ea typeface="Helvetica Neue"/>
                 <a:cs typeface="Helvetica Neue"/>
               </a:rPr>
-              <a:t>Kush e ka vendin?</a:t>
+              <a:t>Statusi: a u pranua porosia?</a:t>
             </a:r>
           </a:p>
         </p:txBody>
@@ -5714,7 +5690,7 @@
           <p:nvPr/>
         </p:nvPicPr>
         <p:blipFill>
-          <a:blip xmlns:r="http://schemas.openxmlformats.org/officeDocument/2006/relationships" xmlns:a="http://schemas.openxmlformats.org/drawingml/2006/main" r:embed="Rba5f01c83da94874"/>
+          <a:blip xmlns:r="http://schemas.openxmlformats.org/officeDocument/2006/relationships" xmlns:a="http://schemas.openxmlformats.org/drawingml/2006/main" r:embed="R1bfb7d89fb65413f"/>
           <a:stretch xmlns:a="http://schemas.openxmlformats.org/drawingml/2006/main"/>
         </p:blipFill>
         <p:spPr>
@@ -5965,49 +5941,73 @@
           <a:p xmlns:a="http://schemas.openxmlformats.org/drawingml/2006/main">
             <a:pPr algn="l">
               <a:buNone/>
-              <a:defRPr sz="4575" b="1">
-                <a:solidFill>
-                  <a:srgbClr val="F4F2EC"/>
-                </a:solidFill>
-                <a:latin typeface="Helvetica Neue"/>
-                <a:ea typeface="Helvetica Neue"/>
-                <a:cs typeface="Helvetica Neue"/>
-              </a:defRPr>
-            </a:pPr>
-            <a:r>
-              <a:rPr sz="4575" b="1">
-                <a:solidFill>
-                  <a:srgbClr val="F4F2EC"/>
-                </a:solidFill>
-                <a:latin typeface="Helvetica Neue"/>
-                <a:ea typeface="Helvetica Neue"/>
-                <a:cs typeface="Helvetica Neue"/>
-              </a:rPr>
-              <a:t>Statusi i qartë</a:t>
+              <a:defRPr sz="2850" b="1">
+                <a:solidFill>
+                  <a:srgbClr val="F5F7F9"/>
+                </a:solidFill>
+                <a:latin typeface="Helvetica Neue"/>
+                <a:ea typeface="Helvetica Neue"/>
+                <a:cs typeface="Helvetica Neue"/>
+              </a:defRPr>
+            </a:pPr>
+            <a:r>
+              <a:rPr sz="2850" b="1">
+                <a:solidFill>
+                  <a:srgbClr val="F5F7F9"/>
+                </a:solidFill>
+                <a:latin typeface="Helvetica Neue"/>
+                <a:ea typeface="Helvetica Neue"/>
+                <a:cs typeface="Helvetica Neue"/>
+              </a:rPr>
+              <a:t>Checkout i strukturuar</a:t>
             </a:r>
           </a:p>
           <a:p xmlns:a="http://schemas.openxmlformats.org/drawingml/2006/main">
             <a:pPr algn="l">
               <a:buNone/>
-              <a:defRPr sz="4575" b="1">
-                <a:solidFill>
-                  <a:srgbClr val="F4F2EC"/>
-                </a:solidFill>
-                <a:latin typeface="Helvetica Neue"/>
-                <a:ea typeface="Helvetica Neue"/>
-                <a:cs typeface="Helvetica Neue"/>
-              </a:defRPr>
-            </a:pPr>
-            <a:r>
-              <a:rPr sz="4575" b="1">
-                <a:solidFill>
-                  <a:srgbClr val="F4F2EC"/>
-                </a:solidFill>
-                <a:latin typeface="Helvetica Neue"/>
-                <a:ea typeface="Helvetica Neue"/>
-                <a:cs typeface="Helvetica Neue"/>
-              </a:rPr>
-              <a:t>ul pasigurinë.</a:t>
+              <a:defRPr sz="2850" b="1">
+                <a:solidFill>
+                  <a:srgbClr val="F5F7F9"/>
+                </a:solidFill>
+                <a:latin typeface="Helvetica Neue"/>
+                <a:ea typeface="Helvetica Neue"/>
+                <a:cs typeface="Helvetica Neue"/>
+              </a:defRPr>
+            </a:pPr>
+            <a:r>
+              <a:rPr sz="2850" b="1">
+                <a:solidFill>
+                  <a:srgbClr val="F5F7F9"/>
+                </a:solidFill>
+                <a:latin typeface="Helvetica Neue"/>
+                <a:ea typeface="Helvetica Neue"/>
+                <a:cs typeface="Helvetica Neue"/>
+              </a:rPr>
+              <a:t>dhe statusi i dukshëm</a:t>
+            </a:r>
+          </a:p>
+          <a:p xmlns:a="http://schemas.openxmlformats.org/drawingml/2006/main">
+            <a:pPr algn="l">
+              <a:buNone/>
+              <a:defRPr sz="2850" b="1">
+                <a:solidFill>
+                  <a:srgbClr val="F5F7F9"/>
+                </a:solidFill>
+                <a:latin typeface="Helvetica Neue"/>
+                <a:ea typeface="Helvetica Neue"/>
+                <a:cs typeface="Helvetica Neue"/>
+              </a:defRPr>
+            </a:pPr>
+            <a:r>
+              <a:rPr sz="2850" b="1">
+                <a:solidFill>
+                  <a:srgbClr val="F5F7F9"/>
+                </a:solidFill>
+                <a:latin typeface="Helvetica Neue"/>
+                <a:ea typeface="Helvetica Neue"/>
+                <a:cs typeface="Helvetica Neue"/>
+              </a:rPr>
+              <a:t>ulin pasigurinë.</a:t>
             </a:r>
           </a:p>
         </p:txBody>
@@ -6065,7 +6065,7 @@
                 <a:ea typeface="Helvetica Neue"/>
                 <a:cs typeface="Helvetica Neue"/>
               </a:rPr>
-              <a:t>EKSPERIMENT I PROPOZUAR</a:t>
+              <a:t>PRAG HIPOTETIK I PËRDORIMIT</a:t>
             </a:r>
           </a:p>
         </p:txBody>
@@ -6263,7 +6263,7 @@
                 <a:ea typeface="Helvetica Neue"/>
                 <a:cs typeface="Helvetica Neue"/>
               </a:rPr>
-              <a:t>Prag mësimor, ende pa rezultate</a:t>
+              <a:t>Prag hipotetik, ende pa rezultate</a:t>
             </a:r>
           </a:p>
         </p:txBody>
@@ -6335,7 +6335,7 @@
           <p:nvPr/>
         </p:nvPicPr>
         <p:blipFill>
-          <a:blip xmlns:r="http://schemas.openxmlformats.org/officeDocument/2006/relationships" xmlns:a="http://schemas.openxmlformats.org/drawingml/2006/main" r:embed="R54b3663926e04dfa"/>
+          <a:blip xmlns:r="http://schemas.openxmlformats.org/officeDocument/2006/relationships" xmlns:a="http://schemas.openxmlformats.org/drawingml/2006/main" r:embed="Rc3aa58ad78b14f87"/>
           <a:stretch xmlns:a="http://schemas.openxmlformats.org/drawingml/2006/main"/>
         </p:blipFill>
         <p:spPr>
@@ -6546,7 +6546,7 @@
                 <a:ea typeface="Helvetica Neue"/>
                 <a:cs typeface="Helvetica Neue"/>
               </a:rPr>
-              <a:t>Një faqe para kodit</a:t>
+              <a:t>PRD-ja e porosisë</a:t>
             </a:r>
           </a:p>
         </p:txBody>
@@ -6644,73 +6644,73 @@
           <a:p xmlns:a="http://schemas.openxmlformats.org/drawingml/2006/main">
             <a:pPr algn="l">
               <a:buNone/>
-              <a:defRPr sz="2925" b="0">
-                <a:solidFill>
-                  <a:srgbClr val="F4F2EC"/>
-                </a:solidFill>
-                <a:latin typeface="Helvetica Neue"/>
-                <a:ea typeface="Helvetica Neue"/>
-                <a:cs typeface="Helvetica Neue"/>
-              </a:defRPr>
-            </a:pPr>
-            <a:r>
-              <a:rPr sz="2925" b="0">
-                <a:solidFill>
-                  <a:srgbClr val="F4F2EC"/>
-                </a:solidFill>
-                <a:latin typeface="Helvetica Neue"/>
-                <a:ea typeface="Helvetica Neue"/>
-                <a:cs typeface="Helvetica Neue"/>
-              </a:rPr>
-              <a:t>Një marrëveshje</a:t>
+              <a:defRPr sz="1800" b="0">
+                <a:solidFill>
+                  <a:srgbClr val="F5F7F9"/>
+                </a:solidFill>
+                <a:latin typeface="Helvetica Neue"/>
+                <a:ea typeface="Helvetica Neue"/>
+                <a:cs typeface="Helvetica Neue"/>
+              </a:defRPr>
+            </a:pPr>
+            <a:r>
+              <a:rPr sz="1800" b="0">
+                <a:solidFill>
+                  <a:srgbClr val="F5F7F9"/>
+                </a:solidFill>
+                <a:latin typeface="Helvetica Neue"/>
+                <a:ea typeface="Helvetica Neue"/>
+                <a:cs typeface="Helvetica Neue"/>
+              </a:rPr>
+              <a:t>Dokumenti i shkurtër para kodit:</a:t>
             </a:r>
           </a:p>
           <a:p xmlns:a="http://schemas.openxmlformats.org/drawingml/2006/main">
             <a:pPr algn="l">
               <a:buNone/>
-              <a:defRPr sz="2925" b="0">
-                <a:solidFill>
-                  <a:srgbClr val="F4F2EC"/>
-                </a:solidFill>
-                <a:latin typeface="Helvetica Neue"/>
-                <a:ea typeface="Helvetica Neue"/>
-                <a:cs typeface="Helvetica Neue"/>
-              </a:defRPr>
-            </a:pPr>
-            <a:r>
-              <a:rPr sz="2925" b="0">
-                <a:solidFill>
-                  <a:srgbClr val="F4F2EC"/>
-                </a:solidFill>
-                <a:latin typeface="Helvetica Neue"/>
-                <a:ea typeface="Helvetica Neue"/>
-                <a:cs typeface="Helvetica Neue"/>
-              </a:rPr>
-              <a:t>për sjelljen</a:t>
+              <a:defRPr sz="1800" b="0">
+                <a:solidFill>
+                  <a:srgbClr val="F5F7F9"/>
+                </a:solidFill>
+                <a:latin typeface="Helvetica Neue"/>
+                <a:ea typeface="Helvetica Neue"/>
+                <a:cs typeface="Helvetica Neue"/>
+              </a:defRPr>
+            </a:pPr>
+            <a:r>
+              <a:rPr sz="1800" b="0">
+                <a:solidFill>
+                  <a:srgbClr val="F5F7F9"/>
+                </a:solidFill>
+                <a:latin typeface="Helvetica Neue"/>
+                <a:ea typeface="Helvetica Neue"/>
+                <a:cs typeface="Helvetica Neue"/>
+              </a:rPr>
+              <a:t>përdoruesi, problemi, rrjedha,</a:t>
             </a:r>
           </a:p>
           <a:p xmlns:a="http://schemas.openxmlformats.org/drawingml/2006/main">
             <a:pPr algn="l">
               <a:buNone/>
-              <a:defRPr sz="2925" b="0">
-                <a:solidFill>
-                  <a:srgbClr val="F4F2EC"/>
-                </a:solidFill>
-                <a:latin typeface="Helvetica Neue"/>
-                <a:ea typeface="Helvetica Neue"/>
-                <a:cs typeface="Helvetica Neue"/>
-              </a:defRPr>
-            </a:pPr>
-            <a:r>
-              <a:rPr sz="2925" b="0">
-                <a:solidFill>
-                  <a:srgbClr val="F4F2EC"/>
-                </a:solidFill>
-                <a:latin typeface="Helvetica Neue"/>
-                <a:ea typeface="Helvetica Neue"/>
-                <a:cs typeface="Helvetica Neue"/>
-              </a:rPr>
-              <a:t>e produktit.</a:t>
+              <a:defRPr sz="1800" b="0">
+                <a:solidFill>
+                  <a:srgbClr val="F5F7F9"/>
+                </a:solidFill>
+                <a:latin typeface="Helvetica Neue"/>
+                <a:ea typeface="Helvetica Neue"/>
+                <a:cs typeface="Helvetica Neue"/>
+              </a:defRPr>
+            </a:pPr>
+            <a:r>
+              <a:rPr sz="1800" b="0">
+                <a:solidFill>
+                  <a:srgbClr val="F5F7F9"/>
+                </a:solidFill>
+                <a:latin typeface="Helvetica Neue"/>
+                <a:ea typeface="Helvetica Neue"/>
+                <a:cs typeface="Helvetica Neue"/>
+              </a:rPr>
+              <a:t>kufijtë dhe kriteret e pranimit.</a:t>
             </a:r>
           </a:p>
         </p:txBody>
@@ -6808,25 +6808,25 @@
           <a:p xmlns:a="http://schemas.openxmlformats.org/drawingml/2006/main">
             <a:pPr algn="l">
               <a:buNone/>
-              <a:defRPr sz="2100" b="0">
-                <a:solidFill>
-                  <a:srgbClr val="F4F2EC"/>
-                </a:solidFill>
-                <a:latin typeface="Helvetica Neue"/>
-                <a:ea typeface="Helvetica Neue"/>
-                <a:cs typeface="Helvetica Neue"/>
-              </a:defRPr>
-            </a:pPr>
-            <a:r>
-              <a:rPr sz="2100" b="0">
-                <a:solidFill>
-                  <a:srgbClr val="F4F2EC"/>
-                </a:solidFill>
-                <a:latin typeface="Helvetica Neue"/>
-                <a:ea typeface="Helvetica Neue"/>
-                <a:cs typeface="Helvetica Neue"/>
-              </a:rPr>
-              <a:t>Student që kërkon udhëtim</a:t>
+              <a:defRPr sz="1575" b="0">
+                <a:solidFill>
+                  <a:srgbClr val="F5F7F9"/>
+                </a:solidFill>
+                <a:latin typeface="Helvetica Neue"/>
+                <a:ea typeface="Helvetica Neue"/>
+                <a:cs typeface="Helvetica Neue"/>
+              </a:defRPr>
+            </a:pPr>
+            <a:r>
+              <a:rPr sz="1575" b="0">
+                <a:solidFill>
+                  <a:srgbClr val="F5F7F9"/>
+                </a:solidFill>
+                <a:latin typeface="Helvetica Neue"/>
+                <a:ea typeface="Helvetica Neue"/>
+                <a:cs typeface="Helvetica Neue"/>
+              </a:rPr>
+              <a:t>Një klient i restorantit familjar</a:t>
             </a:r>
           </a:p>
         </p:txBody>
@@ -6954,25 +6954,25 @@
           <a:p xmlns:a="http://schemas.openxmlformats.org/drawingml/2006/main">
             <a:pPr algn="l">
               <a:buNone/>
-              <a:defRPr sz="2100" b="0">
-                <a:solidFill>
-                  <a:srgbClr val="F4F2EC"/>
-                </a:solidFill>
-                <a:latin typeface="Helvetica Neue"/>
-                <a:ea typeface="Helvetica Neue"/>
-                <a:cs typeface="Helvetica Neue"/>
-              </a:defRPr>
-            </a:pPr>
-            <a:r>
-              <a:rPr sz="2100" b="0">
-                <a:solidFill>
-                  <a:srgbClr val="F4F2EC"/>
-                </a:solidFill>
-                <a:latin typeface="Helvetica Neue"/>
-                <a:ea typeface="Helvetica Neue"/>
-                <a:cs typeface="Helvetica Neue"/>
-              </a:rPr>
-              <a:t>Konfirmimi mbetet i paqartë</a:t>
+              <a:defRPr sz="1575" b="0">
+                <a:solidFill>
+                  <a:srgbClr val="F5F7F9"/>
+                </a:solidFill>
+                <a:latin typeface="Helvetica Neue"/>
+                <a:ea typeface="Helvetica Neue"/>
+                <a:cs typeface="Helvetica Neue"/>
+              </a:defRPr>
+            </a:pPr>
+            <a:r>
+              <a:rPr sz="1575" b="0">
+                <a:solidFill>
+                  <a:srgbClr val="F5F7F9"/>
+                </a:solidFill>
+                <a:latin typeface="Helvetica Neue"/>
+                <a:ea typeface="Helvetica Neue"/>
+                <a:cs typeface="Helvetica Neue"/>
+              </a:rPr>
+              <a:t>Mesazhi nuk plotëson porosinë</a:t>
             </a:r>
           </a:p>
         </p:txBody>
@@ -7100,25 +7100,25 @@
           <a:p xmlns:a="http://schemas.openxmlformats.org/drawingml/2006/main">
             <a:pPr algn="l">
               <a:buNone/>
-              <a:defRPr sz="2100" b="0">
-                <a:solidFill>
-                  <a:srgbClr val="F4F2EC"/>
-                </a:solidFill>
-                <a:latin typeface="Helvetica Neue"/>
-                <a:ea typeface="Helvetica Neue"/>
-                <a:cs typeface="Helvetica Neue"/>
-              </a:defRPr>
-            </a:pPr>
-            <a:r>
-              <a:rPr sz="2100" b="0">
-                <a:solidFill>
-                  <a:srgbClr val="F4F2EC"/>
-                </a:solidFill>
-                <a:latin typeface="Helvetica Neue"/>
-                <a:ea typeface="Helvetica Neue"/>
-                <a:cs typeface="Helvetica Neue"/>
-              </a:rPr>
-              <a:t>Kërkon vend dhe sheh përgjigjen</a:t>
+              <a:defRPr sz="1575" b="0">
+                <a:solidFill>
+                  <a:srgbClr val="F5F7F9"/>
+                </a:solidFill>
+                <a:latin typeface="Helvetica Neue"/>
+                <a:ea typeface="Helvetica Neue"/>
+                <a:cs typeface="Helvetica Neue"/>
+              </a:defRPr>
+            </a:pPr>
+            <a:r>
+              <a:rPr sz="1575" b="0">
+                <a:solidFill>
+                  <a:srgbClr val="F5F7F9"/>
+                </a:solidFill>
+                <a:latin typeface="Helvetica Neue"/>
+                <a:ea typeface="Helvetica Neue"/>
+                <a:cs typeface="Helvetica Neue"/>
+              </a:rPr>
+              <a:t>Menu → Cart → Order → Ready</a:t>
             </a:r>
           </a:p>
         </p:txBody>
@@ -7246,25 +7246,25 @@
           <a:p xmlns:a="http://schemas.openxmlformats.org/drawingml/2006/main">
             <a:pPr algn="l">
               <a:buNone/>
-              <a:defRPr sz="2100" b="0">
-                <a:solidFill>
-                  <a:srgbClr val="F4F2EC"/>
-                </a:solidFill>
-                <a:latin typeface="Helvetica Neue"/>
-                <a:ea typeface="Helvetica Neue"/>
-                <a:cs typeface="Helvetica Neue"/>
-              </a:defRPr>
-            </a:pPr>
-            <a:r>
-              <a:rPr sz="2100" b="0">
-                <a:solidFill>
-                  <a:srgbClr val="F4F2EC"/>
-                </a:solidFill>
-                <a:latin typeface="Helvetica Neue"/>
-                <a:ea typeface="Helvetica Neue"/>
-                <a:cs typeface="Helvetica Neue"/>
-              </a:rPr>
-              <a:t>Pa pagesa ose GPS live</a:t>
+              <a:defRPr sz="1575" b="0">
+                <a:solidFill>
+                  <a:srgbClr val="F5F7F9"/>
+                </a:solidFill>
+                <a:latin typeface="Helvetica Neue"/>
+                <a:ea typeface="Helvetica Neue"/>
+                <a:cs typeface="Helvetica Neue"/>
+              </a:defRPr>
+            </a:pPr>
+            <a:r>
+              <a:rPr sz="1575" b="0">
+                <a:solidFill>
+                  <a:srgbClr val="F5F7F9"/>
+                </a:solidFill>
+                <a:latin typeface="Helvetica Neue"/>
+                <a:ea typeface="Helvetica Neue"/>
+                <a:cs typeface="Helvetica Neue"/>
+              </a:rPr>
+              <a:t>Pa pagesa ose GPS të korrierit</a:t>
             </a:r>
           </a:p>
         </p:txBody>
@@ -7392,25 +7392,25 @@
           <a:p xmlns:a="http://schemas.openxmlformats.org/drawingml/2006/main">
             <a:pPr algn="l">
               <a:buNone/>
-              <a:defRPr sz="2100" b="0">
-                <a:solidFill>
-                  <a:srgbClr val="F4F2EC"/>
-                </a:solidFill>
-                <a:latin typeface="Helvetica Neue"/>
-                <a:ea typeface="Helvetica Neue"/>
-                <a:cs typeface="Helvetica Neue"/>
-              </a:defRPr>
-            </a:pPr>
-            <a:r>
-              <a:rPr sz="2100" b="0">
-                <a:solidFill>
-                  <a:srgbClr val="F4F2EC"/>
-                </a:solidFill>
-                <a:latin typeface="Helvetica Neue"/>
-                <a:ea typeface="Helvetica Neue"/>
-                <a:cs typeface="Helvetica Neue"/>
-              </a:rPr>
-              <a:t>Kërkesë me status të qartë</a:t>
+              <a:defRPr sz="1500" b="0">
+                <a:solidFill>
+                  <a:srgbClr val="F5F7F9"/>
+                </a:solidFill>
+                <a:latin typeface="Helvetica Neue"/>
+                <a:ea typeface="Helvetica Neue"/>
+                <a:cs typeface="Helvetica Neue"/>
+              </a:defRPr>
+            </a:pPr>
+            <a:r>
+              <a:rPr sz="1500" b="0">
+                <a:solidFill>
+                  <a:srgbClr val="F5F7F9"/>
+                </a:solidFill>
+                <a:latin typeface="Helvetica Neue"/>
+                <a:ea typeface="Helvetica Neue"/>
+                <a:cs typeface="Helvetica Neue"/>
+              </a:rPr>
+              <a:t>Serveri konfirmon vetëm një porosi</a:t>
             </a:r>
           </a:p>
         </p:txBody>
@@ -7424,7 +7424,7 @@
           <p:nvPr/>
         </p:nvPicPr>
         <p:blipFill>
-          <a:blip xmlns:r="http://schemas.openxmlformats.org/officeDocument/2006/relationships" xmlns:a="http://schemas.openxmlformats.org/drawingml/2006/main" r:embed="R2cc19a352b8440f3"/>
+          <a:blip xmlns:r="http://schemas.openxmlformats.org/officeDocument/2006/relationships" xmlns:a="http://schemas.openxmlformats.org/drawingml/2006/main" r:embed="R01f5370d1c3842f4"/>
           <a:stretch xmlns:a="http://schemas.openxmlformats.org/drawingml/2006/main"/>
         </p:blipFill>
         <p:spPr>
@@ -7751,7 +7751,7 @@
                 <a:ea typeface="Helvetica Neue"/>
                 <a:cs typeface="Helvetica Neue"/>
               </a:rPr>
-              <a:t>Publiko</a:t>
+              <a:t>Shiko menunë</a:t>
             </a:r>
           </a:p>
         </p:txBody>
@@ -7809,7 +7809,7 @@
                 <a:ea typeface="Helvetica Neue"/>
                 <a:cs typeface="Helvetica Neue"/>
               </a:rPr>
-              <a:t>Shoferi</a:t>
+              <a:t>Klienti</a:t>
             </a:r>
           </a:p>
         </p:txBody>
@@ -7955,7 +7955,7 @@
                 <a:ea typeface="Helvetica Neue"/>
                 <a:cs typeface="Helvetica Neue"/>
               </a:rPr>
-              <a:t>Kërko</a:t>
+              <a:t>Vendos porosi</a:t>
             </a:r>
           </a:p>
         </p:txBody>
@@ -8013,7 +8013,7 @@
                 <a:ea typeface="Helvetica Neue"/>
                 <a:cs typeface="Helvetica Neue"/>
               </a:rPr>
-              <a:t>Studenti</a:t>
+              <a:t>Klienti</a:t>
             </a:r>
           </a:p>
         </p:txBody>
@@ -8141,25 +8141,25 @@
           <a:p xmlns:a="http://schemas.openxmlformats.org/drawingml/2006/main">
             <a:pPr algn="l">
               <a:buNone/>
-              <a:defRPr sz="3600" b="1">
-                <a:solidFill>
-                  <a:srgbClr val="F4F2EC"/>
-                </a:solidFill>
-                <a:latin typeface="Helvetica Neue"/>
-                <a:ea typeface="Helvetica Neue"/>
-                <a:cs typeface="Helvetica Neue"/>
-              </a:defRPr>
-            </a:pPr>
-            <a:r>
-              <a:rPr sz="3600" b="1">
-                <a:solidFill>
-                  <a:srgbClr val="F4F2EC"/>
-                </a:solidFill>
-                <a:latin typeface="Helvetica Neue"/>
-                <a:ea typeface="Helvetica Neue"/>
-                <a:cs typeface="Helvetica Neue"/>
-              </a:rPr>
-              <a:t>Vendos</a:t>
+              <a:defRPr sz="1875" b="1">
+                <a:solidFill>
+                  <a:srgbClr val="5DCEF2"/>
+                </a:solidFill>
+                <a:latin typeface="Helvetica Neue"/>
+                <a:ea typeface="Helvetica Neue"/>
+                <a:cs typeface="Helvetica Neue"/>
+              </a:defRPr>
+            </a:pPr>
+            <a:r>
+              <a:rPr sz="1875" b="1">
+                <a:solidFill>
+                  <a:srgbClr val="5DCEF2"/>
+                </a:solidFill>
+                <a:latin typeface="Helvetica Neue"/>
+                <a:ea typeface="Helvetica Neue"/>
+                <a:cs typeface="Helvetica Neue"/>
+              </a:rPr>
+              <a:t>Përditëso statusin</a:t>
             </a:r>
           </a:p>
         </p:txBody>
@@ -8217,7 +8217,7 @@
                 <a:ea typeface="Helvetica Neue"/>
                 <a:cs typeface="Helvetica Neue"/>
               </a:rPr>
-              <a:t>Shoferi</a:t>
+              <a:t>Stafi</a:t>
             </a:r>
           </a:p>
         </p:txBody>
@@ -8345,25 +8345,25 @@
           <a:p xmlns:a="http://schemas.openxmlformats.org/drawingml/2006/main">
             <a:pPr algn="l">
               <a:buNone/>
-              <a:defRPr sz="2250" b="0">
-                <a:solidFill>
-                  <a:srgbClr val="AEBFCB"/>
-                </a:solidFill>
-                <a:latin typeface="Helvetica Neue"/>
-                <a:ea typeface="Helvetica Neue"/>
-                <a:cs typeface="Helvetica Neue"/>
-              </a:defRPr>
-            </a:pPr>
-            <a:r>
-              <a:rPr sz="2250" b="0">
-                <a:solidFill>
-                  <a:srgbClr val="AEBFCB"/>
-                </a:solidFill>
-                <a:latin typeface="Helvetica Neue"/>
-                <a:ea typeface="Helvetica Neue"/>
-                <a:cs typeface="Helvetica Neue"/>
-              </a:rPr>
-              <a:t>Pagesa     GPS live     Chat     Vlerësime</a:t>
+              <a:defRPr sz="1275" b="0">
+                <a:solidFill>
+                  <a:srgbClr val="B6C5CE"/>
+                </a:solidFill>
+                <a:latin typeface="Helvetica Neue"/>
+                <a:ea typeface="Helvetica Neue"/>
+                <a:cs typeface="Helvetica Neue"/>
+              </a:defRPr>
+            </a:pPr>
+            <a:r>
+              <a:rPr sz="1275" b="0">
+                <a:solidFill>
+                  <a:srgbClr val="B6C5CE"/>
+                </a:solidFill>
+                <a:latin typeface="Helvetica Neue"/>
+                <a:ea typeface="Helvetica Neue"/>
+                <a:cs typeface="Helvetica Neue"/>
+              </a:rPr>
+              <a:t>Pagesa   marketplace me shumë restorante   GPS live i korrierit   vlerësime</a:t>
             </a:r>
           </a:p>
         </p:txBody>
@@ -8421,7 +8421,7 @@
                 <a:ea typeface="Helvetica Neue"/>
                 <a:cs typeface="Helvetica Neue"/>
               </a:rPr>
-              <a:t>Cilin rrezik ul veçoria që po zgjidhni?</a:t>
+              <a:t>Cili hap i rrjedhës ul pasigurinë e klientit?</a:t>
             </a:r>
           </a:p>
         </p:txBody>
@@ -8435,7 +8435,7 @@
           <p:nvPr/>
         </p:nvPicPr>
         <p:blipFill>
-          <a:blip xmlns:r="http://schemas.openxmlformats.org/officeDocument/2006/relationships" xmlns:a="http://schemas.openxmlformats.org/drawingml/2006/main" r:embed="R58907d9627b54a78"/>
+          <a:blip xmlns:r="http://schemas.openxmlformats.org/officeDocument/2006/relationships" xmlns:a="http://schemas.openxmlformats.org/drawingml/2006/main" r:embed="R4bd16e0b6d04469e"/>
           <a:stretch xmlns:a="http://schemas.openxmlformats.org/drawingml/2006/main"/>
         </p:blipFill>
         <p:spPr>
@@ -8796,7 +8796,7 @@
                 <a:ea typeface="Helvetica Neue"/>
                 <a:cs typeface="Helvetica Neue"/>
               </a:rPr>
-              <a:t>Kërkesa A</a:t>
+              <a:t>Menu</a:t>
             </a:r>
           </a:p>
         </p:txBody>
@@ -8888,7 +8888,7 @@
                 <a:ea typeface="Helvetica Neue"/>
                 <a:cs typeface="Helvetica Neue"/>
               </a:rPr>
-              <a:t>1 vend</a:t>
+              <a:t>Cart</a:t>
             </a:r>
           </a:p>
         </p:txBody>
@@ -8980,7 +8980,7 @@
                 <a:ea typeface="Helvetica Neue"/>
                 <a:cs typeface="Helvetica Neue"/>
               </a:rPr>
-              <a:t>Pranuar</a:t>
+              <a:t>Order</a:t>
             </a:r>
           </a:p>
         </p:txBody>
@@ -9098,7 +9098,7 @@
                 <a:ea typeface="Helvetica Neue"/>
                 <a:cs typeface="Helvetica Neue"/>
               </a:rPr>
-              <a:t>Kërkesa B</a:t>
+              <a:t>Ready</a:t>
             </a:r>
           </a:p>
         </p:txBody>
@@ -9138,25 +9138,25 @@
           <a:p xmlns:a="http://schemas.openxmlformats.org/drawingml/2006/main">
             <a:pPr algn="l">
               <a:buNone/>
-              <a:defRPr sz="2550" b="1">
-                <a:solidFill>
-                  <a:srgbClr val="F2BB66"/>
-                </a:solidFill>
-                <a:latin typeface="Helvetica Neue"/>
-                <a:ea typeface="Helvetica Neue"/>
-                <a:cs typeface="Helvetica Neue"/>
-              </a:defRPr>
-            </a:pPr>
-            <a:r>
-              <a:rPr sz="2550" b="1">
-                <a:solidFill>
-                  <a:srgbClr val="F2BB66"/>
-                </a:solidFill>
-                <a:latin typeface="Helvetica Neue"/>
-                <a:ea typeface="Helvetica Neue"/>
-                <a:cs typeface="Helvetica Neue"/>
-              </a:rPr>
-              <a:t>Pa tejkalim kapaciteti</a:t>
+              <a:defRPr sz="1875" b="1">
+                <a:solidFill>
+                  <a:srgbClr val="F3BE5C"/>
+                </a:solidFill>
+                <a:latin typeface="Helvetica Neue"/>
+                <a:ea typeface="Helvetica Neue"/>
+                <a:cs typeface="Helvetica Neue"/>
+              </a:defRPr>
+            </a:pPr>
+            <a:r>
+              <a:rPr sz="1875" b="1">
+                <a:solidFill>
+                  <a:srgbClr val="F3BE5C"/>
+                </a:solidFill>
+                <a:latin typeface="Helvetica Neue"/>
+                <a:ea typeface="Helvetica Neue"/>
+                <a:cs typeface="Helvetica Neue"/>
+              </a:rPr>
+              <a:t>Vetëm pas konfirmimit të serverit</a:t>
             </a:r>
           </a:p>
         </p:txBody>
@@ -9196,25 +9196,25 @@
           <a:p xmlns:a="http://schemas.openxmlformats.org/drawingml/2006/main">
             <a:pPr algn="l">
               <a:buNone/>
-              <a:defRPr sz="3150" b="1">
-                <a:solidFill>
-                  <a:srgbClr val="F4F2EC"/>
-                </a:solidFill>
-                <a:latin typeface="Helvetica Neue"/>
-                <a:ea typeface="Helvetica Neue"/>
-                <a:cs typeface="Helvetica Neue"/>
-              </a:defRPr>
-            </a:pPr>
-            <a:r>
-              <a:rPr sz="3150" b="1">
-                <a:solidFill>
-                  <a:srgbClr val="F4F2EC"/>
-                </a:solidFill>
-                <a:latin typeface="Helvetica Neue"/>
-                <a:ea typeface="Helvetica Neue"/>
-                <a:cs typeface="Helvetica Neue"/>
-              </a:rPr>
-              <a:t>Vendet e konfirmuara ≤ kapaciteti</a:t>
+              <a:defRPr sz="2025" b="1">
+                <a:solidFill>
+                  <a:srgbClr val="F5F7F9"/>
+                </a:solidFill>
+                <a:latin typeface="Helvetica Neue"/>
+                <a:ea typeface="Helvetica Neue"/>
+                <a:cs typeface="Helvetica Neue"/>
+              </a:defRPr>
+            </a:pPr>
+            <a:r>
+              <a:rPr sz="2025" b="1">
+                <a:solidFill>
+                  <a:srgbClr val="F5F7F9"/>
+                </a:solidFill>
+                <a:latin typeface="Helvetica Neue"/>
+                <a:ea typeface="Helvetica Neue"/>
+                <a:cs typeface="Helvetica Neue"/>
+              </a:rPr>
+              <a:t>Porosia ruhet një herë dhe statusi arrin “Ready”</a:t>
             </a:r>
           </a:p>
         </p:txBody>
@@ -9272,7 +9272,7 @@
                 <a:ea typeface="Helvetica Neue"/>
                 <a:cs typeface="Helvetica Neue"/>
               </a:rPr>
-              <a:t>Çfarë ndodh kur dy kërkesa mbërrijnë njëkohësisht?</a:t>
+              <a:t>Çfarë ndodh kur klienti shtyp “Porosit” dy herë?</a:t>
             </a:r>
           </a:p>
         </p:txBody>
@@ -9286,7 +9286,7 @@
           <p:nvPr/>
         </p:nvPicPr>
         <p:blipFill>
-          <a:blip xmlns:r="http://schemas.openxmlformats.org/officeDocument/2006/relationships" xmlns:a="http://schemas.openxmlformats.org/drawingml/2006/main" r:embed="Rbd4973aaa44e43db"/>
+          <a:blip xmlns:r="http://schemas.openxmlformats.org/officeDocument/2006/relationships" xmlns:a="http://schemas.openxmlformats.org/drawingml/2006/main" r:embed="R14ee83dcf5424339"/>
           <a:stretch xmlns:a="http://schemas.openxmlformats.org/drawingml/2006/main"/>
         </p:blipFill>
         <p:spPr>
@@ -9653,7 +9653,7 @@
                 <a:ea typeface="Helvetica Neue"/>
                 <a:cs typeface="Helvetica Neue"/>
               </a:rPr>
-              <a:t>AAB RideShare</a:t>
+              <a:t>Restoranti Sofra</a:t>
             </a:r>
           </a:p>
         </p:txBody>
@@ -9711,7 +9711,7 @@
                 <a:ea typeface="Helvetica Neue"/>
                 <a:cs typeface="Helvetica Neue"/>
               </a:rPr>
-              <a:t>Udhëtimet</a:t>
+              <a:t>MENU</a:t>
             </a:r>
           </a:p>
         </p:txBody>
@@ -9769,31 +9769,7 @@
                 <a:ea typeface="Helvetica Neue"/>
                 <a:cs typeface="Helvetica Neue"/>
               </a:rPr>
-              <a:t>Fushë Kosovë</a:t>
-            </a:r>
-          </a:p>
-          <a:p xmlns:a="http://schemas.openxmlformats.org/drawingml/2006/main">
-            <a:pPr algn="l">
-              <a:buNone/>
-              <a:defRPr sz="2025" b="1">
-                <a:solidFill>
-                  <a:srgbClr val="F4F2EC"/>
-                </a:solidFill>
-                <a:latin typeface="Helvetica Neue"/>
-                <a:ea typeface="Helvetica Neue"/>
-                <a:cs typeface="Helvetica Neue"/>
-              </a:defRPr>
-            </a:pPr>
-            <a:r>
-              <a:rPr sz="2025" b="1">
-                <a:solidFill>
-                  <a:srgbClr val="F4F2EC"/>
-                </a:solidFill>
-                <a:latin typeface="Helvetica Neue"/>
-                <a:ea typeface="Helvetica Neue"/>
-                <a:cs typeface="Helvetica Neue"/>
-              </a:rPr>
-              <a:t>Kampus</a:t>
+              <a:t>Tavë shtëpie</a:t>
             </a:r>
           </a:p>
         </p:txBody>
@@ -9833,25 +9809,25 @@
           <a:p xmlns:a="http://schemas.openxmlformats.org/drawingml/2006/main">
             <a:pPr algn="l">
               <a:buNone/>
-              <a:defRPr sz="1725" b="0">
-                <a:solidFill>
-                  <a:srgbClr val="AEBFCB"/>
-                </a:solidFill>
-                <a:latin typeface="Helvetica Neue"/>
-                <a:ea typeface="Helvetica Neue"/>
-                <a:cs typeface="Helvetica Neue"/>
-              </a:defRPr>
-            </a:pPr>
-            <a:r>
-              <a:rPr sz="1725" b="0">
-                <a:solidFill>
-                  <a:srgbClr val="AEBFCB"/>
-                </a:solidFill>
-                <a:latin typeface="Helvetica Neue"/>
-                <a:ea typeface="Helvetica Neue"/>
-                <a:cs typeface="Helvetica Neue"/>
-              </a:rPr>
-              <a:t>07:30     1 vend</a:t>
+              <a:defRPr sz="1200" b="0">
+                <a:solidFill>
+                  <a:srgbClr val="B6C5CE"/>
+                </a:solidFill>
+                <a:latin typeface="Helvetica Neue"/>
+                <a:ea typeface="Helvetica Neue"/>
+                <a:cs typeface="Helvetica Neue"/>
+              </a:defRPr>
+            </a:pPr>
+            <a:r>
+              <a:rPr sz="1200" b="0">
+                <a:solidFill>
+                  <a:srgbClr val="B6C5CE"/>
+                </a:solidFill>
+                <a:latin typeface="Helvetica Neue"/>
+                <a:ea typeface="Helvetica Neue"/>
+                <a:cs typeface="Helvetica Neue"/>
+              </a:rPr>
+              <a:t>8 €     Në dispozicion</a:t>
             </a:r>
           </a:p>
         </p:txBody>
@@ -9941,7 +9917,7 @@
                 <a:ea typeface="Helvetica Neue"/>
                 <a:cs typeface="Helvetica Neue"/>
               </a:rPr>
-              <a:t>Shiko detajet</a:t>
+              <a:t>Shto</a:t>
             </a:r>
           </a:p>
         </p:txBody>
@@ -10097,7 +10073,7 @@
                 <a:ea typeface="Helvetica Neue"/>
                 <a:cs typeface="Helvetica Neue"/>
               </a:rPr>
-              <a:t>AAB RideShare</a:t>
+              <a:t>Restoranti Sofra</a:t>
             </a:r>
           </a:p>
         </p:txBody>
@@ -10155,7 +10131,7 @@
                 <a:ea typeface="Helvetica Neue"/>
                 <a:cs typeface="Helvetica Neue"/>
               </a:rPr>
-              <a:t>Fushë Kosovë</a:t>
+              <a:t>CART</a:t>
             </a:r>
           </a:p>
           <a:p xmlns:a="http://schemas.openxmlformats.org/drawingml/2006/main">
@@ -10179,7 +10155,7 @@
                 <a:ea typeface="Helvetica Neue"/>
                 <a:cs typeface="Helvetica Neue"/>
               </a:rPr>
-              <a:t>Kampus</a:t>
+              <a:t>Tavë shtëpie</a:t>
             </a:r>
           </a:p>
         </p:txBody>
@@ -10237,7 +10213,7 @@
                 <a:ea typeface="Helvetica Neue"/>
                 <a:cs typeface="Helvetica Neue"/>
               </a:rPr>
-              <a:t>07:30</a:t>
+              <a:t>Sasia: 1</a:t>
             </a:r>
           </a:p>
         </p:txBody>
@@ -10277,25 +10253,25 @@
           <a:p xmlns:a="http://schemas.openxmlformats.org/drawingml/2006/main">
             <a:pPr algn="l">
               <a:buNone/>
-              <a:defRPr sz="1875" b="0">
-                <a:solidFill>
-                  <a:srgbClr val="AEBFCB"/>
-                </a:solidFill>
-                <a:latin typeface="Helvetica Neue"/>
-                <a:ea typeface="Helvetica Neue"/>
-                <a:cs typeface="Helvetica Neue"/>
-              </a:defRPr>
-            </a:pPr>
-            <a:r>
-              <a:rPr sz="1875" b="0">
-                <a:solidFill>
-                  <a:srgbClr val="AEBFCB"/>
-                </a:solidFill>
-                <a:latin typeface="Helvetica Neue"/>
-                <a:ea typeface="Helvetica Neue"/>
-                <a:cs typeface="Helvetica Neue"/>
-              </a:rPr>
-              <a:t>1 vend i lirë</a:t>
+              <a:defRPr sz="1200" b="0">
+                <a:solidFill>
+                  <a:srgbClr val="B6C5CE"/>
+                </a:solidFill>
+                <a:latin typeface="Helvetica Neue"/>
+                <a:ea typeface="Helvetica Neue"/>
+                <a:cs typeface="Helvetica Neue"/>
+              </a:defRPr>
+            </a:pPr>
+            <a:r>
+              <a:rPr sz="1200" b="0">
+                <a:solidFill>
+                  <a:srgbClr val="B6C5CE"/>
+                </a:solidFill>
+                <a:latin typeface="Helvetica Neue"/>
+                <a:ea typeface="Helvetica Neue"/>
+                <a:cs typeface="Helvetica Neue"/>
+              </a:rPr>
+              <a:t>Gjithsej: 8 €</a:t>
             </a:r>
           </a:p>
         </p:txBody>
@@ -10385,7 +10361,7 @@
                 <a:ea typeface="Helvetica Neue"/>
                 <a:cs typeface="Helvetica Neue"/>
               </a:rPr>
-              <a:t>Kërko vend</a:t>
+              <a:t>Porosit</a:t>
             </a:r>
           </a:p>
         </p:txBody>
@@ -10541,7 +10517,7 @@
                 <a:ea typeface="Helvetica Neue"/>
                 <a:cs typeface="Helvetica Neue"/>
               </a:rPr>
-              <a:t>AAB RideShare</a:t>
+              <a:t>Restoranti Sofra</a:t>
             </a:r>
           </a:p>
         </p:txBody>
@@ -10599,7 +10575,7 @@
                 <a:ea typeface="Helvetica Neue"/>
                 <a:cs typeface="Helvetica Neue"/>
               </a:rPr>
-              <a:t>Kërkesa juaj</a:t>
+              <a:t>ORDER #1042</a:t>
             </a:r>
           </a:p>
         </p:txBody>
@@ -10657,7 +10633,7 @@
                 <a:ea typeface="Helvetica Neue"/>
                 <a:cs typeface="Helvetica Neue"/>
               </a:rPr>
-              <a:t>NË PRITJE</a:t>
+              <a:t>U PRANUA</a:t>
             </a:r>
           </a:p>
         </p:txBody>
@@ -10697,49 +10673,49 @@
           <a:p xmlns:a="http://schemas.openxmlformats.org/drawingml/2006/main">
             <a:pPr algn="l">
               <a:buNone/>
-              <a:defRPr sz="1875" b="0">
-                <a:solidFill>
-                  <a:srgbClr val="AEBFCB"/>
-                </a:solidFill>
-                <a:latin typeface="Helvetica Neue"/>
-                <a:ea typeface="Helvetica Neue"/>
-                <a:cs typeface="Helvetica Neue"/>
-              </a:defRPr>
-            </a:pPr>
-            <a:r>
-              <a:rPr sz="1875" b="0">
-                <a:solidFill>
-                  <a:srgbClr val="AEBFCB"/>
-                </a:solidFill>
-                <a:latin typeface="Helvetica Neue"/>
-                <a:ea typeface="Helvetica Neue"/>
-                <a:cs typeface="Helvetica Neue"/>
-              </a:rPr>
-              <a:t>Shoferi ende</a:t>
+              <a:defRPr sz="1275" b="0">
+                <a:solidFill>
+                  <a:srgbClr val="B6C5CE"/>
+                </a:solidFill>
+                <a:latin typeface="Helvetica Neue"/>
+                <a:ea typeface="Helvetica Neue"/>
+                <a:cs typeface="Helvetica Neue"/>
+              </a:defRPr>
+            </a:pPr>
+            <a:r>
+              <a:rPr sz="1275" b="0">
+                <a:solidFill>
+                  <a:srgbClr val="B6C5CE"/>
+                </a:solidFill>
+                <a:latin typeface="Helvetica Neue"/>
+                <a:ea typeface="Helvetica Neue"/>
+                <a:cs typeface="Helvetica Neue"/>
+              </a:rPr>
+              <a:t>READY</a:t>
             </a:r>
           </a:p>
           <a:p xmlns:a="http://schemas.openxmlformats.org/drawingml/2006/main">
             <a:pPr algn="l">
               <a:buNone/>
-              <a:defRPr sz="1875" b="0">
-                <a:solidFill>
-                  <a:srgbClr val="AEBFCB"/>
-                </a:solidFill>
-                <a:latin typeface="Helvetica Neue"/>
-                <a:ea typeface="Helvetica Neue"/>
-                <a:cs typeface="Helvetica Neue"/>
-              </a:defRPr>
-            </a:pPr>
-            <a:r>
-              <a:rPr sz="1875" b="0">
-                <a:solidFill>
-                  <a:srgbClr val="AEBFCB"/>
-                </a:solidFill>
-                <a:latin typeface="Helvetica Neue"/>
-                <a:ea typeface="Helvetica Neue"/>
-                <a:cs typeface="Helvetica Neue"/>
-              </a:rPr>
-              <a:t>nuk e ka pranuar.</a:t>
+              <a:defRPr sz="1275" b="0">
+                <a:solidFill>
+                  <a:srgbClr val="B6C5CE"/>
+                </a:solidFill>
+                <a:latin typeface="Helvetica Neue"/>
+                <a:ea typeface="Helvetica Neue"/>
+                <a:cs typeface="Helvetica Neue"/>
+              </a:defRPr>
+            </a:pPr>
+            <a:r>
+              <a:rPr sz="1275" b="0">
+                <a:solidFill>
+                  <a:srgbClr val="B6C5CE"/>
+                </a:solidFill>
+                <a:latin typeface="Helvetica Neue"/>
+                <a:ea typeface="Helvetica Neue"/>
+                <a:cs typeface="Helvetica Neue"/>
+              </a:rPr>
+              <a:t>Prit njoftimin e stafit.</a:t>
             </a:r>
           </a:p>
         </p:txBody>
@@ -10857,7 +10833,7 @@
                 <a:ea typeface="Helvetica Neue"/>
                 <a:cs typeface="Helvetica Neue"/>
               </a:rPr>
-              <a:t>Në cilën pamje mund të keqkuptohet konfirmimi?</a:t>
+              <a:t>A ndiqet qartë rrjedha MENU → CART → ORDER → READY?</a:t>
             </a:r>
           </a:p>
         </p:txBody>
@@ -10871,7 +10847,7 @@
           <p:nvPr/>
         </p:nvPicPr>
         <p:blipFill>
-          <a:blip xmlns:r="http://schemas.openxmlformats.org/officeDocument/2006/relationships" xmlns:a="http://schemas.openxmlformats.org/drawingml/2006/main" r:embed="Rb6623f22b2be473b"/>
+          <a:blip xmlns:r="http://schemas.openxmlformats.org/officeDocument/2006/relationships" xmlns:a="http://schemas.openxmlformats.org/drawingml/2006/main" r:embed="R02a3c3e90b9d454f"/>
           <a:stretch xmlns:a="http://schemas.openxmlformats.org/drawingml/2006/main"/>
         </p:blipFill>
         <p:spPr>
@@ -11082,7 +11058,7 @@
                 <a:ea typeface="Helvetica Neue"/>
                 <a:cs typeface="Helvetica Neue"/>
               </a:rPr>
-              <a:t>Produkti mbërrin me një lidhje</a:t>
+              <a:t>PWA për pilotin e restorantit</a:t>
             </a:r>
           </a:p>
         </p:txBody>
@@ -11180,73 +11156,97 @@
           <a:p xmlns:a="http://schemas.openxmlformats.org/drawingml/2006/main">
             <a:pPr algn="l">
               <a:buNone/>
-              <a:defRPr sz="2700" b="0">
-                <a:solidFill>
-                  <a:srgbClr val="F4F2EC"/>
-                </a:solidFill>
-                <a:latin typeface="Helvetica Neue"/>
-                <a:ea typeface="Helvetica Neue"/>
-                <a:cs typeface="Helvetica Neue"/>
-              </a:defRPr>
-            </a:pPr>
-            <a:r>
-              <a:rPr sz="2700" b="0">
-                <a:solidFill>
-                  <a:srgbClr val="F4F2EC"/>
-                </a:solidFill>
-                <a:latin typeface="Helvetica Neue"/>
-                <a:ea typeface="Helvetica Neue"/>
-                <a:cs typeface="Helvetica Neue"/>
-              </a:rPr>
-              <a:t>Një lidhje për ta provuar</a:t>
+              <a:defRPr sz="1875" b="0">
+                <a:solidFill>
+                  <a:srgbClr val="F5F7F9"/>
+                </a:solidFill>
+                <a:latin typeface="Helvetica Neue"/>
+                <a:ea typeface="Helvetica Neue"/>
+                <a:cs typeface="Helvetica Neue"/>
+              </a:defRPr>
+            </a:pPr>
+            <a:r>
+              <a:rPr sz="1875" b="0">
+                <a:solidFill>
+                  <a:srgbClr val="F5F7F9"/>
+                </a:solidFill>
+                <a:latin typeface="Helvetica Neue"/>
+                <a:ea typeface="Helvetica Neue"/>
+                <a:cs typeface="Helvetica Neue"/>
+              </a:rPr>
+              <a:t>Aplikacion web për telefon,</a:t>
             </a:r>
           </a:p>
           <a:p xmlns:a="http://schemas.openxmlformats.org/drawingml/2006/main">
             <a:pPr algn="l">
               <a:buNone/>
-              <a:defRPr sz="2700" b="0">
-                <a:solidFill>
-                  <a:srgbClr val="F4F2EC"/>
-                </a:solidFill>
-                <a:latin typeface="Helvetica Neue"/>
-                <a:ea typeface="Helvetica Neue"/>
-                <a:cs typeface="Helvetica Neue"/>
-              </a:defRPr>
-            </a:pPr>
-            <a:r>
-              <a:rPr sz="2700" b="0">
-                <a:solidFill>
-                  <a:srgbClr val="F4F2EC"/>
-                </a:solidFill>
-                <a:latin typeface="Helvetica Neue"/>
-                <a:ea typeface="Helvetica Neue"/>
-                <a:cs typeface="Helvetica Neue"/>
-              </a:rPr>
-              <a:t>Instalim kur mbështetet</a:t>
+              <a:defRPr sz="1875" b="0">
+                <a:solidFill>
+                  <a:srgbClr val="F5F7F9"/>
+                </a:solidFill>
+                <a:latin typeface="Helvetica Neue"/>
+                <a:ea typeface="Helvetica Neue"/>
+                <a:cs typeface="Helvetica Neue"/>
+              </a:defRPr>
+            </a:pPr>
+            <a:r>
+              <a:rPr sz="1875" b="0">
+                <a:solidFill>
+                  <a:srgbClr val="F5F7F9"/>
+                </a:solidFill>
+                <a:latin typeface="Helvetica Neue"/>
+                <a:ea typeface="Helvetica Neue"/>
+                <a:cs typeface="Helvetica Neue"/>
+              </a:rPr>
+              <a:t>hapet nga një link.</a:t>
             </a:r>
           </a:p>
           <a:p xmlns:a="http://schemas.openxmlformats.org/drawingml/2006/main">
             <a:pPr algn="l">
               <a:buNone/>
-              <a:defRPr sz="2700" b="0">
-                <a:solidFill>
-                  <a:srgbClr val="F4F2EC"/>
-                </a:solidFill>
-                <a:latin typeface="Helvetica Neue"/>
-                <a:ea typeface="Helvetica Neue"/>
-                <a:cs typeface="Helvetica Neue"/>
-              </a:defRPr>
-            </a:pPr>
-            <a:r>
-              <a:rPr sz="2700" b="0">
-                <a:solidFill>
-                  <a:srgbClr val="F4F2EC"/>
-                </a:solidFill>
-                <a:latin typeface="Helvetica Neue"/>
-                <a:ea typeface="Helvetica Neue"/>
-                <a:cs typeface="Helvetica Neue"/>
-              </a:rPr>
-              <a:t>Sjellje offline e projektuar</a:t>
+              <a:defRPr sz="1875" b="0">
+                <a:solidFill>
+                  <a:srgbClr val="F5F7F9"/>
+                </a:solidFill>
+                <a:latin typeface="Helvetica Neue"/>
+                <a:ea typeface="Helvetica Neue"/>
+                <a:cs typeface="Helvetica Neue"/>
+              </a:defRPr>
+            </a:pPr>
+            <a:r>
+              <a:rPr sz="1875" b="0">
+                <a:solidFill>
+                  <a:srgbClr val="F5F7F9"/>
+                </a:solidFill>
+                <a:latin typeface="Helvetica Neue"/>
+                <a:ea typeface="Helvetica Neue"/>
+                <a:cs typeface="Helvetica Neue"/>
+              </a:rPr>
+              <a:t>Instalohet kur mbështetet.</a:t>
+            </a:r>
+          </a:p>
+          <a:p xmlns:a="http://schemas.openxmlformats.org/drawingml/2006/main">
+            <a:pPr algn="l">
+              <a:buNone/>
+              <a:defRPr sz="1875" b="0">
+                <a:solidFill>
+                  <a:srgbClr val="F5F7F9"/>
+                </a:solidFill>
+                <a:latin typeface="Helvetica Neue"/>
+                <a:ea typeface="Helvetica Neue"/>
+                <a:cs typeface="Helvetica Neue"/>
+              </a:defRPr>
+            </a:pPr>
+            <a:r>
+              <a:rPr sz="1875" b="0">
+                <a:solidFill>
+                  <a:srgbClr val="F5F7F9"/>
+                </a:solidFill>
+                <a:latin typeface="Helvetica Neue"/>
+                <a:ea typeface="Helvetica Neue"/>
+                <a:cs typeface="Helvetica Neue"/>
+              </a:rPr>
+              <a:t>Sjellja offline projektohet.</a:t>
             </a:r>
           </a:p>
         </p:txBody>
@@ -11402,7 +11402,7 @@
                 <a:ea typeface="Helvetica Neue"/>
                 <a:cs typeface="Helvetica Neue"/>
               </a:rPr>
-              <a:t>AAB RideShare</a:t>
+              <a:t>Restoranti Sofra</a:t>
             </a:r>
           </a:p>
         </p:txBody>
@@ -11460,7 +11460,7 @@
                 <a:ea typeface="Helvetica Neue"/>
                 <a:cs typeface="Helvetica Neue"/>
               </a:rPr>
-              <a:t>Udhëtimet</a:t>
+              <a:t>MENU</a:t>
             </a:r>
           </a:p>
         </p:txBody>
@@ -11518,31 +11518,7 @@
                 <a:ea typeface="Helvetica Neue"/>
                 <a:cs typeface="Helvetica Neue"/>
               </a:rPr>
-              <a:t>Fushë Kosovë</a:t>
-            </a:r>
-          </a:p>
-          <a:p xmlns:a="http://schemas.openxmlformats.org/drawingml/2006/main">
-            <a:pPr algn="l">
-              <a:buNone/>
-              <a:defRPr sz="2025" b="1">
-                <a:solidFill>
-                  <a:srgbClr val="F4F2EC"/>
-                </a:solidFill>
-                <a:latin typeface="Helvetica Neue"/>
-                <a:ea typeface="Helvetica Neue"/>
-                <a:cs typeface="Helvetica Neue"/>
-              </a:defRPr>
-            </a:pPr>
-            <a:r>
-              <a:rPr sz="2025" b="1">
-                <a:solidFill>
-                  <a:srgbClr val="F4F2EC"/>
-                </a:solidFill>
-                <a:latin typeface="Helvetica Neue"/>
-                <a:ea typeface="Helvetica Neue"/>
-                <a:cs typeface="Helvetica Neue"/>
-              </a:rPr>
-              <a:t>Kampus</a:t>
+              <a:t>Tavë shtëpie</a:t>
             </a:r>
           </a:p>
         </p:txBody>
@@ -11582,25 +11558,25 @@
           <a:p xmlns:a="http://schemas.openxmlformats.org/drawingml/2006/main">
             <a:pPr algn="l">
               <a:buNone/>
-              <a:defRPr sz="1725" b="0">
-                <a:solidFill>
-                  <a:srgbClr val="AEBFCB"/>
-                </a:solidFill>
-                <a:latin typeface="Helvetica Neue"/>
-                <a:ea typeface="Helvetica Neue"/>
-                <a:cs typeface="Helvetica Neue"/>
-              </a:defRPr>
-            </a:pPr>
-            <a:r>
-              <a:rPr sz="1725" b="0">
-                <a:solidFill>
-                  <a:srgbClr val="AEBFCB"/>
-                </a:solidFill>
-                <a:latin typeface="Helvetica Neue"/>
-                <a:ea typeface="Helvetica Neue"/>
-                <a:cs typeface="Helvetica Neue"/>
-              </a:rPr>
-              <a:t>07:30     1 vend</a:t>
+              <a:defRPr sz="1125" b="0">
+                <a:solidFill>
+                  <a:srgbClr val="B6C5CE"/>
+                </a:solidFill>
+                <a:latin typeface="Helvetica Neue"/>
+                <a:ea typeface="Helvetica Neue"/>
+                <a:cs typeface="Helvetica Neue"/>
+              </a:defRPr>
+            </a:pPr>
+            <a:r>
+              <a:rPr sz="1125" b="0">
+                <a:solidFill>
+                  <a:srgbClr val="B6C5CE"/>
+                </a:solidFill>
+                <a:latin typeface="Helvetica Neue"/>
+                <a:ea typeface="Helvetica Neue"/>
+                <a:cs typeface="Helvetica Neue"/>
+              </a:rPr>
+              <a:t>8 €     Në dispozicion</a:t>
             </a:r>
           </a:p>
         </p:txBody>
@@ -11690,7 +11666,7 @@
                 <a:ea typeface="Helvetica Neue"/>
                 <a:cs typeface="Helvetica Neue"/>
               </a:rPr>
-              <a:t>Shiko detajet</a:t>
+              <a:t>Shto</a:t>
             </a:r>
           </a:p>
         </p:txBody>
@@ -11748,7 +11724,7 @@
                 <a:ea typeface="Helvetica Neue"/>
                 <a:cs typeface="Helvetica Neue"/>
               </a:rPr>
-              <a:t>Zgjedhja varet nga aftësitë e pajisjes dhe kërkesat e produktit.</a:t>
+              <a:t>Piloti nis me një link, pa publikim fillestar në App Store.</a:t>
             </a:r>
           </a:p>
         </p:txBody>
@@ -11762,7 +11738,7 @@
           <p:nvPr/>
         </p:nvPicPr>
         <p:blipFill>
-          <a:blip xmlns:r="http://schemas.openxmlformats.org/officeDocument/2006/relationships" xmlns:a="http://schemas.openxmlformats.org/drawingml/2006/main" r:embed="R1afc3fae45b64d34"/>
+          <a:blip xmlns:r="http://schemas.openxmlformats.org/officeDocument/2006/relationships" xmlns:a="http://schemas.openxmlformats.org/drawingml/2006/main" r:embed="R2462c9486002476f"/>
           <a:stretch xmlns:a="http://schemas.openxmlformats.org/drawingml/2006/main"/>
         </p:blipFill>
         <p:spPr>
@@ -11838,6 +11814,7 @@
           <a:lstStyle xmlns:a="http://schemas.openxmlformats.org/drawingml/2006/main"/>
           <a:p xmlns:a="http://schemas.openxmlformats.org/drawingml/2006/main">
             <a:pPr>
+              <a:buNone/>
               <a:defRPr sz="1350" b="1">
                 <a:solidFill>
                   <a:srgbClr val="5DCEF2"/>
@@ -11895,6 +11872,7 @@
           <a:lstStyle xmlns:a="http://schemas.openxmlformats.org/drawingml/2006/main"/>
           <a:p xmlns:a="http://schemas.openxmlformats.org/drawingml/2006/main">
             <a:pPr>
+              <a:buNone/>
               <a:defRPr sz="3600" b="1">
                 <a:solidFill>
                   <a:srgbClr val="F5F7F9"/>
@@ -11952,6 +11930,7 @@
           <a:lstStyle xmlns:a="http://schemas.openxmlformats.org/drawingml/2006/main"/>
           <a:p xmlns:a="http://schemas.openxmlformats.org/drawingml/2006/main">
             <a:pPr>
+              <a:buNone/>
               <a:defRPr sz="3600" b="1">
                 <a:solidFill>
                   <a:srgbClr val="5DCEF2"/>
@@ -12009,6 +11988,7 @@
           <a:lstStyle xmlns:a="http://schemas.openxmlformats.org/drawingml/2006/main"/>
           <a:p xmlns:a="http://schemas.openxmlformats.org/drawingml/2006/main">
             <a:pPr>
+              <a:buNone/>
               <a:defRPr sz="2550" b="0">
                 <a:solidFill>
                   <a:srgbClr val="F5F7F9"/>
@@ -12032,6 +12012,7 @@
           </a:p>
           <a:p xmlns:a="http://schemas.openxmlformats.org/drawingml/2006/main">
             <a:pPr>
+              <a:buNone/>
               <a:defRPr sz="2550" b="0">
                 <a:solidFill>
                   <a:srgbClr val="F5F7F9"/>
@@ -12055,6 +12036,7 @@
           </a:p>
           <a:p xmlns:a="http://schemas.openxmlformats.org/drawingml/2006/main">
             <a:pPr>
+              <a:buNone/>
               <a:defRPr sz="2550" b="0">
                 <a:solidFill>
                   <a:srgbClr val="F5F7F9"/>
@@ -12112,6 +12094,7 @@
           <a:lstStyle xmlns:a="http://schemas.openxmlformats.org/drawingml/2006/main"/>
           <a:p xmlns:a="http://schemas.openxmlformats.org/drawingml/2006/main">
             <a:pPr>
+              <a:buNone/>
               <a:defRPr sz="3600" b="1">
                 <a:solidFill>
                   <a:srgbClr val="5DCEF2"/>
@@ -12169,6 +12152,7 @@
           <a:lstStyle xmlns:a="http://schemas.openxmlformats.org/drawingml/2006/main"/>
           <a:p xmlns:a="http://schemas.openxmlformats.org/drawingml/2006/main">
             <a:pPr>
+              <a:buNone/>
               <a:defRPr sz="2550" b="0">
                 <a:solidFill>
                   <a:srgbClr val="F5F7F9"/>
@@ -12192,6 +12176,7 @@
           </a:p>
           <a:p xmlns:a="http://schemas.openxmlformats.org/drawingml/2006/main">
             <a:pPr>
+              <a:buNone/>
               <a:defRPr sz="2550" b="0">
                 <a:solidFill>
                   <a:srgbClr val="F5F7F9"/>
@@ -12215,6 +12200,7 @@
           </a:p>
           <a:p xmlns:a="http://schemas.openxmlformats.org/drawingml/2006/main">
             <a:pPr>
+              <a:buNone/>
               <a:defRPr sz="2550" b="0">
                 <a:solidFill>
                   <a:srgbClr val="F5F7F9"/>
@@ -12272,6 +12258,7 @@
           <a:lstStyle xmlns:a="http://schemas.openxmlformats.org/drawingml/2006/main"/>
           <a:p xmlns:a="http://schemas.openxmlformats.org/drawingml/2006/main">
             <a:pPr>
+              <a:buNone/>
               <a:defRPr sz="2100" b="0">
                 <a:solidFill>
                   <a:srgbClr val="B6C5CE"/>
@@ -12290,7 +12277,7 @@
                 <a:ea typeface="Helvetica Neue"/>
                 <a:cs typeface="Helvetica Neue"/>
               </a:rPr>
-              <a:t>Një student, një aplikacion, përmirësime gjatë gjithë semestrit</a:t>
+              <a:t>Restoranti është shembulli i ligjëratës. Biznesi juaj është projekti semestral.</a:t>
             </a:r>
           </a:p>
         </p:txBody>
@@ -12329,6 +12316,7 @@
           <a:lstStyle xmlns:a="http://schemas.openxmlformats.org/drawingml/2006/main"/>
           <a:p xmlns:a="http://schemas.openxmlformats.org/drawingml/2006/main">
             <a:pPr>
+              <a:buNone/>
               <a:defRPr sz="1350" b="0">
                 <a:solidFill>
                   <a:srgbClr val="B6C5CE"/>
@@ -12354,14 +12342,14 @@
       </p:sp>
       <p:pic>
         <p:nvPicPr>
-          <p:cNvPr id="18" name=""/>
+          <p:cNvPr id="20" name=""/>
           <p:cNvPicPr>
             <a:picLocks xmlns:a="http://schemas.openxmlformats.org/drawingml/2006/main" noChangeAspect="1"/>
           </p:cNvPicPr>
           <p:nvPr/>
         </p:nvPicPr>
         <p:blipFill>
-          <a:blip xmlns:r="http://schemas.openxmlformats.org/officeDocument/2006/relationships" xmlns:a="http://schemas.openxmlformats.org/drawingml/2006/main" r:embed="R1fc20b2eaa22486f"/>
+          <a:blip xmlns:r="http://schemas.openxmlformats.org/officeDocument/2006/relationships" xmlns:a="http://schemas.openxmlformats.org/drawingml/2006/main" r:embed="R3c2d012dc1594b0b"/>
           <a:stretch xmlns:a="http://schemas.openxmlformats.org/drawingml/2006/main"/>
         </p:blipFill>
         <p:spPr>
@@ -12572,7 +12560,7 @@
                 <a:ea typeface="Helvetica Neue"/>
                 <a:cs typeface="Helvetica Neue"/>
               </a:rPr>
-              <a:t>Ku ekzekutohet vendimi?</a:t>
+              <a:t>Telefon, server dhe të dhëna</a:t>
             </a:r>
           </a:p>
         </p:txBody>
@@ -12838,7 +12826,7 @@
                 <a:ea typeface="Helvetica Neue"/>
                 <a:cs typeface="Helvetica Neue"/>
               </a:rPr>
-              <a:t>React 19</a:t>
+              <a:t>Next.js PWA</a:t>
             </a:r>
           </a:p>
         </p:txBody>
@@ -12896,7 +12884,7 @@
                 <a:ea typeface="Helvetica Neue"/>
                 <a:cs typeface="Helvetica Neue"/>
               </a:rPr>
-              <a:t>Ndërfaqja mobile</a:t>
+              <a:t>Menu / Cart</a:t>
             </a:r>
           </a:p>
         </p:txBody>
@@ -13018,7 +13006,7 @@
                 <a:ea typeface="Helvetica Neue"/>
                 <a:cs typeface="Helvetica Neue"/>
               </a:rPr>
-              <a:t>Next.js 15</a:t>
+              <a:t>Next.js API</a:t>
             </a:r>
           </a:p>
         </p:txBody>
@@ -13076,7 +13064,7 @@
                 <a:ea typeface="Helvetica Neue"/>
                 <a:cs typeface="Helvetica Neue"/>
               </a:rPr>
-              <a:t>App Router / Vercel</a:t>
+              <a:t>Krijon porosinë</a:t>
             </a:r>
           </a:p>
         </p:txBody>
@@ -13256,7 +13244,7 @@
                 <a:ea typeface="Helvetica Neue"/>
                 <a:cs typeface="Helvetica Neue"/>
               </a:rPr>
-              <a:t>Auth / PostgreSQL</a:t>
+              <a:t>Menu / status</a:t>
             </a:r>
           </a:p>
         </p:txBody>
@@ -13314,7 +13302,7 @@
                 <a:ea typeface="Helvetica Neue"/>
                 <a:cs typeface="Helvetica Neue"/>
               </a:rPr>
-              <a:t>TypeScript + Tailwind</a:t>
+              <a:t>Dërgon qëllimin</a:t>
             </a:r>
           </a:p>
         </p:txBody>
@@ -13354,25 +13342,25 @@
           <a:p xmlns:a="http://schemas.openxmlformats.org/drawingml/2006/main">
             <a:pPr algn="l">
               <a:buNone/>
-              <a:defRPr sz="1950" b="0">
-                <a:solidFill>
-                  <a:srgbClr val="AEBFCB"/>
-                </a:solidFill>
-                <a:latin typeface="Helvetica Neue"/>
-                <a:ea typeface="Helvetica Neue"/>
-                <a:cs typeface="Helvetica Neue"/>
-              </a:defRPr>
-            </a:pPr>
-            <a:r>
-              <a:rPr sz="1950" b="0">
-                <a:solidFill>
-                  <a:srgbClr val="AEBFCB"/>
-                </a:solidFill>
-                <a:latin typeface="Helvetica Neue"/>
-                <a:ea typeface="Helvetica Neue"/>
-                <a:cs typeface="Helvetica Neue"/>
-              </a:rPr>
-              <a:t>Server / Client Components</a:t>
+              <a:defRPr sz="1350" b="0">
+                <a:solidFill>
+                  <a:srgbClr val="B6C5CE"/>
+                </a:solidFill>
+                <a:latin typeface="Helvetica Neue"/>
+                <a:ea typeface="Helvetica Neue"/>
+                <a:cs typeface="Helvetica Neue"/>
+              </a:defRPr>
+            </a:pPr>
+            <a:r>
+              <a:rPr sz="1350" b="0">
+                <a:solidFill>
+                  <a:srgbClr val="B6C5CE"/>
+                </a:solidFill>
+                <a:latin typeface="Helvetica Neue"/>
+                <a:ea typeface="Helvetica Neue"/>
+                <a:cs typeface="Helvetica Neue"/>
+              </a:rPr>
+              <a:t>Verifikon dhe shmang dublikatën</a:t>
             </a:r>
           </a:p>
         </p:txBody>
@@ -13412,25 +13400,25 @@
           <a:p xmlns:a="http://schemas.openxmlformats.org/drawingml/2006/main">
             <a:pPr algn="l">
               <a:buNone/>
-              <a:defRPr sz="1950" b="0">
-                <a:solidFill>
-                  <a:srgbClr val="AEBFCB"/>
-                </a:solidFill>
-                <a:latin typeface="Helvetica Neue"/>
-                <a:ea typeface="Helvetica Neue"/>
-                <a:cs typeface="Helvetica Neue"/>
-              </a:defRPr>
-            </a:pPr>
-            <a:r>
-              <a:rPr sz="1950" b="0">
-                <a:solidFill>
-                  <a:srgbClr val="AEBFCB"/>
-                </a:solidFill>
-                <a:latin typeface="Helvetica Neue"/>
-                <a:ea typeface="Helvetica Neue"/>
-                <a:cs typeface="Helvetica Neue"/>
-              </a:rPr>
-              <a:t>RLS + rregullat e të dhënave</a:t>
+              <a:defRPr sz="1350" b="0">
+                <a:solidFill>
+                  <a:srgbClr val="B6C5CE"/>
+                </a:solidFill>
+                <a:latin typeface="Helvetica Neue"/>
+                <a:ea typeface="Helvetica Neue"/>
+                <a:cs typeface="Helvetica Neue"/>
+              </a:defRPr>
+            </a:pPr>
+            <a:r>
+              <a:rPr sz="1350" b="0">
+                <a:solidFill>
+                  <a:srgbClr val="B6C5CE"/>
+                </a:solidFill>
+                <a:latin typeface="Helvetica Neue"/>
+                <a:ea typeface="Helvetica Neue"/>
+                <a:cs typeface="Helvetica Neue"/>
+              </a:rPr>
+              <a:t>RLS zbaton lejet</a:t>
             </a:r>
           </a:p>
         </p:txBody>
@@ -13488,7 +13476,7 @@
                 <a:ea typeface="Helvetica Neue"/>
                 <a:cs typeface="Helvetica Neue"/>
               </a:rPr>
-              <a:t>Ku kontrollohet ndryshimi i numrit të vendeve?</a:t>
+              <a:t>Ku ndryshon disponueshmëria e vaktit ose statusi i porosisë?</a:t>
             </a:r>
           </a:p>
         </p:txBody>
@@ -13502,7 +13490,7 @@
           <p:nvPr/>
         </p:nvPicPr>
         <p:blipFill>
-          <a:blip xmlns:r="http://schemas.openxmlformats.org/officeDocument/2006/relationships" xmlns:a="http://schemas.openxmlformats.org/drawingml/2006/main" r:embed="R98ace120382a43e3"/>
+          <a:blip xmlns:r="http://schemas.openxmlformats.org/officeDocument/2006/relationships" xmlns:a="http://schemas.openxmlformats.org/drawingml/2006/main" r:embed="R70e85076b7a34c75"/>
           <a:stretch xmlns:a="http://schemas.openxmlformats.org/drawingml/2006/main"/>
         </p:blipFill>
         <p:spPr>
@@ -13713,7 +13701,7 @@
                 <a:ea typeface="Helvetica Neue"/>
                 <a:cs typeface="Helvetica Neue"/>
               </a:rPr>
-              <a:t>Telefoni kërkon. Sistemi verifikon.</a:t>
+              <a:t>Vetëm stafi ndryshon menunë dhe statusin</a:t>
             </a:r>
           </a:p>
         </p:txBody>
@@ -13903,25 +13891,25 @@
           <a:p xmlns:a="http://schemas.openxmlformats.org/drawingml/2006/main">
             <a:pPr algn="ctr">
               <a:buNone/>
-              <a:defRPr sz="2250" b="1">
-                <a:solidFill>
-                  <a:srgbClr val="63CDF2"/>
-                </a:solidFill>
-                <a:latin typeface="Helvetica Neue"/>
-                <a:ea typeface="Helvetica Neue"/>
-                <a:cs typeface="Helvetica Neue"/>
-              </a:defRPr>
-            </a:pPr>
-            <a:r>
-              <a:rPr sz="2250" b="1">
-                <a:solidFill>
-                  <a:srgbClr val="63CDF2"/>
-                </a:solidFill>
-                <a:latin typeface="Helvetica Neue"/>
-                <a:ea typeface="Helvetica Neue"/>
-                <a:cs typeface="Helvetica Neue"/>
-              </a:rPr>
-              <a:t>Ndrysho udhëtimin 42</a:t>
+              <a:defRPr sz="1350" b="1">
+                <a:solidFill>
+                  <a:srgbClr val="F5F7F9"/>
+                </a:solidFill>
+                <a:latin typeface="Helvetica Neue"/>
+                <a:ea typeface="Helvetica Neue"/>
+                <a:cs typeface="Helvetica Neue"/>
+              </a:defRPr>
+            </a:pPr>
+            <a:r>
+              <a:rPr sz="1350" b="1">
+                <a:solidFill>
+                  <a:srgbClr val="F5F7F9"/>
+                </a:solidFill>
+                <a:latin typeface="Helvetica Neue"/>
+                <a:ea typeface="Helvetica Neue"/>
+                <a:cs typeface="Helvetica Neue"/>
+              </a:rPr>
+              <a:t>Ndrysho statusin e porosisë #1042</a:t>
             </a:r>
           </a:p>
         </p:txBody>
@@ -14367,7 +14355,7 @@
                 <a:ea typeface="Helvetica Neue"/>
                 <a:cs typeface="Helvetica Neue"/>
               </a:rPr>
-              <a:t>A është ky pronari?</a:t>
+              <a:t>A është ky anëtar i stafit?</a:t>
             </a:r>
           </a:p>
         </p:txBody>
@@ -14541,7 +14529,7 @@
                 <a:ea typeface="Helvetica Neue"/>
                 <a:cs typeface="Helvetica Neue"/>
               </a:rPr>
-              <a:t>RLS + privilegjet e qasjes</a:t>
+              <a:t>RLS + roli i stafit</a:t>
             </a:r>
           </a:p>
         </p:txBody>
@@ -14613,7 +14601,7 @@
           <p:nvPr/>
         </p:nvPicPr>
         <p:blipFill>
-          <a:blip xmlns:r="http://schemas.openxmlformats.org/officeDocument/2006/relationships" xmlns:a="http://schemas.openxmlformats.org/drawingml/2006/main" r:embed="R5d14c913be434580"/>
+          <a:blip xmlns:r="http://schemas.openxmlformats.org/officeDocument/2006/relationships" xmlns:a="http://schemas.openxmlformats.org/drawingml/2006/main" r:embed="R33a1bf0371014d64"/>
           <a:stretch xmlns:a="http://schemas.openxmlformats.org/drawingml/2006/main"/>
         </p:blipFill>
         <p:spPr>
@@ -14980,7 +14968,7 @@
                 <a:ea typeface="Helvetica Neue"/>
                 <a:cs typeface="Helvetica Neue"/>
               </a:rPr>
-              <a:t>AAB RideShare</a:t>
+              <a:t>Restoranti Sofra</a:t>
             </a:r>
           </a:p>
         </p:txBody>
@@ -15096,7 +15084,7 @@
                 <a:ea typeface="Helvetica Neue"/>
                 <a:cs typeface="Helvetica Neue"/>
               </a:rPr>
-              <a:t>Pamje e ruajtur</a:t>
+              <a:t>Menu e ruajtur</a:t>
             </a:r>
           </a:p>
           <a:p xmlns:a="http://schemas.openxmlformats.org/drawingml/2006/main">
@@ -15120,7 +15108,7 @@
                 <a:ea typeface="Helvetica Neue"/>
                 <a:cs typeface="Helvetica Neue"/>
               </a:rPr>
-              <a:t>Përditësuar 07:10</a:t>
+              <a:t>Përditësuar 11:30</a:t>
             </a:r>
           </a:p>
         </p:txBody>
@@ -15190,49 +15178,49 @@
           <a:p xmlns:a="http://schemas.openxmlformats.org/drawingml/2006/main">
             <a:pPr algn="l">
               <a:buNone/>
-              <a:defRPr sz="1800" b="0">
-                <a:solidFill>
-                  <a:srgbClr val="F4F2EC"/>
-                </a:solidFill>
-                <a:latin typeface="Helvetica Neue"/>
-                <a:ea typeface="Helvetica Neue"/>
-                <a:cs typeface="Helvetica Neue"/>
-              </a:defRPr>
-            </a:pPr>
-            <a:r>
-              <a:rPr sz="1800" b="0">
-                <a:solidFill>
-                  <a:srgbClr val="F4F2EC"/>
-                </a:solidFill>
-                <a:latin typeface="Helvetica Neue"/>
-                <a:ea typeface="Helvetica Neue"/>
-                <a:cs typeface="Helvetica Neue"/>
-              </a:rPr>
-              <a:t>Konfirmimi kërkon</a:t>
+              <a:defRPr sz="1200" b="0">
+                <a:solidFill>
+                  <a:srgbClr val="B6C5CE"/>
+                </a:solidFill>
+                <a:latin typeface="Helvetica Neue"/>
+                <a:ea typeface="Helvetica Neue"/>
+                <a:cs typeface="Helvetica Neue"/>
+              </a:defRPr>
+            </a:pPr>
+            <a:r>
+              <a:rPr sz="1200" b="0">
+                <a:solidFill>
+                  <a:srgbClr val="B6C5CE"/>
+                </a:solidFill>
+                <a:latin typeface="Helvetica Neue"/>
+                <a:ea typeface="Helvetica Neue"/>
+                <a:cs typeface="Helvetica Neue"/>
+              </a:rPr>
+              <a:t>Mund të lexohet.</a:t>
             </a:r>
           </a:p>
           <a:p xmlns:a="http://schemas.openxmlformats.org/drawingml/2006/main">
             <a:pPr algn="l">
               <a:buNone/>
-              <a:defRPr sz="1800" b="0">
-                <a:solidFill>
-                  <a:srgbClr val="F4F2EC"/>
-                </a:solidFill>
-                <a:latin typeface="Helvetica Neue"/>
-                <a:ea typeface="Helvetica Neue"/>
-                <a:cs typeface="Helvetica Neue"/>
-              </a:defRPr>
-            </a:pPr>
-            <a:r>
-              <a:rPr sz="1800" b="0">
-                <a:solidFill>
-                  <a:srgbClr val="F4F2EC"/>
-                </a:solidFill>
-                <a:latin typeface="Helvetica Neue"/>
-                <a:ea typeface="Helvetica Neue"/>
-                <a:cs typeface="Helvetica Neue"/>
-              </a:rPr>
-              <a:t>lidhje me serverin.</a:t>
+              <a:defRPr sz="1200" b="0">
+                <a:solidFill>
+                  <a:srgbClr val="B6C5CE"/>
+                </a:solidFill>
+                <a:latin typeface="Helvetica Neue"/>
+                <a:ea typeface="Helvetica Neue"/>
+                <a:cs typeface="Helvetica Neue"/>
+              </a:defRPr>
+            </a:pPr>
+            <a:r>
+              <a:rPr sz="1200" b="0">
+                <a:solidFill>
+                  <a:srgbClr val="B6C5CE"/>
+                </a:solidFill>
+                <a:latin typeface="Helvetica Neue"/>
+                <a:ea typeface="Helvetica Neue"/>
+                <a:cs typeface="Helvetica Neue"/>
+              </a:rPr>
+              <a:t>MUND TË JETË E VJETRUAR</a:t>
             </a:r>
           </a:p>
         </p:txBody>
@@ -15774,7 +15762,7 @@
                 <a:ea typeface="Helvetica Neue"/>
                 <a:cs typeface="Helvetica Neue"/>
               </a:rPr>
-              <a:t>burime të përzgjedhura</a:t>
+              <a:t>menu e ruajtur</a:t>
             </a:r>
           </a:p>
         </p:txBody>
@@ -15832,7 +15820,7 @@
                 <a:ea typeface="Helvetica Neue"/>
                 <a:cs typeface="Helvetica Neue"/>
               </a:rPr>
-              <a:t>Çfarë mund të lexohet pa rrjet? Çfarë kërkon konfirmim?</a:t>
+              <a:t>Menuja lexohet offline. Porosia kërkon konfirmim nga serveri.</a:t>
             </a:r>
           </a:p>
         </p:txBody>
@@ -15846,7 +15834,7 @@
           <p:nvPr/>
         </p:nvPicPr>
         <p:blipFill>
-          <a:blip xmlns:r="http://schemas.openxmlformats.org/officeDocument/2006/relationships" xmlns:a="http://schemas.openxmlformats.org/drawingml/2006/main" r:embed="Rf8eaaf691b6349f2"/>
+          <a:blip xmlns:r="http://schemas.openxmlformats.org/officeDocument/2006/relationships" xmlns:a="http://schemas.openxmlformats.org/drawingml/2006/main" r:embed="Rfb48ce16e4d44311"/>
           <a:stretch xmlns:a="http://schemas.openxmlformats.org/drawingml/2006/main"/>
         </p:blipFill>
         <p:spPr>
@@ -16057,7 +16045,7 @@
                 <a:ea typeface="Helvetica Neue"/>
                 <a:cs typeface="Helvetica Neue"/>
               </a:rPr>
-              <a:t>Kërkesa nuk është konfirmim</a:t>
+              <a:t>Gjendja e porosisë</a:t>
             </a:r>
           </a:p>
         </p:txBody>
@@ -16115,7 +16103,7 @@
                 <a:ea typeface="Helvetica Neue"/>
                 <a:cs typeface="Helvetica Neue"/>
               </a:rPr>
-              <a:t>Dërgimi i pakonfirmuar</a:t>
+              <a:t>Statusi ndryshon vetëm me prova</a:t>
             </a:r>
           </a:p>
         </p:txBody>
@@ -16189,25 +16177,25 @@
           <a:p xmlns:a="http://schemas.openxmlformats.org/drawingml/2006/main">
             <a:pPr algn="ctr">
               <a:buNone/>
-              <a:defRPr sz="2250" b="1">
-                <a:solidFill>
-                  <a:srgbClr val="63CDF2"/>
-                </a:solidFill>
-                <a:latin typeface="Helvetica Neue"/>
-                <a:ea typeface="Helvetica Neue"/>
-                <a:cs typeface="Helvetica Neue"/>
-              </a:defRPr>
-            </a:pPr>
-            <a:r>
-              <a:rPr sz="2250" b="1">
-                <a:solidFill>
-                  <a:srgbClr val="63CDF2"/>
-                </a:solidFill>
-                <a:latin typeface="Helvetica Neue"/>
-                <a:ea typeface="Helvetica Neue"/>
-                <a:cs typeface="Helvetica Neue"/>
-              </a:rPr>
-              <a:t>Dërguar</a:t>
+              <a:defRPr sz="1500" b="1">
+                <a:solidFill>
+                  <a:srgbClr val="5DCEF2"/>
+                </a:solidFill>
+                <a:latin typeface="Helvetica Neue"/>
+                <a:ea typeface="Helvetica Neue"/>
+                <a:cs typeface="Helvetica Neue"/>
+              </a:defRPr>
+            </a:pPr>
+            <a:r>
+              <a:rPr sz="1500" b="1">
+                <a:solidFill>
+                  <a:srgbClr val="5DCEF2"/>
+                </a:solidFill>
+                <a:latin typeface="Helvetica Neue"/>
+                <a:ea typeface="Helvetica Neue"/>
+                <a:cs typeface="Helvetica Neue"/>
+              </a:rPr>
+              <a:t>Dërguar lokalisht</a:t>
             </a:r>
           </a:p>
         </p:txBody>
@@ -16299,7 +16287,7 @@
                 <a:ea typeface="Helvetica Neue"/>
                 <a:cs typeface="Helvetica Neue"/>
               </a:rPr>
-              <a:t>Në pritje</a:t>
+              <a:t>Marrë</a:t>
             </a:r>
           </a:p>
         </p:txBody>
@@ -16373,25 +16361,25 @@
           <a:p xmlns:a="http://schemas.openxmlformats.org/drawingml/2006/main">
             <a:pPr algn="ctr">
               <a:buNone/>
-              <a:defRPr sz="2250" b="1">
-                <a:solidFill>
-                  <a:srgbClr val="91DEBB"/>
-                </a:solidFill>
-                <a:latin typeface="Helvetica Neue"/>
-                <a:ea typeface="Helvetica Neue"/>
-                <a:cs typeface="Helvetica Neue"/>
-              </a:defRPr>
-            </a:pPr>
-            <a:r>
-              <a:rPr sz="2250" b="1">
-                <a:solidFill>
-                  <a:srgbClr val="91DEBB"/>
-                </a:solidFill>
-                <a:latin typeface="Helvetica Neue"/>
-                <a:ea typeface="Helvetica Neue"/>
-                <a:cs typeface="Helvetica Neue"/>
-              </a:rPr>
-              <a:t>Pranuar</a:t>
+              <a:defRPr sz="1575" b="1">
+                <a:solidFill>
+                  <a:srgbClr val="7FD3AA"/>
+                </a:solidFill>
+                <a:latin typeface="Helvetica Neue"/>
+                <a:ea typeface="Helvetica Neue"/>
+                <a:cs typeface="Helvetica Neue"/>
+              </a:defRPr>
+            </a:pPr>
+            <a:r>
+              <a:rPr sz="1575" b="1">
+                <a:solidFill>
+                  <a:srgbClr val="7FD3AA"/>
+                </a:solidFill>
+                <a:latin typeface="Helvetica Neue"/>
+                <a:ea typeface="Helvetica Neue"/>
+                <a:cs typeface="Helvetica Neue"/>
+              </a:rPr>
+              <a:t>Në përgatitje</a:t>
             </a:r>
           </a:p>
         </p:txBody>
@@ -16539,7 +16527,7 @@
                 <a:ea typeface="Helvetica Neue"/>
                 <a:cs typeface="Helvetica Neue"/>
               </a:rPr>
-              <a:t>Refuzuar / Anuluar</a:t>
+              <a:t>Gati</a:t>
             </a:r>
           </a:p>
         </p:txBody>
@@ -16597,7 +16585,7 @@
                 <a:ea typeface="Helvetica Neue"/>
                 <a:cs typeface="Helvetica Neue"/>
               </a:rPr>
-              <a:t>Pa përgjigje: dështim apo rezultat ende i panjohur?</a:t>
+              <a:t>Pa provë nga serveri: dështuar ose status i panjohur.</a:t>
             </a:r>
           </a:p>
         </p:txBody>
@@ -16611,7 +16599,7 @@
           <p:nvPr/>
         </p:nvPicPr>
         <p:blipFill>
-          <a:blip xmlns:r="http://schemas.openxmlformats.org/officeDocument/2006/relationships" xmlns:a="http://schemas.openxmlformats.org/drawingml/2006/main" r:embed="R349646eef29c4cd9"/>
+          <a:blip xmlns:r="http://schemas.openxmlformats.org/officeDocument/2006/relationships" xmlns:a="http://schemas.openxmlformats.org/drawingml/2006/main" r:embed="Rda8ee1ef3d224ab8"/>
           <a:stretch xmlns:a="http://schemas.openxmlformats.org/drawingml/2006/main"/>
         </p:blipFill>
         <p:spPr>
@@ -17036,25 +17024,25 @@
           <a:p xmlns:a="http://schemas.openxmlformats.org/drawingml/2006/main">
             <a:pPr algn="l">
               <a:buNone/>
-              <a:defRPr sz="2400" b="0">
-                <a:solidFill>
-                  <a:srgbClr val="AEBFCB"/>
-                </a:solidFill>
-                <a:latin typeface="Helvetica Neue"/>
-                <a:ea typeface="Helvetica Neue"/>
-                <a:cs typeface="Helvetica Neue"/>
-              </a:defRPr>
-            </a:pPr>
-            <a:r>
-              <a:rPr sz="2400" b="0">
-                <a:solidFill>
-                  <a:srgbClr val="AEBFCB"/>
-                </a:solidFill>
-                <a:latin typeface="Helvetica Neue"/>
-                <a:ea typeface="Helvetica Neue"/>
-                <a:cs typeface="Helvetica Neue"/>
-              </a:rPr>
-              <a:t>Supozimin</a:t>
+              <a:defRPr sz="1500" b="0">
+                <a:solidFill>
+                  <a:srgbClr val="B6C5CE"/>
+                </a:solidFill>
+                <a:latin typeface="Helvetica Neue"/>
+                <a:ea typeface="Helvetica Neue"/>
+                <a:cs typeface="Helvetica Neue"/>
+              </a:defRPr>
+            </a:pPr>
+            <a:r>
+              <a:rPr sz="1500" b="0">
+                <a:solidFill>
+                  <a:srgbClr val="B6C5CE"/>
+                </a:solidFill>
+                <a:latin typeface="Helvetica Neue"/>
+                <a:ea typeface="Helvetica Neue"/>
+                <a:cs typeface="Helvetica Neue"/>
+              </a:rPr>
+              <a:t>Identitetin e porosisë</a:t>
             </a:r>
           </a:p>
         </p:txBody>
@@ -17094,25 +17082,25 @@
           <a:p xmlns:a="http://schemas.openxmlformats.org/drawingml/2006/main">
             <a:pPr algn="l">
               <a:buNone/>
-              <a:defRPr sz="2400" b="0">
-                <a:solidFill>
-                  <a:srgbClr val="AEBFCB"/>
-                </a:solidFill>
-                <a:latin typeface="Helvetica Neue"/>
-                <a:ea typeface="Helvetica Neue"/>
-                <a:cs typeface="Helvetica Neue"/>
-              </a:defRPr>
-            </a:pPr>
-            <a:r>
-              <a:rPr sz="2400" b="0">
-                <a:solidFill>
-                  <a:srgbClr val="AEBFCB"/>
-                </a:solidFill>
-                <a:latin typeface="Helvetica Neue"/>
-                <a:ea typeface="Helvetica Neue"/>
-                <a:cs typeface="Helvetica Neue"/>
-              </a:rPr>
-              <a:t>Vendimin</a:t>
+              <a:defRPr sz="1500" b="0">
+                <a:solidFill>
+                  <a:srgbClr val="B6C5CE"/>
+                </a:solidFill>
+                <a:latin typeface="Helvetica Neue"/>
+                <a:ea typeface="Helvetica Neue"/>
+                <a:cs typeface="Helvetica Neue"/>
+              </a:defRPr>
+            </a:pPr>
+            <a:r>
+              <a:rPr sz="1500" b="0">
+                <a:solidFill>
+                  <a:srgbClr val="B6C5CE"/>
+                </a:solidFill>
+                <a:latin typeface="Helvetica Neue"/>
+                <a:ea typeface="Helvetica Neue"/>
+                <a:cs typeface="Helvetica Neue"/>
+              </a:rPr>
+              <a:t>Disponueshmërinë</a:t>
             </a:r>
           </a:p>
         </p:txBody>
@@ -17152,25 +17140,25 @@
           <a:p xmlns:a="http://schemas.openxmlformats.org/drawingml/2006/main">
             <a:pPr algn="l">
               <a:buNone/>
-              <a:defRPr sz="2325" b="0">
-                <a:solidFill>
-                  <a:srgbClr val="AEBFCB"/>
-                </a:solidFill>
-                <a:latin typeface="Helvetica Neue"/>
-                <a:ea typeface="Helvetica Neue"/>
-                <a:cs typeface="Helvetica Neue"/>
-              </a:defRPr>
-            </a:pPr>
-            <a:r>
-              <a:rPr sz="2325" b="0">
-                <a:solidFill>
-                  <a:srgbClr val="AEBFCB"/>
-                </a:solidFill>
-                <a:latin typeface="Helvetica Neue"/>
-                <a:ea typeface="Helvetica Neue"/>
-                <a:cs typeface="Helvetica Neue"/>
-              </a:rPr>
-              <a:t>Kundërshembullin</a:t>
+              <a:defRPr sz="1425" b="0">
+                <a:solidFill>
+                  <a:srgbClr val="B6C5CE"/>
+                </a:solidFill>
+                <a:latin typeface="Helvetica Neue"/>
+                <a:ea typeface="Helvetica Neue"/>
+                <a:cs typeface="Helvetica Neue"/>
+              </a:defRPr>
+            </a:pPr>
+            <a:r>
+              <a:rPr sz="1425" b="0">
+                <a:solidFill>
+                  <a:srgbClr val="B6C5CE"/>
+                </a:solidFill>
+                <a:latin typeface="Helvetica Neue"/>
+                <a:ea typeface="Helvetica Neue"/>
+                <a:cs typeface="Helvetica Neue"/>
+              </a:rPr>
+              <a:t>Riprovimin pa dublikatë</a:t>
             </a:r>
           </a:p>
         </p:txBody>
@@ -17286,7 +17274,7 @@
                 <a:ea typeface="Helvetica Neue"/>
                 <a:cs typeface="Helvetica Neue"/>
               </a:rPr>
-              <a:t>Çfarë po supozon zgjidhja që propozoi AI?</a:t>
+              <a:t>Çfarë supozon AI për identitetin, disponueshmërinë dhe retry-t?</a:t>
             </a:r>
           </a:p>
         </p:txBody>
@@ -17300,7 +17288,7 @@
           <p:nvPr/>
         </p:nvPicPr>
         <p:blipFill>
-          <a:blip xmlns:r="http://schemas.openxmlformats.org/officeDocument/2006/relationships" xmlns:a="http://schemas.openxmlformats.org/drawingml/2006/main" r:embed="Rc08b661624bd4359"/>
+          <a:blip xmlns:r="http://schemas.openxmlformats.org/officeDocument/2006/relationships" xmlns:a="http://schemas.openxmlformats.org/drawingml/2006/main" r:embed="Rdec5b89e0d3649d7"/>
           <a:stretch xmlns:a="http://schemas.openxmlformats.org/drawingml/2006/main"/>
         </p:blipFill>
         <p:spPr>
@@ -17551,25 +17539,25 @@
           <a:p xmlns:a="http://schemas.openxmlformats.org/drawingml/2006/main">
             <a:pPr algn="l">
               <a:buNone/>
-              <a:defRPr sz="3525" b="0">
-                <a:solidFill>
-                  <a:srgbClr val="AEBFCB"/>
-                </a:solidFill>
-                <a:latin typeface="Helvetica Neue"/>
-                <a:ea typeface="Helvetica Neue"/>
-                <a:cs typeface="Helvetica Neue"/>
-              </a:defRPr>
-            </a:pPr>
-            <a:r>
-              <a:rPr sz="3525" b="0">
-                <a:solidFill>
-                  <a:srgbClr val="AEBFCB"/>
-                </a:solidFill>
-                <a:latin typeface="Helvetica Neue"/>
-                <a:ea typeface="Helvetica Neue"/>
-                <a:cs typeface="Helvetica Neue"/>
-              </a:rPr>
-              <a:t>“Ndërto RideShare.”</a:t>
+              <a:defRPr sz="1650" b="0">
+                <a:solidFill>
+                  <a:srgbClr val="B6C5CE"/>
+                </a:solidFill>
+                <a:latin typeface="Helvetica Neue"/>
+                <a:ea typeface="Helvetica Neue"/>
+                <a:cs typeface="Helvetica Neue"/>
+              </a:defRPr>
+            </a:pPr>
+            <a:r>
+              <a:rPr sz="1650" b="0">
+                <a:solidFill>
+                  <a:srgbClr val="B6C5CE"/>
+                </a:solidFill>
+                <a:latin typeface="Helvetica Neue"/>
+                <a:ea typeface="Helvetica Neue"/>
+                <a:cs typeface="Helvetica Neue"/>
+              </a:rPr>
+              <a:t>“Krijo operacionin e porosisë për një restorant. Përdor një idempotency key që retry-t të mos krijojnë dublikatë.”</a:t>
             </a:r>
           </a:p>
         </p:txBody>
@@ -17715,7 +17703,7 @@
                 <a:ea typeface="Helvetica Neue"/>
                 <a:cs typeface="Helvetica Neue"/>
               </a:rPr>
-              <a:t>Kërko një vend</a:t>
+              <a:t>Krijo porosinë</a:t>
             </a:r>
           </a:p>
         </p:txBody>
@@ -17813,25 +17801,25 @@
           <a:p xmlns:a="http://schemas.openxmlformats.org/drawingml/2006/main">
             <a:pPr algn="l">
               <a:buNone/>
-              <a:defRPr sz="2400" b="0">
-                <a:solidFill>
-                  <a:srgbClr val="F4F2EC"/>
-                </a:solidFill>
-                <a:latin typeface="Helvetica Neue"/>
-                <a:ea typeface="Helvetica Neue"/>
-                <a:cs typeface="Helvetica Neue"/>
-              </a:defRPr>
-            </a:pPr>
-            <a:r>
-              <a:rPr sz="2400" b="0">
-                <a:solidFill>
-                  <a:srgbClr val="F4F2EC"/>
-                </a:solidFill>
-                <a:latin typeface="Helvetica Neue"/>
-                <a:ea typeface="Helvetica Neue"/>
-                <a:cs typeface="Helvetica Neue"/>
-              </a:rPr>
-              <a:t>Identitet i verifikuar, pa dublikatë</a:t>
+              <a:defRPr sz="1425" b="0">
+                <a:solidFill>
+                  <a:srgbClr val="F5F7F9"/>
+                </a:solidFill>
+                <a:latin typeface="Helvetica Neue"/>
+                <a:ea typeface="Helvetica Neue"/>
+                <a:cs typeface="Helvetica Neue"/>
+              </a:defRPr>
+            </a:pPr>
+            <a:r>
+              <a:rPr sz="1425" b="0">
+                <a:solidFill>
+                  <a:srgbClr val="F5F7F9"/>
+                </a:solidFill>
+                <a:latin typeface="Helvetica Neue"/>
+                <a:ea typeface="Helvetica Neue"/>
+                <a:cs typeface="Helvetica Neue"/>
+              </a:rPr>
+              <a:t>Sesioni jep klientin. Menuja verifikon disponueshmërinë.</a:t>
             </a:r>
           </a:p>
         </p:txBody>
@@ -17929,25 +17917,25 @@
           <a:p xmlns:a="http://schemas.openxmlformats.org/drawingml/2006/main">
             <a:pPr algn="l">
               <a:buNone/>
-              <a:defRPr sz="2400" b="0">
-                <a:solidFill>
-                  <a:srgbClr val="F4F2EC"/>
-                </a:solidFill>
-                <a:latin typeface="Helvetica Neue"/>
-                <a:ea typeface="Helvetica Neue"/>
-                <a:cs typeface="Helvetica Neue"/>
-              </a:defRPr>
-            </a:pPr>
-            <a:r>
-              <a:rPr sz="2400" b="0">
-                <a:solidFill>
-                  <a:srgbClr val="F4F2EC"/>
-                </a:solidFill>
-                <a:latin typeface="Helvetica Neue"/>
-                <a:ea typeface="Helvetica Neue"/>
-                <a:cs typeface="Helvetica Neue"/>
-              </a:rPr>
-              <a:t>Përsëritje, qasje e palejuar</a:t>
+              <a:defRPr sz="1350" b="0">
+                <a:solidFill>
+                  <a:srgbClr val="F5F7F9"/>
+                </a:solidFill>
+                <a:latin typeface="Helvetica Neue"/>
+                <a:ea typeface="Helvetica Neue"/>
+                <a:cs typeface="Helvetica Neue"/>
+              </a:defRPr>
+            </a:pPr>
+            <a:r>
+              <a:rPr sz="1350" b="0">
+                <a:solidFill>
+                  <a:srgbClr val="F5F7F9"/>
+                </a:solidFill>
+                <a:latin typeface="Helvetica Neue"/>
+                <a:ea typeface="Helvetica Neue"/>
+                <a:cs typeface="Helvetica Neue"/>
+              </a:rPr>
+              <a:t>I njëjti retry kthen të njëjtën porosi. Qasja pa leje dështon.</a:t>
             </a:r>
           </a:p>
         </p:txBody>
@@ -18019,7 +18007,7 @@
           <p:nvPr/>
         </p:nvPicPr>
         <p:blipFill>
-          <a:blip xmlns:r="http://schemas.openxmlformats.org/officeDocument/2006/relationships" xmlns:a="http://schemas.openxmlformats.org/drawingml/2006/main" r:embed="R2faaef6cf63549da"/>
+          <a:blip xmlns:r="http://schemas.openxmlformats.org/officeDocument/2006/relationships" xmlns:a="http://schemas.openxmlformats.org/drawingml/2006/main" r:embed="Rf5145ec025874654"/>
           <a:stretch xmlns:a="http://schemas.openxmlformats.org/drawingml/2006/main"/>
         </p:blipFill>
         <p:spPr>
@@ -18247,7 +18235,7 @@
         </p:xfrm>
         <a:graphic xmlns:a="http://schemas.openxmlformats.org/drawingml/2006/main">
           <a:graphicData uri="http://schemas.openxmlformats.org/drawingml/2006/chart">
-            <c:chart xmlns:r="http://schemas.openxmlformats.org/officeDocument/2006/relationships" xmlns:c="http://schemas.openxmlformats.org/drawingml/2006/chart" r:id="Ra5480f1dec004572"/>
+            <c:chart xmlns:r="http://schemas.openxmlformats.org/officeDocument/2006/relationships" xmlns:c="http://schemas.openxmlformats.org/drawingml/2006/chart" r:id="R162a29531a2142b9"/>
           </a:graphicData>
         </a:graphic>
       </p:graphicFrame>
@@ -18286,25 +18274,25 @@
           <a:p xmlns:a="http://schemas.openxmlformats.org/drawingml/2006/main">
             <a:pPr algn="l">
               <a:buNone/>
-              <a:defRPr sz="2475" b="0">
-                <a:solidFill>
-                  <a:srgbClr val="AEBFCB"/>
-                </a:solidFill>
-                <a:latin typeface="Helvetica Neue"/>
-                <a:ea typeface="Helvetica Neue"/>
-                <a:cs typeface="Helvetica Neue"/>
-              </a:defRPr>
-            </a:pPr>
-            <a:r>
-              <a:rPr sz="2475" b="0">
-                <a:solidFill>
-                  <a:srgbClr val="AEBFCB"/>
-                </a:solidFill>
-                <a:latin typeface="Helvetica Neue"/>
-                <a:ea typeface="Helvetica Neue"/>
-                <a:cs typeface="Helvetica Neue"/>
-              </a:rPr>
-              <a:t>Rubrika publikohet para dorëzimit.</a:t>
+              <a:defRPr sz="1575" b="0">
+                <a:solidFill>
+                  <a:srgbClr val="B6C5CE"/>
+                </a:solidFill>
+                <a:latin typeface="Helvetica Neue"/>
+                <a:ea typeface="Helvetica Neue"/>
+                <a:cs typeface="Helvetica Neue"/>
+              </a:defRPr>
+            </a:pPr>
+            <a:r>
+              <a:rPr sz="1575" b="0">
+                <a:solidFill>
+                  <a:srgbClr val="B6C5CE"/>
+                </a:solidFill>
+                <a:latin typeface="Helvetica Neue"/>
+                <a:ea typeface="Helvetica Neue"/>
+                <a:cs typeface="Helvetica Neue"/>
+              </a:rPr>
+              <a:t>Provat përfshijnë vakt të padisponueshëm, rrjet të humbur dhe editim të palejuar të menusë.</a:t>
             </a:r>
           </a:p>
         </p:txBody>
@@ -18318,7 +18306,7 @@
           <p:nvPr/>
         </p:nvPicPr>
         <p:blipFill>
-          <a:blip xmlns:r="http://schemas.openxmlformats.org/officeDocument/2006/relationships" xmlns:a="http://schemas.openxmlformats.org/drawingml/2006/main" r:embed="Rb66087b0c8c04312"/>
+          <a:blip xmlns:r="http://schemas.openxmlformats.org/officeDocument/2006/relationships" xmlns:a="http://schemas.openxmlformats.org/drawingml/2006/main" r:embed="Rba37aad4e2d84e70"/>
           <a:stretch xmlns:a="http://schemas.openxmlformats.org/drawingml/2006/main"/>
         </p:blipFill>
         <p:spPr>
@@ -19091,25 +19079,25 @@
           <a:p xmlns:a="http://schemas.openxmlformats.org/drawingml/2006/main">
             <a:pPr algn="l">
               <a:buNone/>
-              <a:defRPr sz="2700" b="0">
-                <a:solidFill>
-                  <a:srgbClr val="F4F2EC"/>
-                </a:solidFill>
-                <a:latin typeface="Helvetica Neue"/>
-                <a:ea typeface="Helvetica Neue"/>
-                <a:cs typeface="Helvetica Neue"/>
-              </a:defRPr>
-            </a:pPr>
-            <a:r>
-              <a:rPr sz="2700" b="0">
-                <a:solidFill>
-                  <a:srgbClr val="F4F2EC"/>
-                </a:solidFill>
-                <a:latin typeface="Helvetica Neue"/>
-                <a:ea typeface="Helvetica Neue"/>
-                <a:cs typeface="Helvetica Neue"/>
-              </a:rPr>
-              <a:t>Pastaj: pyetjet e jurisë dhe mbrojtja individuale</a:t>
+              <a:defRPr sz="1650" b="0">
+                <a:solidFill>
+                  <a:srgbClr val="F5F7F9"/>
+                </a:solidFill>
+                <a:latin typeface="Helvetica Neue"/>
+                <a:ea typeface="Helvetica Neue"/>
+                <a:cs typeface="Helvetica Neue"/>
+              </a:defRPr>
+            </a:pPr>
+            <a:r>
+              <a:rPr sz="1650" b="0">
+                <a:solidFill>
+                  <a:srgbClr val="F5F7F9"/>
+                </a:solidFill>
+                <a:latin typeface="Helvetica Neue"/>
+                <a:ea typeface="Helvetica Neue"/>
+                <a:cs typeface="Helvetica Neue"/>
+              </a:rPr>
+              <a:t>Vakt i padisponueshëm, rrjet i humbur ose editim i palejuar i menusë.</a:t>
             </a:r>
           </a:p>
         </p:txBody>
@@ -19181,7 +19169,7 @@
           <p:nvPr/>
         </p:nvPicPr>
         <p:blipFill>
-          <a:blip xmlns:r="http://schemas.openxmlformats.org/officeDocument/2006/relationships" xmlns:a="http://schemas.openxmlformats.org/drawingml/2006/main" r:embed="R6283e919e6d64c50"/>
+          <a:blip xmlns:r="http://schemas.openxmlformats.org/officeDocument/2006/relationships" xmlns:a="http://schemas.openxmlformats.org/drawingml/2006/main" r:embed="R96ff5aa3f01248a8"/>
           <a:stretch xmlns:a="http://schemas.openxmlformats.org/drawingml/2006/main"/>
         </p:blipFill>
         <p:spPr>
@@ -19374,25 +19362,25 @@
           <a:p xmlns:a="http://schemas.openxmlformats.org/drawingml/2006/main">
             <a:pPr algn="l">
               <a:buNone/>
-              <a:defRPr sz="3825" b="1">
-                <a:solidFill>
-                  <a:srgbClr val="F4F2EC"/>
-                </a:solidFill>
-                <a:latin typeface="Helvetica Neue"/>
-                <a:ea typeface="Helvetica Neue"/>
-                <a:cs typeface="Helvetica Neue"/>
-              </a:defRPr>
-            </a:pPr>
-            <a:r>
-              <a:rPr sz="3825" b="1">
-                <a:solidFill>
-                  <a:srgbClr val="F4F2EC"/>
-                </a:solidFill>
-                <a:latin typeface="Helvetica Neue"/>
-                <a:ea typeface="Helvetica Neue"/>
-                <a:cs typeface="Helvetica Neue"/>
-              </a:rPr>
-              <a:t>Ndryshimi juaj, në telefon</a:t>
+              <a:defRPr sz="3000" b="1">
+                <a:solidFill>
+                  <a:srgbClr val="F5F7F9"/>
+                </a:solidFill>
+                <a:latin typeface="Helvetica Neue"/>
+                <a:ea typeface="Helvetica Neue"/>
+                <a:cs typeface="Helvetica Neue"/>
+              </a:defRPr>
+            </a:pPr>
+            <a:r>
+              <a:rPr sz="3000" b="1">
+                <a:solidFill>
+                  <a:srgbClr val="F5F7F9"/>
+                </a:solidFill>
+                <a:latin typeface="Helvetica Neue"/>
+                <a:ea typeface="Helvetica Neue"/>
+                <a:cs typeface="Helvetica Neue"/>
+              </a:rPr>
+              <a:t>Demo live: porosia bëhet “Gati”</a:t>
             </a:r>
           </a:p>
         </p:txBody>
@@ -19413,8 +19401,8 @@
         </p:nvSpPr>
         <p:spPr>
           <a:xfrm xmlns:a="http://schemas.openxmlformats.org/drawingml/2006/main">
-            <a:off x="647700" y="1971675"/>
-            <a:ext cx="10572750" cy="447675"/>
+            <a:off x="647700" y="1885950"/>
+            <a:ext cx="7620000" cy="447675"/>
           </a:xfrm>
           <a:prstGeom xmlns:a="http://schemas.openxmlformats.org/drawingml/2006/main" prst="rect">
             <a:avLst/>
@@ -19432,25 +19420,25 @@
           <a:p xmlns:a="http://schemas.openxmlformats.org/drawingml/2006/main">
             <a:pPr algn="l">
               <a:buNone/>
-              <a:defRPr sz="2025" b="1">
-                <a:solidFill>
-                  <a:srgbClr val="63CDF2"/>
-                </a:solidFill>
-                <a:latin typeface="Helvetica Neue"/>
-                <a:ea typeface="Helvetica Neue"/>
-                <a:cs typeface="Helvetica Neue"/>
-              </a:defRPr>
-            </a:pPr>
-            <a:r>
-              <a:rPr sz="2025" b="1">
-                <a:solidFill>
-                  <a:srgbClr val="63CDF2"/>
-                </a:solidFill>
-                <a:latin typeface="Helvetica Neue"/>
-                <a:ea typeface="Helvetica Neue"/>
-                <a:cs typeface="Helvetica Neue"/>
-              </a:rPr>
-              <a:t>JAVA 2: PUBLIKIMI I PARË</a:t>
+              <a:defRPr sz="1650" b="1">
+                <a:solidFill>
+                  <a:srgbClr val="5DCEF2"/>
+                </a:solidFill>
+                <a:latin typeface="Helvetica Neue"/>
+                <a:ea typeface="Helvetica Neue"/>
+                <a:cs typeface="Helvetica Neue"/>
+              </a:defRPr>
+            </a:pPr>
+            <a:r>
+              <a:rPr sz="1650" b="1">
+                <a:solidFill>
+                  <a:srgbClr val="5DCEF2"/>
+                </a:solidFill>
+                <a:latin typeface="Helvetica Neue"/>
+                <a:ea typeface="Helvetica Neue"/>
+                <a:cs typeface="Helvetica Neue"/>
+              </a:rPr>
+              <a:t>QR I DEMONSTRIMIT — nuk regjistron pjesëmarrjen</a:t>
             </a:r>
           </a:p>
         </p:txBody>
@@ -19471,44 +19459,44 @@
         </p:nvSpPr>
         <p:spPr>
           <a:xfrm xmlns:a="http://schemas.openxmlformats.org/drawingml/2006/main">
-            <a:off x="685800" y="2867025"/>
-            <a:ext cx="2362200" cy="666750"/>
-          </a:xfrm>
-          <a:prstGeom xmlns:a="http://schemas.openxmlformats.org/drawingml/2006/main" prst="rect">
-            <a:avLst/>
-          </a:prstGeom>
-          <a:noFill xmlns:a="http://schemas.openxmlformats.org/drawingml/2006/main"/>
-          <a:ln xmlns:a="http://schemas.openxmlformats.org/drawingml/2006/main" w="0">
-            <a:noFill/>
-          </a:ln>
-        </p:spPr>
-        <p:txBody>
-          <a:bodyPr xmlns:a="http://schemas.openxmlformats.org/drawingml/2006/main" wrap="square" lIns="0" tIns="0" rIns="0" bIns="0" anchor="ctr">
-            <a:noAutofit/>
-          </a:bodyPr>
-          <a:lstStyle xmlns:a="http://schemas.openxmlformats.org/drawingml/2006/main"/>
-          <a:p xmlns:a="http://schemas.openxmlformats.org/drawingml/2006/main">
-            <a:pPr algn="l">
-              <a:buNone/>
-              <a:defRPr sz="3675" b="1">
-                <a:solidFill>
-                  <a:srgbClr val="F4F2EC"/>
-                </a:solidFill>
-                <a:latin typeface="Helvetica Neue"/>
-                <a:ea typeface="Helvetica Neue"/>
-                <a:cs typeface="Helvetica Neue"/>
-              </a:defRPr>
-            </a:pPr>
-            <a:r>
-              <a:rPr sz="3675" b="1">
-                <a:solidFill>
-                  <a:srgbClr val="F4F2EC"/>
-                </a:solidFill>
-                <a:latin typeface="Helvetica Neue"/>
-                <a:ea typeface="Helvetica Neue"/>
-                <a:cs typeface="Helvetica Neue"/>
-              </a:rPr>
-              <a:t>Repo</a:t>
+            <a:off x="685800" y="2857500"/>
+            <a:ext cx="1476375" cy="523875"/>
+          </a:xfrm>
+          <a:prstGeom xmlns:a="http://schemas.openxmlformats.org/drawingml/2006/main" prst="rect">
+            <a:avLst/>
+          </a:prstGeom>
+          <a:noFill xmlns:a="http://schemas.openxmlformats.org/drawingml/2006/main"/>
+          <a:ln xmlns:a="http://schemas.openxmlformats.org/drawingml/2006/main" w="0">
+            <a:noFill/>
+          </a:ln>
+        </p:spPr>
+        <p:txBody>
+          <a:bodyPr xmlns:a="http://schemas.openxmlformats.org/drawingml/2006/main" wrap="square" lIns="0" tIns="0" rIns="0" bIns="0" anchor="ctr">
+            <a:noAutofit/>
+          </a:bodyPr>
+          <a:lstStyle xmlns:a="http://schemas.openxmlformats.org/drawingml/2006/main"/>
+          <a:p xmlns:a="http://schemas.openxmlformats.org/drawingml/2006/main">
+            <a:pPr algn="ctr">
+              <a:buNone/>
+              <a:defRPr sz="2250" b="1">
+                <a:solidFill>
+                  <a:srgbClr val="5DCEF2"/>
+                </a:solidFill>
+                <a:latin typeface="Helvetica Neue"/>
+                <a:ea typeface="Helvetica Neue"/>
+                <a:cs typeface="Helvetica Neue"/>
+              </a:defRPr>
+            </a:pPr>
+            <a:r>
+              <a:rPr sz="2250" b="1">
+                <a:solidFill>
+                  <a:srgbClr val="5DCEF2"/>
+                </a:solidFill>
+                <a:latin typeface="Helvetica Neue"/>
+                <a:ea typeface="Helvetica Neue"/>
+                <a:cs typeface="Helvetica Neue"/>
+              </a:rPr>
+              <a:t>Menu</a:t>
             </a:r>
           </a:p>
         </p:txBody>
@@ -19529,44 +19517,44 @@
         </p:nvSpPr>
         <p:spPr>
           <a:xfrm xmlns:a="http://schemas.openxmlformats.org/drawingml/2006/main">
-            <a:off x="685800" y="3829050"/>
-            <a:ext cx="2438400" cy="504825"/>
-          </a:xfrm>
-          <a:prstGeom xmlns:a="http://schemas.openxmlformats.org/drawingml/2006/main" prst="rect">
-            <a:avLst/>
-          </a:prstGeom>
-          <a:noFill xmlns:a="http://schemas.openxmlformats.org/drawingml/2006/main"/>
-          <a:ln xmlns:a="http://schemas.openxmlformats.org/drawingml/2006/main" w="0">
-            <a:noFill/>
-          </a:ln>
-        </p:spPr>
-        <p:txBody>
-          <a:bodyPr xmlns:a="http://schemas.openxmlformats.org/drawingml/2006/main" wrap="square" lIns="0" tIns="0" rIns="0" bIns="0" anchor="ctr">
-            <a:noAutofit/>
-          </a:bodyPr>
-          <a:lstStyle xmlns:a="http://schemas.openxmlformats.org/drawingml/2006/main"/>
-          <a:p xmlns:a="http://schemas.openxmlformats.org/drawingml/2006/main">
-            <a:pPr algn="l">
-              <a:buNone/>
-              <a:defRPr sz="2100" b="0">
-                <a:solidFill>
-                  <a:srgbClr val="AEBFCB"/>
-                </a:solidFill>
-                <a:latin typeface="Helvetica Neue"/>
-                <a:ea typeface="Helvetica Neue"/>
-                <a:cs typeface="Helvetica Neue"/>
-              </a:defRPr>
-            </a:pPr>
-            <a:r>
-              <a:rPr sz="2100" b="0">
-                <a:solidFill>
-                  <a:srgbClr val="AEBFCB"/>
-                </a:solidFill>
-                <a:latin typeface="Helvetica Neue"/>
-                <a:ea typeface="Helvetica Neue"/>
-                <a:cs typeface="Helvetica Neue"/>
-              </a:rPr>
-              <a:t>0–10 min</a:t>
+            <a:off x="685800" y="3476625"/>
+            <a:ext cx="1476375" cy="409575"/>
+          </a:xfrm>
+          <a:prstGeom xmlns:a="http://schemas.openxmlformats.org/drawingml/2006/main" prst="rect">
+            <a:avLst/>
+          </a:prstGeom>
+          <a:noFill xmlns:a="http://schemas.openxmlformats.org/drawingml/2006/main"/>
+          <a:ln xmlns:a="http://schemas.openxmlformats.org/drawingml/2006/main" w="0">
+            <a:noFill/>
+          </a:ln>
+        </p:spPr>
+        <p:txBody>
+          <a:bodyPr xmlns:a="http://schemas.openxmlformats.org/drawingml/2006/main" wrap="square" lIns="0" tIns="0" rIns="0" bIns="0" anchor="ctr">
+            <a:noAutofit/>
+          </a:bodyPr>
+          <a:lstStyle xmlns:a="http://schemas.openxmlformats.org/drawingml/2006/main"/>
+          <a:p xmlns:a="http://schemas.openxmlformats.org/drawingml/2006/main">
+            <a:pPr algn="ctr">
+              <a:buNone/>
+              <a:defRPr sz="1200" b="0">
+                <a:solidFill>
+                  <a:srgbClr val="B6C5CE"/>
+                </a:solidFill>
+                <a:latin typeface="Helvetica Neue"/>
+                <a:ea typeface="Helvetica Neue"/>
+                <a:cs typeface="Helvetica Neue"/>
+              </a:defRPr>
+            </a:pPr>
+            <a:r>
+              <a:rPr sz="1200" b="0">
+                <a:solidFill>
+                  <a:srgbClr val="B6C5CE"/>
+                </a:solidFill>
+                <a:latin typeface="Helvetica Neue"/>
+                <a:ea typeface="Helvetica Neue"/>
+                <a:cs typeface="Helvetica Neue"/>
+              </a:rPr>
+              <a:t>Zgjidh vaktin</a:t>
             </a:r>
           </a:p>
         </p:txBody>
@@ -19587,8 +19575,8 @@
         </p:nvSpPr>
         <p:spPr>
           <a:xfrm xmlns:a="http://schemas.openxmlformats.org/drawingml/2006/main">
-            <a:off x="2933700" y="3124200"/>
-            <a:ext cx="304800" cy="171450"/>
+            <a:off x="2276475" y="3028950"/>
+            <a:ext cx="266700" cy="171450"/>
           </a:xfrm>
           <a:prstGeom xmlns:a="http://schemas.openxmlformats.org/drawingml/2006/main" prst="rightArrow">
             <a:avLst/>
@@ -19617,44 +19605,44 @@
         </p:nvSpPr>
         <p:spPr>
           <a:xfrm xmlns:a="http://schemas.openxmlformats.org/drawingml/2006/main">
-            <a:off x="3448050" y="2867025"/>
-            <a:ext cx="2362200" cy="666750"/>
-          </a:xfrm>
-          <a:prstGeom xmlns:a="http://schemas.openxmlformats.org/drawingml/2006/main" prst="rect">
-            <a:avLst/>
-          </a:prstGeom>
-          <a:noFill xmlns:a="http://schemas.openxmlformats.org/drawingml/2006/main"/>
-          <a:ln xmlns:a="http://schemas.openxmlformats.org/drawingml/2006/main" w="0">
-            <a:noFill/>
-          </a:ln>
-        </p:spPr>
-        <p:txBody>
-          <a:bodyPr xmlns:a="http://schemas.openxmlformats.org/drawingml/2006/main" wrap="square" lIns="0" tIns="0" rIns="0" bIns="0" anchor="ctr">
-            <a:noAutofit/>
-          </a:bodyPr>
-          <a:lstStyle xmlns:a="http://schemas.openxmlformats.org/drawingml/2006/main"/>
-          <a:p xmlns:a="http://schemas.openxmlformats.org/drawingml/2006/main">
-            <a:pPr algn="l">
-              <a:buNone/>
-              <a:defRPr sz="3675" b="1">
-                <a:solidFill>
-                  <a:srgbClr val="F4F2EC"/>
-                </a:solidFill>
-                <a:latin typeface="Helvetica Neue"/>
-                <a:ea typeface="Helvetica Neue"/>
-                <a:cs typeface="Helvetica Neue"/>
-              </a:defRPr>
-            </a:pPr>
-            <a:r>
-              <a:rPr sz="3675" b="1">
-                <a:solidFill>
-                  <a:srgbClr val="F4F2EC"/>
-                </a:solidFill>
-                <a:latin typeface="Helvetica Neue"/>
-                <a:ea typeface="Helvetica Neue"/>
-                <a:cs typeface="Helvetica Neue"/>
-              </a:rPr>
-              <a:t>Commit</a:t>
+            <a:off x="2667000" y="2857500"/>
+            <a:ext cx="1476375" cy="523875"/>
+          </a:xfrm>
+          <a:prstGeom xmlns:a="http://schemas.openxmlformats.org/drawingml/2006/main" prst="rect">
+            <a:avLst/>
+          </a:prstGeom>
+          <a:noFill xmlns:a="http://schemas.openxmlformats.org/drawingml/2006/main"/>
+          <a:ln xmlns:a="http://schemas.openxmlformats.org/drawingml/2006/main" w="0">
+            <a:noFill/>
+          </a:ln>
+        </p:spPr>
+        <p:txBody>
+          <a:bodyPr xmlns:a="http://schemas.openxmlformats.org/drawingml/2006/main" wrap="square" lIns="0" tIns="0" rIns="0" bIns="0" anchor="ctr">
+            <a:noAutofit/>
+          </a:bodyPr>
+          <a:lstStyle xmlns:a="http://schemas.openxmlformats.org/drawingml/2006/main"/>
+          <a:p xmlns:a="http://schemas.openxmlformats.org/drawingml/2006/main">
+            <a:pPr algn="ctr">
+              <a:buNone/>
+              <a:defRPr sz="2250" b="1">
+                <a:solidFill>
+                  <a:srgbClr val="F5F7F9"/>
+                </a:solidFill>
+                <a:latin typeface="Helvetica Neue"/>
+                <a:ea typeface="Helvetica Neue"/>
+                <a:cs typeface="Helvetica Neue"/>
+              </a:defRPr>
+            </a:pPr>
+            <a:r>
+              <a:rPr sz="2250" b="1">
+                <a:solidFill>
+                  <a:srgbClr val="F5F7F9"/>
+                </a:solidFill>
+                <a:latin typeface="Helvetica Neue"/>
+                <a:ea typeface="Helvetica Neue"/>
+                <a:cs typeface="Helvetica Neue"/>
+              </a:rPr>
+              <a:t>Cart</a:t>
             </a:r>
           </a:p>
         </p:txBody>
@@ -19675,44 +19663,44 @@
         </p:nvSpPr>
         <p:spPr>
           <a:xfrm xmlns:a="http://schemas.openxmlformats.org/drawingml/2006/main">
-            <a:off x="3448050" y="3829050"/>
-            <a:ext cx="2438400" cy="504825"/>
-          </a:xfrm>
-          <a:prstGeom xmlns:a="http://schemas.openxmlformats.org/drawingml/2006/main" prst="rect">
-            <a:avLst/>
-          </a:prstGeom>
-          <a:noFill xmlns:a="http://schemas.openxmlformats.org/drawingml/2006/main"/>
-          <a:ln xmlns:a="http://schemas.openxmlformats.org/drawingml/2006/main" w="0">
-            <a:noFill/>
-          </a:ln>
-        </p:spPr>
-        <p:txBody>
-          <a:bodyPr xmlns:a="http://schemas.openxmlformats.org/drawingml/2006/main" wrap="square" lIns="0" tIns="0" rIns="0" bIns="0" anchor="ctr">
-            <a:noAutofit/>
-          </a:bodyPr>
-          <a:lstStyle xmlns:a="http://schemas.openxmlformats.org/drawingml/2006/main"/>
-          <a:p xmlns:a="http://schemas.openxmlformats.org/drawingml/2006/main">
-            <a:pPr algn="l">
-              <a:buNone/>
-              <a:defRPr sz="2100" b="0">
-                <a:solidFill>
-                  <a:srgbClr val="AEBFCB"/>
-                </a:solidFill>
-                <a:latin typeface="Helvetica Neue"/>
-                <a:ea typeface="Helvetica Neue"/>
-                <a:cs typeface="Helvetica Neue"/>
-              </a:defRPr>
-            </a:pPr>
-            <a:r>
-              <a:rPr sz="2100" b="0">
-                <a:solidFill>
-                  <a:srgbClr val="AEBFCB"/>
-                </a:solidFill>
-                <a:latin typeface="Helvetica Neue"/>
-                <a:ea typeface="Helvetica Neue"/>
-                <a:cs typeface="Helvetica Neue"/>
-              </a:rPr>
-              <a:t>10–20 min</a:t>
+            <a:off x="2667000" y="3476625"/>
+            <a:ext cx="1476375" cy="409575"/>
+          </a:xfrm>
+          <a:prstGeom xmlns:a="http://schemas.openxmlformats.org/drawingml/2006/main" prst="rect">
+            <a:avLst/>
+          </a:prstGeom>
+          <a:noFill xmlns:a="http://schemas.openxmlformats.org/drawingml/2006/main"/>
+          <a:ln xmlns:a="http://schemas.openxmlformats.org/drawingml/2006/main" w="0">
+            <a:noFill/>
+          </a:ln>
+        </p:spPr>
+        <p:txBody>
+          <a:bodyPr xmlns:a="http://schemas.openxmlformats.org/drawingml/2006/main" wrap="square" lIns="0" tIns="0" rIns="0" bIns="0" anchor="ctr">
+            <a:noAutofit/>
+          </a:bodyPr>
+          <a:lstStyle xmlns:a="http://schemas.openxmlformats.org/drawingml/2006/main"/>
+          <a:p xmlns:a="http://schemas.openxmlformats.org/drawingml/2006/main">
+            <a:pPr algn="ctr">
+              <a:buNone/>
+              <a:defRPr sz="1125" b="0">
+                <a:solidFill>
+                  <a:srgbClr val="B6C5CE"/>
+                </a:solidFill>
+                <a:latin typeface="Helvetica Neue"/>
+                <a:ea typeface="Helvetica Neue"/>
+                <a:cs typeface="Helvetica Neue"/>
+              </a:defRPr>
+            </a:pPr>
+            <a:r>
+              <a:rPr sz="1125" b="0">
+                <a:solidFill>
+                  <a:srgbClr val="B6C5CE"/>
+                </a:solidFill>
+                <a:latin typeface="Helvetica Neue"/>
+                <a:ea typeface="Helvetica Neue"/>
+                <a:cs typeface="Helvetica Neue"/>
+              </a:rPr>
+              <a:t>Sasia 1</a:t>
             </a:r>
           </a:p>
         </p:txBody>
@@ -19733,8 +19721,8 @@
         </p:nvSpPr>
         <p:spPr>
           <a:xfrm xmlns:a="http://schemas.openxmlformats.org/drawingml/2006/main">
-            <a:off x="5695950" y="3124200"/>
-            <a:ext cx="304800" cy="171450"/>
+            <a:off x="4257675" y="3028950"/>
+            <a:ext cx="266700" cy="171450"/>
           </a:xfrm>
           <a:prstGeom xmlns:a="http://schemas.openxmlformats.org/drawingml/2006/main" prst="rightArrow">
             <a:avLst/>
@@ -19763,44 +19751,44 @@
         </p:nvSpPr>
         <p:spPr>
           <a:xfrm xmlns:a="http://schemas.openxmlformats.org/drawingml/2006/main">
-            <a:off x="6210300" y="2867025"/>
-            <a:ext cx="2362200" cy="666750"/>
-          </a:xfrm>
-          <a:prstGeom xmlns:a="http://schemas.openxmlformats.org/drawingml/2006/main" prst="rect">
-            <a:avLst/>
-          </a:prstGeom>
-          <a:noFill xmlns:a="http://schemas.openxmlformats.org/drawingml/2006/main"/>
-          <a:ln xmlns:a="http://schemas.openxmlformats.org/drawingml/2006/main" w="0">
-            <a:noFill/>
-          </a:ln>
-        </p:spPr>
-        <p:txBody>
-          <a:bodyPr xmlns:a="http://schemas.openxmlformats.org/drawingml/2006/main" wrap="square" lIns="0" tIns="0" rIns="0" bIns="0" anchor="ctr">
-            <a:noAutofit/>
-          </a:bodyPr>
-          <a:lstStyle xmlns:a="http://schemas.openxmlformats.org/drawingml/2006/main"/>
-          <a:p xmlns:a="http://schemas.openxmlformats.org/drawingml/2006/main">
-            <a:pPr algn="l">
-              <a:buNone/>
-              <a:defRPr sz="3675" b="1">
-                <a:solidFill>
-                  <a:srgbClr val="F4F2EC"/>
-                </a:solidFill>
-                <a:latin typeface="Helvetica Neue"/>
-                <a:ea typeface="Helvetica Neue"/>
-                <a:cs typeface="Helvetica Neue"/>
-              </a:defRPr>
-            </a:pPr>
-            <a:r>
-              <a:rPr sz="3675" b="1">
-                <a:solidFill>
-                  <a:srgbClr val="F4F2EC"/>
-                </a:solidFill>
-                <a:latin typeface="Helvetica Neue"/>
-                <a:ea typeface="Helvetica Neue"/>
-                <a:cs typeface="Helvetica Neue"/>
-              </a:rPr>
-              <a:t>Deploy</a:t>
+            <a:off x="4648200" y="2857500"/>
+            <a:ext cx="1476375" cy="523875"/>
+          </a:xfrm>
+          <a:prstGeom xmlns:a="http://schemas.openxmlformats.org/drawingml/2006/main" prst="rect">
+            <a:avLst/>
+          </a:prstGeom>
+          <a:noFill xmlns:a="http://schemas.openxmlformats.org/drawingml/2006/main"/>
+          <a:ln xmlns:a="http://schemas.openxmlformats.org/drawingml/2006/main" w="0">
+            <a:noFill/>
+          </a:ln>
+        </p:spPr>
+        <p:txBody>
+          <a:bodyPr xmlns:a="http://schemas.openxmlformats.org/drawingml/2006/main" wrap="square" lIns="0" tIns="0" rIns="0" bIns="0" anchor="ctr">
+            <a:noAutofit/>
+          </a:bodyPr>
+          <a:lstStyle xmlns:a="http://schemas.openxmlformats.org/drawingml/2006/main"/>
+          <a:p xmlns:a="http://schemas.openxmlformats.org/drawingml/2006/main">
+            <a:pPr algn="ctr">
+              <a:buNone/>
+              <a:defRPr sz="2250" b="1">
+                <a:solidFill>
+                  <a:srgbClr val="F5F7F9"/>
+                </a:solidFill>
+                <a:latin typeface="Helvetica Neue"/>
+                <a:ea typeface="Helvetica Neue"/>
+                <a:cs typeface="Helvetica Neue"/>
+              </a:defRPr>
+            </a:pPr>
+            <a:r>
+              <a:rPr sz="2250" b="1">
+                <a:solidFill>
+                  <a:srgbClr val="F5F7F9"/>
+                </a:solidFill>
+                <a:latin typeface="Helvetica Neue"/>
+                <a:ea typeface="Helvetica Neue"/>
+                <a:cs typeface="Helvetica Neue"/>
+              </a:rPr>
+              <a:t>Order</a:t>
             </a:r>
           </a:p>
         </p:txBody>
@@ -19821,44 +19809,44 @@
         </p:nvSpPr>
         <p:spPr>
           <a:xfrm xmlns:a="http://schemas.openxmlformats.org/drawingml/2006/main">
-            <a:off x="6210300" y="3829050"/>
-            <a:ext cx="2438400" cy="504825"/>
-          </a:xfrm>
-          <a:prstGeom xmlns:a="http://schemas.openxmlformats.org/drawingml/2006/main" prst="rect">
-            <a:avLst/>
-          </a:prstGeom>
-          <a:noFill xmlns:a="http://schemas.openxmlformats.org/drawingml/2006/main"/>
-          <a:ln xmlns:a="http://schemas.openxmlformats.org/drawingml/2006/main" w="0">
-            <a:noFill/>
-          </a:ln>
-        </p:spPr>
-        <p:txBody>
-          <a:bodyPr xmlns:a="http://schemas.openxmlformats.org/drawingml/2006/main" wrap="square" lIns="0" tIns="0" rIns="0" bIns="0" anchor="ctr">
-            <a:noAutofit/>
-          </a:bodyPr>
-          <a:lstStyle xmlns:a="http://schemas.openxmlformats.org/drawingml/2006/main"/>
-          <a:p xmlns:a="http://schemas.openxmlformats.org/drawingml/2006/main">
-            <a:pPr algn="l">
-              <a:buNone/>
-              <a:defRPr sz="2100" b="0">
-                <a:solidFill>
-                  <a:srgbClr val="AEBFCB"/>
-                </a:solidFill>
-                <a:latin typeface="Helvetica Neue"/>
-                <a:ea typeface="Helvetica Neue"/>
-                <a:cs typeface="Helvetica Neue"/>
-              </a:defRPr>
-            </a:pPr>
-            <a:r>
-              <a:rPr sz="2100" b="0">
-                <a:solidFill>
-                  <a:srgbClr val="AEBFCB"/>
-                </a:solidFill>
-                <a:latin typeface="Helvetica Neue"/>
-                <a:ea typeface="Helvetica Neue"/>
-                <a:cs typeface="Helvetica Neue"/>
-              </a:rPr>
-              <a:t>20–35 min</a:t>
+            <a:off x="4648200" y="3476625"/>
+            <a:ext cx="1476375" cy="409575"/>
+          </a:xfrm>
+          <a:prstGeom xmlns:a="http://schemas.openxmlformats.org/drawingml/2006/main" prst="rect">
+            <a:avLst/>
+          </a:prstGeom>
+          <a:noFill xmlns:a="http://schemas.openxmlformats.org/drawingml/2006/main"/>
+          <a:ln xmlns:a="http://schemas.openxmlformats.org/drawingml/2006/main" w="0">
+            <a:noFill/>
+          </a:ln>
+        </p:spPr>
+        <p:txBody>
+          <a:bodyPr xmlns:a="http://schemas.openxmlformats.org/drawingml/2006/main" wrap="square" lIns="0" tIns="0" rIns="0" bIns="0" anchor="ctr">
+            <a:noAutofit/>
+          </a:bodyPr>
+          <a:lstStyle xmlns:a="http://schemas.openxmlformats.org/drawingml/2006/main"/>
+          <a:p xmlns:a="http://schemas.openxmlformats.org/drawingml/2006/main">
+            <a:pPr algn="ctr">
+              <a:buNone/>
+              <a:defRPr sz="1125" b="0">
+                <a:solidFill>
+                  <a:srgbClr val="B6C5CE"/>
+                </a:solidFill>
+                <a:latin typeface="Helvetica Neue"/>
+                <a:ea typeface="Helvetica Neue"/>
+                <a:cs typeface="Helvetica Neue"/>
+              </a:defRPr>
+            </a:pPr>
+            <a:r>
+              <a:rPr sz="1125" b="0">
+                <a:solidFill>
+                  <a:srgbClr val="B6C5CE"/>
+                </a:solidFill>
+                <a:latin typeface="Helvetica Neue"/>
+                <a:ea typeface="Helvetica Neue"/>
+                <a:cs typeface="Helvetica Neue"/>
+              </a:rPr>
+              <a:t>U ruajt</a:t>
             </a:r>
           </a:p>
         </p:txBody>
@@ -19879,8 +19867,8 @@
         </p:nvSpPr>
         <p:spPr>
           <a:xfrm xmlns:a="http://schemas.openxmlformats.org/drawingml/2006/main">
-            <a:off x="8458200" y="3124200"/>
-            <a:ext cx="304800" cy="171450"/>
+            <a:off x="6238875" y="3028950"/>
+            <a:ext cx="266700" cy="171450"/>
           </a:xfrm>
           <a:prstGeom xmlns:a="http://schemas.openxmlformats.org/drawingml/2006/main" prst="rightArrow">
             <a:avLst/>
@@ -19909,8 +19897,124 @@
         </p:nvSpPr>
         <p:spPr>
           <a:xfrm xmlns:a="http://schemas.openxmlformats.org/drawingml/2006/main">
-            <a:off x="8972550" y="2867025"/>
-            <a:ext cx="2362200" cy="666750"/>
+            <a:off x="6629400" y="2857500"/>
+            <a:ext cx="1476375" cy="523875"/>
+          </a:xfrm>
+          <a:prstGeom xmlns:a="http://schemas.openxmlformats.org/drawingml/2006/main" prst="rect">
+            <a:avLst/>
+          </a:prstGeom>
+          <a:noFill xmlns:a="http://schemas.openxmlformats.org/drawingml/2006/main"/>
+          <a:ln xmlns:a="http://schemas.openxmlformats.org/drawingml/2006/main" w="0">
+            <a:noFill/>
+          </a:ln>
+        </p:spPr>
+        <p:txBody>
+          <a:bodyPr xmlns:a="http://schemas.openxmlformats.org/drawingml/2006/main" wrap="square" lIns="0" tIns="0" rIns="0" bIns="0" anchor="ctr">
+            <a:noAutofit/>
+          </a:bodyPr>
+          <a:lstStyle xmlns:a="http://schemas.openxmlformats.org/drawingml/2006/main"/>
+          <a:p xmlns:a="http://schemas.openxmlformats.org/drawingml/2006/main">
+            <a:pPr algn="ctr">
+              <a:buNone/>
+              <a:defRPr sz="2250" b="1">
+                <a:solidFill>
+                  <a:srgbClr val="7FD3AA"/>
+                </a:solidFill>
+                <a:latin typeface="Helvetica Neue"/>
+                <a:ea typeface="Helvetica Neue"/>
+                <a:cs typeface="Helvetica Neue"/>
+              </a:defRPr>
+            </a:pPr>
+            <a:r>
+              <a:rPr sz="2250" b="1">
+                <a:solidFill>
+                  <a:srgbClr val="7FD3AA"/>
+                </a:solidFill>
+                <a:latin typeface="Helvetica Neue"/>
+                <a:ea typeface="Helvetica Neue"/>
+                <a:cs typeface="Helvetica Neue"/>
+              </a:rPr>
+              <a:t>Gati</a:t>
+            </a:r>
+          </a:p>
+        </p:txBody>
+      </p:sp>
+      <p:sp>
+        <p:nvSpPr>
+          <p:cNvPr id="15" name="text-336">
+            <a:extLst xmlns:a="http://schemas.openxmlformats.org/drawingml/2006/main">
+              <a:ext uri="{FF2B5EF4-FFF2-40B4-BE49-F238E27FC236}">
+                <a16:creationId xmlns:a16="http://schemas.microsoft.com/office/drawing/2014/main" id="{017BC553-2884-4219-938C-C1BAA44C4EAB}"/>
+              </a:ext>
+            </a:extLst>
+          </p:cNvPr>
+          <p:cNvSpPr>
+            <a:spLocks xmlns:a="http://schemas.openxmlformats.org/drawingml/2006/main" noGrp="1"/>
+          </p:cNvSpPr>
+          <p:nvPr/>
+        </p:nvSpPr>
+        <p:spPr>
+          <a:xfrm xmlns:a="http://schemas.openxmlformats.org/drawingml/2006/main">
+            <a:off x="6629400" y="3476625"/>
+            <a:ext cx="1476375" cy="409575"/>
+          </a:xfrm>
+          <a:prstGeom xmlns:a="http://schemas.openxmlformats.org/drawingml/2006/main" prst="rect">
+            <a:avLst/>
+          </a:prstGeom>
+          <a:noFill xmlns:a="http://schemas.openxmlformats.org/drawingml/2006/main"/>
+          <a:ln xmlns:a="http://schemas.openxmlformats.org/drawingml/2006/main" w="0">
+            <a:noFill/>
+          </a:ln>
+        </p:spPr>
+        <p:txBody>
+          <a:bodyPr xmlns:a="http://schemas.openxmlformats.org/drawingml/2006/main" wrap="square" lIns="0" tIns="0" rIns="0" bIns="0" anchor="ctr">
+            <a:noAutofit/>
+          </a:bodyPr>
+          <a:lstStyle xmlns:a="http://schemas.openxmlformats.org/drawingml/2006/main"/>
+          <a:p xmlns:a="http://schemas.openxmlformats.org/drawingml/2006/main">
+            <a:pPr algn="ctr">
+              <a:buNone/>
+              <a:defRPr sz="1125" b="0">
+                <a:solidFill>
+                  <a:srgbClr val="B6C5CE"/>
+                </a:solidFill>
+                <a:latin typeface="Helvetica Neue"/>
+                <a:ea typeface="Helvetica Neue"/>
+                <a:cs typeface="Helvetica Neue"/>
+              </a:defRPr>
+            </a:pPr>
+            <a:r>
+              <a:rPr sz="1125" b="0">
+                <a:solidFill>
+                  <a:srgbClr val="B6C5CE"/>
+                </a:solidFill>
+                <a:latin typeface="Helvetica Neue"/>
+                <a:ea typeface="Helvetica Neue"/>
+                <a:cs typeface="Helvetica Neue"/>
+              </a:rPr>
+              <a:t>Stafi e mbylli</a:t>
+            </a:r>
+          </a:p>
+        </p:txBody>
+      </p:sp>
+      <p:sp>
+        <p:nvSpPr>
+          <p:cNvPr id="16" name="text-337">
+            <a:extLst xmlns:a="http://schemas.openxmlformats.org/drawingml/2006/main">
+              <a:ext uri="{FF2B5EF4-FFF2-40B4-BE49-F238E27FC236}">
+                <a16:creationId xmlns:a16="http://schemas.microsoft.com/office/drawing/2014/main" id="{3E5A6713-8ED9-47C0-94EA-A242E87F2754}"/>
+              </a:ext>
+            </a:extLst>
+          </p:cNvPr>
+          <p:cNvSpPr>
+            <a:spLocks xmlns:a="http://schemas.openxmlformats.org/drawingml/2006/main" noGrp="1"/>
+          </p:cNvSpPr>
+          <p:nvPr/>
+        </p:nvSpPr>
+        <p:spPr>
+          <a:xfrm xmlns:a="http://schemas.openxmlformats.org/drawingml/2006/main">
+            <a:off x="685800" y="4552950"/>
+            <a:ext cx="10810875" cy="914400"/>
           </a:xfrm>
           <a:prstGeom xmlns:a="http://schemas.openxmlformats.org/drawingml/2006/main" prst="rect">
             <a:avLst/>
@@ -19928,105 +20032,71 @@
           <a:p xmlns:a="http://schemas.openxmlformats.org/drawingml/2006/main">
             <a:pPr algn="l">
               <a:buNone/>
-              <a:defRPr sz="3675" b="1">
-                <a:solidFill>
-                  <a:srgbClr val="F4F2EC"/>
-                </a:solidFill>
-                <a:latin typeface="Helvetica Neue"/>
-                <a:ea typeface="Helvetica Neue"/>
-                <a:cs typeface="Helvetica Neue"/>
-              </a:defRPr>
-            </a:pPr>
-            <a:r>
-              <a:rPr sz="3675" b="1">
-                <a:solidFill>
-                  <a:srgbClr val="F4F2EC"/>
-                </a:solidFill>
-                <a:latin typeface="Helvetica Neue"/>
-                <a:ea typeface="Helvetica Neue"/>
-                <a:cs typeface="Helvetica Neue"/>
-              </a:rPr>
-              <a:t>Telefon</a:t>
-            </a:r>
-          </a:p>
-        </p:txBody>
-      </p:sp>
-      <p:sp>
-        <p:nvSpPr>
-          <p:cNvPr id="15" name="text-336">
-            <a:extLst xmlns:a="http://schemas.openxmlformats.org/drawingml/2006/main">
-              <a:ext uri="{FF2B5EF4-FFF2-40B4-BE49-F238E27FC236}">
-                <a16:creationId xmlns:a16="http://schemas.microsoft.com/office/drawing/2014/main" id="{017BC553-2884-4219-938C-C1BAA44C4EAB}"/>
-              </a:ext>
-            </a:extLst>
-          </p:cNvPr>
-          <p:cNvSpPr>
-            <a:spLocks xmlns:a="http://schemas.openxmlformats.org/drawingml/2006/main" noGrp="1"/>
-          </p:cNvSpPr>
-          <p:nvPr/>
-        </p:nvSpPr>
-        <p:spPr>
-          <a:xfrm xmlns:a="http://schemas.openxmlformats.org/drawingml/2006/main">
-            <a:off x="8972550" y="3829050"/>
-            <a:ext cx="2438400" cy="504825"/>
-          </a:xfrm>
-          <a:prstGeom xmlns:a="http://schemas.openxmlformats.org/drawingml/2006/main" prst="rect">
-            <a:avLst/>
-          </a:prstGeom>
-          <a:noFill xmlns:a="http://schemas.openxmlformats.org/drawingml/2006/main"/>
-          <a:ln xmlns:a="http://schemas.openxmlformats.org/drawingml/2006/main" w="0">
-            <a:noFill/>
-          </a:ln>
-        </p:spPr>
-        <p:txBody>
-          <a:bodyPr xmlns:a="http://schemas.openxmlformats.org/drawingml/2006/main" wrap="square" lIns="0" tIns="0" rIns="0" bIns="0" anchor="ctr">
-            <a:noAutofit/>
-          </a:bodyPr>
-          <a:lstStyle xmlns:a="http://schemas.openxmlformats.org/drawingml/2006/main"/>
+              <a:defRPr sz="1500" b="1">
+                <a:solidFill>
+                  <a:srgbClr val="F5F7F9"/>
+                </a:solidFill>
+                <a:latin typeface="Helvetica Neue"/>
+                <a:ea typeface="Helvetica Neue"/>
+                <a:cs typeface="Helvetica Neue"/>
+              </a:defRPr>
+            </a:pPr>
+            <a:r>
+              <a:rPr sz="1500" b="1">
+                <a:solidFill>
+                  <a:srgbClr val="F5F7F9"/>
+                </a:solidFill>
+                <a:latin typeface="Helvetica Neue"/>
+                <a:ea typeface="Helvetica Neue"/>
+                <a:cs typeface="Helvetica Neue"/>
+              </a:rPr>
+              <a:t>QR I PJESËMARRJES — vetëm në mes të orës; regjistron praninë</a:t>
+            </a:r>
+          </a:p>
           <a:p xmlns:a="http://schemas.openxmlformats.org/drawingml/2006/main">
             <a:pPr algn="l">
               <a:buNone/>
-              <a:defRPr sz="2100" b="0">
-                <a:solidFill>
-                  <a:srgbClr val="AEBFCB"/>
-                </a:solidFill>
-                <a:latin typeface="Helvetica Neue"/>
-                <a:ea typeface="Helvetica Neue"/>
-                <a:cs typeface="Helvetica Neue"/>
-              </a:defRPr>
-            </a:pPr>
-            <a:r>
-              <a:rPr sz="2100" b="0">
-                <a:solidFill>
-                  <a:srgbClr val="AEBFCB"/>
-                </a:solidFill>
-                <a:latin typeface="Helvetica Neue"/>
-                <a:ea typeface="Helvetica Neue"/>
-                <a:cs typeface="Helvetica Neue"/>
-              </a:rPr>
-              <a:t>35–45 min</a:t>
-            </a:r>
-          </a:p>
-        </p:txBody>
-      </p:sp>
-      <p:sp>
-        <p:nvSpPr>
-          <p:cNvPr id="16" name="text-337">
-            <a:extLst xmlns:a="http://schemas.openxmlformats.org/drawingml/2006/main">
-              <a:ext uri="{FF2B5EF4-FFF2-40B4-BE49-F238E27FC236}">
-                <a16:creationId xmlns:a16="http://schemas.microsoft.com/office/drawing/2014/main" id="{3E5A6713-8ED9-47C0-94EA-A242E87F2754}"/>
-              </a:ext>
-            </a:extLst>
-          </p:cNvPr>
-          <p:cNvSpPr>
-            <a:spLocks xmlns:a="http://schemas.openxmlformats.org/drawingml/2006/main" noGrp="1"/>
-          </p:cNvSpPr>
-          <p:nvPr/>
-        </p:nvSpPr>
-        <p:spPr>
-          <a:xfrm xmlns:a="http://schemas.openxmlformats.org/drawingml/2006/main">
-            <a:off x="695325" y="4914900"/>
-            <a:ext cx="10763250" cy="781050"/>
+              <a:defRPr sz="1500" b="1">
+                <a:solidFill>
+                  <a:srgbClr val="F5F7F9"/>
+                </a:solidFill>
+                <a:latin typeface="Helvetica Neue"/>
+                <a:ea typeface="Helvetica Neue"/>
+                <a:cs typeface="Helvetica Neue"/>
+              </a:defRPr>
+            </a:pPr>
+            <a:r>
+              <a:rPr sz="1500" b="1">
+                <a:solidFill>
+                  <a:srgbClr val="F5F7F9"/>
+                </a:solidFill>
+                <a:latin typeface="Helvetica Neue"/>
+                <a:ea typeface="Helvetica Neue"/>
+                <a:cs typeface="Helvetica Neue"/>
+              </a:rPr>
+              <a:t>QR I DEMONSTRIMIT — në fund; hap aplikacionin dhe nuk regjistron praninë</a:t>
+            </a:r>
+          </a:p>
+        </p:txBody>
+      </p:sp>
+      <p:sp>
+        <p:nvSpPr>
+          <p:cNvPr id="17" name="text-338">
+            <a:extLst xmlns:a="http://schemas.openxmlformats.org/drawingml/2006/main">
+              <a:ext uri="{FF2B5EF4-FFF2-40B4-BE49-F238E27FC236}">
+                <a16:creationId xmlns:a16="http://schemas.microsoft.com/office/drawing/2014/main" id="{3FD56265-CA8B-4650-BEB9-C46E17AC08DD}"/>
+              </a:ext>
+            </a:extLst>
+          </p:cNvPr>
+          <p:cNvSpPr>
+            <a:spLocks xmlns:a="http://schemas.openxmlformats.org/drawingml/2006/main" noGrp="1"/>
+          </p:cNvSpPr>
+          <p:nvPr/>
+        </p:nvSpPr>
+        <p:spPr>
+          <a:xfrm xmlns:a="http://schemas.openxmlformats.org/drawingml/2006/main">
+            <a:off x="685800" y="5715000"/>
+            <a:ext cx="10810875" cy="428625"/>
           </a:xfrm>
           <a:prstGeom xmlns:a="http://schemas.openxmlformats.org/drawingml/2006/main" prst="rect">
             <a:avLst/>
@@ -20044,103 +20114,67 @@
           <a:p xmlns:a="http://schemas.openxmlformats.org/drawingml/2006/main">
             <a:pPr algn="l">
               <a:buNone/>
-              <a:defRPr sz="2925" b="1">
-                <a:solidFill>
-                  <a:srgbClr val="91DEBB"/>
-                </a:solidFill>
-                <a:latin typeface="Helvetica Neue"/>
-                <a:ea typeface="Helvetica Neue"/>
-                <a:cs typeface="Helvetica Neue"/>
-              </a:defRPr>
-            </a:pPr>
-            <a:r>
-              <a:rPr sz="2925" b="1">
-                <a:solidFill>
-                  <a:srgbClr val="91DEBB"/>
-                </a:solidFill>
-                <a:latin typeface="Helvetica Neue"/>
-                <a:ea typeface="Helvetica Neue"/>
-                <a:cs typeface="Helvetica Neue"/>
-              </a:rPr>
-              <a:t>Prova: një ndryshim i dytë, i dukshëm në telefon.</a:t>
-            </a:r>
-          </a:p>
-        </p:txBody>
-      </p:sp>
-      <p:sp>
-        <p:nvSpPr>
-          <p:cNvPr id="17" name="text-338">
-            <a:extLst xmlns:a="http://schemas.openxmlformats.org/drawingml/2006/main">
-              <a:ext uri="{FF2B5EF4-FFF2-40B4-BE49-F238E27FC236}">
-                <a16:creationId xmlns:a16="http://schemas.microsoft.com/office/drawing/2014/main" id="{3FD56265-CA8B-4650-BEB9-C46E17AC08DD}"/>
-              </a:ext>
-            </a:extLst>
-          </p:cNvPr>
-          <p:cNvSpPr>
-            <a:spLocks xmlns:a="http://schemas.openxmlformats.org/drawingml/2006/main" noGrp="1"/>
-          </p:cNvSpPr>
-          <p:nvPr/>
-        </p:nvSpPr>
-        <p:spPr>
-          <a:xfrm xmlns:a="http://schemas.openxmlformats.org/drawingml/2006/main">
-            <a:off x="609600" y="5962650"/>
-            <a:ext cx="10763250" cy="428625"/>
-          </a:xfrm>
-          <a:prstGeom xmlns:a="http://schemas.openxmlformats.org/drawingml/2006/main" prst="rect">
-            <a:avLst/>
-          </a:prstGeom>
-          <a:noFill xmlns:a="http://schemas.openxmlformats.org/drawingml/2006/main"/>
-          <a:ln xmlns:a="http://schemas.openxmlformats.org/drawingml/2006/main" w="0">
-            <a:noFill/>
-          </a:ln>
-        </p:spPr>
-        <p:txBody>
-          <a:bodyPr xmlns:a="http://schemas.openxmlformats.org/drawingml/2006/main" wrap="square" lIns="0" tIns="0" rIns="0" bIns="0" anchor="ctr">
-            <a:noAutofit/>
-          </a:bodyPr>
-          <a:lstStyle xmlns:a="http://schemas.openxmlformats.org/drawingml/2006/main"/>
-          <a:p xmlns:a="http://schemas.openxmlformats.org/drawingml/2006/main">
-            <a:pPr algn="l">
-              <a:buNone/>
-              <a:defRPr sz="1950" b="0">
-                <a:solidFill>
-                  <a:srgbClr val="AEBFCB"/>
-                </a:solidFill>
-                <a:latin typeface="Helvetica Neue"/>
-                <a:ea typeface="Helvetica Neue"/>
-                <a:cs typeface="Helvetica Neue"/>
-              </a:defRPr>
-            </a:pPr>
-            <a:r>
-              <a:rPr sz="1950" b="0">
-                <a:solidFill>
-                  <a:srgbClr val="AEBFCB"/>
-                </a:solidFill>
-                <a:latin typeface="Helvetica Neue"/>
-                <a:ea typeface="Helvetica Neue"/>
-                <a:cs typeface="Helvetica Neue"/>
-              </a:rPr>
-              <a:t>24 shtator: segmenti hyrës i ushtrimeve. Vazhdoni në aplikacionin tuaj.</a:t>
+              <a:defRPr sz="1500" b="1">
+                <a:solidFill>
+                  <a:srgbClr val="5DCEF2"/>
+                </a:solidFill>
+                <a:latin typeface="Helvetica Neue"/>
+                <a:ea typeface="Helvetica Neue"/>
+                <a:cs typeface="Helvetica Neue"/>
+              </a:defRPr>
+            </a:pPr>
+            <a:r>
+              <a:rPr sz="1500" b="1">
+                <a:solidFill>
+                  <a:srgbClr val="5DCEF2"/>
+                </a:solidFill>
+                <a:latin typeface="Helvetica Neue"/>
+                <a:ea typeface="Helvetica Neue"/>
+                <a:cs typeface="Helvetica Neue"/>
+              </a:rPr>
+              <a:t>https://arbenl.github.io/demo/restaurant/</a:t>
             </a:r>
           </a:p>
         </p:txBody>
       </p:sp>
       <p:pic>
         <p:nvPicPr>
-          <p:cNvPr id="37" name=""/>
+          <p:cNvPr id="38" name=""/>
           <p:cNvPicPr>
             <a:picLocks xmlns:a="http://schemas.openxmlformats.org/drawingml/2006/main" noChangeAspect="1"/>
           </p:cNvPicPr>
           <p:nvPr/>
         </p:nvPicPr>
         <p:blipFill>
-          <a:blip xmlns:r="http://schemas.openxmlformats.org/officeDocument/2006/relationships" xmlns:a="http://schemas.openxmlformats.org/drawingml/2006/main" r:embed="R0e9f8901551f4f7f"/>
+          <a:blip xmlns:r="http://schemas.openxmlformats.org/officeDocument/2006/relationships" xmlns:a="http://schemas.openxmlformats.org/drawingml/2006/main" r:embed="R4d657ecec4464fca"/>
           <a:stretch xmlns:a="http://schemas.openxmlformats.org/drawingml/2006/main"/>
         </p:blipFill>
         <p:spPr>
           <a:xfrm xmlns:a="http://schemas.openxmlformats.org/drawingml/2006/main">
             <a:off x="9525000" y="299045"/>
             <a:ext cx="1190625" cy="240109"/>
+          </a:xfrm>
+          <a:prstGeom xmlns:a="http://schemas.openxmlformats.org/drawingml/2006/main" prst="rect">
+            <a:avLst/>
+          </a:prstGeom>
+        </p:spPr>
+      </p:pic>
+      <p:pic>
+        <p:nvPicPr>
+          <p:cNvPr id="39" name=""/>
+          <p:cNvPicPr>
+            <a:picLocks xmlns:a="http://schemas.openxmlformats.org/drawingml/2006/main" noChangeAspect="1"/>
+          </p:cNvPicPr>
+          <p:nvPr/>
+        </p:nvPicPr>
+        <p:blipFill>
+          <a:blip xmlns:r="http://schemas.openxmlformats.org/officeDocument/2006/relationships" xmlns:a="http://schemas.openxmlformats.org/drawingml/2006/main" r:embed="R7fc2827eddb84183"/>
+          <a:stretch xmlns:a="http://schemas.openxmlformats.org/drawingml/2006/main"/>
+        </p:blipFill>
+        <p:spPr>
+          <a:xfrm xmlns:a="http://schemas.openxmlformats.org/drawingml/2006/main">
+            <a:off x="9144000" y="1952625"/>
+            <a:ext cx="2095500" cy="2095500"/>
           </a:xfrm>
           <a:prstGeom xmlns:a="http://schemas.openxmlformats.org/drawingml/2006/main" prst="rect">
             <a:avLst/>
@@ -20540,8 +20574,8 @@
         </p:nvSpPr>
         <p:spPr>
           <a:xfrm xmlns:a="http://schemas.openxmlformats.org/drawingml/2006/main">
-            <a:off x="695325" y="5381625"/>
-            <a:ext cx="1809750" cy="504825"/>
+            <a:off x="695325" y="5095875"/>
+            <a:ext cx="1333500" cy="504825"/>
           </a:xfrm>
           <a:prstGeom xmlns:a="http://schemas.openxmlformats.org/drawingml/2006/main" prst="rect">
             <a:avLst/>
@@ -20559,25 +20593,25 @@
           <a:p xmlns:a="http://schemas.openxmlformats.org/drawingml/2006/main">
             <a:pPr algn="l">
               <a:buNone/>
-              <a:defRPr sz="1950" b="1">
-                <a:solidFill>
-                  <a:srgbClr val="F2BB66"/>
-                </a:solidFill>
-                <a:latin typeface="Helvetica Neue"/>
-                <a:ea typeface="Helvetica Neue"/>
-                <a:cs typeface="Helvetica Neue"/>
-              </a:defRPr>
-            </a:pPr>
-            <a:r>
-              <a:rPr sz="1950" b="1">
-                <a:solidFill>
-                  <a:srgbClr val="F2BB66"/>
-                </a:solidFill>
-                <a:latin typeface="Helvetica Neue"/>
-                <a:ea typeface="Helvetica Neue"/>
-                <a:cs typeface="Helvetica Neue"/>
-              </a:rPr>
-              <a:t>JAVA 2</a:t>
+              <a:defRPr sz="1275" b="1">
+                <a:solidFill>
+                  <a:srgbClr val="F3BE5C"/>
+                </a:solidFill>
+                <a:latin typeface="Helvetica Neue"/>
+                <a:ea typeface="Helvetica Neue"/>
+                <a:cs typeface="Helvetica Neue"/>
+              </a:defRPr>
+            </a:pPr>
+            <a:r>
+              <a:rPr sz="1275" b="1">
+                <a:solidFill>
+                  <a:srgbClr val="F3BE5C"/>
+                </a:solidFill>
+                <a:latin typeface="Helvetica Neue"/>
+                <a:ea typeface="Helvetica Neue"/>
+                <a:cs typeface="Helvetica Neue"/>
+              </a:rPr>
+              <a:t>MBYLLJA</a:t>
             </a:r>
           </a:p>
         </p:txBody>
@@ -20598,8 +20632,8 @@
         </p:nvSpPr>
         <p:spPr>
           <a:xfrm xmlns:a="http://schemas.openxmlformats.org/drawingml/2006/main">
-            <a:off x="2676525" y="5305425"/>
-            <a:ext cx="8610600" cy="647700"/>
+            <a:off x="2095500" y="4876800"/>
+            <a:ext cx="9191625" cy="1028700"/>
           </a:xfrm>
           <a:prstGeom xmlns:a="http://schemas.openxmlformats.org/drawingml/2006/main" prst="rect">
             <a:avLst/>
@@ -20617,25 +20651,25 @@
           <a:p xmlns:a="http://schemas.openxmlformats.org/drawingml/2006/main">
             <a:pPr algn="l">
               <a:buNone/>
-              <a:defRPr sz="2775" b="1">
-                <a:solidFill>
-                  <a:srgbClr val="F4F2EC"/>
-                </a:solidFill>
-                <a:latin typeface="Helvetica Neue"/>
-                <a:ea typeface="Helvetica Neue"/>
-                <a:cs typeface="Helvetica Neue"/>
-              </a:defRPr>
-            </a:pPr>
-            <a:r>
-              <a:rPr sz="2775" b="1">
-                <a:solidFill>
-                  <a:srgbClr val="F4F2EC"/>
-                </a:solidFill>
-                <a:latin typeface="Helvetica Neue"/>
-                <a:ea typeface="Helvetica Neue"/>
-                <a:cs typeface="Helvetica Neue"/>
-              </a:rPr>
-              <a:t>Tri biseda + PRD paraprake</a:t>
+              <a:defRPr sz="1575" b="1">
+                <a:solidFill>
+                  <a:srgbClr val="F5F7F9"/>
+                </a:solidFill>
+                <a:latin typeface="Helvetica Neue"/>
+                <a:ea typeface="Helvetica Neue"/>
+                <a:cs typeface="Helvetica Neue"/>
+              </a:defRPr>
+            </a:pPr>
+            <a:r>
+              <a:rPr sz="1575" b="1">
+                <a:solidFill>
+                  <a:srgbClr val="F5F7F9"/>
+                </a:solidFill>
+                <a:latin typeface="Helvetica Neue"/>
+                <a:ea typeface="Helvetica Neue"/>
+                <a:cs typeface="Helvetica Neue"/>
+              </a:rPr>
+              <a:t>15 javë më vonë, këtë mund ta ndërtoni ju. Filloni me një biznes. Gjeni një problem. Ndërtoni një rrjedhë që funksionon.</a:t>
             </a:r>
           </a:p>
         </p:txBody>
@@ -20707,7 +20741,7 @@
           <p:nvPr/>
         </p:nvPicPr>
         <p:blipFill>
-          <a:blip xmlns:r="http://schemas.openxmlformats.org/officeDocument/2006/relationships" xmlns:a="http://schemas.openxmlformats.org/drawingml/2006/main" r:embed="Re2405347440b457e"/>
+          <a:blip xmlns:r="http://schemas.openxmlformats.org/officeDocument/2006/relationships" xmlns:a="http://schemas.openxmlformats.org/drawingml/2006/main" r:embed="Rcbd8d669c1724f77"/>
           <a:stretch xmlns:a="http://schemas.openxmlformats.org/drawingml/2006/main"/>
         </p:blipFill>
         <p:spPr>
@@ -20783,6 +20817,7 @@
           <a:lstStyle xmlns:a="http://schemas.openxmlformats.org/drawingml/2006/main"/>
           <a:p xmlns:a="http://schemas.openxmlformats.org/drawingml/2006/main">
             <a:pPr>
+              <a:buNone/>
               <a:defRPr sz="1350" b="1">
                 <a:solidFill>
                   <a:srgbClr val="5DCEF2"/>
@@ -20840,6 +20875,7 @@
           <a:lstStyle xmlns:a="http://schemas.openxmlformats.org/drawingml/2006/main"/>
           <a:p xmlns:a="http://schemas.openxmlformats.org/drawingml/2006/main">
             <a:pPr>
+              <a:buNone/>
               <a:defRPr sz="3600" b="1">
                 <a:solidFill>
                   <a:srgbClr val="F5F7F9"/>
@@ -20897,6 +20933,7 @@
           <a:lstStyle xmlns:a="http://schemas.openxmlformats.org/drawingml/2006/main"/>
           <a:p xmlns:a="http://schemas.openxmlformats.org/drawingml/2006/main">
             <a:pPr>
+              <a:buNone/>
               <a:defRPr sz="2550" b="1">
                 <a:solidFill>
                   <a:srgbClr val="5DCEF2"/>
@@ -20954,6 +20991,7 @@
           <a:lstStyle xmlns:a="http://schemas.openxmlformats.org/drawingml/2006/main"/>
           <a:p xmlns:a="http://schemas.openxmlformats.org/drawingml/2006/main">
             <a:pPr>
+              <a:buNone/>
               <a:defRPr sz="2400" b="0">
                 <a:solidFill>
                   <a:srgbClr val="F5F7F9"/>
@@ -21011,6 +21049,7 @@
           <a:lstStyle xmlns:a="http://schemas.openxmlformats.org/drawingml/2006/main"/>
           <a:p xmlns:a="http://schemas.openxmlformats.org/drawingml/2006/main">
             <a:pPr>
+              <a:buNone/>
               <a:defRPr sz="2550" b="1">
                 <a:solidFill>
                   <a:srgbClr val="5DCEF2"/>
@@ -21068,6 +21107,7 @@
           <a:lstStyle xmlns:a="http://schemas.openxmlformats.org/drawingml/2006/main"/>
           <a:p xmlns:a="http://schemas.openxmlformats.org/drawingml/2006/main">
             <a:pPr>
+              <a:buNone/>
               <a:defRPr sz="2400" b="0">
                 <a:solidFill>
                   <a:srgbClr val="F5F7F9"/>
@@ -21125,6 +21165,7 @@
           <a:lstStyle xmlns:a="http://schemas.openxmlformats.org/drawingml/2006/main"/>
           <a:p xmlns:a="http://schemas.openxmlformats.org/drawingml/2006/main">
             <a:pPr>
+              <a:buNone/>
               <a:defRPr sz="2550" b="1">
                 <a:solidFill>
                   <a:srgbClr val="5DCEF2"/>
@@ -21182,6 +21223,7 @@
           <a:lstStyle xmlns:a="http://schemas.openxmlformats.org/drawingml/2006/main"/>
           <a:p xmlns:a="http://schemas.openxmlformats.org/drawingml/2006/main">
             <a:pPr>
+              <a:buNone/>
               <a:defRPr sz="2400" b="0">
                 <a:solidFill>
                   <a:srgbClr val="F5F7F9"/>
@@ -21239,6 +21281,7 @@
           <a:lstStyle xmlns:a="http://schemas.openxmlformats.org/drawingml/2006/main"/>
           <a:p xmlns:a="http://schemas.openxmlformats.org/drawingml/2006/main">
             <a:pPr>
+              <a:buNone/>
               <a:defRPr sz="2550" b="1">
                 <a:solidFill>
                   <a:srgbClr val="5DCEF2"/>
@@ -21296,6 +21339,7 @@
           <a:lstStyle xmlns:a="http://schemas.openxmlformats.org/drawingml/2006/main"/>
           <a:p xmlns:a="http://schemas.openxmlformats.org/drawingml/2006/main">
             <a:pPr>
+              <a:buNone/>
               <a:defRPr sz="2400" b="0">
                 <a:solidFill>
                   <a:srgbClr val="F5F7F9"/>
@@ -21353,6 +21397,7 @@
           <a:lstStyle xmlns:a="http://schemas.openxmlformats.org/drawingml/2006/main"/>
           <a:p xmlns:a="http://schemas.openxmlformats.org/drawingml/2006/main">
             <a:pPr>
+              <a:buNone/>
               <a:defRPr sz="2100" b="0">
                 <a:solidFill>
                   <a:srgbClr val="B6C5CE"/>
@@ -21410,6 +21455,7 @@
           <a:lstStyle xmlns:a="http://schemas.openxmlformats.org/drawingml/2006/main"/>
           <a:p xmlns:a="http://schemas.openxmlformats.org/drawingml/2006/main">
             <a:pPr>
+              <a:buNone/>
               <a:defRPr sz="1350" b="0">
                 <a:solidFill>
                   <a:srgbClr val="B6C5CE"/>
@@ -21435,14 +21481,14 @@
       </p:sp>
       <p:pic>
         <p:nvPicPr>
-          <p:cNvPr id="26" name=""/>
+          <p:cNvPr id="28" name=""/>
           <p:cNvPicPr>
             <a:picLocks xmlns:a="http://schemas.openxmlformats.org/drawingml/2006/main" noChangeAspect="1"/>
           </p:cNvPicPr>
           <p:nvPr/>
         </p:nvPicPr>
         <p:blipFill>
-          <a:blip xmlns:r="http://schemas.openxmlformats.org/officeDocument/2006/relationships" xmlns:a="http://schemas.openxmlformats.org/drawingml/2006/main" r:embed="Re1363725f64349c4"/>
+          <a:blip xmlns:r="http://schemas.openxmlformats.org/officeDocument/2006/relationships" xmlns:a="http://schemas.openxmlformats.org/drawingml/2006/main" r:embed="Rb48e5277eba5415a"/>
           <a:stretch xmlns:a="http://schemas.openxmlformats.org/drawingml/2006/main"/>
         </p:blipFill>
         <p:spPr>
@@ -21518,6 +21564,7 @@
           <a:lstStyle xmlns:a="http://schemas.openxmlformats.org/drawingml/2006/main"/>
           <a:p xmlns:a="http://schemas.openxmlformats.org/drawingml/2006/main">
             <a:pPr>
+              <a:buNone/>
               <a:defRPr sz="1350" b="1">
                 <a:solidFill>
                   <a:srgbClr val="5DCEF2"/>
@@ -21575,6 +21622,7 @@
           <a:lstStyle xmlns:a="http://schemas.openxmlformats.org/drawingml/2006/main"/>
           <a:p xmlns:a="http://schemas.openxmlformats.org/drawingml/2006/main">
             <a:pPr>
+              <a:buNone/>
               <a:defRPr sz="3600" b="1">
                 <a:solidFill>
                   <a:srgbClr val="F5F7F9"/>
@@ -21632,6 +21680,7 @@
           <a:lstStyle xmlns:a="http://schemas.openxmlformats.org/drawingml/2006/main"/>
           <a:p xmlns:a="http://schemas.openxmlformats.org/drawingml/2006/main">
             <a:pPr>
+              <a:buNone/>
               <a:defRPr sz="2400" b="1">
                 <a:solidFill>
                   <a:srgbClr val="5DCEF2"/>
@@ -21689,6 +21738,7 @@
           <a:lstStyle xmlns:a="http://schemas.openxmlformats.org/drawingml/2006/main"/>
           <a:p xmlns:a="http://schemas.openxmlformats.org/drawingml/2006/main">
             <a:pPr>
+              <a:buNone/>
               <a:defRPr sz="2250" b="0">
                 <a:solidFill>
                   <a:srgbClr val="F5F7F9"/>
@@ -21746,6 +21796,7 @@
           <a:lstStyle xmlns:a="http://schemas.openxmlformats.org/drawingml/2006/main"/>
           <a:p xmlns:a="http://schemas.openxmlformats.org/drawingml/2006/main">
             <a:pPr>
+              <a:buNone/>
               <a:defRPr sz="2400" b="1">
                 <a:solidFill>
                   <a:srgbClr val="5DCEF2"/>
@@ -21803,6 +21854,7 @@
           <a:lstStyle xmlns:a="http://schemas.openxmlformats.org/drawingml/2006/main"/>
           <a:p xmlns:a="http://schemas.openxmlformats.org/drawingml/2006/main">
             <a:pPr>
+              <a:buNone/>
               <a:defRPr sz="2250" b="0">
                 <a:solidFill>
                   <a:srgbClr val="F5F7F9"/>
@@ -21860,6 +21912,7 @@
           <a:lstStyle xmlns:a="http://schemas.openxmlformats.org/drawingml/2006/main"/>
           <a:p xmlns:a="http://schemas.openxmlformats.org/drawingml/2006/main">
             <a:pPr>
+              <a:buNone/>
               <a:defRPr sz="2400" b="1">
                 <a:solidFill>
                   <a:srgbClr val="5DCEF2"/>
@@ -21917,6 +21970,7 @@
           <a:lstStyle xmlns:a="http://schemas.openxmlformats.org/drawingml/2006/main"/>
           <a:p xmlns:a="http://schemas.openxmlformats.org/drawingml/2006/main">
             <a:pPr>
+              <a:buNone/>
               <a:defRPr sz="2250" b="0">
                 <a:solidFill>
                   <a:srgbClr val="F5F7F9"/>
@@ -21974,6 +22028,7 @@
           <a:lstStyle xmlns:a="http://schemas.openxmlformats.org/drawingml/2006/main"/>
           <a:p xmlns:a="http://schemas.openxmlformats.org/drawingml/2006/main">
             <a:pPr>
+              <a:buNone/>
               <a:defRPr sz="2400" b="1">
                 <a:solidFill>
                   <a:srgbClr val="5DCEF2"/>
@@ -22031,6 +22086,7 @@
           <a:lstStyle xmlns:a="http://schemas.openxmlformats.org/drawingml/2006/main"/>
           <a:p xmlns:a="http://schemas.openxmlformats.org/drawingml/2006/main">
             <a:pPr>
+              <a:buNone/>
               <a:defRPr sz="2250" b="0">
                 <a:solidFill>
                   <a:srgbClr val="F5F7F9"/>
@@ -22088,6 +22144,7 @@
           <a:lstStyle xmlns:a="http://schemas.openxmlformats.org/drawingml/2006/main"/>
           <a:p xmlns:a="http://schemas.openxmlformats.org/drawingml/2006/main">
             <a:pPr>
+              <a:buNone/>
               <a:defRPr sz="1350" b="0">
                 <a:solidFill>
                   <a:srgbClr val="B6C5CE"/>
@@ -22113,14 +22170,14 @@
       </p:sp>
       <p:pic>
         <p:nvPicPr>
-          <p:cNvPr id="24" name=""/>
+          <p:cNvPr id="26" name=""/>
           <p:cNvPicPr>
             <a:picLocks xmlns:a="http://schemas.openxmlformats.org/drawingml/2006/main" noChangeAspect="1"/>
           </p:cNvPicPr>
           <p:nvPr/>
         </p:nvPicPr>
         <p:blipFill>
-          <a:blip xmlns:r="http://schemas.openxmlformats.org/officeDocument/2006/relationships" xmlns:a="http://schemas.openxmlformats.org/drawingml/2006/main" r:embed="R36ce272619b1429a"/>
+          <a:blip xmlns:r="http://schemas.openxmlformats.org/officeDocument/2006/relationships" xmlns:a="http://schemas.openxmlformats.org/drawingml/2006/main" r:embed="R0ca4307bf4f24220"/>
           <a:stretch xmlns:a="http://schemas.openxmlformats.org/drawingml/2006/main"/>
         </p:blipFill>
         <p:spPr>
@@ -22196,6 +22253,7 @@
           <a:lstStyle xmlns:a="http://schemas.openxmlformats.org/drawingml/2006/main"/>
           <a:p xmlns:a="http://schemas.openxmlformats.org/drawingml/2006/main">
             <a:pPr>
+              <a:buNone/>
               <a:defRPr sz="1350" b="1">
                 <a:solidFill>
                   <a:srgbClr val="5DCEF2"/>
@@ -22253,6 +22311,7 @@
           <a:lstStyle xmlns:a="http://schemas.openxmlformats.org/drawingml/2006/main"/>
           <a:p xmlns:a="http://schemas.openxmlformats.org/drawingml/2006/main">
             <a:pPr>
+              <a:buNone/>
               <a:defRPr sz="3600" b="1">
                 <a:solidFill>
                   <a:srgbClr val="F5F7F9"/>
@@ -22310,6 +22369,7 @@
           <a:lstStyle xmlns:a="http://schemas.openxmlformats.org/drawingml/2006/main"/>
           <a:p xmlns:a="http://schemas.openxmlformats.org/drawingml/2006/main">
             <a:pPr>
+              <a:buNone/>
               <a:defRPr sz="3000" b="1">
                 <a:solidFill>
                   <a:srgbClr val="5DCEF2"/>
@@ -22367,6 +22427,7 @@
           <a:lstStyle xmlns:a="http://schemas.openxmlformats.org/drawingml/2006/main"/>
           <a:p xmlns:a="http://schemas.openxmlformats.org/drawingml/2006/main">
             <a:pPr>
+              <a:buNone/>
               <a:defRPr sz="2325" b="0">
                 <a:solidFill>
                   <a:srgbClr val="F5F7F9"/>
@@ -22424,6 +22485,7 @@
           <a:lstStyle xmlns:a="http://schemas.openxmlformats.org/drawingml/2006/main"/>
           <a:p xmlns:a="http://schemas.openxmlformats.org/drawingml/2006/main">
             <a:pPr>
+              <a:buNone/>
               <a:defRPr sz="3000" b="1">
                 <a:solidFill>
                   <a:srgbClr val="5DCEF2"/>
@@ -22481,6 +22543,7 @@
           <a:lstStyle xmlns:a="http://schemas.openxmlformats.org/drawingml/2006/main"/>
           <a:p xmlns:a="http://schemas.openxmlformats.org/drawingml/2006/main">
             <a:pPr>
+              <a:buNone/>
               <a:defRPr sz="2325" b="0">
                 <a:solidFill>
                   <a:srgbClr val="F5F7F9"/>
@@ -22538,6 +22601,7 @@
           <a:lstStyle xmlns:a="http://schemas.openxmlformats.org/drawingml/2006/main"/>
           <a:p xmlns:a="http://schemas.openxmlformats.org/drawingml/2006/main">
             <a:pPr>
+              <a:buNone/>
               <a:defRPr sz="3000" b="1">
                 <a:solidFill>
                   <a:srgbClr val="5DCEF2"/>
@@ -22595,6 +22659,7 @@
           <a:lstStyle xmlns:a="http://schemas.openxmlformats.org/drawingml/2006/main"/>
           <a:p xmlns:a="http://schemas.openxmlformats.org/drawingml/2006/main">
             <a:pPr>
+              <a:buNone/>
               <a:defRPr sz="2325" b="0">
                 <a:solidFill>
                   <a:srgbClr val="F5F7F9"/>
@@ -22652,6 +22717,7 @@
           <a:lstStyle xmlns:a="http://schemas.openxmlformats.org/drawingml/2006/main"/>
           <a:p xmlns:a="http://schemas.openxmlformats.org/drawingml/2006/main">
             <a:pPr>
+              <a:buNone/>
               <a:defRPr sz="3000" b="1">
                 <a:solidFill>
                   <a:srgbClr val="5DCEF2"/>
@@ -22709,6 +22775,7 @@
           <a:lstStyle xmlns:a="http://schemas.openxmlformats.org/drawingml/2006/main"/>
           <a:p xmlns:a="http://schemas.openxmlformats.org/drawingml/2006/main">
             <a:pPr>
+              <a:buNone/>
               <a:defRPr sz="2325" b="0">
                 <a:solidFill>
                   <a:srgbClr val="F5F7F9"/>
@@ -22766,6 +22833,7 @@
           <a:lstStyle xmlns:a="http://schemas.openxmlformats.org/drawingml/2006/main"/>
           <a:p xmlns:a="http://schemas.openxmlformats.org/drawingml/2006/main">
             <a:pPr>
+              <a:buNone/>
               <a:defRPr sz="1350" b="0">
                 <a:solidFill>
                   <a:srgbClr val="B6C5CE"/>
@@ -22791,14 +22859,14 @@
       </p:sp>
       <p:pic>
         <p:nvPicPr>
-          <p:cNvPr id="24" name=""/>
+          <p:cNvPr id="26" name=""/>
           <p:cNvPicPr>
             <a:picLocks xmlns:a="http://schemas.openxmlformats.org/drawingml/2006/main" noChangeAspect="1"/>
           </p:cNvPicPr>
           <p:nvPr/>
         </p:nvPicPr>
         <p:blipFill>
-          <a:blip xmlns:r="http://schemas.openxmlformats.org/officeDocument/2006/relationships" xmlns:a="http://schemas.openxmlformats.org/drawingml/2006/main" r:embed="R62afa0df71354993"/>
+          <a:blip xmlns:r="http://schemas.openxmlformats.org/officeDocument/2006/relationships" xmlns:a="http://schemas.openxmlformats.org/drawingml/2006/main" r:embed="R747f8405bbfd48d3"/>
           <a:stretch xmlns:a="http://schemas.openxmlformats.org/drawingml/2006/main"/>
         </p:blipFill>
         <p:spPr>
@@ -22874,6 +22942,7 @@
           <a:lstStyle xmlns:a="http://schemas.openxmlformats.org/drawingml/2006/main"/>
           <a:p xmlns:a="http://schemas.openxmlformats.org/drawingml/2006/main">
             <a:pPr>
+              <a:buNone/>
               <a:defRPr sz="1350" b="1">
                 <a:solidFill>
                   <a:srgbClr val="5DCEF2"/>
@@ -22931,6 +23000,7 @@
           <a:lstStyle xmlns:a="http://schemas.openxmlformats.org/drawingml/2006/main"/>
           <a:p xmlns:a="http://schemas.openxmlformats.org/drawingml/2006/main">
             <a:pPr>
+              <a:buNone/>
               <a:defRPr sz="3600" b="1">
                 <a:solidFill>
                   <a:srgbClr val="F5F7F9"/>
@@ -22988,6 +23058,7 @@
           <a:lstStyle xmlns:a="http://schemas.openxmlformats.org/drawingml/2006/main"/>
           <a:p xmlns:a="http://schemas.openxmlformats.org/drawingml/2006/main">
             <a:pPr>
+              <a:buNone/>
               <a:defRPr sz="3000" b="1">
                 <a:solidFill>
                   <a:srgbClr val="5DCEF2"/>
@@ -23045,6 +23116,7 @@
           <a:lstStyle xmlns:a="http://schemas.openxmlformats.org/drawingml/2006/main"/>
           <a:p xmlns:a="http://schemas.openxmlformats.org/drawingml/2006/main">
             <a:pPr>
+              <a:buNone/>
               <a:defRPr sz="2325" b="0">
                 <a:solidFill>
                   <a:srgbClr val="F5F7F9"/>
@@ -23102,6 +23174,7 @@
           <a:lstStyle xmlns:a="http://schemas.openxmlformats.org/drawingml/2006/main"/>
           <a:p xmlns:a="http://schemas.openxmlformats.org/drawingml/2006/main">
             <a:pPr>
+              <a:buNone/>
               <a:defRPr sz="3000" b="1">
                 <a:solidFill>
                   <a:srgbClr val="5DCEF2"/>
@@ -23159,6 +23232,7 @@
           <a:lstStyle xmlns:a="http://schemas.openxmlformats.org/drawingml/2006/main"/>
           <a:p xmlns:a="http://schemas.openxmlformats.org/drawingml/2006/main">
             <a:pPr>
+              <a:buNone/>
               <a:defRPr sz="2325" b="0">
                 <a:solidFill>
                   <a:srgbClr val="F5F7F9"/>
@@ -23216,6 +23290,7 @@
           <a:lstStyle xmlns:a="http://schemas.openxmlformats.org/drawingml/2006/main"/>
           <a:p xmlns:a="http://schemas.openxmlformats.org/drawingml/2006/main">
             <a:pPr>
+              <a:buNone/>
               <a:defRPr sz="3000" b="1">
                 <a:solidFill>
                   <a:srgbClr val="5DCEF2"/>
@@ -23273,6 +23348,7 @@
           <a:lstStyle xmlns:a="http://schemas.openxmlformats.org/drawingml/2006/main"/>
           <a:p xmlns:a="http://schemas.openxmlformats.org/drawingml/2006/main">
             <a:pPr>
+              <a:buNone/>
               <a:defRPr sz="2325" b="0">
                 <a:solidFill>
                   <a:srgbClr val="F5F7F9"/>
@@ -23330,6 +23406,7 @@
           <a:lstStyle xmlns:a="http://schemas.openxmlformats.org/drawingml/2006/main"/>
           <a:p xmlns:a="http://schemas.openxmlformats.org/drawingml/2006/main">
             <a:pPr>
+              <a:buNone/>
               <a:defRPr sz="3000" b="1">
                 <a:solidFill>
                   <a:srgbClr val="5DCEF2"/>
@@ -23387,6 +23464,7 @@
           <a:lstStyle xmlns:a="http://schemas.openxmlformats.org/drawingml/2006/main"/>
           <a:p xmlns:a="http://schemas.openxmlformats.org/drawingml/2006/main">
             <a:pPr>
+              <a:buNone/>
               <a:defRPr sz="2325" b="0">
                 <a:solidFill>
                   <a:srgbClr val="F5F7F9"/>
@@ -23444,6 +23522,7 @@
           <a:lstStyle xmlns:a="http://schemas.openxmlformats.org/drawingml/2006/main"/>
           <a:p xmlns:a="http://schemas.openxmlformats.org/drawingml/2006/main">
             <a:pPr>
+              <a:buNone/>
               <a:defRPr sz="1350" b="0">
                 <a:solidFill>
                   <a:srgbClr val="B6C5CE"/>
@@ -23469,14 +23548,14 @@
       </p:sp>
       <p:pic>
         <p:nvPicPr>
-          <p:cNvPr id="24" name=""/>
+          <p:cNvPr id="26" name=""/>
           <p:cNvPicPr>
             <a:picLocks xmlns:a="http://schemas.openxmlformats.org/drawingml/2006/main" noChangeAspect="1"/>
           </p:cNvPicPr>
           <p:nvPr/>
         </p:nvPicPr>
         <p:blipFill>
-          <a:blip xmlns:r="http://schemas.openxmlformats.org/officeDocument/2006/relationships" xmlns:a="http://schemas.openxmlformats.org/drawingml/2006/main" r:embed="Rc65f15f84fce44f1"/>
+          <a:blip xmlns:r="http://schemas.openxmlformats.org/officeDocument/2006/relationships" xmlns:a="http://schemas.openxmlformats.org/drawingml/2006/main" r:embed="Red49676455c44ae1"/>
           <a:stretch xmlns:a="http://schemas.openxmlformats.org/drawingml/2006/main"/>
         </p:blipFill>
         <p:spPr>
@@ -23552,6 +23631,7 @@
           <a:lstStyle xmlns:a="http://schemas.openxmlformats.org/drawingml/2006/main"/>
           <a:p xmlns:a="http://schemas.openxmlformats.org/drawingml/2006/main">
             <a:pPr>
+              <a:buNone/>
               <a:defRPr sz="1350" b="1">
                 <a:solidFill>
                   <a:srgbClr val="5DCEF2"/>
@@ -23609,6 +23689,7 @@
           <a:lstStyle xmlns:a="http://schemas.openxmlformats.org/drawingml/2006/main"/>
           <a:p xmlns:a="http://schemas.openxmlformats.org/drawingml/2006/main">
             <a:pPr>
+              <a:buNone/>
               <a:defRPr sz="3600" b="1">
                 <a:solidFill>
                   <a:srgbClr val="F5F7F9"/>
@@ -23666,6 +23747,7 @@
           <a:lstStyle xmlns:a="http://schemas.openxmlformats.org/drawingml/2006/main"/>
           <a:p xmlns:a="http://schemas.openxmlformats.org/drawingml/2006/main">
             <a:pPr>
+              <a:buNone/>
               <a:defRPr sz="3000" b="1">
                 <a:solidFill>
                   <a:srgbClr val="5DCEF2"/>
@@ -23723,6 +23805,7 @@
           <a:lstStyle xmlns:a="http://schemas.openxmlformats.org/drawingml/2006/main"/>
           <a:p xmlns:a="http://schemas.openxmlformats.org/drawingml/2006/main">
             <a:pPr>
+              <a:buNone/>
               <a:defRPr sz="2400" b="0">
                 <a:solidFill>
                   <a:srgbClr val="F5F7F9"/>
@@ -23780,6 +23863,7 @@
           <a:lstStyle xmlns:a="http://schemas.openxmlformats.org/drawingml/2006/main"/>
           <a:p xmlns:a="http://schemas.openxmlformats.org/drawingml/2006/main">
             <a:pPr>
+              <a:buNone/>
               <a:defRPr sz="3000" b="1">
                 <a:solidFill>
                   <a:srgbClr val="5DCEF2"/>
@@ -23837,6 +23921,7 @@
           <a:lstStyle xmlns:a="http://schemas.openxmlformats.org/drawingml/2006/main"/>
           <a:p xmlns:a="http://schemas.openxmlformats.org/drawingml/2006/main">
             <a:pPr>
+              <a:buNone/>
               <a:defRPr sz="2400" b="0">
                 <a:solidFill>
                   <a:srgbClr val="F5F7F9"/>
@@ -23894,6 +23979,7 @@
           <a:lstStyle xmlns:a="http://schemas.openxmlformats.org/drawingml/2006/main"/>
           <a:p xmlns:a="http://schemas.openxmlformats.org/drawingml/2006/main">
             <a:pPr>
+              <a:buNone/>
               <a:defRPr sz="3000" b="1">
                 <a:solidFill>
                   <a:srgbClr val="5DCEF2"/>
@@ -23951,6 +24037,7 @@
           <a:lstStyle xmlns:a="http://schemas.openxmlformats.org/drawingml/2006/main"/>
           <a:p xmlns:a="http://schemas.openxmlformats.org/drawingml/2006/main">
             <a:pPr>
+              <a:buNone/>
               <a:defRPr sz="2400" b="0">
                 <a:solidFill>
                   <a:srgbClr val="F5F7F9"/>
@@ -24008,6 +24095,7 @@
           <a:lstStyle xmlns:a="http://schemas.openxmlformats.org/drawingml/2006/main"/>
           <a:p xmlns:a="http://schemas.openxmlformats.org/drawingml/2006/main">
             <a:pPr>
+              <a:buNone/>
               <a:defRPr sz="3000" b="1">
                 <a:solidFill>
                   <a:srgbClr val="5DCEF2"/>
@@ -24065,6 +24153,7 @@
           <a:lstStyle xmlns:a="http://schemas.openxmlformats.org/drawingml/2006/main"/>
           <a:p xmlns:a="http://schemas.openxmlformats.org/drawingml/2006/main">
             <a:pPr>
+              <a:buNone/>
               <a:defRPr sz="2400" b="0">
                 <a:solidFill>
                   <a:srgbClr val="F5F7F9"/>
@@ -24122,6 +24211,7 @@
           <a:lstStyle xmlns:a="http://schemas.openxmlformats.org/drawingml/2006/main"/>
           <a:p xmlns:a="http://schemas.openxmlformats.org/drawingml/2006/main">
             <a:pPr>
+              <a:buNone/>
               <a:defRPr sz="2100" b="0">
                 <a:solidFill>
                   <a:srgbClr val="B6C5CE"/>
@@ -24179,6 +24269,7 @@
           <a:lstStyle xmlns:a="http://schemas.openxmlformats.org/drawingml/2006/main"/>
           <a:p xmlns:a="http://schemas.openxmlformats.org/drawingml/2006/main">
             <a:pPr>
+              <a:buNone/>
               <a:defRPr sz="1350" b="0">
                 <a:solidFill>
                   <a:srgbClr val="B6C5CE"/>
@@ -24204,14 +24295,14 @@
       </p:sp>
       <p:pic>
         <p:nvPicPr>
-          <p:cNvPr id="26" name=""/>
+          <p:cNvPr id="28" name=""/>
           <p:cNvPicPr>
             <a:picLocks xmlns:a="http://schemas.openxmlformats.org/drawingml/2006/main" noChangeAspect="1"/>
           </p:cNvPicPr>
           <p:nvPr/>
         </p:nvPicPr>
         <p:blipFill>
-          <a:blip xmlns:r="http://schemas.openxmlformats.org/officeDocument/2006/relationships" xmlns:a="http://schemas.openxmlformats.org/drawingml/2006/main" r:embed="Rc8d13fb93b974a77"/>
+          <a:blip xmlns:r="http://schemas.openxmlformats.org/officeDocument/2006/relationships" xmlns:a="http://schemas.openxmlformats.org/drawingml/2006/main" r:embed="R1dfe96568c7e4884"/>
           <a:stretch xmlns:a="http://schemas.openxmlformats.org/drawingml/2006/main"/>
         </p:blipFill>
         <p:spPr>
@@ -24287,6 +24378,7 @@
           <a:lstStyle xmlns:a="http://schemas.openxmlformats.org/drawingml/2006/main"/>
           <a:p xmlns:a="http://schemas.openxmlformats.org/drawingml/2006/main">
             <a:pPr>
+              <a:buNone/>
               <a:defRPr sz="1350" b="1">
                 <a:solidFill>
                   <a:srgbClr val="5DCEF2"/>
@@ -24344,6 +24436,7 @@
           <a:lstStyle xmlns:a="http://schemas.openxmlformats.org/drawingml/2006/main"/>
           <a:p xmlns:a="http://schemas.openxmlformats.org/drawingml/2006/main">
             <a:pPr>
+              <a:buNone/>
               <a:defRPr sz="3600" b="1">
                 <a:solidFill>
                   <a:srgbClr val="F5F7F9"/>
@@ -24401,6 +24494,7 @@
           <a:lstStyle xmlns:a="http://schemas.openxmlformats.org/drawingml/2006/main"/>
           <a:p xmlns:a="http://schemas.openxmlformats.org/drawingml/2006/main">
             <a:pPr>
+              <a:buNone/>
               <a:defRPr sz="4800" b="1">
                 <a:solidFill>
                   <a:srgbClr val="5DCEF2"/>
@@ -24458,6 +24552,7 @@
           <a:lstStyle xmlns:a="http://schemas.openxmlformats.org/drawingml/2006/main"/>
           <a:p xmlns:a="http://schemas.openxmlformats.org/drawingml/2006/main">
             <a:pPr>
+              <a:buNone/>
               <a:defRPr sz="2325" b="0">
                 <a:solidFill>
                   <a:srgbClr val="F5F7F9"/>
@@ -24481,6 +24576,7 @@
           </a:p>
           <a:p xmlns:a="http://schemas.openxmlformats.org/drawingml/2006/main">
             <a:pPr>
+              <a:buNone/>
               <a:defRPr sz="2325" b="0">
                 <a:solidFill>
                   <a:srgbClr val="F5F7F9"/>
@@ -24504,6 +24600,7 @@
           </a:p>
           <a:p xmlns:a="http://schemas.openxmlformats.org/drawingml/2006/main">
             <a:pPr>
+              <a:buNone/>
               <a:defRPr sz="2325" b="0">
                 <a:solidFill>
                   <a:srgbClr val="F5F7F9"/>
@@ -24561,6 +24658,7 @@
           <a:lstStyle xmlns:a="http://schemas.openxmlformats.org/drawingml/2006/main"/>
           <a:p xmlns:a="http://schemas.openxmlformats.org/drawingml/2006/main">
             <a:pPr>
+              <a:buNone/>
               <a:defRPr sz="2100" b="0">
                 <a:solidFill>
                   <a:srgbClr val="B6C5CE"/>
@@ -24618,6 +24716,7 @@
           <a:lstStyle xmlns:a="http://schemas.openxmlformats.org/drawingml/2006/main"/>
           <a:p xmlns:a="http://schemas.openxmlformats.org/drawingml/2006/main">
             <a:pPr>
+              <a:buNone/>
               <a:defRPr sz="1350" b="0">
                 <a:solidFill>
                   <a:srgbClr val="B6C5CE"/>
@@ -24643,14 +24742,14 @@
       </p:sp>
       <p:pic>
         <p:nvPicPr>
-          <p:cNvPr id="14" name=""/>
+          <p:cNvPr id="16" name=""/>
           <p:cNvPicPr>
             <a:picLocks xmlns:a="http://schemas.openxmlformats.org/drawingml/2006/main" noChangeAspect="1"/>
           </p:cNvPicPr>
           <p:nvPr/>
         </p:nvPicPr>
         <p:blipFill>
-          <a:blip xmlns:r="http://schemas.openxmlformats.org/officeDocument/2006/relationships" xmlns:a="http://schemas.openxmlformats.org/drawingml/2006/main" r:embed="R313cc01891e84e22"/>
+          <a:blip xmlns:r="http://schemas.openxmlformats.org/officeDocument/2006/relationships" xmlns:a="http://schemas.openxmlformats.org/drawingml/2006/main" r:embed="Re1695202f3bc443f"/>
           <a:stretch xmlns:a="http://schemas.openxmlformats.org/drawingml/2006/main"/>
         </p:blipFill>
         <p:spPr>
@@ -24726,6 +24825,7 @@
           <a:lstStyle xmlns:a="http://schemas.openxmlformats.org/drawingml/2006/main"/>
           <a:p xmlns:a="http://schemas.openxmlformats.org/drawingml/2006/main">
             <a:pPr>
+              <a:buNone/>
               <a:defRPr sz="1350" b="1">
                 <a:solidFill>
                   <a:srgbClr val="5DCEF2"/>
@@ -24783,6 +24883,7 @@
           <a:lstStyle xmlns:a="http://schemas.openxmlformats.org/drawingml/2006/main"/>
           <a:p xmlns:a="http://schemas.openxmlformats.org/drawingml/2006/main">
             <a:pPr>
+              <a:buNone/>
               <a:defRPr sz="3600" b="1">
                 <a:solidFill>
                   <a:srgbClr val="F5F7F9"/>
@@ -24840,6 +24941,7 @@
           <a:lstStyle xmlns:a="http://schemas.openxmlformats.org/drawingml/2006/main"/>
           <a:p xmlns:a="http://schemas.openxmlformats.org/drawingml/2006/main">
             <a:pPr>
+              <a:buNone/>
               <a:defRPr sz="3900" b="1">
                 <a:solidFill>
                   <a:srgbClr val="5DCEF2"/>
@@ -24897,6 +24999,7 @@
           <a:lstStyle xmlns:a="http://schemas.openxmlformats.org/drawingml/2006/main"/>
           <a:p xmlns:a="http://schemas.openxmlformats.org/drawingml/2006/main">
             <a:pPr>
+              <a:buNone/>
               <a:defRPr sz="2400" b="1">
                 <a:solidFill>
                   <a:srgbClr val="5DCEF2"/>
@@ -24954,6 +25057,7 @@
           <a:lstStyle xmlns:a="http://schemas.openxmlformats.org/drawingml/2006/main"/>
           <a:p xmlns:a="http://schemas.openxmlformats.org/drawingml/2006/main">
             <a:pPr>
+              <a:buNone/>
               <a:defRPr sz="2550" b="0">
                 <a:solidFill>
                   <a:srgbClr val="F5F7F9"/>
@@ -25011,6 +25115,7 @@
           <a:lstStyle xmlns:a="http://schemas.openxmlformats.org/drawingml/2006/main"/>
           <a:p xmlns:a="http://schemas.openxmlformats.org/drawingml/2006/main">
             <a:pPr>
+              <a:buNone/>
               <a:defRPr sz="2400" b="1">
                 <a:solidFill>
                   <a:srgbClr val="5DCEF2"/>
@@ -25068,6 +25173,7 @@
           <a:lstStyle xmlns:a="http://schemas.openxmlformats.org/drawingml/2006/main"/>
           <a:p xmlns:a="http://schemas.openxmlformats.org/drawingml/2006/main">
             <a:pPr>
+              <a:buNone/>
               <a:defRPr sz="2550" b="0">
                 <a:solidFill>
                   <a:srgbClr val="F5F7F9"/>
@@ -25125,6 +25231,7 @@
           <a:lstStyle xmlns:a="http://schemas.openxmlformats.org/drawingml/2006/main"/>
           <a:p xmlns:a="http://schemas.openxmlformats.org/drawingml/2006/main">
             <a:pPr>
+              <a:buNone/>
               <a:defRPr sz="1950" b="0">
                 <a:solidFill>
                   <a:srgbClr val="B6C5CE"/>
@@ -25182,6 +25289,7 @@
           <a:lstStyle xmlns:a="http://schemas.openxmlformats.org/drawingml/2006/main"/>
           <a:p xmlns:a="http://schemas.openxmlformats.org/drawingml/2006/main">
             <a:pPr>
+              <a:buNone/>
               <a:defRPr sz="1350" b="0">
                 <a:solidFill>
                   <a:srgbClr val="B6C5CE"/>
@@ -25207,14 +25315,14 @@
       </p:sp>
       <p:pic>
         <p:nvPicPr>
-          <p:cNvPr id="20" name=""/>
+          <p:cNvPr id="22" name=""/>
           <p:cNvPicPr>
             <a:picLocks xmlns:a="http://schemas.openxmlformats.org/drawingml/2006/main" noChangeAspect="1"/>
           </p:cNvPicPr>
           <p:nvPr/>
         </p:nvPicPr>
         <p:blipFill>
-          <a:blip xmlns:r="http://schemas.openxmlformats.org/officeDocument/2006/relationships" xmlns:a="http://schemas.openxmlformats.org/drawingml/2006/main" r:embed="Rbacc376dffb34012"/>
+          <a:blip xmlns:r="http://schemas.openxmlformats.org/officeDocument/2006/relationships" xmlns:a="http://schemas.openxmlformats.org/drawingml/2006/main" r:embed="Rceb22c55c2b3415c"/>
           <a:stretch xmlns:a="http://schemas.openxmlformats.org/drawingml/2006/main"/>
         </p:blipFill>
         <p:spPr>

</xml_diff>

<commit_message>
Update Lecture 01 restaurant story (#6)
</commit_message>
<xml_diff>
--- a/Jave1_Hyrje_Nextjs_PWA_Copilot_2026.pptx
+++ b/Jave1_Hyrje_Nextjs_PWA_Copilot_2026.pptx
@@ -2,38 +2,38 @@
 <file path=ppt/presentation.xml><?xml version="1.0" encoding="utf-8"?>
 <p:presentation xmlns:p="http://schemas.openxmlformats.org/presentationml/2006/main">
   <p:sldMasterIdLst>
-    <p:sldMasterId xmlns:r="http://schemas.openxmlformats.org/officeDocument/2006/relationships" id="2147483648" r:id="R23ed594d3c874fff"/>
+    <p:sldMasterId xmlns:r="http://schemas.openxmlformats.org/officeDocument/2006/relationships" id="2147483648" r:id="Rc99adde3bfc14622"/>
   </p:sldMasterIdLst>
   <p:sldIdLst>
-    <p:sldId xmlns:r="http://schemas.openxmlformats.org/officeDocument/2006/relationships" id="256" r:id="R680531d7c8d64170"/>
-    <p:sldId xmlns:r="http://schemas.openxmlformats.org/officeDocument/2006/relationships" id="257" r:id="Rff792a8fc6b64130"/>
-    <p:sldId xmlns:r="http://schemas.openxmlformats.org/officeDocument/2006/relationships" id="258" r:id="Rec8b5cd0ac2947a1"/>
-    <p:sldId xmlns:r="http://schemas.openxmlformats.org/officeDocument/2006/relationships" id="259" r:id="Rc976631b983c4f0d"/>
-    <p:sldId xmlns:r="http://schemas.openxmlformats.org/officeDocument/2006/relationships" id="260" r:id="R6929fd60dd9e43d1"/>
-    <p:sldId xmlns:r="http://schemas.openxmlformats.org/officeDocument/2006/relationships" id="261" r:id="R95a9336130cb4c3d"/>
-    <p:sldId xmlns:r="http://schemas.openxmlformats.org/officeDocument/2006/relationships" id="262" r:id="R3ab32a06e8354b1f"/>
-    <p:sldId xmlns:r="http://schemas.openxmlformats.org/officeDocument/2006/relationships" id="263" r:id="R6fef2d2775ca4193"/>
-    <p:sldId xmlns:r="http://schemas.openxmlformats.org/officeDocument/2006/relationships" id="264" r:id="R3e7df30a18d9477c"/>
-    <p:sldId xmlns:r="http://schemas.openxmlformats.org/officeDocument/2006/relationships" id="265" r:id="Re0e13d699e0340e8"/>
-    <p:sldId xmlns:r="http://schemas.openxmlformats.org/officeDocument/2006/relationships" id="266" r:id="R61c1f25830d0435d"/>
-    <p:sldId xmlns:r="http://schemas.openxmlformats.org/officeDocument/2006/relationships" id="267" r:id="R6119d367e4b04c54"/>
-    <p:sldId xmlns:r="http://schemas.openxmlformats.org/officeDocument/2006/relationships" id="268" r:id="R59b8de1e50604a3c"/>
-    <p:sldId xmlns:r="http://schemas.openxmlformats.org/officeDocument/2006/relationships" id="269" r:id="R7fa0640df4204a27"/>
-    <p:sldId xmlns:r="http://schemas.openxmlformats.org/officeDocument/2006/relationships" id="270" r:id="Rd9b32368748c4db5"/>
-    <p:sldId xmlns:r="http://schemas.openxmlformats.org/officeDocument/2006/relationships" id="271" r:id="R182f79178dae4434"/>
-    <p:sldId xmlns:r="http://schemas.openxmlformats.org/officeDocument/2006/relationships" id="272" r:id="Rd5de8247305f487e"/>
-    <p:sldId xmlns:r="http://schemas.openxmlformats.org/officeDocument/2006/relationships" id="273" r:id="R858f6b8de79542ac"/>
-    <p:sldId xmlns:r="http://schemas.openxmlformats.org/officeDocument/2006/relationships" id="274" r:id="Rab9e0b49b5a244ce"/>
-    <p:sldId xmlns:r="http://schemas.openxmlformats.org/officeDocument/2006/relationships" id="275" r:id="Rd7b1e3376daf4253"/>
-    <p:sldId xmlns:r="http://schemas.openxmlformats.org/officeDocument/2006/relationships" id="276" r:id="R94e51465628e403b"/>
-    <p:sldId xmlns:r="http://schemas.openxmlformats.org/officeDocument/2006/relationships" id="277" r:id="Refbbdaebd851445d"/>
-    <p:sldId xmlns:r="http://schemas.openxmlformats.org/officeDocument/2006/relationships" id="278" r:id="R7fe04622b0274ac7"/>
-    <p:sldId xmlns:r="http://schemas.openxmlformats.org/officeDocument/2006/relationships" id="279" r:id="R721e7f2c1b9a438b"/>
-    <p:sldId xmlns:r="http://schemas.openxmlformats.org/officeDocument/2006/relationships" id="280" r:id="Rb9529caa9c6c457e"/>
-    <p:sldId xmlns:r="http://schemas.openxmlformats.org/officeDocument/2006/relationships" id="281" r:id="Rffe8cf25171c4459"/>
-    <p:sldId xmlns:r="http://schemas.openxmlformats.org/officeDocument/2006/relationships" id="282" r:id="R72c4436e3bd14980"/>
-    <p:sldId xmlns:r="http://schemas.openxmlformats.org/officeDocument/2006/relationships" id="283" r:id="R9d46f5b0ad4e4755"/>
-    <p:sldId xmlns:r="http://schemas.openxmlformats.org/officeDocument/2006/relationships" id="284" r:id="R7279bdfd901941c7"/>
+    <p:sldId xmlns:r="http://schemas.openxmlformats.org/officeDocument/2006/relationships" id="256" r:id="Rb5df68abbea24449"/>
+    <p:sldId xmlns:r="http://schemas.openxmlformats.org/officeDocument/2006/relationships" id="257" r:id="R86c224ac868e48eb"/>
+    <p:sldId xmlns:r="http://schemas.openxmlformats.org/officeDocument/2006/relationships" id="258" r:id="R37209b7858ab46e6"/>
+    <p:sldId xmlns:r="http://schemas.openxmlformats.org/officeDocument/2006/relationships" id="259" r:id="Re5bd5dfdac8c455d"/>
+    <p:sldId xmlns:r="http://schemas.openxmlformats.org/officeDocument/2006/relationships" id="260" r:id="Recc37fcd10e145d6"/>
+    <p:sldId xmlns:r="http://schemas.openxmlformats.org/officeDocument/2006/relationships" id="261" r:id="R3476c86ecbe34502"/>
+    <p:sldId xmlns:r="http://schemas.openxmlformats.org/officeDocument/2006/relationships" id="262" r:id="R750be0211a7e446a"/>
+    <p:sldId xmlns:r="http://schemas.openxmlformats.org/officeDocument/2006/relationships" id="263" r:id="Rf90f3b8d0f254776"/>
+    <p:sldId xmlns:r="http://schemas.openxmlformats.org/officeDocument/2006/relationships" id="264" r:id="R7d944e5f17d1446f"/>
+    <p:sldId xmlns:r="http://schemas.openxmlformats.org/officeDocument/2006/relationships" id="265" r:id="Rad4d5a38425f4841"/>
+    <p:sldId xmlns:r="http://schemas.openxmlformats.org/officeDocument/2006/relationships" id="266" r:id="Rbd25cf0e5e7e4554"/>
+    <p:sldId xmlns:r="http://schemas.openxmlformats.org/officeDocument/2006/relationships" id="267" r:id="Rd8d1b97dad5c49ef"/>
+    <p:sldId xmlns:r="http://schemas.openxmlformats.org/officeDocument/2006/relationships" id="268" r:id="Ra737bd6e2122458e"/>
+    <p:sldId xmlns:r="http://schemas.openxmlformats.org/officeDocument/2006/relationships" id="269" r:id="Re69ec57bea594eb5"/>
+    <p:sldId xmlns:r="http://schemas.openxmlformats.org/officeDocument/2006/relationships" id="270" r:id="R8dbbc04a46934b70"/>
+    <p:sldId xmlns:r="http://schemas.openxmlformats.org/officeDocument/2006/relationships" id="271" r:id="Rbe785212417d4332"/>
+    <p:sldId xmlns:r="http://schemas.openxmlformats.org/officeDocument/2006/relationships" id="272" r:id="R30bccf968651423e"/>
+    <p:sldId xmlns:r="http://schemas.openxmlformats.org/officeDocument/2006/relationships" id="273" r:id="R603cf261503644fe"/>
+    <p:sldId xmlns:r="http://schemas.openxmlformats.org/officeDocument/2006/relationships" id="274" r:id="R94e32af86b9d4c15"/>
+    <p:sldId xmlns:r="http://schemas.openxmlformats.org/officeDocument/2006/relationships" id="275" r:id="R2caa62c305164714"/>
+    <p:sldId xmlns:r="http://schemas.openxmlformats.org/officeDocument/2006/relationships" id="276" r:id="R59146143671e4904"/>
+    <p:sldId xmlns:r="http://schemas.openxmlformats.org/officeDocument/2006/relationships" id="277" r:id="R1ad8cb1a710749d8"/>
+    <p:sldId xmlns:r="http://schemas.openxmlformats.org/officeDocument/2006/relationships" id="278" r:id="R98c64833e7f8403c"/>
+    <p:sldId xmlns:r="http://schemas.openxmlformats.org/officeDocument/2006/relationships" id="279" r:id="Rb671e5fffa54461b"/>
+    <p:sldId xmlns:r="http://schemas.openxmlformats.org/officeDocument/2006/relationships" id="280" r:id="Re1bfb3773799448a"/>
+    <p:sldId xmlns:r="http://schemas.openxmlformats.org/officeDocument/2006/relationships" id="281" r:id="Rdad9ac7bbda645b4"/>
+    <p:sldId xmlns:r="http://schemas.openxmlformats.org/officeDocument/2006/relationships" id="282" r:id="Rd5ee2c84e0c14d05"/>
+    <p:sldId xmlns:r="http://schemas.openxmlformats.org/officeDocument/2006/relationships" id="283" r:id="R0d6e04e5c347457d"/>
+    <p:sldId xmlns:r="http://schemas.openxmlformats.org/officeDocument/2006/relationships" id="284" r:id="R7248704c773b4eb4"/>
   </p:sldIdLst>
   <p:sldSz cx="12192000" cy="6858000"/>
   <p:notesSz cx="6858000" cy="9144000"/>
@@ -78,7 +78,7 @@
   </p:cSld>
   <p:clrMap bg1="lt1" tx1="dk1" bg2="lt2" tx2="dk2" accent1="accent1" accent2="accent2" accent3="accent3" accent4="accent4" accent5="accent5" accent6="accent6" hlink="hlink" folHlink="folHlink"/>
   <p:sldLayoutIdLst>
-    <p:sldLayoutId xmlns:r="http://schemas.openxmlformats.org/officeDocument/2006/relationships" id="2147483649" r:id="R0754685b2e434198"/>
+    <p:sldLayoutId xmlns:r="http://schemas.openxmlformats.org/officeDocument/2006/relationships" id="2147483649" r:id="Rfe6a5ccf7b13489a"/>
   </p:sldLayoutIdLst>
   <p:txStyles>
     <p:titleStyle>
@@ -1094,7 +1094,7 @@
                 <a:ea typeface="Helvetica Neue"/>
                 <a:cs typeface="Helvetica Neue"/>
               </a:rPr>
-              <a:t>Një aplikacion për një biznes real.</a:t>
+              <a:t>Projekti juaj: aplikacion për një biznes real.</a:t>
             </a:r>
           </a:p>
         </p:txBody>
@@ -1448,7 +1448,7 @@
                 <a:ea typeface="Helvetica Neue"/>
                 <a:cs typeface="Helvetica Neue"/>
               </a:rPr>
-              <a:t>AAB RideShare</a:t>
+              <a:t>Restoranti “Sofra”</a:t>
             </a:r>
           </a:p>
         </p:txBody>
@@ -1506,31 +1506,7 @@
                 <a:ea typeface="Helvetica Neue"/>
                 <a:cs typeface="Helvetica Neue"/>
               </a:rPr>
-              <a:t>Fushë Kosovë</a:t>
-            </a:r>
-          </a:p>
-          <a:p xmlns:a="http://schemas.openxmlformats.org/drawingml/2006/main">
-            <a:pPr algn="l">
-              <a:buNone/>
-              <a:defRPr sz="2550" b="1">
-                <a:solidFill>
-                  <a:srgbClr val="F4F2EC"/>
-                </a:solidFill>
-                <a:latin typeface="Helvetica Neue"/>
-                <a:ea typeface="Helvetica Neue"/>
-                <a:cs typeface="Helvetica Neue"/>
-              </a:defRPr>
-            </a:pPr>
-            <a:r>
-              <a:rPr sz="2550" b="1">
-                <a:solidFill>
-                  <a:srgbClr val="F4F2EC"/>
-                </a:solidFill>
-                <a:latin typeface="Helvetica Neue"/>
-                <a:ea typeface="Helvetica Neue"/>
-                <a:cs typeface="Helvetica Neue"/>
-              </a:rPr>
-              <a:t>Kampus</a:t>
+              <a:t>A mund të porosis?</a:t>
             </a:r>
           </a:p>
         </p:txBody>
@@ -1570,25 +1546,25 @@
           <a:p xmlns:a="http://schemas.openxmlformats.org/drawingml/2006/main">
             <a:pPr algn="l">
               <a:buNone/>
-              <a:defRPr sz="3450" b="1">
-                <a:solidFill>
-                  <a:srgbClr val="F4F2EC"/>
-                </a:solidFill>
-                <a:latin typeface="Helvetica Neue"/>
-                <a:ea typeface="Helvetica Neue"/>
-                <a:cs typeface="Helvetica Neue"/>
-              </a:defRPr>
-            </a:pPr>
-            <a:r>
-              <a:rPr sz="3450" b="1">
-                <a:solidFill>
-                  <a:srgbClr val="F4F2EC"/>
-                </a:solidFill>
-                <a:latin typeface="Helvetica Neue"/>
-                <a:ea typeface="Helvetica Neue"/>
-                <a:cs typeface="Helvetica Neue"/>
-              </a:rPr>
-              <a:t>07:30</a:t>
+              <a:defRPr sz="1875" b="1">
+                <a:solidFill>
+                  <a:srgbClr val="F5F7F9"/>
+                </a:solidFill>
+                <a:latin typeface="Helvetica Neue"/>
+                <a:ea typeface="Helvetica Neue"/>
+                <a:cs typeface="Helvetica Neue"/>
+              </a:defRPr>
+            </a:pPr>
+            <a:r>
+              <a:rPr sz="1875" b="1">
+                <a:solidFill>
+                  <a:srgbClr val="F5F7F9"/>
+                </a:solidFill>
+                <a:latin typeface="Helvetica Neue"/>
+                <a:ea typeface="Helvetica Neue"/>
+                <a:cs typeface="Helvetica Neue"/>
+              </a:rPr>
+              <a:t>Tavë shtëpie</a:t>
             </a:r>
           </a:p>
         </p:txBody>
@@ -1646,7 +1622,7 @@
                 <a:ea typeface="Helvetica Neue"/>
                 <a:cs typeface="Helvetica Neue"/>
               </a:rPr>
-              <a:t>1 vend i lirë</a:t>
+              <a:t>Sasia: 1</a:t>
             </a:r>
           </a:p>
         </p:txBody>
@@ -1736,7 +1712,7 @@
                 <a:ea typeface="Helvetica Neue"/>
                 <a:cs typeface="Helvetica Neue"/>
               </a:rPr>
-              <a:t>Kërko vend</a:t>
+              <a:t>Porosit</a:t>
             </a:r>
           </a:p>
         </p:txBody>
@@ -1750,7 +1726,7 @@
           <p:nvPr/>
         </p:nvPicPr>
         <p:blipFill>
-          <a:blip xmlns:r="http://schemas.openxmlformats.org/officeDocument/2006/relationships" xmlns:a="http://schemas.openxmlformats.org/drawingml/2006/main" r:embed="Ra243a7a739104693"/>
+          <a:blip xmlns:r="http://schemas.openxmlformats.org/officeDocument/2006/relationships" xmlns:a="http://schemas.openxmlformats.org/drawingml/2006/main" r:embed="R59a4256bbe014b77"/>
           <a:stretch xmlns:a="http://schemas.openxmlformats.org/drawingml/2006/main"/>
         </p:blipFill>
         <p:spPr>
@@ -1975,7 +1951,7 @@
           <p:nvPr/>
         </p:nvPicPr>
         <p:blipFill>
-          <a:blip xmlns:r="http://schemas.openxmlformats.org/officeDocument/2006/relationships" xmlns:a="http://schemas.openxmlformats.org/drawingml/2006/main" r:embed="R9774eb9d87664a5a"/>
+          <a:blip xmlns:r="http://schemas.openxmlformats.org/officeDocument/2006/relationships" xmlns:a="http://schemas.openxmlformats.org/drawingml/2006/main" r:embed="R2a57d42d75f04264"/>
           <a:stretch xmlns:a="http://schemas.openxmlformats.org/drawingml/2006/main"/>
         </p:blipFill>
         <p:spPr>
@@ -2277,7 +2253,7 @@
           <p:nvPr/>
         </p:nvPicPr>
         <p:blipFill>
-          <a:blip xmlns:r="http://schemas.openxmlformats.org/officeDocument/2006/relationships" xmlns:a="http://schemas.openxmlformats.org/drawingml/2006/main" r:embed="Rba131908bd9f48cd"/>
+          <a:blip xmlns:r="http://schemas.openxmlformats.org/officeDocument/2006/relationships" xmlns:a="http://schemas.openxmlformats.org/drawingml/2006/main" r:embed="R19f3b7d3891a4672"/>
           <a:stretch xmlns:a="http://schemas.openxmlformats.org/drawingml/2006/main"/>
         </p:blipFill>
         <p:spPr>
@@ -3624,7 +3600,7 @@
                 <a:ea typeface="Helvetica Neue"/>
                 <a:cs typeface="Helvetica Neue"/>
               </a:rPr>
-              <a:t>Çfarë prove keni përtej miratimit verbal?</a:t>
+              <a:t>Çfarë prove tregon se porosia u mor dhe nuk u dyfishua?</a:t>
             </a:r>
           </a:p>
         </p:txBody>
@@ -3638,7 +3614,7 @@
           <p:nvPr/>
         </p:nvPicPr>
         <p:blipFill>
-          <a:blip xmlns:r="http://schemas.openxmlformats.org/officeDocument/2006/relationships" xmlns:a="http://schemas.openxmlformats.org/drawingml/2006/main" r:embed="R51bef60c1719491a"/>
+          <a:blip xmlns:r="http://schemas.openxmlformats.org/officeDocument/2006/relationships" xmlns:a="http://schemas.openxmlformats.org/drawingml/2006/main" r:embed="Re39faa6fb8f0409c"/>
           <a:stretch xmlns:a="http://schemas.openxmlformats.org/drawingml/2006/main"/>
         </p:blipFill>
         <p:spPr>
@@ -3849,7 +3825,7 @@
                 <a:ea typeface="Helvetica Neue"/>
                 <a:cs typeface="Helvetica Neue"/>
               </a:rPr>
-              <a:t>07:20. Ende pa konfirmim</a:t>
+              <a:t>11:45. Ende pa konfirmim</a:t>
             </a:r>
           </a:p>
         </p:txBody>
@@ -3941,7 +3917,7 @@
                 <a:ea typeface="Helvetica Neue"/>
                 <a:cs typeface="Helvetica Neue"/>
               </a:rPr>
-              <a:t>Prishtinë</a:t>
+              <a:t>Telefoni</a:t>
             </a:r>
           </a:p>
         </p:txBody>
@@ -4033,7 +4009,7 @@
                 <a:ea typeface="Helvetica Neue"/>
                 <a:cs typeface="Helvetica Neue"/>
               </a:rPr>
-              <a:t>Fushë Kosovë</a:t>
+              <a:t>Instagram</a:t>
             </a:r>
           </a:p>
         </p:txBody>
@@ -4125,7 +4101,7 @@
                 <a:ea typeface="Helvetica Neue"/>
                 <a:cs typeface="Helvetica Neue"/>
               </a:rPr>
-              <a:t>Kampus</a:t>
+              <a:t>Restoranti</a:t>
             </a:r>
           </a:p>
         </p:txBody>
@@ -4243,7 +4219,7 @@
                 <a:ea typeface="Helvetica Neue"/>
                 <a:cs typeface="Helvetica Neue"/>
               </a:rPr>
-              <a:t>Kërkim</a:t>
+              <a:t>Konsumatori</a:t>
             </a:r>
           </a:p>
         </p:txBody>
@@ -4301,7 +4277,7 @@
                 <a:ea typeface="Helvetica Neue"/>
                 <a:cs typeface="Helvetica Neue"/>
               </a:rPr>
-              <a:t>Mesazh</a:t>
+              <a:t>Mesazhi</a:t>
             </a:r>
           </a:p>
         </p:txBody>
@@ -4359,7 +4335,7 @@
                 <a:ea typeface="Helvetica Neue"/>
                 <a:cs typeface="Helvetica Neue"/>
               </a:rPr>
-              <a:t>Pritje</a:t>
+              <a:t>Pa përgjigje</a:t>
             </a:r>
           </a:p>
         </p:txBody>
@@ -4417,7 +4393,7 @@
                 <a:ea typeface="Helvetica Neue"/>
                 <a:cs typeface="Helvetica Neue"/>
               </a:rPr>
-              <a:t>Nisje</a:t>
+              <a:t>Porosia?</a:t>
             </a:r>
           </a:p>
         </p:txBody>
@@ -4535,7 +4511,7 @@
                 <a:ea typeface="Helvetica Neue"/>
                 <a:cs typeface="Helvetica Neue"/>
               </a:rPr>
-              <a:t>Pasiguria ka kosto</a:t>
+              <a:t>A u pranua porosia?</a:t>
             </a:r>
           </a:p>
         </p:txBody>
@@ -4607,7 +4583,7 @@
           <p:nvPr/>
         </p:nvPicPr>
         <p:blipFill>
-          <a:blip xmlns:r="http://schemas.openxmlformats.org/officeDocument/2006/relationships" xmlns:a="http://schemas.openxmlformats.org/drawingml/2006/main" r:embed="R968fcfa1e2c24eaf"/>
+          <a:blip xmlns:r="http://schemas.openxmlformats.org/officeDocument/2006/relationships" xmlns:a="http://schemas.openxmlformats.org/drawingml/2006/main" r:embed="Rd238091616dc4dc1"/>
           <a:stretch xmlns:a="http://schemas.openxmlformats.org/drawingml/2006/main"/>
         </p:blipFill>
         <p:spPr>
@@ -4818,7 +4794,7 @@
                 <a:ea typeface="Helvetica Neue"/>
                 <a:cs typeface="Helvetica Neue"/>
               </a:rPr>
-              <a:t>Mesazhi nuk është rezervim</a:t>
+              <a:t>Mesazhi nuk është porosi</a:t>
             </a:r>
           </a:p>
         </p:txBody>
@@ -4966,7 +4942,7 @@
                 <a:ea typeface="Helvetica Neue"/>
                 <a:cs typeface="Helvetica Neue"/>
               </a:rPr>
-              <a:t>Kam një vend.</a:t>
+              <a:t>Dua një porosi.</a:t>
             </a:r>
           </a:p>
         </p:txBody>
@@ -5056,7 +5032,7 @@
                 <a:ea typeface="Helvetica Neue"/>
                 <a:cs typeface="Helvetica Neue"/>
               </a:rPr>
-              <a:t>Vij unë.</a:t>
+              <a:t>Cilin vakt?</a:t>
             </a:r>
           </a:p>
         </p:txBody>
@@ -5146,7 +5122,7 @@
                 <a:ea typeface="Helvetica Neue"/>
                 <a:cs typeface="Helvetica Neue"/>
               </a:rPr>
-              <a:t>A është ende?</a:t>
+              <a:t>Për katër veta.</a:t>
             </a:r>
           </a:p>
         </p:txBody>
@@ -5236,7 +5212,7 @@
                 <a:ea typeface="Helvetica Neue"/>
                 <a:cs typeface="Helvetica Neue"/>
               </a:rPr>
-              <a:t>U nisët?</a:t>
+              <a:t>Në cilën adresë?</a:t>
             </a:r>
           </a:p>
         </p:txBody>
@@ -5294,7 +5270,7 @@
                 <a:ea typeface="Helvetica Neue"/>
                 <a:cs typeface="Helvetica Neue"/>
               </a:rPr>
-              <a:t>Gjendja e kërkesës</a:t>
+              <a:t>Të dhënat që mungojnë</a:t>
             </a:r>
           </a:p>
         </p:txBody>
@@ -5410,7 +5386,7 @@
                 <a:ea typeface="Helvetica Neue"/>
                 <a:cs typeface="Helvetica Neue"/>
               </a:rPr>
-              <a:t>Kërkuar</a:t>
+              <a:t>Vakti</a:t>
             </a:r>
           </a:p>
         </p:txBody>
@@ -5526,7 +5502,7 @@
                 <a:ea typeface="Helvetica Neue"/>
                 <a:cs typeface="Helvetica Neue"/>
               </a:rPr>
-              <a:t>Pranuar</a:t>
+              <a:t>Sasia</a:t>
             </a:r>
           </a:p>
         </p:txBody>
@@ -5642,7 +5618,7 @@
                 <a:ea typeface="Helvetica Neue"/>
                 <a:cs typeface="Helvetica Neue"/>
               </a:rPr>
-              <a:t>Refuzuar</a:t>
+              <a:t>Adresa</a:t>
             </a:r>
           </a:p>
         </p:txBody>
@@ -5700,7 +5676,7 @@
                 <a:ea typeface="Helvetica Neue"/>
                 <a:cs typeface="Helvetica Neue"/>
               </a:rPr>
-              <a:t>Kush e ka vendin?</a:t>
+              <a:t>Statusi: a u pranua porosia?</a:t>
             </a:r>
           </a:p>
         </p:txBody>
@@ -5714,7 +5690,7 @@
           <p:nvPr/>
         </p:nvPicPr>
         <p:blipFill>
-          <a:blip xmlns:r="http://schemas.openxmlformats.org/officeDocument/2006/relationships" xmlns:a="http://schemas.openxmlformats.org/drawingml/2006/main" r:embed="Rba5f01c83da94874"/>
+          <a:blip xmlns:r="http://schemas.openxmlformats.org/officeDocument/2006/relationships" xmlns:a="http://schemas.openxmlformats.org/drawingml/2006/main" r:embed="R1bfb7d89fb65413f"/>
           <a:stretch xmlns:a="http://schemas.openxmlformats.org/drawingml/2006/main"/>
         </p:blipFill>
         <p:spPr>
@@ -5965,49 +5941,73 @@
           <a:p xmlns:a="http://schemas.openxmlformats.org/drawingml/2006/main">
             <a:pPr algn="l">
               <a:buNone/>
-              <a:defRPr sz="4575" b="1">
-                <a:solidFill>
-                  <a:srgbClr val="F4F2EC"/>
-                </a:solidFill>
-                <a:latin typeface="Helvetica Neue"/>
-                <a:ea typeface="Helvetica Neue"/>
-                <a:cs typeface="Helvetica Neue"/>
-              </a:defRPr>
-            </a:pPr>
-            <a:r>
-              <a:rPr sz="4575" b="1">
-                <a:solidFill>
-                  <a:srgbClr val="F4F2EC"/>
-                </a:solidFill>
-                <a:latin typeface="Helvetica Neue"/>
-                <a:ea typeface="Helvetica Neue"/>
-                <a:cs typeface="Helvetica Neue"/>
-              </a:rPr>
-              <a:t>Statusi i qartë</a:t>
+              <a:defRPr sz="2850" b="1">
+                <a:solidFill>
+                  <a:srgbClr val="F5F7F9"/>
+                </a:solidFill>
+                <a:latin typeface="Helvetica Neue"/>
+                <a:ea typeface="Helvetica Neue"/>
+                <a:cs typeface="Helvetica Neue"/>
+              </a:defRPr>
+            </a:pPr>
+            <a:r>
+              <a:rPr sz="2850" b="1">
+                <a:solidFill>
+                  <a:srgbClr val="F5F7F9"/>
+                </a:solidFill>
+                <a:latin typeface="Helvetica Neue"/>
+                <a:ea typeface="Helvetica Neue"/>
+                <a:cs typeface="Helvetica Neue"/>
+              </a:rPr>
+              <a:t>Checkout i strukturuar</a:t>
             </a:r>
           </a:p>
           <a:p xmlns:a="http://schemas.openxmlformats.org/drawingml/2006/main">
             <a:pPr algn="l">
               <a:buNone/>
-              <a:defRPr sz="4575" b="1">
-                <a:solidFill>
-                  <a:srgbClr val="F4F2EC"/>
-                </a:solidFill>
-                <a:latin typeface="Helvetica Neue"/>
-                <a:ea typeface="Helvetica Neue"/>
-                <a:cs typeface="Helvetica Neue"/>
-              </a:defRPr>
-            </a:pPr>
-            <a:r>
-              <a:rPr sz="4575" b="1">
-                <a:solidFill>
-                  <a:srgbClr val="F4F2EC"/>
-                </a:solidFill>
-                <a:latin typeface="Helvetica Neue"/>
-                <a:ea typeface="Helvetica Neue"/>
-                <a:cs typeface="Helvetica Neue"/>
-              </a:rPr>
-              <a:t>ul pasigurinë.</a:t>
+              <a:defRPr sz="2850" b="1">
+                <a:solidFill>
+                  <a:srgbClr val="F5F7F9"/>
+                </a:solidFill>
+                <a:latin typeface="Helvetica Neue"/>
+                <a:ea typeface="Helvetica Neue"/>
+                <a:cs typeface="Helvetica Neue"/>
+              </a:defRPr>
+            </a:pPr>
+            <a:r>
+              <a:rPr sz="2850" b="1">
+                <a:solidFill>
+                  <a:srgbClr val="F5F7F9"/>
+                </a:solidFill>
+                <a:latin typeface="Helvetica Neue"/>
+                <a:ea typeface="Helvetica Neue"/>
+                <a:cs typeface="Helvetica Neue"/>
+              </a:rPr>
+              <a:t>dhe statusi i dukshëm</a:t>
+            </a:r>
+          </a:p>
+          <a:p xmlns:a="http://schemas.openxmlformats.org/drawingml/2006/main">
+            <a:pPr algn="l">
+              <a:buNone/>
+              <a:defRPr sz="2850" b="1">
+                <a:solidFill>
+                  <a:srgbClr val="F5F7F9"/>
+                </a:solidFill>
+                <a:latin typeface="Helvetica Neue"/>
+                <a:ea typeface="Helvetica Neue"/>
+                <a:cs typeface="Helvetica Neue"/>
+              </a:defRPr>
+            </a:pPr>
+            <a:r>
+              <a:rPr sz="2850" b="1">
+                <a:solidFill>
+                  <a:srgbClr val="F5F7F9"/>
+                </a:solidFill>
+                <a:latin typeface="Helvetica Neue"/>
+                <a:ea typeface="Helvetica Neue"/>
+                <a:cs typeface="Helvetica Neue"/>
+              </a:rPr>
+              <a:t>ulin pasigurinë.</a:t>
             </a:r>
           </a:p>
         </p:txBody>
@@ -6065,7 +6065,7 @@
                 <a:ea typeface="Helvetica Neue"/>
                 <a:cs typeface="Helvetica Neue"/>
               </a:rPr>
-              <a:t>EKSPERIMENT I PROPOZUAR</a:t>
+              <a:t>PRAG HIPOTETIK I PËRDORIMIT</a:t>
             </a:r>
           </a:p>
         </p:txBody>
@@ -6263,7 +6263,7 @@
                 <a:ea typeface="Helvetica Neue"/>
                 <a:cs typeface="Helvetica Neue"/>
               </a:rPr>
-              <a:t>Prag mësimor, ende pa rezultate</a:t>
+              <a:t>Prag hipotetik, ende pa rezultate</a:t>
             </a:r>
           </a:p>
         </p:txBody>
@@ -6335,7 +6335,7 @@
           <p:nvPr/>
         </p:nvPicPr>
         <p:blipFill>
-          <a:blip xmlns:r="http://schemas.openxmlformats.org/officeDocument/2006/relationships" xmlns:a="http://schemas.openxmlformats.org/drawingml/2006/main" r:embed="R54b3663926e04dfa"/>
+          <a:blip xmlns:r="http://schemas.openxmlformats.org/officeDocument/2006/relationships" xmlns:a="http://schemas.openxmlformats.org/drawingml/2006/main" r:embed="Rc3aa58ad78b14f87"/>
           <a:stretch xmlns:a="http://schemas.openxmlformats.org/drawingml/2006/main"/>
         </p:blipFill>
         <p:spPr>
@@ -6546,7 +6546,7 @@
                 <a:ea typeface="Helvetica Neue"/>
                 <a:cs typeface="Helvetica Neue"/>
               </a:rPr>
-              <a:t>Një faqe para kodit</a:t>
+              <a:t>PRD-ja e porosisë</a:t>
             </a:r>
           </a:p>
         </p:txBody>
@@ -6644,73 +6644,73 @@
           <a:p xmlns:a="http://schemas.openxmlformats.org/drawingml/2006/main">
             <a:pPr algn="l">
               <a:buNone/>
-              <a:defRPr sz="2925" b="0">
-                <a:solidFill>
-                  <a:srgbClr val="F4F2EC"/>
-                </a:solidFill>
-                <a:latin typeface="Helvetica Neue"/>
-                <a:ea typeface="Helvetica Neue"/>
-                <a:cs typeface="Helvetica Neue"/>
-              </a:defRPr>
-            </a:pPr>
-            <a:r>
-              <a:rPr sz="2925" b="0">
-                <a:solidFill>
-                  <a:srgbClr val="F4F2EC"/>
-                </a:solidFill>
-                <a:latin typeface="Helvetica Neue"/>
-                <a:ea typeface="Helvetica Neue"/>
-                <a:cs typeface="Helvetica Neue"/>
-              </a:rPr>
-              <a:t>Një marrëveshje</a:t>
+              <a:defRPr sz="1800" b="0">
+                <a:solidFill>
+                  <a:srgbClr val="F5F7F9"/>
+                </a:solidFill>
+                <a:latin typeface="Helvetica Neue"/>
+                <a:ea typeface="Helvetica Neue"/>
+                <a:cs typeface="Helvetica Neue"/>
+              </a:defRPr>
+            </a:pPr>
+            <a:r>
+              <a:rPr sz="1800" b="0">
+                <a:solidFill>
+                  <a:srgbClr val="F5F7F9"/>
+                </a:solidFill>
+                <a:latin typeface="Helvetica Neue"/>
+                <a:ea typeface="Helvetica Neue"/>
+                <a:cs typeface="Helvetica Neue"/>
+              </a:rPr>
+              <a:t>Dokumenti i shkurtër para kodit:</a:t>
             </a:r>
           </a:p>
           <a:p xmlns:a="http://schemas.openxmlformats.org/drawingml/2006/main">
             <a:pPr algn="l">
               <a:buNone/>
-              <a:defRPr sz="2925" b="0">
-                <a:solidFill>
-                  <a:srgbClr val="F4F2EC"/>
-                </a:solidFill>
-                <a:latin typeface="Helvetica Neue"/>
-                <a:ea typeface="Helvetica Neue"/>
-                <a:cs typeface="Helvetica Neue"/>
-              </a:defRPr>
-            </a:pPr>
-            <a:r>
-              <a:rPr sz="2925" b="0">
-                <a:solidFill>
-                  <a:srgbClr val="F4F2EC"/>
-                </a:solidFill>
-                <a:latin typeface="Helvetica Neue"/>
-                <a:ea typeface="Helvetica Neue"/>
-                <a:cs typeface="Helvetica Neue"/>
-              </a:rPr>
-              <a:t>për sjelljen</a:t>
+              <a:defRPr sz="1800" b="0">
+                <a:solidFill>
+                  <a:srgbClr val="F5F7F9"/>
+                </a:solidFill>
+                <a:latin typeface="Helvetica Neue"/>
+                <a:ea typeface="Helvetica Neue"/>
+                <a:cs typeface="Helvetica Neue"/>
+              </a:defRPr>
+            </a:pPr>
+            <a:r>
+              <a:rPr sz="1800" b="0">
+                <a:solidFill>
+                  <a:srgbClr val="F5F7F9"/>
+                </a:solidFill>
+                <a:latin typeface="Helvetica Neue"/>
+                <a:ea typeface="Helvetica Neue"/>
+                <a:cs typeface="Helvetica Neue"/>
+              </a:rPr>
+              <a:t>përdoruesi, problemi, rrjedha,</a:t>
             </a:r>
           </a:p>
           <a:p xmlns:a="http://schemas.openxmlformats.org/drawingml/2006/main">
             <a:pPr algn="l">
               <a:buNone/>
-              <a:defRPr sz="2925" b="0">
-                <a:solidFill>
-                  <a:srgbClr val="F4F2EC"/>
-                </a:solidFill>
-                <a:latin typeface="Helvetica Neue"/>
-                <a:ea typeface="Helvetica Neue"/>
-                <a:cs typeface="Helvetica Neue"/>
-              </a:defRPr>
-            </a:pPr>
-            <a:r>
-              <a:rPr sz="2925" b="0">
-                <a:solidFill>
-                  <a:srgbClr val="F4F2EC"/>
-                </a:solidFill>
-                <a:latin typeface="Helvetica Neue"/>
-                <a:ea typeface="Helvetica Neue"/>
-                <a:cs typeface="Helvetica Neue"/>
-              </a:rPr>
-              <a:t>e produktit.</a:t>
+              <a:defRPr sz="1800" b="0">
+                <a:solidFill>
+                  <a:srgbClr val="F5F7F9"/>
+                </a:solidFill>
+                <a:latin typeface="Helvetica Neue"/>
+                <a:ea typeface="Helvetica Neue"/>
+                <a:cs typeface="Helvetica Neue"/>
+              </a:defRPr>
+            </a:pPr>
+            <a:r>
+              <a:rPr sz="1800" b="0">
+                <a:solidFill>
+                  <a:srgbClr val="F5F7F9"/>
+                </a:solidFill>
+                <a:latin typeface="Helvetica Neue"/>
+                <a:ea typeface="Helvetica Neue"/>
+                <a:cs typeface="Helvetica Neue"/>
+              </a:rPr>
+              <a:t>kufijtë dhe kriteret e pranimit.</a:t>
             </a:r>
           </a:p>
         </p:txBody>
@@ -6808,25 +6808,25 @@
           <a:p xmlns:a="http://schemas.openxmlformats.org/drawingml/2006/main">
             <a:pPr algn="l">
               <a:buNone/>
-              <a:defRPr sz="2100" b="0">
-                <a:solidFill>
-                  <a:srgbClr val="F4F2EC"/>
-                </a:solidFill>
-                <a:latin typeface="Helvetica Neue"/>
-                <a:ea typeface="Helvetica Neue"/>
-                <a:cs typeface="Helvetica Neue"/>
-              </a:defRPr>
-            </a:pPr>
-            <a:r>
-              <a:rPr sz="2100" b="0">
-                <a:solidFill>
-                  <a:srgbClr val="F4F2EC"/>
-                </a:solidFill>
-                <a:latin typeface="Helvetica Neue"/>
-                <a:ea typeface="Helvetica Neue"/>
-                <a:cs typeface="Helvetica Neue"/>
-              </a:rPr>
-              <a:t>Student që kërkon udhëtim</a:t>
+              <a:defRPr sz="1575" b="0">
+                <a:solidFill>
+                  <a:srgbClr val="F5F7F9"/>
+                </a:solidFill>
+                <a:latin typeface="Helvetica Neue"/>
+                <a:ea typeface="Helvetica Neue"/>
+                <a:cs typeface="Helvetica Neue"/>
+              </a:defRPr>
+            </a:pPr>
+            <a:r>
+              <a:rPr sz="1575" b="0">
+                <a:solidFill>
+                  <a:srgbClr val="F5F7F9"/>
+                </a:solidFill>
+                <a:latin typeface="Helvetica Neue"/>
+                <a:ea typeface="Helvetica Neue"/>
+                <a:cs typeface="Helvetica Neue"/>
+              </a:rPr>
+              <a:t>Një klient i restorantit familjar</a:t>
             </a:r>
           </a:p>
         </p:txBody>
@@ -6954,25 +6954,25 @@
           <a:p xmlns:a="http://schemas.openxmlformats.org/drawingml/2006/main">
             <a:pPr algn="l">
               <a:buNone/>
-              <a:defRPr sz="2100" b="0">
-                <a:solidFill>
-                  <a:srgbClr val="F4F2EC"/>
-                </a:solidFill>
-                <a:latin typeface="Helvetica Neue"/>
-                <a:ea typeface="Helvetica Neue"/>
-                <a:cs typeface="Helvetica Neue"/>
-              </a:defRPr>
-            </a:pPr>
-            <a:r>
-              <a:rPr sz="2100" b="0">
-                <a:solidFill>
-                  <a:srgbClr val="F4F2EC"/>
-                </a:solidFill>
-                <a:latin typeface="Helvetica Neue"/>
-                <a:ea typeface="Helvetica Neue"/>
-                <a:cs typeface="Helvetica Neue"/>
-              </a:rPr>
-              <a:t>Konfirmimi mbetet i paqartë</a:t>
+              <a:defRPr sz="1575" b="0">
+                <a:solidFill>
+                  <a:srgbClr val="F5F7F9"/>
+                </a:solidFill>
+                <a:latin typeface="Helvetica Neue"/>
+                <a:ea typeface="Helvetica Neue"/>
+                <a:cs typeface="Helvetica Neue"/>
+              </a:defRPr>
+            </a:pPr>
+            <a:r>
+              <a:rPr sz="1575" b="0">
+                <a:solidFill>
+                  <a:srgbClr val="F5F7F9"/>
+                </a:solidFill>
+                <a:latin typeface="Helvetica Neue"/>
+                <a:ea typeface="Helvetica Neue"/>
+                <a:cs typeface="Helvetica Neue"/>
+              </a:rPr>
+              <a:t>Mesazhi nuk plotëson porosinë</a:t>
             </a:r>
           </a:p>
         </p:txBody>
@@ -7100,25 +7100,25 @@
           <a:p xmlns:a="http://schemas.openxmlformats.org/drawingml/2006/main">
             <a:pPr algn="l">
               <a:buNone/>
-              <a:defRPr sz="2100" b="0">
-                <a:solidFill>
-                  <a:srgbClr val="F4F2EC"/>
-                </a:solidFill>
-                <a:latin typeface="Helvetica Neue"/>
-                <a:ea typeface="Helvetica Neue"/>
-                <a:cs typeface="Helvetica Neue"/>
-              </a:defRPr>
-            </a:pPr>
-            <a:r>
-              <a:rPr sz="2100" b="0">
-                <a:solidFill>
-                  <a:srgbClr val="F4F2EC"/>
-                </a:solidFill>
-                <a:latin typeface="Helvetica Neue"/>
-                <a:ea typeface="Helvetica Neue"/>
-                <a:cs typeface="Helvetica Neue"/>
-              </a:rPr>
-              <a:t>Kërkon vend dhe sheh përgjigjen</a:t>
+              <a:defRPr sz="1575" b="0">
+                <a:solidFill>
+                  <a:srgbClr val="F5F7F9"/>
+                </a:solidFill>
+                <a:latin typeface="Helvetica Neue"/>
+                <a:ea typeface="Helvetica Neue"/>
+                <a:cs typeface="Helvetica Neue"/>
+              </a:defRPr>
+            </a:pPr>
+            <a:r>
+              <a:rPr sz="1575" b="0">
+                <a:solidFill>
+                  <a:srgbClr val="F5F7F9"/>
+                </a:solidFill>
+                <a:latin typeface="Helvetica Neue"/>
+                <a:ea typeface="Helvetica Neue"/>
+                <a:cs typeface="Helvetica Neue"/>
+              </a:rPr>
+              <a:t>Menu → Cart → Order → Ready</a:t>
             </a:r>
           </a:p>
         </p:txBody>
@@ -7246,25 +7246,25 @@
           <a:p xmlns:a="http://schemas.openxmlformats.org/drawingml/2006/main">
             <a:pPr algn="l">
               <a:buNone/>
-              <a:defRPr sz="2100" b="0">
-                <a:solidFill>
-                  <a:srgbClr val="F4F2EC"/>
-                </a:solidFill>
-                <a:latin typeface="Helvetica Neue"/>
-                <a:ea typeface="Helvetica Neue"/>
-                <a:cs typeface="Helvetica Neue"/>
-              </a:defRPr>
-            </a:pPr>
-            <a:r>
-              <a:rPr sz="2100" b="0">
-                <a:solidFill>
-                  <a:srgbClr val="F4F2EC"/>
-                </a:solidFill>
-                <a:latin typeface="Helvetica Neue"/>
-                <a:ea typeface="Helvetica Neue"/>
-                <a:cs typeface="Helvetica Neue"/>
-              </a:rPr>
-              <a:t>Pa pagesa ose GPS live</a:t>
+              <a:defRPr sz="1575" b="0">
+                <a:solidFill>
+                  <a:srgbClr val="F5F7F9"/>
+                </a:solidFill>
+                <a:latin typeface="Helvetica Neue"/>
+                <a:ea typeface="Helvetica Neue"/>
+                <a:cs typeface="Helvetica Neue"/>
+              </a:defRPr>
+            </a:pPr>
+            <a:r>
+              <a:rPr sz="1575" b="0">
+                <a:solidFill>
+                  <a:srgbClr val="F5F7F9"/>
+                </a:solidFill>
+                <a:latin typeface="Helvetica Neue"/>
+                <a:ea typeface="Helvetica Neue"/>
+                <a:cs typeface="Helvetica Neue"/>
+              </a:rPr>
+              <a:t>Pa pagesa ose GPS të korrierit</a:t>
             </a:r>
           </a:p>
         </p:txBody>
@@ -7392,25 +7392,25 @@
           <a:p xmlns:a="http://schemas.openxmlformats.org/drawingml/2006/main">
             <a:pPr algn="l">
               <a:buNone/>
-              <a:defRPr sz="2100" b="0">
-                <a:solidFill>
-                  <a:srgbClr val="F4F2EC"/>
-                </a:solidFill>
-                <a:latin typeface="Helvetica Neue"/>
-                <a:ea typeface="Helvetica Neue"/>
-                <a:cs typeface="Helvetica Neue"/>
-              </a:defRPr>
-            </a:pPr>
-            <a:r>
-              <a:rPr sz="2100" b="0">
-                <a:solidFill>
-                  <a:srgbClr val="F4F2EC"/>
-                </a:solidFill>
-                <a:latin typeface="Helvetica Neue"/>
-                <a:ea typeface="Helvetica Neue"/>
-                <a:cs typeface="Helvetica Neue"/>
-              </a:rPr>
-              <a:t>Kërkesë me status të qartë</a:t>
+              <a:defRPr sz="1500" b="0">
+                <a:solidFill>
+                  <a:srgbClr val="F5F7F9"/>
+                </a:solidFill>
+                <a:latin typeface="Helvetica Neue"/>
+                <a:ea typeface="Helvetica Neue"/>
+                <a:cs typeface="Helvetica Neue"/>
+              </a:defRPr>
+            </a:pPr>
+            <a:r>
+              <a:rPr sz="1500" b="0">
+                <a:solidFill>
+                  <a:srgbClr val="F5F7F9"/>
+                </a:solidFill>
+                <a:latin typeface="Helvetica Neue"/>
+                <a:ea typeface="Helvetica Neue"/>
+                <a:cs typeface="Helvetica Neue"/>
+              </a:rPr>
+              <a:t>Serveri konfirmon vetëm një porosi</a:t>
             </a:r>
           </a:p>
         </p:txBody>
@@ -7424,7 +7424,7 @@
           <p:nvPr/>
         </p:nvPicPr>
         <p:blipFill>
-          <a:blip xmlns:r="http://schemas.openxmlformats.org/officeDocument/2006/relationships" xmlns:a="http://schemas.openxmlformats.org/drawingml/2006/main" r:embed="R2cc19a352b8440f3"/>
+          <a:blip xmlns:r="http://schemas.openxmlformats.org/officeDocument/2006/relationships" xmlns:a="http://schemas.openxmlformats.org/drawingml/2006/main" r:embed="R01f5370d1c3842f4"/>
           <a:stretch xmlns:a="http://schemas.openxmlformats.org/drawingml/2006/main"/>
         </p:blipFill>
         <p:spPr>
@@ -7751,7 +7751,7 @@
                 <a:ea typeface="Helvetica Neue"/>
                 <a:cs typeface="Helvetica Neue"/>
               </a:rPr>
-              <a:t>Publiko</a:t>
+              <a:t>Shiko menunë</a:t>
             </a:r>
           </a:p>
         </p:txBody>
@@ -7809,7 +7809,7 @@
                 <a:ea typeface="Helvetica Neue"/>
                 <a:cs typeface="Helvetica Neue"/>
               </a:rPr>
-              <a:t>Shoferi</a:t>
+              <a:t>Klienti</a:t>
             </a:r>
           </a:p>
         </p:txBody>
@@ -7955,7 +7955,7 @@
                 <a:ea typeface="Helvetica Neue"/>
                 <a:cs typeface="Helvetica Neue"/>
               </a:rPr>
-              <a:t>Kërko</a:t>
+              <a:t>Vendos porosi</a:t>
             </a:r>
           </a:p>
         </p:txBody>
@@ -8013,7 +8013,7 @@
                 <a:ea typeface="Helvetica Neue"/>
                 <a:cs typeface="Helvetica Neue"/>
               </a:rPr>
-              <a:t>Studenti</a:t>
+              <a:t>Klienti</a:t>
             </a:r>
           </a:p>
         </p:txBody>
@@ -8141,25 +8141,25 @@
           <a:p xmlns:a="http://schemas.openxmlformats.org/drawingml/2006/main">
             <a:pPr algn="l">
               <a:buNone/>
-              <a:defRPr sz="3600" b="1">
-                <a:solidFill>
-                  <a:srgbClr val="F4F2EC"/>
-                </a:solidFill>
-                <a:latin typeface="Helvetica Neue"/>
-                <a:ea typeface="Helvetica Neue"/>
-                <a:cs typeface="Helvetica Neue"/>
-              </a:defRPr>
-            </a:pPr>
-            <a:r>
-              <a:rPr sz="3600" b="1">
-                <a:solidFill>
-                  <a:srgbClr val="F4F2EC"/>
-                </a:solidFill>
-                <a:latin typeface="Helvetica Neue"/>
-                <a:ea typeface="Helvetica Neue"/>
-                <a:cs typeface="Helvetica Neue"/>
-              </a:rPr>
-              <a:t>Vendos</a:t>
+              <a:defRPr sz="1875" b="1">
+                <a:solidFill>
+                  <a:srgbClr val="5DCEF2"/>
+                </a:solidFill>
+                <a:latin typeface="Helvetica Neue"/>
+                <a:ea typeface="Helvetica Neue"/>
+                <a:cs typeface="Helvetica Neue"/>
+              </a:defRPr>
+            </a:pPr>
+            <a:r>
+              <a:rPr sz="1875" b="1">
+                <a:solidFill>
+                  <a:srgbClr val="5DCEF2"/>
+                </a:solidFill>
+                <a:latin typeface="Helvetica Neue"/>
+                <a:ea typeface="Helvetica Neue"/>
+                <a:cs typeface="Helvetica Neue"/>
+              </a:rPr>
+              <a:t>Përditëso statusin</a:t>
             </a:r>
           </a:p>
         </p:txBody>
@@ -8217,7 +8217,7 @@
                 <a:ea typeface="Helvetica Neue"/>
                 <a:cs typeface="Helvetica Neue"/>
               </a:rPr>
-              <a:t>Shoferi</a:t>
+              <a:t>Stafi</a:t>
             </a:r>
           </a:p>
         </p:txBody>
@@ -8345,25 +8345,25 @@
           <a:p xmlns:a="http://schemas.openxmlformats.org/drawingml/2006/main">
             <a:pPr algn="l">
               <a:buNone/>
-              <a:defRPr sz="2250" b="0">
-                <a:solidFill>
-                  <a:srgbClr val="AEBFCB"/>
-                </a:solidFill>
-                <a:latin typeface="Helvetica Neue"/>
-                <a:ea typeface="Helvetica Neue"/>
-                <a:cs typeface="Helvetica Neue"/>
-              </a:defRPr>
-            </a:pPr>
-            <a:r>
-              <a:rPr sz="2250" b="0">
-                <a:solidFill>
-                  <a:srgbClr val="AEBFCB"/>
-                </a:solidFill>
-                <a:latin typeface="Helvetica Neue"/>
-                <a:ea typeface="Helvetica Neue"/>
-                <a:cs typeface="Helvetica Neue"/>
-              </a:rPr>
-              <a:t>Pagesa     GPS live     Chat     Vlerësime</a:t>
+              <a:defRPr sz="1275" b="0">
+                <a:solidFill>
+                  <a:srgbClr val="B6C5CE"/>
+                </a:solidFill>
+                <a:latin typeface="Helvetica Neue"/>
+                <a:ea typeface="Helvetica Neue"/>
+                <a:cs typeface="Helvetica Neue"/>
+              </a:defRPr>
+            </a:pPr>
+            <a:r>
+              <a:rPr sz="1275" b="0">
+                <a:solidFill>
+                  <a:srgbClr val="B6C5CE"/>
+                </a:solidFill>
+                <a:latin typeface="Helvetica Neue"/>
+                <a:ea typeface="Helvetica Neue"/>
+                <a:cs typeface="Helvetica Neue"/>
+              </a:rPr>
+              <a:t>Pagesa   marketplace me shumë restorante   GPS live i korrierit   vlerësime</a:t>
             </a:r>
           </a:p>
         </p:txBody>
@@ -8421,7 +8421,7 @@
                 <a:ea typeface="Helvetica Neue"/>
                 <a:cs typeface="Helvetica Neue"/>
               </a:rPr>
-              <a:t>Cilin rrezik ul veçoria që po zgjidhni?</a:t>
+              <a:t>Cili hap i rrjedhës ul pasigurinë e klientit?</a:t>
             </a:r>
           </a:p>
         </p:txBody>
@@ -8435,7 +8435,7 @@
           <p:nvPr/>
         </p:nvPicPr>
         <p:blipFill>
-          <a:blip xmlns:r="http://schemas.openxmlformats.org/officeDocument/2006/relationships" xmlns:a="http://schemas.openxmlformats.org/drawingml/2006/main" r:embed="R58907d9627b54a78"/>
+          <a:blip xmlns:r="http://schemas.openxmlformats.org/officeDocument/2006/relationships" xmlns:a="http://schemas.openxmlformats.org/drawingml/2006/main" r:embed="R4bd16e0b6d04469e"/>
           <a:stretch xmlns:a="http://schemas.openxmlformats.org/drawingml/2006/main"/>
         </p:blipFill>
         <p:spPr>
@@ -8796,7 +8796,7 @@
                 <a:ea typeface="Helvetica Neue"/>
                 <a:cs typeface="Helvetica Neue"/>
               </a:rPr>
-              <a:t>Kërkesa A</a:t>
+              <a:t>Menu</a:t>
             </a:r>
           </a:p>
         </p:txBody>
@@ -8888,7 +8888,7 @@
                 <a:ea typeface="Helvetica Neue"/>
                 <a:cs typeface="Helvetica Neue"/>
               </a:rPr>
-              <a:t>1 vend</a:t>
+              <a:t>Cart</a:t>
             </a:r>
           </a:p>
         </p:txBody>
@@ -8980,7 +8980,7 @@
                 <a:ea typeface="Helvetica Neue"/>
                 <a:cs typeface="Helvetica Neue"/>
               </a:rPr>
-              <a:t>Pranuar</a:t>
+              <a:t>Order</a:t>
             </a:r>
           </a:p>
         </p:txBody>
@@ -9098,7 +9098,7 @@
                 <a:ea typeface="Helvetica Neue"/>
                 <a:cs typeface="Helvetica Neue"/>
               </a:rPr>
-              <a:t>Kërkesa B</a:t>
+              <a:t>Ready</a:t>
             </a:r>
           </a:p>
         </p:txBody>
@@ -9138,25 +9138,25 @@
           <a:p xmlns:a="http://schemas.openxmlformats.org/drawingml/2006/main">
             <a:pPr algn="l">
               <a:buNone/>
-              <a:defRPr sz="2550" b="1">
-                <a:solidFill>
-                  <a:srgbClr val="F2BB66"/>
-                </a:solidFill>
-                <a:latin typeface="Helvetica Neue"/>
-                <a:ea typeface="Helvetica Neue"/>
-                <a:cs typeface="Helvetica Neue"/>
-              </a:defRPr>
-            </a:pPr>
-            <a:r>
-              <a:rPr sz="2550" b="1">
-                <a:solidFill>
-                  <a:srgbClr val="F2BB66"/>
-                </a:solidFill>
-                <a:latin typeface="Helvetica Neue"/>
-                <a:ea typeface="Helvetica Neue"/>
-                <a:cs typeface="Helvetica Neue"/>
-              </a:rPr>
-              <a:t>Pa tejkalim kapaciteti</a:t>
+              <a:defRPr sz="1875" b="1">
+                <a:solidFill>
+                  <a:srgbClr val="F3BE5C"/>
+                </a:solidFill>
+                <a:latin typeface="Helvetica Neue"/>
+                <a:ea typeface="Helvetica Neue"/>
+                <a:cs typeface="Helvetica Neue"/>
+              </a:defRPr>
+            </a:pPr>
+            <a:r>
+              <a:rPr sz="1875" b="1">
+                <a:solidFill>
+                  <a:srgbClr val="F3BE5C"/>
+                </a:solidFill>
+                <a:latin typeface="Helvetica Neue"/>
+                <a:ea typeface="Helvetica Neue"/>
+                <a:cs typeface="Helvetica Neue"/>
+              </a:rPr>
+              <a:t>Vetëm pas konfirmimit të serverit</a:t>
             </a:r>
           </a:p>
         </p:txBody>
@@ -9196,25 +9196,25 @@
           <a:p xmlns:a="http://schemas.openxmlformats.org/drawingml/2006/main">
             <a:pPr algn="l">
               <a:buNone/>
-              <a:defRPr sz="3150" b="1">
-                <a:solidFill>
-                  <a:srgbClr val="F4F2EC"/>
-                </a:solidFill>
-                <a:latin typeface="Helvetica Neue"/>
-                <a:ea typeface="Helvetica Neue"/>
-                <a:cs typeface="Helvetica Neue"/>
-              </a:defRPr>
-            </a:pPr>
-            <a:r>
-              <a:rPr sz="3150" b="1">
-                <a:solidFill>
-                  <a:srgbClr val="F4F2EC"/>
-                </a:solidFill>
-                <a:latin typeface="Helvetica Neue"/>
-                <a:ea typeface="Helvetica Neue"/>
-                <a:cs typeface="Helvetica Neue"/>
-              </a:rPr>
-              <a:t>Vendet e konfirmuara ≤ kapaciteti</a:t>
+              <a:defRPr sz="2025" b="1">
+                <a:solidFill>
+                  <a:srgbClr val="F5F7F9"/>
+                </a:solidFill>
+                <a:latin typeface="Helvetica Neue"/>
+                <a:ea typeface="Helvetica Neue"/>
+                <a:cs typeface="Helvetica Neue"/>
+              </a:defRPr>
+            </a:pPr>
+            <a:r>
+              <a:rPr sz="2025" b="1">
+                <a:solidFill>
+                  <a:srgbClr val="F5F7F9"/>
+                </a:solidFill>
+                <a:latin typeface="Helvetica Neue"/>
+                <a:ea typeface="Helvetica Neue"/>
+                <a:cs typeface="Helvetica Neue"/>
+              </a:rPr>
+              <a:t>Porosia ruhet një herë dhe statusi arrin “Ready”</a:t>
             </a:r>
           </a:p>
         </p:txBody>
@@ -9272,7 +9272,7 @@
                 <a:ea typeface="Helvetica Neue"/>
                 <a:cs typeface="Helvetica Neue"/>
               </a:rPr>
-              <a:t>Çfarë ndodh kur dy kërkesa mbërrijnë njëkohësisht?</a:t>
+              <a:t>Çfarë ndodh kur klienti shtyp “Porosit” dy herë?</a:t>
             </a:r>
           </a:p>
         </p:txBody>
@@ -9286,7 +9286,7 @@
           <p:nvPr/>
         </p:nvPicPr>
         <p:blipFill>
-          <a:blip xmlns:r="http://schemas.openxmlformats.org/officeDocument/2006/relationships" xmlns:a="http://schemas.openxmlformats.org/drawingml/2006/main" r:embed="Rbd4973aaa44e43db"/>
+          <a:blip xmlns:r="http://schemas.openxmlformats.org/officeDocument/2006/relationships" xmlns:a="http://schemas.openxmlformats.org/drawingml/2006/main" r:embed="R14ee83dcf5424339"/>
           <a:stretch xmlns:a="http://schemas.openxmlformats.org/drawingml/2006/main"/>
         </p:blipFill>
         <p:spPr>
@@ -9653,7 +9653,7 @@
                 <a:ea typeface="Helvetica Neue"/>
                 <a:cs typeface="Helvetica Neue"/>
               </a:rPr>
-              <a:t>AAB RideShare</a:t>
+              <a:t>Restoranti Sofra</a:t>
             </a:r>
           </a:p>
         </p:txBody>
@@ -9711,7 +9711,7 @@
                 <a:ea typeface="Helvetica Neue"/>
                 <a:cs typeface="Helvetica Neue"/>
               </a:rPr>
-              <a:t>Udhëtimet</a:t>
+              <a:t>MENU</a:t>
             </a:r>
           </a:p>
         </p:txBody>
@@ -9769,31 +9769,7 @@
                 <a:ea typeface="Helvetica Neue"/>
                 <a:cs typeface="Helvetica Neue"/>
               </a:rPr>
-              <a:t>Fushë Kosovë</a:t>
-            </a:r>
-          </a:p>
-          <a:p xmlns:a="http://schemas.openxmlformats.org/drawingml/2006/main">
-            <a:pPr algn="l">
-              <a:buNone/>
-              <a:defRPr sz="2025" b="1">
-                <a:solidFill>
-                  <a:srgbClr val="F4F2EC"/>
-                </a:solidFill>
-                <a:latin typeface="Helvetica Neue"/>
-                <a:ea typeface="Helvetica Neue"/>
-                <a:cs typeface="Helvetica Neue"/>
-              </a:defRPr>
-            </a:pPr>
-            <a:r>
-              <a:rPr sz="2025" b="1">
-                <a:solidFill>
-                  <a:srgbClr val="F4F2EC"/>
-                </a:solidFill>
-                <a:latin typeface="Helvetica Neue"/>
-                <a:ea typeface="Helvetica Neue"/>
-                <a:cs typeface="Helvetica Neue"/>
-              </a:rPr>
-              <a:t>Kampus</a:t>
+              <a:t>Tavë shtëpie</a:t>
             </a:r>
           </a:p>
         </p:txBody>
@@ -9833,25 +9809,25 @@
           <a:p xmlns:a="http://schemas.openxmlformats.org/drawingml/2006/main">
             <a:pPr algn="l">
               <a:buNone/>
-              <a:defRPr sz="1725" b="0">
-                <a:solidFill>
-                  <a:srgbClr val="AEBFCB"/>
-                </a:solidFill>
-                <a:latin typeface="Helvetica Neue"/>
-                <a:ea typeface="Helvetica Neue"/>
-                <a:cs typeface="Helvetica Neue"/>
-              </a:defRPr>
-            </a:pPr>
-            <a:r>
-              <a:rPr sz="1725" b="0">
-                <a:solidFill>
-                  <a:srgbClr val="AEBFCB"/>
-                </a:solidFill>
-                <a:latin typeface="Helvetica Neue"/>
-                <a:ea typeface="Helvetica Neue"/>
-                <a:cs typeface="Helvetica Neue"/>
-              </a:rPr>
-              <a:t>07:30     1 vend</a:t>
+              <a:defRPr sz="1200" b="0">
+                <a:solidFill>
+                  <a:srgbClr val="B6C5CE"/>
+                </a:solidFill>
+                <a:latin typeface="Helvetica Neue"/>
+                <a:ea typeface="Helvetica Neue"/>
+                <a:cs typeface="Helvetica Neue"/>
+              </a:defRPr>
+            </a:pPr>
+            <a:r>
+              <a:rPr sz="1200" b="0">
+                <a:solidFill>
+                  <a:srgbClr val="B6C5CE"/>
+                </a:solidFill>
+                <a:latin typeface="Helvetica Neue"/>
+                <a:ea typeface="Helvetica Neue"/>
+                <a:cs typeface="Helvetica Neue"/>
+              </a:rPr>
+              <a:t>8 €     Në dispozicion</a:t>
             </a:r>
           </a:p>
         </p:txBody>
@@ -9941,7 +9917,7 @@
                 <a:ea typeface="Helvetica Neue"/>
                 <a:cs typeface="Helvetica Neue"/>
               </a:rPr>
-              <a:t>Shiko detajet</a:t>
+              <a:t>Shto</a:t>
             </a:r>
           </a:p>
         </p:txBody>
@@ -10097,7 +10073,7 @@
                 <a:ea typeface="Helvetica Neue"/>
                 <a:cs typeface="Helvetica Neue"/>
               </a:rPr>
-              <a:t>AAB RideShare</a:t>
+              <a:t>Restoranti Sofra</a:t>
             </a:r>
           </a:p>
         </p:txBody>
@@ -10155,7 +10131,7 @@
                 <a:ea typeface="Helvetica Neue"/>
                 <a:cs typeface="Helvetica Neue"/>
               </a:rPr>
-              <a:t>Fushë Kosovë</a:t>
+              <a:t>CART</a:t>
             </a:r>
           </a:p>
           <a:p xmlns:a="http://schemas.openxmlformats.org/drawingml/2006/main">
@@ -10179,7 +10155,7 @@
                 <a:ea typeface="Helvetica Neue"/>
                 <a:cs typeface="Helvetica Neue"/>
               </a:rPr>
-              <a:t>Kampus</a:t>
+              <a:t>Tavë shtëpie</a:t>
             </a:r>
           </a:p>
         </p:txBody>
@@ -10237,7 +10213,7 @@
                 <a:ea typeface="Helvetica Neue"/>
                 <a:cs typeface="Helvetica Neue"/>
               </a:rPr>
-              <a:t>07:30</a:t>
+              <a:t>Sasia: 1</a:t>
             </a:r>
           </a:p>
         </p:txBody>
@@ -10277,25 +10253,25 @@
           <a:p xmlns:a="http://schemas.openxmlformats.org/drawingml/2006/main">
             <a:pPr algn="l">
               <a:buNone/>
-              <a:defRPr sz="1875" b="0">
-                <a:solidFill>
-                  <a:srgbClr val="AEBFCB"/>
-                </a:solidFill>
-                <a:latin typeface="Helvetica Neue"/>
-                <a:ea typeface="Helvetica Neue"/>
-                <a:cs typeface="Helvetica Neue"/>
-              </a:defRPr>
-            </a:pPr>
-            <a:r>
-              <a:rPr sz="1875" b="0">
-                <a:solidFill>
-                  <a:srgbClr val="AEBFCB"/>
-                </a:solidFill>
-                <a:latin typeface="Helvetica Neue"/>
-                <a:ea typeface="Helvetica Neue"/>
-                <a:cs typeface="Helvetica Neue"/>
-              </a:rPr>
-              <a:t>1 vend i lirë</a:t>
+              <a:defRPr sz="1200" b="0">
+                <a:solidFill>
+                  <a:srgbClr val="B6C5CE"/>
+                </a:solidFill>
+                <a:latin typeface="Helvetica Neue"/>
+                <a:ea typeface="Helvetica Neue"/>
+                <a:cs typeface="Helvetica Neue"/>
+              </a:defRPr>
+            </a:pPr>
+            <a:r>
+              <a:rPr sz="1200" b="0">
+                <a:solidFill>
+                  <a:srgbClr val="B6C5CE"/>
+                </a:solidFill>
+                <a:latin typeface="Helvetica Neue"/>
+                <a:ea typeface="Helvetica Neue"/>
+                <a:cs typeface="Helvetica Neue"/>
+              </a:rPr>
+              <a:t>Gjithsej: 8 €</a:t>
             </a:r>
           </a:p>
         </p:txBody>
@@ -10385,7 +10361,7 @@
                 <a:ea typeface="Helvetica Neue"/>
                 <a:cs typeface="Helvetica Neue"/>
               </a:rPr>
-              <a:t>Kërko vend</a:t>
+              <a:t>Porosit</a:t>
             </a:r>
           </a:p>
         </p:txBody>
@@ -10541,7 +10517,7 @@
                 <a:ea typeface="Helvetica Neue"/>
                 <a:cs typeface="Helvetica Neue"/>
               </a:rPr>
-              <a:t>AAB RideShare</a:t>
+              <a:t>Restoranti Sofra</a:t>
             </a:r>
           </a:p>
         </p:txBody>
@@ -10599,7 +10575,7 @@
                 <a:ea typeface="Helvetica Neue"/>
                 <a:cs typeface="Helvetica Neue"/>
               </a:rPr>
-              <a:t>Kërkesa juaj</a:t>
+              <a:t>ORDER #1042</a:t>
             </a:r>
           </a:p>
         </p:txBody>
@@ -10657,7 +10633,7 @@
                 <a:ea typeface="Helvetica Neue"/>
                 <a:cs typeface="Helvetica Neue"/>
               </a:rPr>
-              <a:t>NË PRITJE</a:t>
+              <a:t>U PRANUA</a:t>
             </a:r>
           </a:p>
         </p:txBody>
@@ -10697,49 +10673,49 @@
           <a:p xmlns:a="http://schemas.openxmlformats.org/drawingml/2006/main">
             <a:pPr algn="l">
               <a:buNone/>
-              <a:defRPr sz="1875" b="0">
-                <a:solidFill>
-                  <a:srgbClr val="AEBFCB"/>
-                </a:solidFill>
-                <a:latin typeface="Helvetica Neue"/>
-                <a:ea typeface="Helvetica Neue"/>
-                <a:cs typeface="Helvetica Neue"/>
-              </a:defRPr>
-            </a:pPr>
-            <a:r>
-              <a:rPr sz="1875" b="0">
-                <a:solidFill>
-                  <a:srgbClr val="AEBFCB"/>
-                </a:solidFill>
-                <a:latin typeface="Helvetica Neue"/>
-                <a:ea typeface="Helvetica Neue"/>
-                <a:cs typeface="Helvetica Neue"/>
-              </a:rPr>
-              <a:t>Shoferi ende</a:t>
+              <a:defRPr sz="1275" b="0">
+                <a:solidFill>
+                  <a:srgbClr val="B6C5CE"/>
+                </a:solidFill>
+                <a:latin typeface="Helvetica Neue"/>
+                <a:ea typeface="Helvetica Neue"/>
+                <a:cs typeface="Helvetica Neue"/>
+              </a:defRPr>
+            </a:pPr>
+            <a:r>
+              <a:rPr sz="1275" b="0">
+                <a:solidFill>
+                  <a:srgbClr val="B6C5CE"/>
+                </a:solidFill>
+                <a:latin typeface="Helvetica Neue"/>
+                <a:ea typeface="Helvetica Neue"/>
+                <a:cs typeface="Helvetica Neue"/>
+              </a:rPr>
+              <a:t>READY</a:t>
             </a:r>
           </a:p>
           <a:p xmlns:a="http://schemas.openxmlformats.org/drawingml/2006/main">
             <a:pPr algn="l">
               <a:buNone/>
-              <a:defRPr sz="1875" b="0">
-                <a:solidFill>
-                  <a:srgbClr val="AEBFCB"/>
-                </a:solidFill>
-                <a:latin typeface="Helvetica Neue"/>
-                <a:ea typeface="Helvetica Neue"/>
-                <a:cs typeface="Helvetica Neue"/>
-              </a:defRPr>
-            </a:pPr>
-            <a:r>
-              <a:rPr sz="1875" b="0">
-                <a:solidFill>
-                  <a:srgbClr val="AEBFCB"/>
-                </a:solidFill>
-                <a:latin typeface="Helvetica Neue"/>
-                <a:ea typeface="Helvetica Neue"/>
-                <a:cs typeface="Helvetica Neue"/>
-              </a:rPr>
-              <a:t>nuk e ka pranuar.</a:t>
+              <a:defRPr sz="1275" b="0">
+                <a:solidFill>
+                  <a:srgbClr val="B6C5CE"/>
+                </a:solidFill>
+                <a:latin typeface="Helvetica Neue"/>
+                <a:ea typeface="Helvetica Neue"/>
+                <a:cs typeface="Helvetica Neue"/>
+              </a:defRPr>
+            </a:pPr>
+            <a:r>
+              <a:rPr sz="1275" b="0">
+                <a:solidFill>
+                  <a:srgbClr val="B6C5CE"/>
+                </a:solidFill>
+                <a:latin typeface="Helvetica Neue"/>
+                <a:ea typeface="Helvetica Neue"/>
+                <a:cs typeface="Helvetica Neue"/>
+              </a:rPr>
+              <a:t>Prit njoftimin e stafit.</a:t>
             </a:r>
           </a:p>
         </p:txBody>
@@ -10857,7 +10833,7 @@
                 <a:ea typeface="Helvetica Neue"/>
                 <a:cs typeface="Helvetica Neue"/>
               </a:rPr>
-              <a:t>Në cilën pamje mund të keqkuptohet konfirmimi?</a:t>
+              <a:t>A ndiqet qartë rrjedha MENU → CART → ORDER → READY?</a:t>
             </a:r>
           </a:p>
         </p:txBody>
@@ -10871,7 +10847,7 @@
           <p:nvPr/>
         </p:nvPicPr>
         <p:blipFill>
-          <a:blip xmlns:r="http://schemas.openxmlformats.org/officeDocument/2006/relationships" xmlns:a="http://schemas.openxmlformats.org/drawingml/2006/main" r:embed="Rb6623f22b2be473b"/>
+          <a:blip xmlns:r="http://schemas.openxmlformats.org/officeDocument/2006/relationships" xmlns:a="http://schemas.openxmlformats.org/drawingml/2006/main" r:embed="R02a3c3e90b9d454f"/>
           <a:stretch xmlns:a="http://schemas.openxmlformats.org/drawingml/2006/main"/>
         </p:blipFill>
         <p:spPr>
@@ -11082,7 +11058,7 @@
                 <a:ea typeface="Helvetica Neue"/>
                 <a:cs typeface="Helvetica Neue"/>
               </a:rPr>
-              <a:t>Produkti mbërrin me një lidhje</a:t>
+              <a:t>PWA për pilotin e restorantit</a:t>
             </a:r>
           </a:p>
         </p:txBody>
@@ -11180,73 +11156,97 @@
           <a:p xmlns:a="http://schemas.openxmlformats.org/drawingml/2006/main">
             <a:pPr algn="l">
               <a:buNone/>
-              <a:defRPr sz="2700" b="0">
-                <a:solidFill>
-                  <a:srgbClr val="F4F2EC"/>
-                </a:solidFill>
-                <a:latin typeface="Helvetica Neue"/>
-                <a:ea typeface="Helvetica Neue"/>
-                <a:cs typeface="Helvetica Neue"/>
-              </a:defRPr>
-            </a:pPr>
-            <a:r>
-              <a:rPr sz="2700" b="0">
-                <a:solidFill>
-                  <a:srgbClr val="F4F2EC"/>
-                </a:solidFill>
-                <a:latin typeface="Helvetica Neue"/>
-                <a:ea typeface="Helvetica Neue"/>
-                <a:cs typeface="Helvetica Neue"/>
-              </a:rPr>
-              <a:t>Një lidhje për ta provuar</a:t>
+              <a:defRPr sz="1875" b="0">
+                <a:solidFill>
+                  <a:srgbClr val="F5F7F9"/>
+                </a:solidFill>
+                <a:latin typeface="Helvetica Neue"/>
+                <a:ea typeface="Helvetica Neue"/>
+                <a:cs typeface="Helvetica Neue"/>
+              </a:defRPr>
+            </a:pPr>
+            <a:r>
+              <a:rPr sz="1875" b="0">
+                <a:solidFill>
+                  <a:srgbClr val="F5F7F9"/>
+                </a:solidFill>
+                <a:latin typeface="Helvetica Neue"/>
+                <a:ea typeface="Helvetica Neue"/>
+                <a:cs typeface="Helvetica Neue"/>
+              </a:rPr>
+              <a:t>Aplikacion web për telefon,</a:t>
             </a:r>
           </a:p>
           <a:p xmlns:a="http://schemas.openxmlformats.org/drawingml/2006/main">
             <a:pPr algn="l">
               <a:buNone/>
-              <a:defRPr sz="2700" b="0">
-                <a:solidFill>
-                  <a:srgbClr val="F4F2EC"/>
-                </a:solidFill>
-                <a:latin typeface="Helvetica Neue"/>
-                <a:ea typeface="Helvetica Neue"/>
-                <a:cs typeface="Helvetica Neue"/>
-              </a:defRPr>
-            </a:pPr>
-            <a:r>
-              <a:rPr sz="2700" b="0">
-                <a:solidFill>
-                  <a:srgbClr val="F4F2EC"/>
-                </a:solidFill>
-                <a:latin typeface="Helvetica Neue"/>
-                <a:ea typeface="Helvetica Neue"/>
-                <a:cs typeface="Helvetica Neue"/>
-              </a:rPr>
-              <a:t>Instalim kur mbështetet</a:t>
+              <a:defRPr sz="1875" b="0">
+                <a:solidFill>
+                  <a:srgbClr val="F5F7F9"/>
+                </a:solidFill>
+                <a:latin typeface="Helvetica Neue"/>
+                <a:ea typeface="Helvetica Neue"/>
+                <a:cs typeface="Helvetica Neue"/>
+              </a:defRPr>
+            </a:pPr>
+            <a:r>
+              <a:rPr sz="1875" b="0">
+                <a:solidFill>
+                  <a:srgbClr val="F5F7F9"/>
+                </a:solidFill>
+                <a:latin typeface="Helvetica Neue"/>
+                <a:ea typeface="Helvetica Neue"/>
+                <a:cs typeface="Helvetica Neue"/>
+              </a:rPr>
+              <a:t>hapet nga një link.</a:t>
             </a:r>
           </a:p>
           <a:p xmlns:a="http://schemas.openxmlformats.org/drawingml/2006/main">
             <a:pPr algn="l">
               <a:buNone/>
-              <a:defRPr sz="2700" b="0">
-                <a:solidFill>
-                  <a:srgbClr val="F4F2EC"/>
-                </a:solidFill>
-                <a:latin typeface="Helvetica Neue"/>
-                <a:ea typeface="Helvetica Neue"/>
-                <a:cs typeface="Helvetica Neue"/>
-              </a:defRPr>
-            </a:pPr>
-            <a:r>
-              <a:rPr sz="2700" b="0">
-                <a:solidFill>
-                  <a:srgbClr val="F4F2EC"/>
-                </a:solidFill>
-                <a:latin typeface="Helvetica Neue"/>
-                <a:ea typeface="Helvetica Neue"/>
-                <a:cs typeface="Helvetica Neue"/>
-              </a:rPr>
-              <a:t>Sjellje offline e projektuar</a:t>
+              <a:defRPr sz="1875" b="0">
+                <a:solidFill>
+                  <a:srgbClr val="F5F7F9"/>
+                </a:solidFill>
+                <a:latin typeface="Helvetica Neue"/>
+                <a:ea typeface="Helvetica Neue"/>
+                <a:cs typeface="Helvetica Neue"/>
+              </a:defRPr>
+            </a:pPr>
+            <a:r>
+              <a:rPr sz="1875" b="0">
+                <a:solidFill>
+                  <a:srgbClr val="F5F7F9"/>
+                </a:solidFill>
+                <a:latin typeface="Helvetica Neue"/>
+                <a:ea typeface="Helvetica Neue"/>
+                <a:cs typeface="Helvetica Neue"/>
+              </a:rPr>
+              <a:t>Instalohet kur mbështetet.</a:t>
+            </a:r>
+          </a:p>
+          <a:p xmlns:a="http://schemas.openxmlformats.org/drawingml/2006/main">
+            <a:pPr algn="l">
+              <a:buNone/>
+              <a:defRPr sz="1875" b="0">
+                <a:solidFill>
+                  <a:srgbClr val="F5F7F9"/>
+                </a:solidFill>
+                <a:latin typeface="Helvetica Neue"/>
+                <a:ea typeface="Helvetica Neue"/>
+                <a:cs typeface="Helvetica Neue"/>
+              </a:defRPr>
+            </a:pPr>
+            <a:r>
+              <a:rPr sz="1875" b="0">
+                <a:solidFill>
+                  <a:srgbClr val="F5F7F9"/>
+                </a:solidFill>
+                <a:latin typeface="Helvetica Neue"/>
+                <a:ea typeface="Helvetica Neue"/>
+                <a:cs typeface="Helvetica Neue"/>
+              </a:rPr>
+              <a:t>Sjellja offline projektohet.</a:t>
             </a:r>
           </a:p>
         </p:txBody>
@@ -11402,7 +11402,7 @@
                 <a:ea typeface="Helvetica Neue"/>
                 <a:cs typeface="Helvetica Neue"/>
               </a:rPr>
-              <a:t>AAB RideShare</a:t>
+              <a:t>Restoranti Sofra</a:t>
             </a:r>
           </a:p>
         </p:txBody>
@@ -11460,7 +11460,7 @@
                 <a:ea typeface="Helvetica Neue"/>
                 <a:cs typeface="Helvetica Neue"/>
               </a:rPr>
-              <a:t>Udhëtimet</a:t>
+              <a:t>MENU</a:t>
             </a:r>
           </a:p>
         </p:txBody>
@@ -11518,31 +11518,7 @@
                 <a:ea typeface="Helvetica Neue"/>
                 <a:cs typeface="Helvetica Neue"/>
               </a:rPr>
-              <a:t>Fushë Kosovë</a:t>
-            </a:r>
-          </a:p>
-          <a:p xmlns:a="http://schemas.openxmlformats.org/drawingml/2006/main">
-            <a:pPr algn="l">
-              <a:buNone/>
-              <a:defRPr sz="2025" b="1">
-                <a:solidFill>
-                  <a:srgbClr val="F4F2EC"/>
-                </a:solidFill>
-                <a:latin typeface="Helvetica Neue"/>
-                <a:ea typeface="Helvetica Neue"/>
-                <a:cs typeface="Helvetica Neue"/>
-              </a:defRPr>
-            </a:pPr>
-            <a:r>
-              <a:rPr sz="2025" b="1">
-                <a:solidFill>
-                  <a:srgbClr val="F4F2EC"/>
-                </a:solidFill>
-                <a:latin typeface="Helvetica Neue"/>
-                <a:ea typeface="Helvetica Neue"/>
-                <a:cs typeface="Helvetica Neue"/>
-              </a:rPr>
-              <a:t>Kampus</a:t>
+              <a:t>Tavë shtëpie</a:t>
             </a:r>
           </a:p>
         </p:txBody>
@@ -11582,25 +11558,25 @@
           <a:p xmlns:a="http://schemas.openxmlformats.org/drawingml/2006/main">
             <a:pPr algn="l">
               <a:buNone/>
-              <a:defRPr sz="1725" b="0">
-                <a:solidFill>
-                  <a:srgbClr val="AEBFCB"/>
-                </a:solidFill>
-                <a:latin typeface="Helvetica Neue"/>
-                <a:ea typeface="Helvetica Neue"/>
-                <a:cs typeface="Helvetica Neue"/>
-              </a:defRPr>
-            </a:pPr>
-            <a:r>
-              <a:rPr sz="1725" b="0">
-                <a:solidFill>
-                  <a:srgbClr val="AEBFCB"/>
-                </a:solidFill>
-                <a:latin typeface="Helvetica Neue"/>
-                <a:ea typeface="Helvetica Neue"/>
-                <a:cs typeface="Helvetica Neue"/>
-              </a:rPr>
-              <a:t>07:30     1 vend</a:t>
+              <a:defRPr sz="1125" b="0">
+                <a:solidFill>
+                  <a:srgbClr val="B6C5CE"/>
+                </a:solidFill>
+                <a:latin typeface="Helvetica Neue"/>
+                <a:ea typeface="Helvetica Neue"/>
+                <a:cs typeface="Helvetica Neue"/>
+              </a:defRPr>
+            </a:pPr>
+            <a:r>
+              <a:rPr sz="1125" b="0">
+                <a:solidFill>
+                  <a:srgbClr val="B6C5CE"/>
+                </a:solidFill>
+                <a:latin typeface="Helvetica Neue"/>
+                <a:ea typeface="Helvetica Neue"/>
+                <a:cs typeface="Helvetica Neue"/>
+              </a:rPr>
+              <a:t>8 €     Në dispozicion</a:t>
             </a:r>
           </a:p>
         </p:txBody>
@@ -11690,7 +11666,7 @@
                 <a:ea typeface="Helvetica Neue"/>
                 <a:cs typeface="Helvetica Neue"/>
               </a:rPr>
-              <a:t>Shiko detajet</a:t>
+              <a:t>Shto</a:t>
             </a:r>
           </a:p>
         </p:txBody>
@@ -11748,7 +11724,7 @@
                 <a:ea typeface="Helvetica Neue"/>
                 <a:cs typeface="Helvetica Neue"/>
               </a:rPr>
-              <a:t>Zgjedhja varet nga aftësitë e pajisjes dhe kërkesat e produktit.</a:t>
+              <a:t>Piloti nis me një link, pa publikim fillestar në App Store.</a:t>
             </a:r>
           </a:p>
         </p:txBody>
@@ -11762,7 +11738,7 @@
           <p:nvPr/>
         </p:nvPicPr>
         <p:blipFill>
-          <a:blip xmlns:r="http://schemas.openxmlformats.org/officeDocument/2006/relationships" xmlns:a="http://schemas.openxmlformats.org/drawingml/2006/main" r:embed="R1afc3fae45b64d34"/>
+          <a:blip xmlns:r="http://schemas.openxmlformats.org/officeDocument/2006/relationships" xmlns:a="http://schemas.openxmlformats.org/drawingml/2006/main" r:embed="R2462c9486002476f"/>
           <a:stretch xmlns:a="http://schemas.openxmlformats.org/drawingml/2006/main"/>
         </p:blipFill>
         <p:spPr>
@@ -11838,6 +11814,7 @@
           <a:lstStyle xmlns:a="http://schemas.openxmlformats.org/drawingml/2006/main"/>
           <a:p xmlns:a="http://schemas.openxmlformats.org/drawingml/2006/main">
             <a:pPr>
+              <a:buNone/>
               <a:defRPr sz="1350" b="1">
                 <a:solidFill>
                   <a:srgbClr val="5DCEF2"/>
@@ -11895,6 +11872,7 @@
           <a:lstStyle xmlns:a="http://schemas.openxmlformats.org/drawingml/2006/main"/>
           <a:p xmlns:a="http://schemas.openxmlformats.org/drawingml/2006/main">
             <a:pPr>
+              <a:buNone/>
               <a:defRPr sz="3600" b="1">
                 <a:solidFill>
                   <a:srgbClr val="F5F7F9"/>
@@ -11952,6 +11930,7 @@
           <a:lstStyle xmlns:a="http://schemas.openxmlformats.org/drawingml/2006/main"/>
           <a:p xmlns:a="http://schemas.openxmlformats.org/drawingml/2006/main">
             <a:pPr>
+              <a:buNone/>
               <a:defRPr sz="3600" b="1">
                 <a:solidFill>
                   <a:srgbClr val="5DCEF2"/>
@@ -12009,6 +11988,7 @@
           <a:lstStyle xmlns:a="http://schemas.openxmlformats.org/drawingml/2006/main"/>
           <a:p xmlns:a="http://schemas.openxmlformats.org/drawingml/2006/main">
             <a:pPr>
+              <a:buNone/>
               <a:defRPr sz="2550" b="0">
                 <a:solidFill>
                   <a:srgbClr val="F5F7F9"/>
@@ -12032,6 +12012,7 @@
           </a:p>
           <a:p xmlns:a="http://schemas.openxmlformats.org/drawingml/2006/main">
             <a:pPr>
+              <a:buNone/>
               <a:defRPr sz="2550" b="0">
                 <a:solidFill>
                   <a:srgbClr val="F5F7F9"/>
@@ -12055,6 +12036,7 @@
           </a:p>
           <a:p xmlns:a="http://schemas.openxmlformats.org/drawingml/2006/main">
             <a:pPr>
+              <a:buNone/>
               <a:defRPr sz="2550" b="0">
                 <a:solidFill>
                   <a:srgbClr val="F5F7F9"/>
@@ -12112,6 +12094,7 @@
           <a:lstStyle xmlns:a="http://schemas.openxmlformats.org/drawingml/2006/main"/>
           <a:p xmlns:a="http://schemas.openxmlformats.org/drawingml/2006/main">
             <a:pPr>
+              <a:buNone/>
               <a:defRPr sz="3600" b="1">
                 <a:solidFill>
                   <a:srgbClr val="5DCEF2"/>
@@ -12169,6 +12152,7 @@
           <a:lstStyle xmlns:a="http://schemas.openxmlformats.org/drawingml/2006/main"/>
           <a:p xmlns:a="http://schemas.openxmlformats.org/drawingml/2006/main">
             <a:pPr>
+              <a:buNone/>
               <a:defRPr sz="2550" b="0">
                 <a:solidFill>
                   <a:srgbClr val="F5F7F9"/>
@@ -12192,6 +12176,7 @@
           </a:p>
           <a:p xmlns:a="http://schemas.openxmlformats.org/drawingml/2006/main">
             <a:pPr>
+              <a:buNone/>
               <a:defRPr sz="2550" b="0">
                 <a:solidFill>
                   <a:srgbClr val="F5F7F9"/>
@@ -12215,6 +12200,7 @@
           </a:p>
           <a:p xmlns:a="http://schemas.openxmlformats.org/drawingml/2006/main">
             <a:pPr>
+              <a:buNone/>
               <a:defRPr sz="2550" b="0">
                 <a:solidFill>
                   <a:srgbClr val="F5F7F9"/>
@@ -12272,6 +12258,7 @@
           <a:lstStyle xmlns:a="http://schemas.openxmlformats.org/drawingml/2006/main"/>
           <a:p xmlns:a="http://schemas.openxmlformats.org/drawingml/2006/main">
             <a:pPr>
+              <a:buNone/>
               <a:defRPr sz="2100" b="0">
                 <a:solidFill>
                   <a:srgbClr val="B6C5CE"/>
@@ -12290,7 +12277,7 @@
                 <a:ea typeface="Helvetica Neue"/>
                 <a:cs typeface="Helvetica Neue"/>
               </a:rPr>
-              <a:t>Një student, një aplikacion, përmirësime gjatë gjithë semestrit</a:t>
+              <a:t>Restoranti është shembulli i ligjëratës. Biznesi juaj është projekti semestral.</a:t>
             </a:r>
           </a:p>
         </p:txBody>
@@ -12329,6 +12316,7 @@
           <a:lstStyle xmlns:a="http://schemas.openxmlformats.org/drawingml/2006/main"/>
           <a:p xmlns:a="http://schemas.openxmlformats.org/drawingml/2006/main">
             <a:pPr>
+              <a:buNone/>
               <a:defRPr sz="1350" b="0">
                 <a:solidFill>
                   <a:srgbClr val="B6C5CE"/>
@@ -12354,14 +12342,14 @@
       </p:sp>
       <p:pic>
         <p:nvPicPr>
-          <p:cNvPr id="18" name=""/>
+          <p:cNvPr id="20" name=""/>
           <p:cNvPicPr>
             <a:picLocks xmlns:a="http://schemas.openxmlformats.org/drawingml/2006/main" noChangeAspect="1"/>
           </p:cNvPicPr>
           <p:nvPr/>
         </p:nvPicPr>
         <p:blipFill>
-          <a:blip xmlns:r="http://schemas.openxmlformats.org/officeDocument/2006/relationships" xmlns:a="http://schemas.openxmlformats.org/drawingml/2006/main" r:embed="R1fc20b2eaa22486f"/>
+          <a:blip xmlns:r="http://schemas.openxmlformats.org/officeDocument/2006/relationships" xmlns:a="http://schemas.openxmlformats.org/drawingml/2006/main" r:embed="R3c2d012dc1594b0b"/>
           <a:stretch xmlns:a="http://schemas.openxmlformats.org/drawingml/2006/main"/>
         </p:blipFill>
         <p:spPr>
@@ -12572,7 +12560,7 @@
                 <a:ea typeface="Helvetica Neue"/>
                 <a:cs typeface="Helvetica Neue"/>
               </a:rPr>
-              <a:t>Ku ekzekutohet vendimi?</a:t>
+              <a:t>Telefon, server dhe të dhëna</a:t>
             </a:r>
           </a:p>
         </p:txBody>
@@ -12838,7 +12826,7 @@
                 <a:ea typeface="Helvetica Neue"/>
                 <a:cs typeface="Helvetica Neue"/>
               </a:rPr>
-              <a:t>React 19</a:t>
+              <a:t>Next.js PWA</a:t>
             </a:r>
           </a:p>
         </p:txBody>
@@ -12896,7 +12884,7 @@
                 <a:ea typeface="Helvetica Neue"/>
                 <a:cs typeface="Helvetica Neue"/>
               </a:rPr>
-              <a:t>Ndërfaqja mobile</a:t>
+              <a:t>Menu / Cart</a:t>
             </a:r>
           </a:p>
         </p:txBody>
@@ -13018,7 +13006,7 @@
                 <a:ea typeface="Helvetica Neue"/>
                 <a:cs typeface="Helvetica Neue"/>
               </a:rPr>
-              <a:t>Next.js 15</a:t>
+              <a:t>Next.js API</a:t>
             </a:r>
           </a:p>
         </p:txBody>
@@ -13076,7 +13064,7 @@
                 <a:ea typeface="Helvetica Neue"/>
                 <a:cs typeface="Helvetica Neue"/>
               </a:rPr>
-              <a:t>App Router / Vercel</a:t>
+              <a:t>Krijon porosinë</a:t>
             </a:r>
           </a:p>
         </p:txBody>
@@ -13256,7 +13244,7 @@
                 <a:ea typeface="Helvetica Neue"/>
                 <a:cs typeface="Helvetica Neue"/>
               </a:rPr>
-              <a:t>Auth / PostgreSQL</a:t>
+              <a:t>Menu / status</a:t>
             </a:r>
           </a:p>
         </p:txBody>
@@ -13314,7 +13302,7 @@
                 <a:ea typeface="Helvetica Neue"/>
                 <a:cs typeface="Helvetica Neue"/>
               </a:rPr>
-              <a:t>TypeScript + Tailwind</a:t>
+              <a:t>Dërgon qëllimin</a:t>
             </a:r>
           </a:p>
         </p:txBody>
@@ -13354,25 +13342,25 @@
           <a:p xmlns:a="http://schemas.openxmlformats.org/drawingml/2006/main">
             <a:pPr algn="l">
               <a:buNone/>
-              <a:defRPr sz="1950" b="0">
-                <a:solidFill>
-                  <a:srgbClr val="AEBFCB"/>
-                </a:solidFill>
-                <a:latin typeface="Helvetica Neue"/>
-                <a:ea typeface="Helvetica Neue"/>
-                <a:cs typeface="Helvetica Neue"/>
-              </a:defRPr>
-            </a:pPr>
-            <a:r>
-              <a:rPr sz="1950" b="0">
-                <a:solidFill>
-                  <a:srgbClr val="AEBFCB"/>
-                </a:solidFill>
-                <a:latin typeface="Helvetica Neue"/>
-                <a:ea typeface="Helvetica Neue"/>
-                <a:cs typeface="Helvetica Neue"/>
-              </a:rPr>
-              <a:t>Server / Client Components</a:t>
+              <a:defRPr sz="1350" b="0">
+                <a:solidFill>
+                  <a:srgbClr val="B6C5CE"/>
+                </a:solidFill>
+                <a:latin typeface="Helvetica Neue"/>
+                <a:ea typeface="Helvetica Neue"/>
+                <a:cs typeface="Helvetica Neue"/>
+              </a:defRPr>
+            </a:pPr>
+            <a:r>
+              <a:rPr sz="1350" b="0">
+                <a:solidFill>
+                  <a:srgbClr val="B6C5CE"/>
+                </a:solidFill>
+                <a:latin typeface="Helvetica Neue"/>
+                <a:ea typeface="Helvetica Neue"/>
+                <a:cs typeface="Helvetica Neue"/>
+              </a:rPr>
+              <a:t>Verifikon dhe shmang dublikatën</a:t>
             </a:r>
           </a:p>
         </p:txBody>
@@ -13412,25 +13400,25 @@
           <a:p xmlns:a="http://schemas.openxmlformats.org/drawingml/2006/main">
             <a:pPr algn="l">
               <a:buNone/>
-              <a:defRPr sz="1950" b="0">
-                <a:solidFill>
-                  <a:srgbClr val="AEBFCB"/>
-                </a:solidFill>
-                <a:latin typeface="Helvetica Neue"/>
-                <a:ea typeface="Helvetica Neue"/>
-                <a:cs typeface="Helvetica Neue"/>
-              </a:defRPr>
-            </a:pPr>
-            <a:r>
-              <a:rPr sz="1950" b="0">
-                <a:solidFill>
-                  <a:srgbClr val="AEBFCB"/>
-                </a:solidFill>
-                <a:latin typeface="Helvetica Neue"/>
-                <a:ea typeface="Helvetica Neue"/>
-                <a:cs typeface="Helvetica Neue"/>
-              </a:rPr>
-              <a:t>RLS + rregullat e të dhënave</a:t>
+              <a:defRPr sz="1350" b="0">
+                <a:solidFill>
+                  <a:srgbClr val="B6C5CE"/>
+                </a:solidFill>
+                <a:latin typeface="Helvetica Neue"/>
+                <a:ea typeface="Helvetica Neue"/>
+                <a:cs typeface="Helvetica Neue"/>
+              </a:defRPr>
+            </a:pPr>
+            <a:r>
+              <a:rPr sz="1350" b="0">
+                <a:solidFill>
+                  <a:srgbClr val="B6C5CE"/>
+                </a:solidFill>
+                <a:latin typeface="Helvetica Neue"/>
+                <a:ea typeface="Helvetica Neue"/>
+                <a:cs typeface="Helvetica Neue"/>
+              </a:rPr>
+              <a:t>RLS zbaton lejet</a:t>
             </a:r>
           </a:p>
         </p:txBody>
@@ -13488,7 +13476,7 @@
                 <a:ea typeface="Helvetica Neue"/>
                 <a:cs typeface="Helvetica Neue"/>
               </a:rPr>
-              <a:t>Ku kontrollohet ndryshimi i numrit të vendeve?</a:t>
+              <a:t>Ku ndryshon disponueshmëria e vaktit ose statusi i porosisë?</a:t>
             </a:r>
           </a:p>
         </p:txBody>
@@ -13502,7 +13490,7 @@
           <p:nvPr/>
         </p:nvPicPr>
         <p:blipFill>
-          <a:blip xmlns:r="http://schemas.openxmlformats.org/officeDocument/2006/relationships" xmlns:a="http://schemas.openxmlformats.org/drawingml/2006/main" r:embed="R98ace120382a43e3"/>
+          <a:blip xmlns:r="http://schemas.openxmlformats.org/officeDocument/2006/relationships" xmlns:a="http://schemas.openxmlformats.org/drawingml/2006/main" r:embed="R70e85076b7a34c75"/>
           <a:stretch xmlns:a="http://schemas.openxmlformats.org/drawingml/2006/main"/>
         </p:blipFill>
         <p:spPr>
@@ -13713,7 +13701,7 @@
                 <a:ea typeface="Helvetica Neue"/>
                 <a:cs typeface="Helvetica Neue"/>
               </a:rPr>
-              <a:t>Telefoni kërkon. Sistemi verifikon.</a:t>
+              <a:t>Vetëm stafi ndryshon menunë dhe statusin</a:t>
             </a:r>
           </a:p>
         </p:txBody>
@@ -13903,25 +13891,25 @@
           <a:p xmlns:a="http://schemas.openxmlformats.org/drawingml/2006/main">
             <a:pPr algn="ctr">
               <a:buNone/>
-              <a:defRPr sz="2250" b="1">
-                <a:solidFill>
-                  <a:srgbClr val="63CDF2"/>
-                </a:solidFill>
-                <a:latin typeface="Helvetica Neue"/>
-                <a:ea typeface="Helvetica Neue"/>
-                <a:cs typeface="Helvetica Neue"/>
-              </a:defRPr>
-            </a:pPr>
-            <a:r>
-              <a:rPr sz="2250" b="1">
-                <a:solidFill>
-                  <a:srgbClr val="63CDF2"/>
-                </a:solidFill>
-                <a:latin typeface="Helvetica Neue"/>
-                <a:ea typeface="Helvetica Neue"/>
-                <a:cs typeface="Helvetica Neue"/>
-              </a:rPr>
-              <a:t>Ndrysho udhëtimin 42</a:t>
+              <a:defRPr sz="1350" b="1">
+                <a:solidFill>
+                  <a:srgbClr val="F5F7F9"/>
+                </a:solidFill>
+                <a:latin typeface="Helvetica Neue"/>
+                <a:ea typeface="Helvetica Neue"/>
+                <a:cs typeface="Helvetica Neue"/>
+              </a:defRPr>
+            </a:pPr>
+            <a:r>
+              <a:rPr sz="1350" b="1">
+                <a:solidFill>
+                  <a:srgbClr val="F5F7F9"/>
+                </a:solidFill>
+                <a:latin typeface="Helvetica Neue"/>
+                <a:ea typeface="Helvetica Neue"/>
+                <a:cs typeface="Helvetica Neue"/>
+              </a:rPr>
+              <a:t>Ndrysho statusin e porosisë #1042</a:t>
             </a:r>
           </a:p>
         </p:txBody>
@@ -14367,7 +14355,7 @@
                 <a:ea typeface="Helvetica Neue"/>
                 <a:cs typeface="Helvetica Neue"/>
               </a:rPr>
-              <a:t>A është ky pronari?</a:t>
+              <a:t>A është ky anëtar i stafit?</a:t>
             </a:r>
           </a:p>
         </p:txBody>
@@ -14541,7 +14529,7 @@
                 <a:ea typeface="Helvetica Neue"/>
                 <a:cs typeface="Helvetica Neue"/>
               </a:rPr>
-              <a:t>RLS + privilegjet e qasjes</a:t>
+              <a:t>RLS + roli i stafit</a:t>
             </a:r>
           </a:p>
         </p:txBody>
@@ -14613,7 +14601,7 @@
           <p:nvPr/>
         </p:nvPicPr>
         <p:blipFill>
-          <a:blip xmlns:r="http://schemas.openxmlformats.org/officeDocument/2006/relationships" xmlns:a="http://schemas.openxmlformats.org/drawingml/2006/main" r:embed="R5d14c913be434580"/>
+          <a:blip xmlns:r="http://schemas.openxmlformats.org/officeDocument/2006/relationships" xmlns:a="http://schemas.openxmlformats.org/drawingml/2006/main" r:embed="R33a1bf0371014d64"/>
           <a:stretch xmlns:a="http://schemas.openxmlformats.org/drawingml/2006/main"/>
         </p:blipFill>
         <p:spPr>
@@ -14980,7 +14968,7 @@
                 <a:ea typeface="Helvetica Neue"/>
                 <a:cs typeface="Helvetica Neue"/>
               </a:rPr>
-              <a:t>AAB RideShare</a:t>
+              <a:t>Restoranti Sofra</a:t>
             </a:r>
           </a:p>
         </p:txBody>
@@ -15096,7 +15084,7 @@
                 <a:ea typeface="Helvetica Neue"/>
                 <a:cs typeface="Helvetica Neue"/>
               </a:rPr>
-              <a:t>Pamje e ruajtur</a:t>
+              <a:t>Menu e ruajtur</a:t>
             </a:r>
           </a:p>
           <a:p xmlns:a="http://schemas.openxmlformats.org/drawingml/2006/main">
@@ -15120,7 +15108,7 @@
                 <a:ea typeface="Helvetica Neue"/>
                 <a:cs typeface="Helvetica Neue"/>
               </a:rPr>
-              <a:t>Përditësuar 07:10</a:t>
+              <a:t>Përditësuar 11:30</a:t>
             </a:r>
           </a:p>
         </p:txBody>
@@ -15190,49 +15178,49 @@
           <a:p xmlns:a="http://schemas.openxmlformats.org/drawingml/2006/main">
             <a:pPr algn="l">
               <a:buNone/>
-              <a:defRPr sz="1800" b="0">
-                <a:solidFill>
-                  <a:srgbClr val="F4F2EC"/>
-                </a:solidFill>
-                <a:latin typeface="Helvetica Neue"/>
-                <a:ea typeface="Helvetica Neue"/>
-                <a:cs typeface="Helvetica Neue"/>
-              </a:defRPr>
-            </a:pPr>
-            <a:r>
-              <a:rPr sz="1800" b="0">
-                <a:solidFill>
-                  <a:srgbClr val="F4F2EC"/>
-                </a:solidFill>
-                <a:latin typeface="Helvetica Neue"/>
-                <a:ea typeface="Helvetica Neue"/>
-                <a:cs typeface="Helvetica Neue"/>
-              </a:rPr>
-              <a:t>Konfirmimi kërkon</a:t>
+              <a:defRPr sz="1200" b="0">
+                <a:solidFill>
+                  <a:srgbClr val="B6C5CE"/>
+                </a:solidFill>
+                <a:latin typeface="Helvetica Neue"/>
+                <a:ea typeface="Helvetica Neue"/>
+                <a:cs typeface="Helvetica Neue"/>
+              </a:defRPr>
+            </a:pPr>
+            <a:r>
+              <a:rPr sz="1200" b="0">
+                <a:solidFill>
+                  <a:srgbClr val="B6C5CE"/>
+                </a:solidFill>
+                <a:latin typeface="Helvetica Neue"/>
+                <a:ea typeface="Helvetica Neue"/>
+                <a:cs typeface="Helvetica Neue"/>
+              </a:rPr>
+              <a:t>Mund të lexohet.</a:t>
             </a:r>
           </a:p>
           <a:p xmlns:a="http://schemas.openxmlformats.org/drawingml/2006/main">
             <a:pPr algn="l">
               <a:buNone/>
-              <a:defRPr sz="1800" b="0">
-                <a:solidFill>
-                  <a:srgbClr val="F4F2EC"/>
-                </a:solidFill>
-                <a:latin typeface="Helvetica Neue"/>
-                <a:ea typeface="Helvetica Neue"/>
-                <a:cs typeface="Helvetica Neue"/>
-              </a:defRPr>
-            </a:pPr>
-            <a:r>
-              <a:rPr sz="1800" b="0">
-                <a:solidFill>
-                  <a:srgbClr val="F4F2EC"/>
-                </a:solidFill>
-                <a:latin typeface="Helvetica Neue"/>
-                <a:ea typeface="Helvetica Neue"/>
-                <a:cs typeface="Helvetica Neue"/>
-              </a:rPr>
-              <a:t>lidhje me serverin.</a:t>
+              <a:defRPr sz="1200" b="0">
+                <a:solidFill>
+                  <a:srgbClr val="B6C5CE"/>
+                </a:solidFill>
+                <a:latin typeface="Helvetica Neue"/>
+                <a:ea typeface="Helvetica Neue"/>
+                <a:cs typeface="Helvetica Neue"/>
+              </a:defRPr>
+            </a:pPr>
+            <a:r>
+              <a:rPr sz="1200" b="0">
+                <a:solidFill>
+                  <a:srgbClr val="B6C5CE"/>
+                </a:solidFill>
+                <a:latin typeface="Helvetica Neue"/>
+                <a:ea typeface="Helvetica Neue"/>
+                <a:cs typeface="Helvetica Neue"/>
+              </a:rPr>
+              <a:t>MUND TË JETË E VJETRUAR</a:t>
             </a:r>
           </a:p>
         </p:txBody>
@@ -15774,7 +15762,7 @@
                 <a:ea typeface="Helvetica Neue"/>
                 <a:cs typeface="Helvetica Neue"/>
               </a:rPr>
-              <a:t>burime të përzgjedhura</a:t>
+              <a:t>menu e ruajtur</a:t>
             </a:r>
           </a:p>
         </p:txBody>
@@ -15832,7 +15820,7 @@
                 <a:ea typeface="Helvetica Neue"/>
                 <a:cs typeface="Helvetica Neue"/>
               </a:rPr>
-              <a:t>Çfarë mund të lexohet pa rrjet? Çfarë kërkon konfirmim?</a:t>
+              <a:t>Menuja lexohet offline. Porosia kërkon konfirmim nga serveri.</a:t>
             </a:r>
           </a:p>
         </p:txBody>
@@ -15846,7 +15834,7 @@
           <p:nvPr/>
         </p:nvPicPr>
         <p:blipFill>
-          <a:blip xmlns:r="http://schemas.openxmlformats.org/officeDocument/2006/relationships" xmlns:a="http://schemas.openxmlformats.org/drawingml/2006/main" r:embed="Rf8eaaf691b6349f2"/>
+          <a:blip xmlns:r="http://schemas.openxmlformats.org/officeDocument/2006/relationships" xmlns:a="http://schemas.openxmlformats.org/drawingml/2006/main" r:embed="Rfb48ce16e4d44311"/>
           <a:stretch xmlns:a="http://schemas.openxmlformats.org/drawingml/2006/main"/>
         </p:blipFill>
         <p:spPr>
@@ -16057,7 +16045,7 @@
                 <a:ea typeface="Helvetica Neue"/>
                 <a:cs typeface="Helvetica Neue"/>
               </a:rPr>
-              <a:t>Kërkesa nuk është konfirmim</a:t>
+              <a:t>Gjendja e porosisë</a:t>
             </a:r>
           </a:p>
         </p:txBody>
@@ -16115,7 +16103,7 @@
                 <a:ea typeface="Helvetica Neue"/>
                 <a:cs typeface="Helvetica Neue"/>
               </a:rPr>
-              <a:t>Dërgimi i pakonfirmuar</a:t>
+              <a:t>Statusi ndryshon vetëm me prova</a:t>
             </a:r>
           </a:p>
         </p:txBody>
@@ -16189,25 +16177,25 @@
           <a:p xmlns:a="http://schemas.openxmlformats.org/drawingml/2006/main">
             <a:pPr algn="ctr">
               <a:buNone/>
-              <a:defRPr sz="2250" b="1">
-                <a:solidFill>
-                  <a:srgbClr val="63CDF2"/>
-                </a:solidFill>
-                <a:latin typeface="Helvetica Neue"/>
-                <a:ea typeface="Helvetica Neue"/>
-                <a:cs typeface="Helvetica Neue"/>
-              </a:defRPr>
-            </a:pPr>
-            <a:r>
-              <a:rPr sz="2250" b="1">
-                <a:solidFill>
-                  <a:srgbClr val="63CDF2"/>
-                </a:solidFill>
-                <a:latin typeface="Helvetica Neue"/>
-                <a:ea typeface="Helvetica Neue"/>
-                <a:cs typeface="Helvetica Neue"/>
-              </a:rPr>
-              <a:t>Dërguar</a:t>
+              <a:defRPr sz="1500" b="1">
+                <a:solidFill>
+                  <a:srgbClr val="5DCEF2"/>
+                </a:solidFill>
+                <a:latin typeface="Helvetica Neue"/>
+                <a:ea typeface="Helvetica Neue"/>
+                <a:cs typeface="Helvetica Neue"/>
+              </a:defRPr>
+            </a:pPr>
+            <a:r>
+              <a:rPr sz="1500" b="1">
+                <a:solidFill>
+                  <a:srgbClr val="5DCEF2"/>
+                </a:solidFill>
+                <a:latin typeface="Helvetica Neue"/>
+                <a:ea typeface="Helvetica Neue"/>
+                <a:cs typeface="Helvetica Neue"/>
+              </a:rPr>
+              <a:t>Dërguar lokalisht</a:t>
             </a:r>
           </a:p>
         </p:txBody>
@@ -16299,7 +16287,7 @@
                 <a:ea typeface="Helvetica Neue"/>
                 <a:cs typeface="Helvetica Neue"/>
               </a:rPr>
-              <a:t>Në pritje</a:t>
+              <a:t>Marrë</a:t>
             </a:r>
           </a:p>
         </p:txBody>
@@ -16373,25 +16361,25 @@
           <a:p xmlns:a="http://schemas.openxmlformats.org/drawingml/2006/main">
             <a:pPr algn="ctr">
               <a:buNone/>
-              <a:defRPr sz="2250" b="1">
-                <a:solidFill>
-                  <a:srgbClr val="91DEBB"/>
-                </a:solidFill>
-                <a:latin typeface="Helvetica Neue"/>
-                <a:ea typeface="Helvetica Neue"/>
-                <a:cs typeface="Helvetica Neue"/>
-              </a:defRPr>
-            </a:pPr>
-            <a:r>
-              <a:rPr sz="2250" b="1">
-                <a:solidFill>
-                  <a:srgbClr val="91DEBB"/>
-                </a:solidFill>
-                <a:latin typeface="Helvetica Neue"/>
-                <a:ea typeface="Helvetica Neue"/>
-                <a:cs typeface="Helvetica Neue"/>
-              </a:rPr>
-              <a:t>Pranuar</a:t>
+              <a:defRPr sz="1575" b="1">
+                <a:solidFill>
+                  <a:srgbClr val="7FD3AA"/>
+                </a:solidFill>
+                <a:latin typeface="Helvetica Neue"/>
+                <a:ea typeface="Helvetica Neue"/>
+                <a:cs typeface="Helvetica Neue"/>
+              </a:defRPr>
+            </a:pPr>
+            <a:r>
+              <a:rPr sz="1575" b="1">
+                <a:solidFill>
+                  <a:srgbClr val="7FD3AA"/>
+                </a:solidFill>
+                <a:latin typeface="Helvetica Neue"/>
+                <a:ea typeface="Helvetica Neue"/>
+                <a:cs typeface="Helvetica Neue"/>
+              </a:rPr>
+              <a:t>Në përgatitje</a:t>
             </a:r>
           </a:p>
         </p:txBody>
@@ -16539,7 +16527,7 @@
                 <a:ea typeface="Helvetica Neue"/>
                 <a:cs typeface="Helvetica Neue"/>
               </a:rPr>
-              <a:t>Refuzuar / Anuluar</a:t>
+              <a:t>Gati</a:t>
             </a:r>
           </a:p>
         </p:txBody>
@@ -16597,7 +16585,7 @@
                 <a:ea typeface="Helvetica Neue"/>
                 <a:cs typeface="Helvetica Neue"/>
               </a:rPr>
-              <a:t>Pa përgjigje: dështim apo rezultat ende i panjohur?</a:t>
+              <a:t>Pa provë nga serveri: dështuar ose status i panjohur.</a:t>
             </a:r>
           </a:p>
         </p:txBody>
@@ -16611,7 +16599,7 @@
           <p:nvPr/>
         </p:nvPicPr>
         <p:blipFill>
-          <a:blip xmlns:r="http://schemas.openxmlformats.org/officeDocument/2006/relationships" xmlns:a="http://schemas.openxmlformats.org/drawingml/2006/main" r:embed="R349646eef29c4cd9"/>
+          <a:blip xmlns:r="http://schemas.openxmlformats.org/officeDocument/2006/relationships" xmlns:a="http://schemas.openxmlformats.org/drawingml/2006/main" r:embed="Rda8ee1ef3d224ab8"/>
           <a:stretch xmlns:a="http://schemas.openxmlformats.org/drawingml/2006/main"/>
         </p:blipFill>
         <p:spPr>
@@ -17036,25 +17024,25 @@
           <a:p xmlns:a="http://schemas.openxmlformats.org/drawingml/2006/main">
             <a:pPr algn="l">
               <a:buNone/>
-              <a:defRPr sz="2400" b="0">
-                <a:solidFill>
-                  <a:srgbClr val="AEBFCB"/>
-                </a:solidFill>
-                <a:latin typeface="Helvetica Neue"/>
-                <a:ea typeface="Helvetica Neue"/>
-                <a:cs typeface="Helvetica Neue"/>
-              </a:defRPr>
-            </a:pPr>
-            <a:r>
-              <a:rPr sz="2400" b="0">
-                <a:solidFill>
-                  <a:srgbClr val="AEBFCB"/>
-                </a:solidFill>
-                <a:latin typeface="Helvetica Neue"/>
-                <a:ea typeface="Helvetica Neue"/>
-                <a:cs typeface="Helvetica Neue"/>
-              </a:rPr>
-              <a:t>Supozimin</a:t>
+              <a:defRPr sz="1500" b="0">
+                <a:solidFill>
+                  <a:srgbClr val="B6C5CE"/>
+                </a:solidFill>
+                <a:latin typeface="Helvetica Neue"/>
+                <a:ea typeface="Helvetica Neue"/>
+                <a:cs typeface="Helvetica Neue"/>
+              </a:defRPr>
+            </a:pPr>
+            <a:r>
+              <a:rPr sz="1500" b="0">
+                <a:solidFill>
+                  <a:srgbClr val="B6C5CE"/>
+                </a:solidFill>
+                <a:latin typeface="Helvetica Neue"/>
+                <a:ea typeface="Helvetica Neue"/>
+                <a:cs typeface="Helvetica Neue"/>
+              </a:rPr>
+              <a:t>Identitetin e porosisë</a:t>
             </a:r>
           </a:p>
         </p:txBody>
@@ -17094,25 +17082,25 @@
           <a:p xmlns:a="http://schemas.openxmlformats.org/drawingml/2006/main">
             <a:pPr algn="l">
               <a:buNone/>
-              <a:defRPr sz="2400" b="0">
-                <a:solidFill>
-                  <a:srgbClr val="AEBFCB"/>
-                </a:solidFill>
-                <a:latin typeface="Helvetica Neue"/>
-                <a:ea typeface="Helvetica Neue"/>
-                <a:cs typeface="Helvetica Neue"/>
-              </a:defRPr>
-            </a:pPr>
-            <a:r>
-              <a:rPr sz="2400" b="0">
-                <a:solidFill>
-                  <a:srgbClr val="AEBFCB"/>
-                </a:solidFill>
-                <a:latin typeface="Helvetica Neue"/>
-                <a:ea typeface="Helvetica Neue"/>
-                <a:cs typeface="Helvetica Neue"/>
-              </a:rPr>
-              <a:t>Vendimin</a:t>
+              <a:defRPr sz="1500" b="0">
+                <a:solidFill>
+                  <a:srgbClr val="B6C5CE"/>
+                </a:solidFill>
+                <a:latin typeface="Helvetica Neue"/>
+                <a:ea typeface="Helvetica Neue"/>
+                <a:cs typeface="Helvetica Neue"/>
+              </a:defRPr>
+            </a:pPr>
+            <a:r>
+              <a:rPr sz="1500" b="0">
+                <a:solidFill>
+                  <a:srgbClr val="B6C5CE"/>
+                </a:solidFill>
+                <a:latin typeface="Helvetica Neue"/>
+                <a:ea typeface="Helvetica Neue"/>
+                <a:cs typeface="Helvetica Neue"/>
+              </a:rPr>
+              <a:t>Disponueshmërinë</a:t>
             </a:r>
           </a:p>
         </p:txBody>
@@ -17152,25 +17140,25 @@
           <a:p xmlns:a="http://schemas.openxmlformats.org/drawingml/2006/main">
             <a:pPr algn="l">
               <a:buNone/>
-              <a:defRPr sz="2325" b="0">
-                <a:solidFill>
-                  <a:srgbClr val="AEBFCB"/>
-                </a:solidFill>
-                <a:latin typeface="Helvetica Neue"/>
-                <a:ea typeface="Helvetica Neue"/>
-                <a:cs typeface="Helvetica Neue"/>
-              </a:defRPr>
-            </a:pPr>
-            <a:r>
-              <a:rPr sz="2325" b="0">
-                <a:solidFill>
-                  <a:srgbClr val="AEBFCB"/>
-                </a:solidFill>
-                <a:latin typeface="Helvetica Neue"/>
-                <a:ea typeface="Helvetica Neue"/>
-                <a:cs typeface="Helvetica Neue"/>
-              </a:rPr>
-              <a:t>Kundërshembullin</a:t>
+              <a:defRPr sz="1425" b="0">
+                <a:solidFill>
+                  <a:srgbClr val="B6C5CE"/>
+                </a:solidFill>
+                <a:latin typeface="Helvetica Neue"/>
+                <a:ea typeface="Helvetica Neue"/>
+                <a:cs typeface="Helvetica Neue"/>
+              </a:defRPr>
+            </a:pPr>
+            <a:r>
+              <a:rPr sz="1425" b="0">
+                <a:solidFill>
+                  <a:srgbClr val="B6C5CE"/>
+                </a:solidFill>
+                <a:latin typeface="Helvetica Neue"/>
+                <a:ea typeface="Helvetica Neue"/>
+                <a:cs typeface="Helvetica Neue"/>
+              </a:rPr>
+              <a:t>Riprovimin pa dublikatë</a:t>
             </a:r>
           </a:p>
         </p:txBody>
@@ -17286,7 +17274,7 @@
                 <a:ea typeface="Helvetica Neue"/>
                 <a:cs typeface="Helvetica Neue"/>
               </a:rPr>
-              <a:t>Çfarë po supozon zgjidhja që propozoi AI?</a:t>
+              <a:t>Çfarë supozon AI për identitetin, disponueshmërinë dhe retry-t?</a:t>
             </a:r>
           </a:p>
         </p:txBody>
@@ -17300,7 +17288,7 @@
           <p:nvPr/>
         </p:nvPicPr>
         <p:blipFill>
-          <a:blip xmlns:r="http://schemas.openxmlformats.org/officeDocument/2006/relationships" xmlns:a="http://schemas.openxmlformats.org/drawingml/2006/main" r:embed="Rc08b661624bd4359"/>
+          <a:blip xmlns:r="http://schemas.openxmlformats.org/officeDocument/2006/relationships" xmlns:a="http://schemas.openxmlformats.org/drawingml/2006/main" r:embed="Rdec5b89e0d3649d7"/>
           <a:stretch xmlns:a="http://schemas.openxmlformats.org/drawingml/2006/main"/>
         </p:blipFill>
         <p:spPr>
@@ -17551,25 +17539,25 @@
           <a:p xmlns:a="http://schemas.openxmlformats.org/drawingml/2006/main">
             <a:pPr algn="l">
               <a:buNone/>
-              <a:defRPr sz="3525" b="0">
-                <a:solidFill>
-                  <a:srgbClr val="AEBFCB"/>
-                </a:solidFill>
-                <a:latin typeface="Helvetica Neue"/>
-                <a:ea typeface="Helvetica Neue"/>
-                <a:cs typeface="Helvetica Neue"/>
-              </a:defRPr>
-            </a:pPr>
-            <a:r>
-              <a:rPr sz="3525" b="0">
-                <a:solidFill>
-                  <a:srgbClr val="AEBFCB"/>
-                </a:solidFill>
-                <a:latin typeface="Helvetica Neue"/>
-                <a:ea typeface="Helvetica Neue"/>
-                <a:cs typeface="Helvetica Neue"/>
-              </a:rPr>
-              <a:t>“Ndërto RideShare.”</a:t>
+              <a:defRPr sz="1650" b="0">
+                <a:solidFill>
+                  <a:srgbClr val="B6C5CE"/>
+                </a:solidFill>
+                <a:latin typeface="Helvetica Neue"/>
+                <a:ea typeface="Helvetica Neue"/>
+                <a:cs typeface="Helvetica Neue"/>
+              </a:defRPr>
+            </a:pPr>
+            <a:r>
+              <a:rPr sz="1650" b="0">
+                <a:solidFill>
+                  <a:srgbClr val="B6C5CE"/>
+                </a:solidFill>
+                <a:latin typeface="Helvetica Neue"/>
+                <a:ea typeface="Helvetica Neue"/>
+                <a:cs typeface="Helvetica Neue"/>
+              </a:rPr>
+              <a:t>“Krijo operacionin e porosisë për një restorant. Përdor një idempotency key që retry-t të mos krijojnë dublikatë.”</a:t>
             </a:r>
           </a:p>
         </p:txBody>
@@ -17715,7 +17703,7 @@
                 <a:ea typeface="Helvetica Neue"/>
                 <a:cs typeface="Helvetica Neue"/>
               </a:rPr>
-              <a:t>Kërko një vend</a:t>
+              <a:t>Krijo porosinë</a:t>
             </a:r>
           </a:p>
         </p:txBody>
@@ -17813,25 +17801,25 @@
           <a:p xmlns:a="http://schemas.openxmlformats.org/drawingml/2006/main">
             <a:pPr algn="l">
               <a:buNone/>
-              <a:defRPr sz="2400" b="0">
-                <a:solidFill>
-                  <a:srgbClr val="F4F2EC"/>
-                </a:solidFill>
-                <a:latin typeface="Helvetica Neue"/>
-                <a:ea typeface="Helvetica Neue"/>
-                <a:cs typeface="Helvetica Neue"/>
-              </a:defRPr>
-            </a:pPr>
-            <a:r>
-              <a:rPr sz="2400" b="0">
-                <a:solidFill>
-                  <a:srgbClr val="F4F2EC"/>
-                </a:solidFill>
-                <a:latin typeface="Helvetica Neue"/>
-                <a:ea typeface="Helvetica Neue"/>
-                <a:cs typeface="Helvetica Neue"/>
-              </a:rPr>
-              <a:t>Identitet i verifikuar, pa dublikatë</a:t>
+              <a:defRPr sz="1425" b="0">
+                <a:solidFill>
+                  <a:srgbClr val="F5F7F9"/>
+                </a:solidFill>
+                <a:latin typeface="Helvetica Neue"/>
+                <a:ea typeface="Helvetica Neue"/>
+                <a:cs typeface="Helvetica Neue"/>
+              </a:defRPr>
+            </a:pPr>
+            <a:r>
+              <a:rPr sz="1425" b="0">
+                <a:solidFill>
+                  <a:srgbClr val="F5F7F9"/>
+                </a:solidFill>
+                <a:latin typeface="Helvetica Neue"/>
+                <a:ea typeface="Helvetica Neue"/>
+                <a:cs typeface="Helvetica Neue"/>
+              </a:rPr>
+              <a:t>Sesioni jep klientin. Menuja verifikon disponueshmërinë.</a:t>
             </a:r>
           </a:p>
         </p:txBody>
@@ -17929,25 +17917,25 @@
           <a:p xmlns:a="http://schemas.openxmlformats.org/drawingml/2006/main">
             <a:pPr algn="l">
               <a:buNone/>
-              <a:defRPr sz="2400" b="0">
-                <a:solidFill>
-                  <a:srgbClr val="F4F2EC"/>
-                </a:solidFill>
-                <a:latin typeface="Helvetica Neue"/>
-                <a:ea typeface="Helvetica Neue"/>
-                <a:cs typeface="Helvetica Neue"/>
-              </a:defRPr>
-            </a:pPr>
-            <a:r>
-              <a:rPr sz="2400" b="0">
-                <a:solidFill>
-                  <a:srgbClr val="F4F2EC"/>
-                </a:solidFill>
-                <a:latin typeface="Helvetica Neue"/>
-                <a:ea typeface="Helvetica Neue"/>
-                <a:cs typeface="Helvetica Neue"/>
-              </a:rPr>
-              <a:t>Përsëritje, qasje e palejuar</a:t>
+              <a:defRPr sz="1350" b="0">
+                <a:solidFill>
+                  <a:srgbClr val="F5F7F9"/>
+                </a:solidFill>
+                <a:latin typeface="Helvetica Neue"/>
+                <a:ea typeface="Helvetica Neue"/>
+                <a:cs typeface="Helvetica Neue"/>
+              </a:defRPr>
+            </a:pPr>
+            <a:r>
+              <a:rPr sz="1350" b="0">
+                <a:solidFill>
+                  <a:srgbClr val="F5F7F9"/>
+                </a:solidFill>
+                <a:latin typeface="Helvetica Neue"/>
+                <a:ea typeface="Helvetica Neue"/>
+                <a:cs typeface="Helvetica Neue"/>
+              </a:rPr>
+              <a:t>I njëjti retry kthen të njëjtën porosi. Qasja pa leje dështon.</a:t>
             </a:r>
           </a:p>
         </p:txBody>
@@ -18019,7 +18007,7 @@
           <p:nvPr/>
         </p:nvPicPr>
         <p:blipFill>
-          <a:blip xmlns:r="http://schemas.openxmlformats.org/officeDocument/2006/relationships" xmlns:a="http://schemas.openxmlformats.org/drawingml/2006/main" r:embed="R2faaef6cf63549da"/>
+          <a:blip xmlns:r="http://schemas.openxmlformats.org/officeDocument/2006/relationships" xmlns:a="http://schemas.openxmlformats.org/drawingml/2006/main" r:embed="Rf5145ec025874654"/>
           <a:stretch xmlns:a="http://schemas.openxmlformats.org/drawingml/2006/main"/>
         </p:blipFill>
         <p:spPr>
@@ -18247,7 +18235,7 @@
         </p:xfrm>
         <a:graphic xmlns:a="http://schemas.openxmlformats.org/drawingml/2006/main">
           <a:graphicData uri="http://schemas.openxmlformats.org/drawingml/2006/chart">
-            <c:chart xmlns:r="http://schemas.openxmlformats.org/officeDocument/2006/relationships" xmlns:c="http://schemas.openxmlformats.org/drawingml/2006/chart" r:id="Ra5480f1dec004572"/>
+            <c:chart xmlns:r="http://schemas.openxmlformats.org/officeDocument/2006/relationships" xmlns:c="http://schemas.openxmlformats.org/drawingml/2006/chart" r:id="R162a29531a2142b9"/>
           </a:graphicData>
         </a:graphic>
       </p:graphicFrame>
@@ -18286,25 +18274,25 @@
           <a:p xmlns:a="http://schemas.openxmlformats.org/drawingml/2006/main">
             <a:pPr algn="l">
               <a:buNone/>
-              <a:defRPr sz="2475" b="0">
-                <a:solidFill>
-                  <a:srgbClr val="AEBFCB"/>
-                </a:solidFill>
-                <a:latin typeface="Helvetica Neue"/>
-                <a:ea typeface="Helvetica Neue"/>
-                <a:cs typeface="Helvetica Neue"/>
-              </a:defRPr>
-            </a:pPr>
-            <a:r>
-              <a:rPr sz="2475" b="0">
-                <a:solidFill>
-                  <a:srgbClr val="AEBFCB"/>
-                </a:solidFill>
-                <a:latin typeface="Helvetica Neue"/>
-                <a:ea typeface="Helvetica Neue"/>
-                <a:cs typeface="Helvetica Neue"/>
-              </a:rPr>
-              <a:t>Rubrika publikohet para dorëzimit.</a:t>
+              <a:defRPr sz="1575" b="0">
+                <a:solidFill>
+                  <a:srgbClr val="B6C5CE"/>
+                </a:solidFill>
+                <a:latin typeface="Helvetica Neue"/>
+                <a:ea typeface="Helvetica Neue"/>
+                <a:cs typeface="Helvetica Neue"/>
+              </a:defRPr>
+            </a:pPr>
+            <a:r>
+              <a:rPr sz="1575" b="0">
+                <a:solidFill>
+                  <a:srgbClr val="B6C5CE"/>
+                </a:solidFill>
+                <a:latin typeface="Helvetica Neue"/>
+                <a:ea typeface="Helvetica Neue"/>
+                <a:cs typeface="Helvetica Neue"/>
+              </a:rPr>
+              <a:t>Provat përfshijnë vakt të padisponueshëm, rrjet të humbur dhe editim të palejuar të menusë.</a:t>
             </a:r>
           </a:p>
         </p:txBody>
@@ -18318,7 +18306,7 @@
           <p:nvPr/>
         </p:nvPicPr>
         <p:blipFill>
-          <a:blip xmlns:r="http://schemas.openxmlformats.org/officeDocument/2006/relationships" xmlns:a="http://schemas.openxmlformats.org/drawingml/2006/main" r:embed="Rb66087b0c8c04312"/>
+          <a:blip xmlns:r="http://schemas.openxmlformats.org/officeDocument/2006/relationships" xmlns:a="http://schemas.openxmlformats.org/drawingml/2006/main" r:embed="Rba37aad4e2d84e70"/>
           <a:stretch xmlns:a="http://schemas.openxmlformats.org/drawingml/2006/main"/>
         </p:blipFill>
         <p:spPr>
@@ -19091,25 +19079,25 @@
           <a:p xmlns:a="http://schemas.openxmlformats.org/drawingml/2006/main">
             <a:pPr algn="l">
               <a:buNone/>
-              <a:defRPr sz="2700" b="0">
-                <a:solidFill>
-                  <a:srgbClr val="F4F2EC"/>
-                </a:solidFill>
-                <a:latin typeface="Helvetica Neue"/>
-                <a:ea typeface="Helvetica Neue"/>
-                <a:cs typeface="Helvetica Neue"/>
-              </a:defRPr>
-            </a:pPr>
-            <a:r>
-              <a:rPr sz="2700" b="0">
-                <a:solidFill>
-                  <a:srgbClr val="F4F2EC"/>
-                </a:solidFill>
-                <a:latin typeface="Helvetica Neue"/>
-                <a:ea typeface="Helvetica Neue"/>
-                <a:cs typeface="Helvetica Neue"/>
-              </a:rPr>
-              <a:t>Pastaj: pyetjet e jurisë dhe mbrojtja individuale</a:t>
+              <a:defRPr sz="1650" b="0">
+                <a:solidFill>
+                  <a:srgbClr val="F5F7F9"/>
+                </a:solidFill>
+                <a:latin typeface="Helvetica Neue"/>
+                <a:ea typeface="Helvetica Neue"/>
+                <a:cs typeface="Helvetica Neue"/>
+              </a:defRPr>
+            </a:pPr>
+            <a:r>
+              <a:rPr sz="1650" b="0">
+                <a:solidFill>
+                  <a:srgbClr val="F5F7F9"/>
+                </a:solidFill>
+                <a:latin typeface="Helvetica Neue"/>
+                <a:ea typeface="Helvetica Neue"/>
+                <a:cs typeface="Helvetica Neue"/>
+              </a:rPr>
+              <a:t>Vakt i padisponueshëm, rrjet i humbur ose editim i palejuar i menusë.</a:t>
             </a:r>
           </a:p>
         </p:txBody>
@@ -19181,7 +19169,7 @@
           <p:nvPr/>
         </p:nvPicPr>
         <p:blipFill>
-          <a:blip xmlns:r="http://schemas.openxmlformats.org/officeDocument/2006/relationships" xmlns:a="http://schemas.openxmlformats.org/drawingml/2006/main" r:embed="R6283e919e6d64c50"/>
+          <a:blip xmlns:r="http://schemas.openxmlformats.org/officeDocument/2006/relationships" xmlns:a="http://schemas.openxmlformats.org/drawingml/2006/main" r:embed="R96ff5aa3f01248a8"/>
           <a:stretch xmlns:a="http://schemas.openxmlformats.org/drawingml/2006/main"/>
         </p:blipFill>
         <p:spPr>
@@ -19374,25 +19362,25 @@
           <a:p xmlns:a="http://schemas.openxmlformats.org/drawingml/2006/main">
             <a:pPr algn="l">
               <a:buNone/>
-              <a:defRPr sz="3825" b="1">
-                <a:solidFill>
-                  <a:srgbClr val="F4F2EC"/>
-                </a:solidFill>
-                <a:latin typeface="Helvetica Neue"/>
-                <a:ea typeface="Helvetica Neue"/>
-                <a:cs typeface="Helvetica Neue"/>
-              </a:defRPr>
-            </a:pPr>
-            <a:r>
-              <a:rPr sz="3825" b="1">
-                <a:solidFill>
-                  <a:srgbClr val="F4F2EC"/>
-                </a:solidFill>
-                <a:latin typeface="Helvetica Neue"/>
-                <a:ea typeface="Helvetica Neue"/>
-                <a:cs typeface="Helvetica Neue"/>
-              </a:rPr>
-              <a:t>Ndryshimi juaj, në telefon</a:t>
+              <a:defRPr sz="3000" b="1">
+                <a:solidFill>
+                  <a:srgbClr val="F5F7F9"/>
+                </a:solidFill>
+                <a:latin typeface="Helvetica Neue"/>
+                <a:ea typeface="Helvetica Neue"/>
+                <a:cs typeface="Helvetica Neue"/>
+              </a:defRPr>
+            </a:pPr>
+            <a:r>
+              <a:rPr sz="3000" b="1">
+                <a:solidFill>
+                  <a:srgbClr val="F5F7F9"/>
+                </a:solidFill>
+                <a:latin typeface="Helvetica Neue"/>
+                <a:ea typeface="Helvetica Neue"/>
+                <a:cs typeface="Helvetica Neue"/>
+              </a:rPr>
+              <a:t>Demo live: porosia bëhet “Gati”</a:t>
             </a:r>
           </a:p>
         </p:txBody>
@@ -19413,8 +19401,8 @@
         </p:nvSpPr>
         <p:spPr>
           <a:xfrm xmlns:a="http://schemas.openxmlformats.org/drawingml/2006/main">
-            <a:off x="647700" y="1971675"/>
-            <a:ext cx="10572750" cy="447675"/>
+            <a:off x="647700" y="1885950"/>
+            <a:ext cx="7620000" cy="447675"/>
           </a:xfrm>
           <a:prstGeom xmlns:a="http://schemas.openxmlformats.org/drawingml/2006/main" prst="rect">
             <a:avLst/>
@@ -19432,25 +19420,25 @@
           <a:p xmlns:a="http://schemas.openxmlformats.org/drawingml/2006/main">
             <a:pPr algn="l">
               <a:buNone/>
-              <a:defRPr sz="2025" b="1">
-                <a:solidFill>
-                  <a:srgbClr val="63CDF2"/>
-                </a:solidFill>
-                <a:latin typeface="Helvetica Neue"/>
-                <a:ea typeface="Helvetica Neue"/>
-                <a:cs typeface="Helvetica Neue"/>
-              </a:defRPr>
-            </a:pPr>
-            <a:r>
-              <a:rPr sz="2025" b="1">
-                <a:solidFill>
-                  <a:srgbClr val="63CDF2"/>
-                </a:solidFill>
-                <a:latin typeface="Helvetica Neue"/>
-                <a:ea typeface="Helvetica Neue"/>
-                <a:cs typeface="Helvetica Neue"/>
-              </a:rPr>
-              <a:t>JAVA 2: PUBLIKIMI I PARË</a:t>
+              <a:defRPr sz="1650" b="1">
+                <a:solidFill>
+                  <a:srgbClr val="5DCEF2"/>
+                </a:solidFill>
+                <a:latin typeface="Helvetica Neue"/>
+                <a:ea typeface="Helvetica Neue"/>
+                <a:cs typeface="Helvetica Neue"/>
+              </a:defRPr>
+            </a:pPr>
+            <a:r>
+              <a:rPr sz="1650" b="1">
+                <a:solidFill>
+                  <a:srgbClr val="5DCEF2"/>
+                </a:solidFill>
+                <a:latin typeface="Helvetica Neue"/>
+                <a:ea typeface="Helvetica Neue"/>
+                <a:cs typeface="Helvetica Neue"/>
+              </a:rPr>
+              <a:t>QR I DEMONSTRIMIT — nuk regjistron pjesëmarrjen</a:t>
             </a:r>
           </a:p>
         </p:txBody>
@@ -19471,44 +19459,44 @@
         </p:nvSpPr>
         <p:spPr>
           <a:xfrm xmlns:a="http://schemas.openxmlformats.org/drawingml/2006/main">
-            <a:off x="685800" y="2867025"/>
-            <a:ext cx="2362200" cy="666750"/>
-          </a:xfrm>
-          <a:prstGeom xmlns:a="http://schemas.openxmlformats.org/drawingml/2006/main" prst="rect">
-            <a:avLst/>
-          </a:prstGeom>
-          <a:noFill xmlns:a="http://schemas.openxmlformats.org/drawingml/2006/main"/>
-          <a:ln xmlns:a="http://schemas.openxmlformats.org/drawingml/2006/main" w="0">
-            <a:noFill/>
-          </a:ln>
-        </p:spPr>
-        <p:txBody>
-          <a:bodyPr xmlns:a="http://schemas.openxmlformats.org/drawingml/2006/main" wrap="square" lIns="0" tIns="0" rIns="0" bIns="0" anchor="ctr">
-            <a:noAutofit/>
-          </a:bodyPr>
-          <a:lstStyle xmlns:a="http://schemas.openxmlformats.org/drawingml/2006/main"/>
-          <a:p xmlns:a="http://schemas.openxmlformats.org/drawingml/2006/main">
-            <a:pPr algn="l">
-              <a:buNone/>
-              <a:defRPr sz="3675" b="1">
-                <a:solidFill>
-                  <a:srgbClr val="F4F2EC"/>
-                </a:solidFill>
-                <a:latin typeface="Helvetica Neue"/>
-                <a:ea typeface="Helvetica Neue"/>
-                <a:cs typeface="Helvetica Neue"/>
-              </a:defRPr>
-            </a:pPr>
-            <a:r>
-              <a:rPr sz="3675" b="1">
-                <a:solidFill>
-                  <a:srgbClr val="F4F2EC"/>
-                </a:solidFill>
-                <a:latin typeface="Helvetica Neue"/>
-                <a:ea typeface="Helvetica Neue"/>
-                <a:cs typeface="Helvetica Neue"/>
-              </a:rPr>
-              <a:t>Repo</a:t>
+            <a:off x="685800" y="2857500"/>
+            <a:ext cx="1476375" cy="523875"/>
+          </a:xfrm>
+          <a:prstGeom xmlns:a="http://schemas.openxmlformats.org/drawingml/2006/main" prst="rect">
+            <a:avLst/>
+          </a:prstGeom>
+          <a:noFill xmlns:a="http://schemas.openxmlformats.org/drawingml/2006/main"/>
+          <a:ln xmlns:a="http://schemas.openxmlformats.org/drawingml/2006/main" w="0">
+            <a:noFill/>
+          </a:ln>
+        </p:spPr>
+        <p:txBody>
+          <a:bodyPr xmlns:a="http://schemas.openxmlformats.org/drawingml/2006/main" wrap="square" lIns="0" tIns="0" rIns="0" bIns="0" anchor="ctr">
+            <a:noAutofit/>
+          </a:bodyPr>
+          <a:lstStyle xmlns:a="http://schemas.openxmlformats.org/drawingml/2006/main"/>
+          <a:p xmlns:a="http://schemas.openxmlformats.org/drawingml/2006/main">
+            <a:pPr algn="ctr">
+              <a:buNone/>
+              <a:defRPr sz="2250" b="1">
+                <a:solidFill>
+                  <a:srgbClr val="5DCEF2"/>
+                </a:solidFill>
+                <a:latin typeface="Helvetica Neue"/>
+                <a:ea typeface="Helvetica Neue"/>
+                <a:cs typeface="Helvetica Neue"/>
+              </a:defRPr>
+            </a:pPr>
+            <a:r>
+              <a:rPr sz="2250" b="1">
+                <a:solidFill>
+                  <a:srgbClr val="5DCEF2"/>
+                </a:solidFill>
+                <a:latin typeface="Helvetica Neue"/>
+                <a:ea typeface="Helvetica Neue"/>
+                <a:cs typeface="Helvetica Neue"/>
+              </a:rPr>
+              <a:t>Menu</a:t>
             </a:r>
           </a:p>
         </p:txBody>
@@ -19529,44 +19517,44 @@
         </p:nvSpPr>
         <p:spPr>
           <a:xfrm xmlns:a="http://schemas.openxmlformats.org/drawingml/2006/main">
-            <a:off x="685800" y="3829050"/>
-            <a:ext cx="2438400" cy="504825"/>
-          </a:xfrm>
-          <a:prstGeom xmlns:a="http://schemas.openxmlformats.org/drawingml/2006/main" prst="rect">
-            <a:avLst/>
-          </a:prstGeom>
-          <a:noFill xmlns:a="http://schemas.openxmlformats.org/drawingml/2006/main"/>
-          <a:ln xmlns:a="http://schemas.openxmlformats.org/drawingml/2006/main" w="0">
-            <a:noFill/>
-          </a:ln>
-        </p:spPr>
-        <p:txBody>
-          <a:bodyPr xmlns:a="http://schemas.openxmlformats.org/drawingml/2006/main" wrap="square" lIns="0" tIns="0" rIns="0" bIns="0" anchor="ctr">
-            <a:noAutofit/>
-          </a:bodyPr>
-          <a:lstStyle xmlns:a="http://schemas.openxmlformats.org/drawingml/2006/main"/>
-          <a:p xmlns:a="http://schemas.openxmlformats.org/drawingml/2006/main">
-            <a:pPr algn="l">
-              <a:buNone/>
-              <a:defRPr sz="2100" b="0">
-                <a:solidFill>
-                  <a:srgbClr val="AEBFCB"/>
-                </a:solidFill>
-                <a:latin typeface="Helvetica Neue"/>
-                <a:ea typeface="Helvetica Neue"/>
-                <a:cs typeface="Helvetica Neue"/>
-              </a:defRPr>
-            </a:pPr>
-            <a:r>
-              <a:rPr sz="2100" b="0">
-                <a:solidFill>
-                  <a:srgbClr val="AEBFCB"/>
-                </a:solidFill>
-                <a:latin typeface="Helvetica Neue"/>
-                <a:ea typeface="Helvetica Neue"/>
-                <a:cs typeface="Helvetica Neue"/>
-              </a:rPr>
-              <a:t>0–10 min</a:t>
+            <a:off x="685800" y="3476625"/>
+            <a:ext cx="1476375" cy="409575"/>
+          </a:xfrm>
+          <a:prstGeom xmlns:a="http://schemas.openxmlformats.org/drawingml/2006/main" prst="rect">
+            <a:avLst/>
+          </a:prstGeom>
+          <a:noFill xmlns:a="http://schemas.openxmlformats.org/drawingml/2006/main"/>
+          <a:ln xmlns:a="http://schemas.openxmlformats.org/drawingml/2006/main" w="0">
+            <a:noFill/>
+          </a:ln>
+        </p:spPr>
+        <p:txBody>
+          <a:bodyPr xmlns:a="http://schemas.openxmlformats.org/drawingml/2006/main" wrap="square" lIns="0" tIns="0" rIns="0" bIns="0" anchor="ctr">
+            <a:noAutofit/>
+          </a:bodyPr>
+          <a:lstStyle xmlns:a="http://schemas.openxmlformats.org/drawingml/2006/main"/>
+          <a:p xmlns:a="http://schemas.openxmlformats.org/drawingml/2006/main">
+            <a:pPr algn="ctr">
+              <a:buNone/>
+              <a:defRPr sz="1200" b="0">
+                <a:solidFill>
+                  <a:srgbClr val="B6C5CE"/>
+                </a:solidFill>
+                <a:latin typeface="Helvetica Neue"/>
+                <a:ea typeface="Helvetica Neue"/>
+                <a:cs typeface="Helvetica Neue"/>
+              </a:defRPr>
+            </a:pPr>
+            <a:r>
+              <a:rPr sz="1200" b="0">
+                <a:solidFill>
+                  <a:srgbClr val="B6C5CE"/>
+                </a:solidFill>
+                <a:latin typeface="Helvetica Neue"/>
+                <a:ea typeface="Helvetica Neue"/>
+                <a:cs typeface="Helvetica Neue"/>
+              </a:rPr>
+              <a:t>Zgjidh vaktin</a:t>
             </a:r>
           </a:p>
         </p:txBody>
@@ -19587,8 +19575,8 @@
         </p:nvSpPr>
         <p:spPr>
           <a:xfrm xmlns:a="http://schemas.openxmlformats.org/drawingml/2006/main">
-            <a:off x="2933700" y="3124200"/>
-            <a:ext cx="304800" cy="171450"/>
+            <a:off x="2276475" y="3028950"/>
+            <a:ext cx="266700" cy="171450"/>
           </a:xfrm>
           <a:prstGeom xmlns:a="http://schemas.openxmlformats.org/drawingml/2006/main" prst="rightArrow">
             <a:avLst/>
@@ -19617,44 +19605,44 @@
         </p:nvSpPr>
         <p:spPr>
           <a:xfrm xmlns:a="http://schemas.openxmlformats.org/drawingml/2006/main">
-            <a:off x="3448050" y="2867025"/>
-            <a:ext cx="2362200" cy="666750"/>
-          </a:xfrm>
-          <a:prstGeom xmlns:a="http://schemas.openxmlformats.org/drawingml/2006/main" prst="rect">
-            <a:avLst/>
-          </a:prstGeom>
-          <a:noFill xmlns:a="http://schemas.openxmlformats.org/drawingml/2006/main"/>
-          <a:ln xmlns:a="http://schemas.openxmlformats.org/drawingml/2006/main" w="0">
-            <a:noFill/>
-          </a:ln>
-        </p:spPr>
-        <p:txBody>
-          <a:bodyPr xmlns:a="http://schemas.openxmlformats.org/drawingml/2006/main" wrap="square" lIns="0" tIns="0" rIns="0" bIns="0" anchor="ctr">
-            <a:noAutofit/>
-          </a:bodyPr>
-          <a:lstStyle xmlns:a="http://schemas.openxmlformats.org/drawingml/2006/main"/>
-          <a:p xmlns:a="http://schemas.openxmlformats.org/drawingml/2006/main">
-            <a:pPr algn="l">
-              <a:buNone/>
-              <a:defRPr sz="3675" b="1">
-                <a:solidFill>
-                  <a:srgbClr val="F4F2EC"/>
-                </a:solidFill>
-                <a:latin typeface="Helvetica Neue"/>
-                <a:ea typeface="Helvetica Neue"/>
-                <a:cs typeface="Helvetica Neue"/>
-              </a:defRPr>
-            </a:pPr>
-            <a:r>
-              <a:rPr sz="3675" b="1">
-                <a:solidFill>
-                  <a:srgbClr val="F4F2EC"/>
-                </a:solidFill>
-                <a:latin typeface="Helvetica Neue"/>
-                <a:ea typeface="Helvetica Neue"/>
-                <a:cs typeface="Helvetica Neue"/>
-              </a:rPr>
-              <a:t>Commit</a:t>
+            <a:off x="2667000" y="2857500"/>
+            <a:ext cx="1476375" cy="523875"/>
+          </a:xfrm>
+          <a:prstGeom xmlns:a="http://schemas.openxmlformats.org/drawingml/2006/main" prst="rect">
+            <a:avLst/>
+          </a:prstGeom>
+          <a:noFill xmlns:a="http://schemas.openxmlformats.org/drawingml/2006/main"/>
+          <a:ln xmlns:a="http://schemas.openxmlformats.org/drawingml/2006/main" w="0">
+            <a:noFill/>
+          </a:ln>
+        </p:spPr>
+        <p:txBody>
+          <a:bodyPr xmlns:a="http://schemas.openxmlformats.org/drawingml/2006/main" wrap="square" lIns="0" tIns="0" rIns="0" bIns="0" anchor="ctr">
+            <a:noAutofit/>
+          </a:bodyPr>
+          <a:lstStyle xmlns:a="http://schemas.openxmlformats.org/drawingml/2006/main"/>
+          <a:p xmlns:a="http://schemas.openxmlformats.org/drawingml/2006/main">
+            <a:pPr algn="ctr">
+              <a:buNone/>
+              <a:defRPr sz="2250" b="1">
+                <a:solidFill>
+                  <a:srgbClr val="F5F7F9"/>
+                </a:solidFill>
+                <a:latin typeface="Helvetica Neue"/>
+                <a:ea typeface="Helvetica Neue"/>
+                <a:cs typeface="Helvetica Neue"/>
+              </a:defRPr>
+            </a:pPr>
+            <a:r>
+              <a:rPr sz="2250" b="1">
+                <a:solidFill>
+                  <a:srgbClr val="F5F7F9"/>
+                </a:solidFill>
+                <a:latin typeface="Helvetica Neue"/>
+                <a:ea typeface="Helvetica Neue"/>
+                <a:cs typeface="Helvetica Neue"/>
+              </a:rPr>
+              <a:t>Cart</a:t>
             </a:r>
           </a:p>
         </p:txBody>
@@ -19675,44 +19663,44 @@
         </p:nvSpPr>
         <p:spPr>
           <a:xfrm xmlns:a="http://schemas.openxmlformats.org/drawingml/2006/main">
-            <a:off x="3448050" y="3829050"/>
-            <a:ext cx="2438400" cy="504825"/>
-          </a:xfrm>
-          <a:prstGeom xmlns:a="http://schemas.openxmlformats.org/drawingml/2006/main" prst="rect">
-            <a:avLst/>
-          </a:prstGeom>
-          <a:noFill xmlns:a="http://schemas.openxmlformats.org/drawingml/2006/main"/>
-          <a:ln xmlns:a="http://schemas.openxmlformats.org/drawingml/2006/main" w="0">
-            <a:noFill/>
-          </a:ln>
-        </p:spPr>
-        <p:txBody>
-          <a:bodyPr xmlns:a="http://schemas.openxmlformats.org/drawingml/2006/main" wrap="square" lIns="0" tIns="0" rIns="0" bIns="0" anchor="ctr">
-            <a:noAutofit/>
-          </a:bodyPr>
-          <a:lstStyle xmlns:a="http://schemas.openxmlformats.org/drawingml/2006/main"/>
-          <a:p xmlns:a="http://schemas.openxmlformats.org/drawingml/2006/main">
-            <a:pPr algn="l">
-              <a:buNone/>
-              <a:defRPr sz="2100" b="0">
-                <a:solidFill>
-                  <a:srgbClr val="AEBFCB"/>
-                </a:solidFill>
-                <a:latin typeface="Helvetica Neue"/>
-                <a:ea typeface="Helvetica Neue"/>
-                <a:cs typeface="Helvetica Neue"/>
-              </a:defRPr>
-            </a:pPr>
-            <a:r>
-              <a:rPr sz="2100" b="0">
-                <a:solidFill>
-                  <a:srgbClr val="AEBFCB"/>
-                </a:solidFill>
-                <a:latin typeface="Helvetica Neue"/>
-                <a:ea typeface="Helvetica Neue"/>
-                <a:cs typeface="Helvetica Neue"/>
-              </a:rPr>
-              <a:t>10–20 min</a:t>
+            <a:off x="2667000" y="3476625"/>
+            <a:ext cx="1476375" cy="409575"/>
+          </a:xfrm>
+          <a:prstGeom xmlns:a="http://schemas.openxmlformats.org/drawingml/2006/main" prst="rect">
+            <a:avLst/>
+          </a:prstGeom>
+          <a:noFill xmlns:a="http://schemas.openxmlformats.org/drawingml/2006/main"/>
+          <a:ln xmlns:a="http://schemas.openxmlformats.org/drawingml/2006/main" w="0">
+            <a:noFill/>
+          </a:ln>
+        </p:spPr>
+        <p:txBody>
+          <a:bodyPr xmlns:a="http://schemas.openxmlformats.org/drawingml/2006/main" wrap="square" lIns="0" tIns="0" rIns="0" bIns="0" anchor="ctr">
+            <a:noAutofit/>
+          </a:bodyPr>
+          <a:lstStyle xmlns:a="http://schemas.openxmlformats.org/drawingml/2006/main"/>
+          <a:p xmlns:a="http://schemas.openxmlformats.org/drawingml/2006/main">
+            <a:pPr algn="ctr">
+              <a:buNone/>
+              <a:defRPr sz="1125" b="0">
+                <a:solidFill>
+                  <a:srgbClr val="B6C5CE"/>
+                </a:solidFill>
+                <a:latin typeface="Helvetica Neue"/>
+                <a:ea typeface="Helvetica Neue"/>
+                <a:cs typeface="Helvetica Neue"/>
+              </a:defRPr>
+            </a:pPr>
+            <a:r>
+              <a:rPr sz="1125" b="0">
+                <a:solidFill>
+                  <a:srgbClr val="B6C5CE"/>
+                </a:solidFill>
+                <a:latin typeface="Helvetica Neue"/>
+                <a:ea typeface="Helvetica Neue"/>
+                <a:cs typeface="Helvetica Neue"/>
+              </a:rPr>
+              <a:t>Sasia 1</a:t>
             </a:r>
           </a:p>
         </p:txBody>
@@ -19733,8 +19721,8 @@
         </p:nvSpPr>
         <p:spPr>
           <a:xfrm xmlns:a="http://schemas.openxmlformats.org/drawingml/2006/main">
-            <a:off x="5695950" y="3124200"/>
-            <a:ext cx="304800" cy="171450"/>
+            <a:off x="4257675" y="3028950"/>
+            <a:ext cx="266700" cy="171450"/>
           </a:xfrm>
           <a:prstGeom xmlns:a="http://schemas.openxmlformats.org/drawingml/2006/main" prst="rightArrow">
             <a:avLst/>
@@ -19763,44 +19751,44 @@
         </p:nvSpPr>
         <p:spPr>
           <a:xfrm xmlns:a="http://schemas.openxmlformats.org/drawingml/2006/main">
-            <a:off x="6210300" y="2867025"/>
-            <a:ext cx="2362200" cy="666750"/>
-          </a:xfrm>
-          <a:prstGeom xmlns:a="http://schemas.openxmlformats.org/drawingml/2006/main" prst="rect">
-            <a:avLst/>
-          </a:prstGeom>
-          <a:noFill xmlns:a="http://schemas.openxmlformats.org/drawingml/2006/main"/>
-          <a:ln xmlns:a="http://schemas.openxmlformats.org/drawingml/2006/main" w="0">
-            <a:noFill/>
-          </a:ln>
-        </p:spPr>
-        <p:txBody>
-          <a:bodyPr xmlns:a="http://schemas.openxmlformats.org/drawingml/2006/main" wrap="square" lIns="0" tIns="0" rIns="0" bIns="0" anchor="ctr">
-            <a:noAutofit/>
-          </a:bodyPr>
-          <a:lstStyle xmlns:a="http://schemas.openxmlformats.org/drawingml/2006/main"/>
-          <a:p xmlns:a="http://schemas.openxmlformats.org/drawingml/2006/main">
-            <a:pPr algn="l">
-              <a:buNone/>
-              <a:defRPr sz="3675" b="1">
-                <a:solidFill>
-                  <a:srgbClr val="F4F2EC"/>
-                </a:solidFill>
-                <a:latin typeface="Helvetica Neue"/>
-                <a:ea typeface="Helvetica Neue"/>
-                <a:cs typeface="Helvetica Neue"/>
-              </a:defRPr>
-            </a:pPr>
-            <a:r>
-              <a:rPr sz="3675" b="1">
-                <a:solidFill>
-                  <a:srgbClr val="F4F2EC"/>
-                </a:solidFill>
-                <a:latin typeface="Helvetica Neue"/>
-                <a:ea typeface="Helvetica Neue"/>
-                <a:cs typeface="Helvetica Neue"/>
-              </a:rPr>
-              <a:t>Deploy</a:t>
+            <a:off x="4648200" y="2857500"/>
+            <a:ext cx="1476375" cy="523875"/>
+          </a:xfrm>
+          <a:prstGeom xmlns:a="http://schemas.openxmlformats.org/drawingml/2006/main" prst="rect">
+            <a:avLst/>
+          </a:prstGeom>
+          <a:noFill xmlns:a="http://schemas.openxmlformats.org/drawingml/2006/main"/>
+          <a:ln xmlns:a="http://schemas.openxmlformats.org/drawingml/2006/main" w="0">
+            <a:noFill/>
+          </a:ln>
+        </p:spPr>
+        <p:txBody>
+          <a:bodyPr xmlns:a="http://schemas.openxmlformats.org/drawingml/2006/main" wrap="square" lIns="0" tIns="0" rIns="0" bIns="0" anchor="ctr">
+            <a:noAutofit/>
+          </a:bodyPr>
+          <a:lstStyle xmlns:a="http://schemas.openxmlformats.org/drawingml/2006/main"/>
+          <a:p xmlns:a="http://schemas.openxmlformats.org/drawingml/2006/main">
+            <a:pPr algn="ctr">
+              <a:buNone/>
+              <a:defRPr sz="2250" b="1">
+                <a:solidFill>
+                  <a:srgbClr val="F5F7F9"/>
+                </a:solidFill>
+                <a:latin typeface="Helvetica Neue"/>
+                <a:ea typeface="Helvetica Neue"/>
+                <a:cs typeface="Helvetica Neue"/>
+              </a:defRPr>
+            </a:pPr>
+            <a:r>
+              <a:rPr sz="2250" b="1">
+                <a:solidFill>
+                  <a:srgbClr val="F5F7F9"/>
+                </a:solidFill>
+                <a:latin typeface="Helvetica Neue"/>
+                <a:ea typeface="Helvetica Neue"/>
+                <a:cs typeface="Helvetica Neue"/>
+              </a:rPr>
+              <a:t>Order</a:t>
             </a:r>
           </a:p>
         </p:txBody>
@@ -19821,44 +19809,44 @@
         </p:nvSpPr>
         <p:spPr>
           <a:xfrm xmlns:a="http://schemas.openxmlformats.org/drawingml/2006/main">
-            <a:off x="6210300" y="3829050"/>
-            <a:ext cx="2438400" cy="504825"/>
-          </a:xfrm>
-          <a:prstGeom xmlns:a="http://schemas.openxmlformats.org/drawingml/2006/main" prst="rect">
-            <a:avLst/>
-          </a:prstGeom>
-          <a:noFill xmlns:a="http://schemas.openxmlformats.org/drawingml/2006/main"/>
-          <a:ln xmlns:a="http://schemas.openxmlformats.org/drawingml/2006/main" w="0">
-            <a:noFill/>
-          </a:ln>
-        </p:spPr>
-        <p:txBody>
-          <a:bodyPr xmlns:a="http://schemas.openxmlformats.org/drawingml/2006/main" wrap="square" lIns="0" tIns="0" rIns="0" bIns="0" anchor="ctr">
-            <a:noAutofit/>
-          </a:bodyPr>
-          <a:lstStyle xmlns:a="http://schemas.openxmlformats.org/drawingml/2006/main"/>
-          <a:p xmlns:a="http://schemas.openxmlformats.org/drawingml/2006/main">
-            <a:pPr algn="l">
-              <a:buNone/>
-              <a:defRPr sz="2100" b="0">
-                <a:solidFill>
-                  <a:srgbClr val="AEBFCB"/>
-                </a:solidFill>
-                <a:latin typeface="Helvetica Neue"/>
-                <a:ea typeface="Helvetica Neue"/>
-                <a:cs typeface="Helvetica Neue"/>
-              </a:defRPr>
-            </a:pPr>
-            <a:r>
-              <a:rPr sz="2100" b="0">
-                <a:solidFill>
-                  <a:srgbClr val="AEBFCB"/>
-                </a:solidFill>
-                <a:latin typeface="Helvetica Neue"/>
-                <a:ea typeface="Helvetica Neue"/>
-                <a:cs typeface="Helvetica Neue"/>
-              </a:rPr>
-              <a:t>20–35 min</a:t>
+            <a:off x="4648200" y="3476625"/>
+            <a:ext cx="1476375" cy="409575"/>
+          </a:xfrm>
+          <a:prstGeom xmlns:a="http://schemas.openxmlformats.org/drawingml/2006/main" prst="rect">
+            <a:avLst/>
+          </a:prstGeom>
+          <a:noFill xmlns:a="http://schemas.openxmlformats.org/drawingml/2006/main"/>
+          <a:ln xmlns:a="http://schemas.openxmlformats.org/drawingml/2006/main" w="0">
+            <a:noFill/>
+          </a:ln>
+        </p:spPr>
+        <p:txBody>
+          <a:bodyPr xmlns:a="http://schemas.openxmlformats.org/drawingml/2006/main" wrap="square" lIns="0" tIns="0" rIns="0" bIns="0" anchor="ctr">
+            <a:noAutofit/>
+          </a:bodyPr>
+          <a:lstStyle xmlns:a="http://schemas.openxmlformats.org/drawingml/2006/main"/>
+          <a:p xmlns:a="http://schemas.openxmlformats.org/drawingml/2006/main">
+            <a:pPr algn="ctr">
+              <a:buNone/>
+              <a:defRPr sz="1125" b="0">
+                <a:solidFill>
+                  <a:srgbClr val="B6C5CE"/>
+                </a:solidFill>
+                <a:latin typeface="Helvetica Neue"/>
+                <a:ea typeface="Helvetica Neue"/>
+                <a:cs typeface="Helvetica Neue"/>
+              </a:defRPr>
+            </a:pPr>
+            <a:r>
+              <a:rPr sz="1125" b="0">
+                <a:solidFill>
+                  <a:srgbClr val="B6C5CE"/>
+                </a:solidFill>
+                <a:latin typeface="Helvetica Neue"/>
+                <a:ea typeface="Helvetica Neue"/>
+                <a:cs typeface="Helvetica Neue"/>
+              </a:rPr>
+              <a:t>U ruajt</a:t>
             </a:r>
           </a:p>
         </p:txBody>
@@ -19879,8 +19867,8 @@
         </p:nvSpPr>
         <p:spPr>
           <a:xfrm xmlns:a="http://schemas.openxmlformats.org/drawingml/2006/main">
-            <a:off x="8458200" y="3124200"/>
-            <a:ext cx="304800" cy="171450"/>
+            <a:off x="6238875" y="3028950"/>
+            <a:ext cx="266700" cy="171450"/>
           </a:xfrm>
           <a:prstGeom xmlns:a="http://schemas.openxmlformats.org/drawingml/2006/main" prst="rightArrow">
             <a:avLst/>
@@ -19909,8 +19897,124 @@
         </p:nvSpPr>
         <p:spPr>
           <a:xfrm xmlns:a="http://schemas.openxmlformats.org/drawingml/2006/main">
-            <a:off x="8972550" y="2867025"/>
-            <a:ext cx="2362200" cy="666750"/>
+            <a:off x="6629400" y="2857500"/>
+            <a:ext cx="1476375" cy="523875"/>
+          </a:xfrm>
+          <a:prstGeom xmlns:a="http://schemas.openxmlformats.org/drawingml/2006/main" prst="rect">
+            <a:avLst/>
+          </a:prstGeom>
+          <a:noFill xmlns:a="http://schemas.openxmlformats.org/drawingml/2006/main"/>
+          <a:ln xmlns:a="http://schemas.openxmlformats.org/drawingml/2006/main" w="0">
+            <a:noFill/>
+          </a:ln>
+        </p:spPr>
+        <p:txBody>
+          <a:bodyPr xmlns:a="http://schemas.openxmlformats.org/drawingml/2006/main" wrap="square" lIns="0" tIns="0" rIns="0" bIns="0" anchor="ctr">
+            <a:noAutofit/>
+          </a:bodyPr>
+          <a:lstStyle xmlns:a="http://schemas.openxmlformats.org/drawingml/2006/main"/>
+          <a:p xmlns:a="http://schemas.openxmlformats.org/drawingml/2006/main">
+            <a:pPr algn="ctr">
+              <a:buNone/>
+              <a:defRPr sz="2250" b="1">
+                <a:solidFill>
+                  <a:srgbClr val="7FD3AA"/>
+                </a:solidFill>
+                <a:latin typeface="Helvetica Neue"/>
+                <a:ea typeface="Helvetica Neue"/>
+                <a:cs typeface="Helvetica Neue"/>
+              </a:defRPr>
+            </a:pPr>
+            <a:r>
+              <a:rPr sz="2250" b="1">
+                <a:solidFill>
+                  <a:srgbClr val="7FD3AA"/>
+                </a:solidFill>
+                <a:latin typeface="Helvetica Neue"/>
+                <a:ea typeface="Helvetica Neue"/>
+                <a:cs typeface="Helvetica Neue"/>
+              </a:rPr>
+              <a:t>Gati</a:t>
+            </a:r>
+          </a:p>
+        </p:txBody>
+      </p:sp>
+      <p:sp>
+        <p:nvSpPr>
+          <p:cNvPr id="15" name="text-336">
+            <a:extLst xmlns:a="http://schemas.openxmlformats.org/drawingml/2006/main">
+              <a:ext uri="{FF2B5EF4-FFF2-40B4-BE49-F238E27FC236}">
+                <a16:creationId xmlns:a16="http://schemas.microsoft.com/office/drawing/2014/main" id="{017BC553-2884-4219-938C-C1BAA44C4EAB}"/>
+              </a:ext>
+            </a:extLst>
+          </p:cNvPr>
+          <p:cNvSpPr>
+            <a:spLocks xmlns:a="http://schemas.openxmlformats.org/drawingml/2006/main" noGrp="1"/>
+          </p:cNvSpPr>
+          <p:nvPr/>
+        </p:nvSpPr>
+        <p:spPr>
+          <a:xfrm xmlns:a="http://schemas.openxmlformats.org/drawingml/2006/main">
+            <a:off x="6629400" y="3476625"/>
+            <a:ext cx="1476375" cy="409575"/>
+          </a:xfrm>
+          <a:prstGeom xmlns:a="http://schemas.openxmlformats.org/drawingml/2006/main" prst="rect">
+            <a:avLst/>
+          </a:prstGeom>
+          <a:noFill xmlns:a="http://schemas.openxmlformats.org/drawingml/2006/main"/>
+          <a:ln xmlns:a="http://schemas.openxmlformats.org/drawingml/2006/main" w="0">
+            <a:noFill/>
+          </a:ln>
+        </p:spPr>
+        <p:txBody>
+          <a:bodyPr xmlns:a="http://schemas.openxmlformats.org/drawingml/2006/main" wrap="square" lIns="0" tIns="0" rIns="0" bIns="0" anchor="ctr">
+            <a:noAutofit/>
+          </a:bodyPr>
+          <a:lstStyle xmlns:a="http://schemas.openxmlformats.org/drawingml/2006/main"/>
+          <a:p xmlns:a="http://schemas.openxmlformats.org/drawingml/2006/main">
+            <a:pPr algn="ctr">
+              <a:buNone/>
+              <a:defRPr sz="1125" b="0">
+                <a:solidFill>
+                  <a:srgbClr val="B6C5CE"/>
+                </a:solidFill>
+                <a:latin typeface="Helvetica Neue"/>
+                <a:ea typeface="Helvetica Neue"/>
+                <a:cs typeface="Helvetica Neue"/>
+              </a:defRPr>
+            </a:pPr>
+            <a:r>
+              <a:rPr sz="1125" b="0">
+                <a:solidFill>
+                  <a:srgbClr val="B6C5CE"/>
+                </a:solidFill>
+                <a:latin typeface="Helvetica Neue"/>
+                <a:ea typeface="Helvetica Neue"/>
+                <a:cs typeface="Helvetica Neue"/>
+              </a:rPr>
+              <a:t>Stafi e mbylli</a:t>
+            </a:r>
+          </a:p>
+        </p:txBody>
+      </p:sp>
+      <p:sp>
+        <p:nvSpPr>
+          <p:cNvPr id="16" name="text-337">
+            <a:extLst xmlns:a="http://schemas.openxmlformats.org/drawingml/2006/main">
+              <a:ext uri="{FF2B5EF4-FFF2-40B4-BE49-F238E27FC236}">
+                <a16:creationId xmlns:a16="http://schemas.microsoft.com/office/drawing/2014/main" id="{3E5A6713-8ED9-47C0-94EA-A242E87F2754}"/>
+              </a:ext>
+            </a:extLst>
+          </p:cNvPr>
+          <p:cNvSpPr>
+            <a:spLocks xmlns:a="http://schemas.openxmlformats.org/drawingml/2006/main" noGrp="1"/>
+          </p:cNvSpPr>
+          <p:nvPr/>
+        </p:nvSpPr>
+        <p:spPr>
+          <a:xfrm xmlns:a="http://schemas.openxmlformats.org/drawingml/2006/main">
+            <a:off x="685800" y="4552950"/>
+            <a:ext cx="10810875" cy="914400"/>
           </a:xfrm>
           <a:prstGeom xmlns:a="http://schemas.openxmlformats.org/drawingml/2006/main" prst="rect">
             <a:avLst/>
@@ -19928,105 +20032,71 @@
           <a:p xmlns:a="http://schemas.openxmlformats.org/drawingml/2006/main">
             <a:pPr algn="l">
               <a:buNone/>
-              <a:defRPr sz="3675" b="1">
-                <a:solidFill>
-                  <a:srgbClr val="F4F2EC"/>
-                </a:solidFill>
-                <a:latin typeface="Helvetica Neue"/>
-                <a:ea typeface="Helvetica Neue"/>
-                <a:cs typeface="Helvetica Neue"/>
-              </a:defRPr>
-            </a:pPr>
-            <a:r>
-              <a:rPr sz="3675" b="1">
-                <a:solidFill>
-                  <a:srgbClr val="F4F2EC"/>
-                </a:solidFill>
-                <a:latin typeface="Helvetica Neue"/>
-                <a:ea typeface="Helvetica Neue"/>
-                <a:cs typeface="Helvetica Neue"/>
-              </a:rPr>
-              <a:t>Telefon</a:t>
-            </a:r>
-          </a:p>
-        </p:txBody>
-      </p:sp>
-      <p:sp>
-        <p:nvSpPr>
-          <p:cNvPr id="15" name="text-336">
-            <a:extLst xmlns:a="http://schemas.openxmlformats.org/drawingml/2006/main">
-              <a:ext uri="{FF2B5EF4-FFF2-40B4-BE49-F238E27FC236}">
-                <a16:creationId xmlns:a16="http://schemas.microsoft.com/office/drawing/2014/main" id="{017BC553-2884-4219-938C-C1BAA44C4EAB}"/>
-              </a:ext>
-            </a:extLst>
-          </p:cNvPr>
-          <p:cNvSpPr>
-            <a:spLocks xmlns:a="http://schemas.openxmlformats.org/drawingml/2006/main" noGrp="1"/>
-          </p:cNvSpPr>
-          <p:nvPr/>
-        </p:nvSpPr>
-        <p:spPr>
-          <a:xfrm xmlns:a="http://schemas.openxmlformats.org/drawingml/2006/main">
-            <a:off x="8972550" y="3829050"/>
-            <a:ext cx="2438400" cy="504825"/>
-          </a:xfrm>
-          <a:prstGeom xmlns:a="http://schemas.openxmlformats.org/drawingml/2006/main" prst="rect">
-            <a:avLst/>
-          </a:prstGeom>
-          <a:noFill xmlns:a="http://schemas.openxmlformats.org/drawingml/2006/main"/>
-          <a:ln xmlns:a="http://schemas.openxmlformats.org/drawingml/2006/main" w="0">
-            <a:noFill/>
-          </a:ln>
-        </p:spPr>
-        <p:txBody>
-          <a:bodyPr xmlns:a="http://schemas.openxmlformats.org/drawingml/2006/main" wrap="square" lIns="0" tIns="0" rIns="0" bIns="0" anchor="ctr">
-            <a:noAutofit/>
-          </a:bodyPr>
-          <a:lstStyle xmlns:a="http://schemas.openxmlformats.org/drawingml/2006/main"/>
+              <a:defRPr sz="1500" b="1">
+                <a:solidFill>
+                  <a:srgbClr val="F5F7F9"/>
+                </a:solidFill>
+                <a:latin typeface="Helvetica Neue"/>
+                <a:ea typeface="Helvetica Neue"/>
+                <a:cs typeface="Helvetica Neue"/>
+              </a:defRPr>
+            </a:pPr>
+            <a:r>
+              <a:rPr sz="1500" b="1">
+                <a:solidFill>
+                  <a:srgbClr val="F5F7F9"/>
+                </a:solidFill>
+                <a:latin typeface="Helvetica Neue"/>
+                <a:ea typeface="Helvetica Neue"/>
+                <a:cs typeface="Helvetica Neue"/>
+              </a:rPr>
+              <a:t>QR I PJESËMARRJES — vetëm në mes të orës; regjistron praninë</a:t>
+            </a:r>
+          </a:p>
           <a:p xmlns:a="http://schemas.openxmlformats.org/drawingml/2006/main">
             <a:pPr algn="l">
               <a:buNone/>
-              <a:defRPr sz="2100" b="0">
-                <a:solidFill>
-                  <a:srgbClr val="AEBFCB"/>
-                </a:solidFill>
-                <a:latin typeface="Helvetica Neue"/>
-                <a:ea typeface="Helvetica Neue"/>
-                <a:cs typeface="Helvetica Neue"/>
-              </a:defRPr>
-            </a:pPr>
-            <a:r>
-              <a:rPr sz="2100" b="0">
-                <a:solidFill>
-                  <a:srgbClr val="AEBFCB"/>
-                </a:solidFill>
-                <a:latin typeface="Helvetica Neue"/>
-                <a:ea typeface="Helvetica Neue"/>
-                <a:cs typeface="Helvetica Neue"/>
-              </a:rPr>
-              <a:t>35–45 min</a:t>
-            </a:r>
-          </a:p>
-        </p:txBody>
-      </p:sp>
-      <p:sp>
-        <p:nvSpPr>
-          <p:cNvPr id="16" name="text-337">
-            <a:extLst xmlns:a="http://schemas.openxmlformats.org/drawingml/2006/main">
-              <a:ext uri="{FF2B5EF4-FFF2-40B4-BE49-F238E27FC236}">
-                <a16:creationId xmlns:a16="http://schemas.microsoft.com/office/drawing/2014/main" id="{3E5A6713-8ED9-47C0-94EA-A242E87F2754}"/>
-              </a:ext>
-            </a:extLst>
-          </p:cNvPr>
-          <p:cNvSpPr>
-            <a:spLocks xmlns:a="http://schemas.openxmlformats.org/drawingml/2006/main" noGrp="1"/>
-          </p:cNvSpPr>
-          <p:nvPr/>
-        </p:nvSpPr>
-        <p:spPr>
-          <a:xfrm xmlns:a="http://schemas.openxmlformats.org/drawingml/2006/main">
-            <a:off x="695325" y="4914900"/>
-            <a:ext cx="10763250" cy="781050"/>
+              <a:defRPr sz="1500" b="1">
+                <a:solidFill>
+                  <a:srgbClr val="F5F7F9"/>
+                </a:solidFill>
+                <a:latin typeface="Helvetica Neue"/>
+                <a:ea typeface="Helvetica Neue"/>
+                <a:cs typeface="Helvetica Neue"/>
+              </a:defRPr>
+            </a:pPr>
+            <a:r>
+              <a:rPr sz="1500" b="1">
+                <a:solidFill>
+                  <a:srgbClr val="F5F7F9"/>
+                </a:solidFill>
+                <a:latin typeface="Helvetica Neue"/>
+                <a:ea typeface="Helvetica Neue"/>
+                <a:cs typeface="Helvetica Neue"/>
+              </a:rPr>
+              <a:t>QR I DEMONSTRIMIT — në fund; hap aplikacionin dhe nuk regjistron praninë</a:t>
+            </a:r>
+          </a:p>
+        </p:txBody>
+      </p:sp>
+      <p:sp>
+        <p:nvSpPr>
+          <p:cNvPr id="17" name="text-338">
+            <a:extLst xmlns:a="http://schemas.openxmlformats.org/drawingml/2006/main">
+              <a:ext uri="{FF2B5EF4-FFF2-40B4-BE49-F238E27FC236}">
+                <a16:creationId xmlns:a16="http://schemas.microsoft.com/office/drawing/2014/main" id="{3FD56265-CA8B-4650-BEB9-C46E17AC08DD}"/>
+              </a:ext>
+            </a:extLst>
+          </p:cNvPr>
+          <p:cNvSpPr>
+            <a:spLocks xmlns:a="http://schemas.openxmlformats.org/drawingml/2006/main" noGrp="1"/>
+          </p:cNvSpPr>
+          <p:nvPr/>
+        </p:nvSpPr>
+        <p:spPr>
+          <a:xfrm xmlns:a="http://schemas.openxmlformats.org/drawingml/2006/main">
+            <a:off x="685800" y="5715000"/>
+            <a:ext cx="10810875" cy="428625"/>
           </a:xfrm>
           <a:prstGeom xmlns:a="http://schemas.openxmlformats.org/drawingml/2006/main" prst="rect">
             <a:avLst/>
@@ -20044,103 +20114,67 @@
           <a:p xmlns:a="http://schemas.openxmlformats.org/drawingml/2006/main">
             <a:pPr algn="l">
               <a:buNone/>
-              <a:defRPr sz="2925" b="1">
-                <a:solidFill>
-                  <a:srgbClr val="91DEBB"/>
-                </a:solidFill>
-                <a:latin typeface="Helvetica Neue"/>
-                <a:ea typeface="Helvetica Neue"/>
-                <a:cs typeface="Helvetica Neue"/>
-              </a:defRPr>
-            </a:pPr>
-            <a:r>
-              <a:rPr sz="2925" b="1">
-                <a:solidFill>
-                  <a:srgbClr val="91DEBB"/>
-                </a:solidFill>
-                <a:latin typeface="Helvetica Neue"/>
-                <a:ea typeface="Helvetica Neue"/>
-                <a:cs typeface="Helvetica Neue"/>
-              </a:rPr>
-              <a:t>Prova: një ndryshim i dytë, i dukshëm në telefon.</a:t>
-            </a:r>
-          </a:p>
-        </p:txBody>
-      </p:sp>
-      <p:sp>
-        <p:nvSpPr>
-          <p:cNvPr id="17" name="text-338">
-            <a:extLst xmlns:a="http://schemas.openxmlformats.org/drawingml/2006/main">
-              <a:ext uri="{FF2B5EF4-FFF2-40B4-BE49-F238E27FC236}">
-                <a16:creationId xmlns:a16="http://schemas.microsoft.com/office/drawing/2014/main" id="{3FD56265-CA8B-4650-BEB9-C46E17AC08DD}"/>
-              </a:ext>
-            </a:extLst>
-          </p:cNvPr>
-          <p:cNvSpPr>
-            <a:spLocks xmlns:a="http://schemas.openxmlformats.org/drawingml/2006/main" noGrp="1"/>
-          </p:cNvSpPr>
-          <p:nvPr/>
-        </p:nvSpPr>
-        <p:spPr>
-          <a:xfrm xmlns:a="http://schemas.openxmlformats.org/drawingml/2006/main">
-            <a:off x="609600" y="5962650"/>
-            <a:ext cx="10763250" cy="428625"/>
-          </a:xfrm>
-          <a:prstGeom xmlns:a="http://schemas.openxmlformats.org/drawingml/2006/main" prst="rect">
-            <a:avLst/>
-          </a:prstGeom>
-          <a:noFill xmlns:a="http://schemas.openxmlformats.org/drawingml/2006/main"/>
-          <a:ln xmlns:a="http://schemas.openxmlformats.org/drawingml/2006/main" w="0">
-            <a:noFill/>
-          </a:ln>
-        </p:spPr>
-        <p:txBody>
-          <a:bodyPr xmlns:a="http://schemas.openxmlformats.org/drawingml/2006/main" wrap="square" lIns="0" tIns="0" rIns="0" bIns="0" anchor="ctr">
-            <a:noAutofit/>
-          </a:bodyPr>
-          <a:lstStyle xmlns:a="http://schemas.openxmlformats.org/drawingml/2006/main"/>
-          <a:p xmlns:a="http://schemas.openxmlformats.org/drawingml/2006/main">
-            <a:pPr algn="l">
-              <a:buNone/>
-              <a:defRPr sz="1950" b="0">
-                <a:solidFill>
-                  <a:srgbClr val="AEBFCB"/>
-                </a:solidFill>
-                <a:latin typeface="Helvetica Neue"/>
-                <a:ea typeface="Helvetica Neue"/>
-                <a:cs typeface="Helvetica Neue"/>
-              </a:defRPr>
-            </a:pPr>
-            <a:r>
-              <a:rPr sz="1950" b="0">
-                <a:solidFill>
-                  <a:srgbClr val="AEBFCB"/>
-                </a:solidFill>
-                <a:latin typeface="Helvetica Neue"/>
-                <a:ea typeface="Helvetica Neue"/>
-                <a:cs typeface="Helvetica Neue"/>
-              </a:rPr>
-              <a:t>24 shtator: segmenti hyrës i ushtrimeve. Vazhdoni në aplikacionin tuaj.</a:t>
+              <a:defRPr sz="1500" b="1">
+                <a:solidFill>
+                  <a:srgbClr val="5DCEF2"/>
+                </a:solidFill>
+                <a:latin typeface="Helvetica Neue"/>
+                <a:ea typeface="Helvetica Neue"/>
+                <a:cs typeface="Helvetica Neue"/>
+              </a:defRPr>
+            </a:pPr>
+            <a:r>
+              <a:rPr sz="1500" b="1">
+                <a:solidFill>
+                  <a:srgbClr val="5DCEF2"/>
+                </a:solidFill>
+                <a:latin typeface="Helvetica Neue"/>
+                <a:ea typeface="Helvetica Neue"/>
+                <a:cs typeface="Helvetica Neue"/>
+              </a:rPr>
+              <a:t>https://arbenl.github.io/demo/restaurant/</a:t>
             </a:r>
           </a:p>
         </p:txBody>
       </p:sp>
       <p:pic>
         <p:nvPicPr>
-          <p:cNvPr id="37" name=""/>
+          <p:cNvPr id="38" name=""/>
           <p:cNvPicPr>
             <a:picLocks xmlns:a="http://schemas.openxmlformats.org/drawingml/2006/main" noChangeAspect="1"/>
           </p:cNvPicPr>
           <p:nvPr/>
         </p:nvPicPr>
         <p:blipFill>
-          <a:blip xmlns:r="http://schemas.openxmlformats.org/officeDocument/2006/relationships" xmlns:a="http://schemas.openxmlformats.org/drawingml/2006/main" r:embed="R0e9f8901551f4f7f"/>
+          <a:blip xmlns:r="http://schemas.openxmlformats.org/officeDocument/2006/relationships" xmlns:a="http://schemas.openxmlformats.org/drawingml/2006/main" r:embed="R4d657ecec4464fca"/>
           <a:stretch xmlns:a="http://schemas.openxmlformats.org/drawingml/2006/main"/>
         </p:blipFill>
         <p:spPr>
           <a:xfrm xmlns:a="http://schemas.openxmlformats.org/drawingml/2006/main">
             <a:off x="9525000" y="299045"/>
             <a:ext cx="1190625" cy="240109"/>
+          </a:xfrm>
+          <a:prstGeom xmlns:a="http://schemas.openxmlformats.org/drawingml/2006/main" prst="rect">
+            <a:avLst/>
+          </a:prstGeom>
+        </p:spPr>
+      </p:pic>
+      <p:pic>
+        <p:nvPicPr>
+          <p:cNvPr id="39" name=""/>
+          <p:cNvPicPr>
+            <a:picLocks xmlns:a="http://schemas.openxmlformats.org/drawingml/2006/main" noChangeAspect="1"/>
+          </p:cNvPicPr>
+          <p:nvPr/>
+        </p:nvPicPr>
+        <p:blipFill>
+          <a:blip xmlns:r="http://schemas.openxmlformats.org/officeDocument/2006/relationships" xmlns:a="http://schemas.openxmlformats.org/drawingml/2006/main" r:embed="R7fc2827eddb84183"/>
+          <a:stretch xmlns:a="http://schemas.openxmlformats.org/drawingml/2006/main"/>
+        </p:blipFill>
+        <p:spPr>
+          <a:xfrm xmlns:a="http://schemas.openxmlformats.org/drawingml/2006/main">
+            <a:off x="9144000" y="1952625"/>
+            <a:ext cx="2095500" cy="2095500"/>
           </a:xfrm>
           <a:prstGeom xmlns:a="http://schemas.openxmlformats.org/drawingml/2006/main" prst="rect">
             <a:avLst/>
@@ -20540,8 +20574,8 @@
         </p:nvSpPr>
         <p:spPr>
           <a:xfrm xmlns:a="http://schemas.openxmlformats.org/drawingml/2006/main">
-            <a:off x="695325" y="5381625"/>
-            <a:ext cx="1809750" cy="504825"/>
+            <a:off x="695325" y="5095875"/>
+            <a:ext cx="1333500" cy="504825"/>
           </a:xfrm>
           <a:prstGeom xmlns:a="http://schemas.openxmlformats.org/drawingml/2006/main" prst="rect">
             <a:avLst/>
@@ -20559,25 +20593,25 @@
           <a:p xmlns:a="http://schemas.openxmlformats.org/drawingml/2006/main">
             <a:pPr algn="l">
               <a:buNone/>
-              <a:defRPr sz="1950" b="1">
-                <a:solidFill>
-                  <a:srgbClr val="F2BB66"/>
-                </a:solidFill>
-                <a:latin typeface="Helvetica Neue"/>
-                <a:ea typeface="Helvetica Neue"/>
-                <a:cs typeface="Helvetica Neue"/>
-              </a:defRPr>
-            </a:pPr>
-            <a:r>
-              <a:rPr sz="1950" b="1">
-                <a:solidFill>
-                  <a:srgbClr val="F2BB66"/>
-                </a:solidFill>
-                <a:latin typeface="Helvetica Neue"/>
-                <a:ea typeface="Helvetica Neue"/>
-                <a:cs typeface="Helvetica Neue"/>
-              </a:rPr>
-              <a:t>JAVA 2</a:t>
+              <a:defRPr sz="1275" b="1">
+                <a:solidFill>
+                  <a:srgbClr val="F3BE5C"/>
+                </a:solidFill>
+                <a:latin typeface="Helvetica Neue"/>
+                <a:ea typeface="Helvetica Neue"/>
+                <a:cs typeface="Helvetica Neue"/>
+              </a:defRPr>
+            </a:pPr>
+            <a:r>
+              <a:rPr sz="1275" b="1">
+                <a:solidFill>
+                  <a:srgbClr val="F3BE5C"/>
+                </a:solidFill>
+                <a:latin typeface="Helvetica Neue"/>
+                <a:ea typeface="Helvetica Neue"/>
+                <a:cs typeface="Helvetica Neue"/>
+              </a:rPr>
+              <a:t>MBYLLJA</a:t>
             </a:r>
           </a:p>
         </p:txBody>
@@ -20598,8 +20632,8 @@
         </p:nvSpPr>
         <p:spPr>
           <a:xfrm xmlns:a="http://schemas.openxmlformats.org/drawingml/2006/main">
-            <a:off x="2676525" y="5305425"/>
-            <a:ext cx="8610600" cy="647700"/>
+            <a:off x="2095500" y="4876800"/>
+            <a:ext cx="9191625" cy="1028700"/>
           </a:xfrm>
           <a:prstGeom xmlns:a="http://schemas.openxmlformats.org/drawingml/2006/main" prst="rect">
             <a:avLst/>
@@ -20617,25 +20651,25 @@
           <a:p xmlns:a="http://schemas.openxmlformats.org/drawingml/2006/main">
             <a:pPr algn="l">
               <a:buNone/>
-              <a:defRPr sz="2775" b="1">
-                <a:solidFill>
-                  <a:srgbClr val="F4F2EC"/>
-                </a:solidFill>
-                <a:latin typeface="Helvetica Neue"/>
-                <a:ea typeface="Helvetica Neue"/>
-                <a:cs typeface="Helvetica Neue"/>
-              </a:defRPr>
-            </a:pPr>
-            <a:r>
-              <a:rPr sz="2775" b="1">
-                <a:solidFill>
-                  <a:srgbClr val="F4F2EC"/>
-                </a:solidFill>
-                <a:latin typeface="Helvetica Neue"/>
-                <a:ea typeface="Helvetica Neue"/>
-                <a:cs typeface="Helvetica Neue"/>
-              </a:rPr>
-              <a:t>Tri biseda + PRD paraprake</a:t>
+              <a:defRPr sz="1575" b="1">
+                <a:solidFill>
+                  <a:srgbClr val="F5F7F9"/>
+                </a:solidFill>
+                <a:latin typeface="Helvetica Neue"/>
+                <a:ea typeface="Helvetica Neue"/>
+                <a:cs typeface="Helvetica Neue"/>
+              </a:defRPr>
+            </a:pPr>
+            <a:r>
+              <a:rPr sz="1575" b="1">
+                <a:solidFill>
+                  <a:srgbClr val="F5F7F9"/>
+                </a:solidFill>
+                <a:latin typeface="Helvetica Neue"/>
+                <a:ea typeface="Helvetica Neue"/>
+                <a:cs typeface="Helvetica Neue"/>
+              </a:rPr>
+              <a:t>15 javë më vonë, këtë mund ta ndërtoni ju. Filloni me një biznes. Gjeni një problem. Ndërtoni një rrjedhë që funksionon.</a:t>
             </a:r>
           </a:p>
         </p:txBody>
@@ -20707,7 +20741,7 @@
           <p:nvPr/>
         </p:nvPicPr>
         <p:blipFill>
-          <a:blip xmlns:r="http://schemas.openxmlformats.org/officeDocument/2006/relationships" xmlns:a="http://schemas.openxmlformats.org/drawingml/2006/main" r:embed="Re2405347440b457e"/>
+          <a:blip xmlns:r="http://schemas.openxmlformats.org/officeDocument/2006/relationships" xmlns:a="http://schemas.openxmlformats.org/drawingml/2006/main" r:embed="Rcbd8d669c1724f77"/>
           <a:stretch xmlns:a="http://schemas.openxmlformats.org/drawingml/2006/main"/>
         </p:blipFill>
         <p:spPr>
@@ -20783,6 +20817,7 @@
           <a:lstStyle xmlns:a="http://schemas.openxmlformats.org/drawingml/2006/main"/>
           <a:p xmlns:a="http://schemas.openxmlformats.org/drawingml/2006/main">
             <a:pPr>
+              <a:buNone/>
               <a:defRPr sz="1350" b="1">
                 <a:solidFill>
                   <a:srgbClr val="5DCEF2"/>
@@ -20840,6 +20875,7 @@
           <a:lstStyle xmlns:a="http://schemas.openxmlformats.org/drawingml/2006/main"/>
           <a:p xmlns:a="http://schemas.openxmlformats.org/drawingml/2006/main">
             <a:pPr>
+              <a:buNone/>
               <a:defRPr sz="3600" b="1">
                 <a:solidFill>
                   <a:srgbClr val="F5F7F9"/>
@@ -20897,6 +20933,7 @@
           <a:lstStyle xmlns:a="http://schemas.openxmlformats.org/drawingml/2006/main"/>
           <a:p xmlns:a="http://schemas.openxmlformats.org/drawingml/2006/main">
             <a:pPr>
+              <a:buNone/>
               <a:defRPr sz="2550" b="1">
                 <a:solidFill>
                   <a:srgbClr val="5DCEF2"/>
@@ -20954,6 +20991,7 @@
           <a:lstStyle xmlns:a="http://schemas.openxmlformats.org/drawingml/2006/main"/>
           <a:p xmlns:a="http://schemas.openxmlformats.org/drawingml/2006/main">
             <a:pPr>
+              <a:buNone/>
               <a:defRPr sz="2400" b="0">
                 <a:solidFill>
                   <a:srgbClr val="F5F7F9"/>
@@ -21011,6 +21049,7 @@
           <a:lstStyle xmlns:a="http://schemas.openxmlformats.org/drawingml/2006/main"/>
           <a:p xmlns:a="http://schemas.openxmlformats.org/drawingml/2006/main">
             <a:pPr>
+              <a:buNone/>
               <a:defRPr sz="2550" b="1">
                 <a:solidFill>
                   <a:srgbClr val="5DCEF2"/>
@@ -21068,6 +21107,7 @@
           <a:lstStyle xmlns:a="http://schemas.openxmlformats.org/drawingml/2006/main"/>
           <a:p xmlns:a="http://schemas.openxmlformats.org/drawingml/2006/main">
             <a:pPr>
+              <a:buNone/>
               <a:defRPr sz="2400" b="0">
                 <a:solidFill>
                   <a:srgbClr val="F5F7F9"/>
@@ -21125,6 +21165,7 @@
           <a:lstStyle xmlns:a="http://schemas.openxmlformats.org/drawingml/2006/main"/>
           <a:p xmlns:a="http://schemas.openxmlformats.org/drawingml/2006/main">
             <a:pPr>
+              <a:buNone/>
               <a:defRPr sz="2550" b="1">
                 <a:solidFill>
                   <a:srgbClr val="5DCEF2"/>
@@ -21182,6 +21223,7 @@
           <a:lstStyle xmlns:a="http://schemas.openxmlformats.org/drawingml/2006/main"/>
           <a:p xmlns:a="http://schemas.openxmlformats.org/drawingml/2006/main">
             <a:pPr>
+              <a:buNone/>
               <a:defRPr sz="2400" b="0">
                 <a:solidFill>
                   <a:srgbClr val="F5F7F9"/>
@@ -21239,6 +21281,7 @@
           <a:lstStyle xmlns:a="http://schemas.openxmlformats.org/drawingml/2006/main"/>
           <a:p xmlns:a="http://schemas.openxmlformats.org/drawingml/2006/main">
             <a:pPr>
+              <a:buNone/>
               <a:defRPr sz="2550" b="1">
                 <a:solidFill>
                   <a:srgbClr val="5DCEF2"/>
@@ -21296,6 +21339,7 @@
           <a:lstStyle xmlns:a="http://schemas.openxmlformats.org/drawingml/2006/main"/>
           <a:p xmlns:a="http://schemas.openxmlformats.org/drawingml/2006/main">
             <a:pPr>
+              <a:buNone/>
               <a:defRPr sz="2400" b="0">
                 <a:solidFill>
                   <a:srgbClr val="F5F7F9"/>
@@ -21353,6 +21397,7 @@
           <a:lstStyle xmlns:a="http://schemas.openxmlformats.org/drawingml/2006/main"/>
           <a:p xmlns:a="http://schemas.openxmlformats.org/drawingml/2006/main">
             <a:pPr>
+              <a:buNone/>
               <a:defRPr sz="2100" b="0">
                 <a:solidFill>
                   <a:srgbClr val="B6C5CE"/>
@@ -21410,6 +21455,7 @@
           <a:lstStyle xmlns:a="http://schemas.openxmlformats.org/drawingml/2006/main"/>
           <a:p xmlns:a="http://schemas.openxmlformats.org/drawingml/2006/main">
             <a:pPr>
+              <a:buNone/>
               <a:defRPr sz="1350" b="0">
                 <a:solidFill>
                   <a:srgbClr val="B6C5CE"/>
@@ -21435,14 +21481,14 @@
       </p:sp>
       <p:pic>
         <p:nvPicPr>
-          <p:cNvPr id="26" name=""/>
+          <p:cNvPr id="28" name=""/>
           <p:cNvPicPr>
             <a:picLocks xmlns:a="http://schemas.openxmlformats.org/drawingml/2006/main" noChangeAspect="1"/>
           </p:cNvPicPr>
           <p:nvPr/>
         </p:nvPicPr>
         <p:blipFill>
-          <a:blip xmlns:r="http://schemas.openxmlformats.org/officeDocument/2006/relationships" xmlns:a="http://schemas.openxmlformats.org/drawingml/2006/main" r:embed="Re1363725f64349c4"/>
+          <a:blip xmlns:r="http://schemas.openxmlformats.org/officeDocument/2006/relationships" xmlns:a="http://schemas.openxmlformats.org/drawingml/2006/main" r:embed="Rb48e5277eba5415a"/>
           <a:stretch xmlns:a="http://schemas.openxmlformats.org/drawingml/2006/main"/>
         </p:blipFill>
         <p:spPr>
@@ -21518,6 +21564,7 @@
           <a:lstStyle xmlns:a="http://schemas.openxmlformats.org/drawingml/2006/main"/>
           <a:p xmlns:a="http://schemas.openxmlformats.org/drawingml/2006/main">
             <a:pPr>
+              <a:buNone/>
               <a:defRPr sz="1350" b="1">
                 <a:solidFill>
                   <a:srgbClr val="5DCEF2"/>
@@ -21575,6 +21622,7 @@
           <a:lstStyle xmlns:a="http://schemas.openxmlformats.org/drawingml/2006/main"/>
           <a:p xmlns:a="http://schemas.openxmlformats.org/drawingml/2006/main">
             <a:pPr>
+              <a:buNone/>
               <a:defRPr sz="3600" b="1">
                 <a:solidFill>
                   <a:srgbClr val="F5F7F9"/>
@@ -21632,6 +21680,7 @@
           <a:lstStyle xmlns:a="http://schemas.openxmlformats.org/drawingml/2006/main"/>
           <a:p xmlns:a="http://schemas.openxmlformats.org/drawingml/2006/main">
             <a:pPr>
+              <a:buNone/>
               <a:defRPr sz="2400" b="1">
                 <a:solidFill>
                   <a:srgbClr val="5DCEF2"/>
@@ -21689,6 +21738,7 @@
           <a:lstStyle xmlns:a="http://schemas.openxmlformats.org/drawingml/2006/main"/>
           <a:p xmlns:a="http://schemas.openxmlformats.org/drawingml/2006/main">
             <a:pPr>
+              <a:buNone/>
               <a:defRPr sz="2250" b="0">
                 <a:solidFill>
                   <a:srgbClr val="F5F7F9"/>
@@ -21746,6 +21796,7 @@
           <a:lstStyle xmlns:a="http://schemas.openxmlformats.org/drawingml/2006/main"/>
           <a:p xmlns:a="http://schemas.openxmlformats.org/drawingml/2006/main">
             <a:pPr>
+              <a:buNone/>
               <a:defRPr sz="2400" b="1">
                 <a:solidFill>
                   <a:srgbClr val="5DCEF2"/>
@@ -21803,6 +21854,7 @@
           <a:lstStyle xmlns:a="http://schemas.openxmlformats.org/drawingml/2006/main"/>
           <a:p xmlns:a="http://schemas.openxmlformats.org/drawingml/2006/main">
             <a:pPr>
+              <a:buNone/>
               <a:defRPr sz="2250" b="0">
                 <a:solidFill>
                   <a:srgbClr val="F5F7F9"/>
@@ -21860,6 +21912,7 @@
           <a:lstStyle xmlns:a="http://schemas.openxmlformats.org/drawingml/2006/main"/>
           <a:p xmlns:a="http://schemas.openxmlformats.org/drawingml/2006/main">
             <a:pPr>
+              <a:buNone/>
               <a:defRPr sz="2400" b="1">
                 <a:solidFill>
                   <a:srgbClr val="5DCEF2"/>
@@ -21917,6 +21970,7 @@
           <a:lstStyle xmlns:a="http://schemas.openxmlformats.org/drawingml/2006/main"/>
           <a:p xmlns:a="http://schemas.openxmlformats.org/drawingml/2006/main">
             <a:pPr>
+              <a:buNone/>
               <a:defRPr sz="2250" b="0">
                 <a:solidFill>
                   <a:srgbClr val="F5F7F9"/>
@@ -21974,6 +22028,7 @@
           <a:lstStyle xmlns:a="http://schemas.openxmlformats.org/drawingml/2006/main"/>
           <a:p xmlns:a="http://schemas.openxmlformats.org/drawingml/2006/main">
             <a:pPr>
+              <a:buNone/>
               <a:defRPr sz="2400" b="1">
                 <a:solidFill>
                   <a:srgbClr val="5DCEF2"/>
@@ -22031,6 +22086,7 @@
           <a:lstStyle xmlns:a="http://schemas.openxmlformats.org/drawingml/2006/main"/>
           <a:p xmlns:a="http://schemas.openxmlformats.org/drawingml/2006/main">
             <a:pPr>
+              <a:buNone/>
               <a:defRPr sz="2250" b="0">
                 <a:solidFill>
                   <a:srgbClr val="F5F7F9"/>
@@ -22088,6 +22144,7 @@
           <a:lstStyle xmlns:a="http://schemas.openxmlformats.org/drawingml/2006/main"/>
           <a:p xmlns:a="http://schemas.openxmlformats.org/drawingml/2006/main">
             <a:pPr>
+              <a:buNone/>
               <a:defRPr sz="1350" b="0">
                 <a:solidFill>
                   <a:srgbClr val="B6C5CE"/>
@@ -22113,14 +22170,14 @@
       </p:sp>
       <p:pic>
         <p:nvPicPr>
-          <p:cNvPr id="24" name=""/>
+          <p:cNvPr id="26" name=""/>
           <p:cNvPicPr>
             <a:picLocks xmlns:a="http://schemas.openxmlformats.org/drawingml/2006/main" noChangeAspect="1"/>
           </p:cNvPicPr>
           <p:nvPr/>
         </p:nvPicPr>
         <p:blipFill>
-          <a:blip xmlns:r="http://schemas.openxmlformats.org/officeDocument/2006/relationships" xmlns:a="http://schemas.openxmlformats.org/drawingml/2006/main" r:embed="R36ce272619b1429a"/>
+          <a:blip xmlns:r="http://schemas.openxmlformats.org/officeDocument/2006/relationships" xmlns:a="http://schemas.openxmlformats.org/drawingml/2006/main" r:embed="R0ca4307bf4f24220"/>
           <a:stretch xmlns:a="http://schemas.openxmlformats.org/drawingml/2006/main"/>
         </p:blipFill>
         <p:spPr>
@@ -22196,6 +22253,7 @@
           <a:lstStyle xmlns:a="http://schemas.openxmlformats.org/drawingml/2006/main"/>
           <a:p xmlns:a="http://schemas.openxmlformats.org/drawingml/2006/main">
             <a:pPr>
+              <a:buNone/>
               <a:defRPr sz="1350" b="1">
                 <a:solidFill>
                   <a:srgbClr val="5DCEF2"/>
@@ -22253,6 +22311,7 @@
           <a:lstStyle xmlns:a="http://schemas.openxmlformats.org/drawingml/2006/main"/>
           <a:p xmlns:a="http://schemas.openxmlformats.org/drawingml/2006/main">
             <a:pPr>
+              <a:buNone/>
               <a:defRPr sz="3600" b="1">
                 <a:solidFill>
                   <a:srgbClr val="F5F7F9"/>
@@ -22310,6 +22369,7 @@
           <a:lstStyle xmlns:a="http://schemas.openxmlformats.org/drawingml/2006/main"/>
           <a:p xmlns:a="http://schemas.openxmlformats.org/drawingml/2006/main">
             <a:pPr>
+              <a:buNone/>
               <a:defRPr sz="3000" b="1">
                 <a:solidFill>
                   <a:srgbClr val="5DCEF2"/>
@@ -22367,6 +22427,7 @@
           <a:lstStyle xmlns:a="http://schemas.openxmlformats.org/drawingml/2006/main"/>
           <a:p xmlns:a="http://schemas.openxmlformats.org/drawingml/2006/main">
             <a:pPr>
+              <a:buNone/>
               <a:defRPr sz="2325" b="0">
                 <a:solidFill>
                   <a:srgbClr val="F5F7F9"/>
@@ -22424,6 +22485,7 @@
           <a:lstStyle xmlns:a="http://schemas.openxmlformats.org/drawingml/2006/main"/>
           <a:p xmlns:a="http://schemas.openxmlformats.org/drawingml/2006/main">
             <a:pPr>
+              <a:buNone/>
               <a:defRPr sz="3000" b="1">
                 <a:solidFill>
                   <a:srgbClr val="5DCEF2"/>
@@ -22481,6 +22543,7 @@
           <a:lstStyle xmlns:a="http://schemas.openxmlformats.org/drawingml/2006/main"/>
           <a:p xmlns:a="http://schemas.openxmlformats.org/drawingml/2006/main">
             <a:pPr>
+              <a:buNone/>
               <a:defRPr sz="2325" b="0">
                 <a:solidFill>
                   <a:srgbClr val="F5F7F9"/>
@@ -22538,6 +22601,7 @@
           <a:lstStyle xmlns:a="http://schemas.openxmlformats.org/drawingml/2006/main"/>
           <a:p xmlns:a="http://schemas.openxmlformats.org/drawingml/2006/main">
             <a:pPr>
+              <a:buNone/>
               <a:defRPr sz="3000" b="1">
                 <a:solidFill>
                   <a:srgbClr val="5DCEF2"/>
@@ -22595,6 +22659,7 @@
           <a:lstStyle xmlns:a="http://schemas.openxmlformats.org/drawingml/2006/main"/>
           <a:p xmlns:a="http://schemas.openxmlformats.org/drawingml/2006/main">
             <a:pPr>
+              <a:buNone/>
               <a:defRPr sz="2325" b="0">
                 <a:solidFill>
                   <a:srgbClr val="F5F7F9"/>
@@ -22652,6 +22717,7 @@
           <a:lstStyle xmlns:a="http://schemas.openxmlformats.org/drawingml/2006/main"/>
           <a:p xmlns:a="http://schemas.openxmlformats.org/drawingml/2006/main">
             <a:pPr>
+              <a:buNone/>
               <a:defRPr sz="3000" b="1">
                 <a:solidFill>
                   <a:srgbClr val="5DCEF2"/>
@@ -22709,6 +22775,7 @@
           <a:lstStyle xmlns:a="http://schemas.openxmlformats.org/drawingml/2006/main"/>
           <a:p xmlns:a="http://schemas.openxmlformats.org/drawingml/2006/main">
             <a:pPr>
+              <a:buNone/>
               <a:defRPr sz="2325" b="0">
                 <a:solidFill>
                   <a:srgbClr val="F5F7F9"/>
@@ -22766,6 +22833,7 @@
           <a:lstStyle xmlns:a="http://schemas.openxmlformats.org/drawingml/2006/main"/>
           <a:p xmlns:a="http://schemas.openxmlformats.org/drawingml/2006/main">
             <a:pPr>
+              <a:buNone/>
               <a:defRPr sz="1350" b="0">
                 <a:solidFill>
                   <a:srgbClr val="B6C5CE"/>
@@ -22791,14 +22859,14 @@
       </p:sp>
       <p:pic>
         <p:nvPicPr>
-          <p:cNvPr id="24" name=""/>
+          <p:cNvPr id="26" name=""/>
           <p:cNvPicPr>
             <a:picLocks xmlns:a="http://schemas.openxmlformats.org/drawingml/2006/main" noChangeAspect="1"/>
           </p:cNvPicPr>
           <p:nvPr/>
         </p:nvPicPr>
         <p:blipFill>
-          <a:blip xmlns:r="http://schemas.openxmlformats.org/officeDocument/2006/relationships" xmlns:a="http://schemas.openxmlformats.org/drawingml/2006/main" r:embed="R62afa0df71354993"/>
+          <a:blip xmlns:r="http://schemas.openxmlformats.org/officeDocument/2006/relationships" xmlns:a="http://schemas.openxmlformats.org/drawingml/2006/main" r:embed="R747f8405bbfd48d3"/>
           <a:stretch xmlns:a="http://schemas.openxmlformats.org/drawingml/2006/main"/>
         </p:blipFill>
         <p:spPr>
@@ -22874,6 +22942,7 @@
           <a:lstStyle xmlns:a="http://schemas.openxmlformats.org/drawingml/2006/main"/>
           <a:p xmlns:a="http://schemas.openxmlformats.org/drawingml/2006/main">
             <a:pPr>
+              <a:buNone/>
               <a:defRPr sz="1350" b="1">
                 <a:solidFill>
                   <a:srgbClr val="5DCEF2"/>
@@ -22931,6 +23000,7 @@
           <a:lstStyle xmlns:a="http://schemas.openxmlformats.org/drawingml/2006/main"/>
           <a:p xmlns:a="http://schemas.openxmlformats.org/drawingml/2006/main">
             <a:pPr>
+              <a:buNone/>
               <a:defRPr sz="3600" b="1">
                 <a:solidFill>
                   <a:srgbClr val="F5F7F9"/>
@@ -22988,6 +23058,7 @@
           <a:lstStyle xmlns:a="http://schemas.openxmlformats.org/drawingml/2006/main"/>
           <a:p xmlns:a="http://schemas.openxmlformats.org/drawingml/2006/main">
             <a:pPr>
+              <a:buNone/>
               <a:defRPr sz="3000" b="1">
                 <a:solidFill>
                   <a:srgbClr val="5DCEF2"/>
@@ -23045,6 +23116,7 @@
           <a:lstStyle xmlns:a="http://schemas.openxmlformats.org/drawingml/2006/main"/>
           <a:p xmlns:a="http://schemas.openxmlformats.org/drawingml/2006/main">
             <a:pPr>
+              <a:buNone/>
               <a:defRPr sz="2325" b="0">
                 <a:solidFill>
                   <a:srgbClr val="F5F7F9"/>
@@ -23102,6 +23174,7 @@
           <a:lstStyle xmlns:a="http://schemas.openxmlformats.org/drawingml/2006/main"/>
           <a:p xmlns:a="http://schemas.openxmlformats.org/drawingml/2006/main">
             <a:pPr>
+              <a:buNone/>
               <a:defRPr sz="3000" b="1">
                 <a:solidFill>
                   <a:srgbClr val="5DCEF2"/>
@@ -23159,6 +23232,7 @@
           <a:lstStyle xmlns:a="http://schemas.openxmlformats.org/drawingml/2006/main"/>
           <a:p xmlns:a="http://schemas.openxmlformats.org/drawingml/2006/main">
             <a:pPr>
+              <a:buNone/>
               <a:defRPr sz="2325" b="0">
                 <a:solidFill>
                   <a:srgbClr val="F5F7F9"/>
@@ -23216,6 +23290,7 @@
           <a:lstStyle xmlns:a="http://schemas.openxmlformats.org/drawingml/2006/main"/>
           <a:p xmlns:a="http://schemas.openxmlformats.org/drawingml/2006/main">
             <a:pPr>
+              <a:buNone/>
               <a:defRPr sz="3000" b="1">
                 <a:solidFill>
                   <a:srgbClr val="5DCEF2"/>
@@ -23273,6 +23348,7 @@
           <a:lstStyle xmlns:a="http://schemas.openxmlformats.org/drawingml/2006/main"/>
           <a:p xmlns:a="http://schemas.openxmlformats.org/drawingml/2006/main">
             <a:pPr>
+              <a:buNone/>
               <a:defRPr sz="2325" b="0">
                 <a:solidFill>
                   <a:srgbClr val="F5F7F9"/>
@@ -23330,6 +23406,7 @@
           <a:lstStyle xmlns:a="http://schemas.openxmlformats.org/drawingml/2006/main"/>
           <a:p xmlns:a="http://schemas.openxmlformats.org/drawingml/2006/main">
             <a:pPr>
+              <a:buNone/>
               <a:defRPr sz="3000" b="1">
                 <a:solidFill>
                   <a:srgbClr val="5DCEF2"/>
@@ -23387,6 +23464,7 @@
           <a:lstStyle xmlns:a="http://schemas.openxmlformats.org/drawingml/2006/main"/>
           <a:p xmlns:a="http://schemas.openxmlformats.org/drawingml/2006/main">
             <a:pPr>
+              <a:buNone/>
               <a:defRPr sz="2325" b="0">
                 <a:solidFill>
                   <a:srgbClr val="F5F7F9"/>
@@ -23444,6 +23522,7 @@
           <a:lstStyle xmlns:a="http://schemas.openxmlformats.org/drawingml/2006/main"/>
           <a:p xmlns:a="http://schemas.openxmlformats.org/drawingml/2006/main">
             <a:pPr>
+              <a:buNone/>
               <a:defRPr sz="1350" b="0">
                 <a:solidFill>
                   <a:srgbClr val="B6C5CE"/>
@@ -23469,14 +23548,14 @@
       </p:sp>
       <p:pic>
         <p:nvPicPr>
-          <p:cNvPr id="24" name=""/>
+          <p:cNvPr id="26" name=""/>
           <p:cNvPicPr>
             <a:picLocks xmlns:a="http://schemas.openxmlformats.org/drawingml/2006/main" noChangeAspect="1"/>
           </p:cNvPicPr>
           <p:nvPr/>
         </p:nvPicPr>
         <p:blipFill>
-          <a:blip xmlns:r="http://schemas.openxmlformats.org/officeDocument/2006/relationships" xmlns:a="http://schemas.openxmlformats.org/drawingml/2006/main" r:embed="Rc65f15f84fce44f1"/>
+          <a:blip xmlns:r="http://schemas.openxmlformats.org/officeDocument/2006/relationships" xmlns:a="http://schemas.openxmlformats.org/drawingml/2006/main" r:embed="Red49676455c44ae1"/>
           <a:stretch xmlns:a="http://schemas.openxmlformats.org/drawingml/2006/main"/>
         </p:blipFill>
         <p:spPr>
@@ -23552,6 +23631,7 @@
           <a:lstStyle xmlns:a="http://schemas.openxmlformats.org/drawingml/2006/main"/>
           <a:p xmlns:a="http://schemas.openxmlformats.org/drawingml/2006/main">
             <a:pPr>
+              <a:buNone/>
               <a:defRPr sz="1350" b="1">
                 <a:solidFill>
                   <a:srgbClr val="5DCEF2"/>
@@ -23609,6 +23689,7 @@
           <a:lstStyle xmlns:a="http://schemas.openxmlformats.org/drawingml/2006/main"/>
           <a:p xmlns:a="http://schemas.openxmlformats.org/drawingml/2006/main">
             <a:pPr>
+              <a:buNone/>
               <a:defRPr sz="3600" b="1">
                 <a:solidFill>
                   <a:srgbClr val="F5F7F9"/>
@@ -23666,6 +23747,7 @@
           <a:lstStyle xmlns:a="http://schemas.openxmlformats.org/drawingml/2006/main"/>
           <a:p xmlns:a="http://schemas.openxmlformats.org/drawingml/2006/main">
             <a:pPr>
+              <a:buNone/>
               <a:defRPr sz="3000" b="1">
                 <a:solidFill>
                   <a:srgbClr val="5DCEF2"/>
@@ -23723,6 +23805,7 @@
           <a:lstStyle xmlns:a="http://schemas.openxmlformats.org/drawingml/2006/main"/>
           <a:p xmlns:a="http://schemas.openxmlformats.org/drawingml/2006/main">
             <a:pPr>
+              <a:buNone/>
               <a:defRPr sz="2400" b="0">
                 <a:solidFill>
                   <a:srgbClr val="F5F7F9"/>
@@ -23780,6 +23863,7 @@
           <a:lstStyle xmlns:a="http://schemas.openxmlformats.org/drawingml/2006/main"/>
           <a:p xmlns:a="http://schemas.openxmlformats.org/drawingml/2006/main">
             <a:pPr>
+              <a:buNone/>
               <a:defRPr sz="3000" b="1">
                 <a:solidFill>
                   <a:srgbClr val="5DCEF2"/>
@@ -23837,6 +23921,7 @@
           <a:lstStyle xmlns:a="http://schemas.openxmlformats.org/drawingml/2006/main"/>
           <a:p xmlns:a="http://schemas.openxmlformats.org/drawingml/2006/main">
             <a:pPr>
+              <a:buNone/>
               <a:defRPr sz="2400" b="0">
                 <a:solidFill>
                   <a:srgbClr val="F5F7F9"/>
@@ -23894,6 +23979,7 @@
           <a:lstStyle xmlns:a="http://schemas.openxmlformats.org/drawingml/2006/main"/>
           <a:p xmlns:a="http://schemas.openxmlformats.org/drawingml/2006/main">
             <a:pPr>
+              <a:buNone/>
               <a:defRPr sz="3000" b="1">
                 <a:solidFill>
                   <a:srgbClr val="5DCEF2"/>
@@ -23951,6 +24037,7 @@
           <a:lstStyle xmlns:a="http://schemas.openxmlformats.org/drawingml/2006/main"/>
           <a:p xmlns:a="http://schemas.openxmlformats.org/drawingml/2006/main">
             <a:pPr>
+              <a:buNone/>
               <a:defRPr sz="2400" b="0">
                 <a:solidFill>
                   <a:srgbClr val="F5F7F9"/>
@@ -24008,6 +24095,7 @@
           <a:lstStyle xmlns:a="http://schemas.openxmlformats.org/drawingml/2006/main"/>
           <a:p xmlns:a="http://schemas.openxmlformats.org/drawingml/2006/main">
             <a:pPr>
+              <a:buNone/>
               <a:defRPr sz="3000" b="1">
                 <a:solidFill>
                   <a:srgbClr val="5DCEF2"/>
@@ -24065,6 +24153,7 @@
           <a:lstStyle xmlns:a="http://schemas.openxmlformats.org/drawingml/2006/main"/>
           <a:p xmlns:a="http://schemas.openxmlformats.org/drawingml/2006/main">
             <a:pPr>
+              <a:buNone/>
               <a:defRPr sz="2400" b="0">
                 <a:solidFill>
                   <a:srgbClr val="F5F7F9"/>
@@ -24122,6 +24211,7 @@
           <a:lstStyle xmlns:a="http://schemas.openxmlformats.org/drawingml/2006/main"/>
           <a:p xmlns:a="http://schemas.openxmlformats.org/drawingml/2006/main">
             <a:pPr>
+              <a:buNone/>
               <a:defRPr sz="2100" b="0">
                 <a:solidFill>
                   <a:srgbClr val="B6C5CE"/>
@@ -24179,6 +24269,7 @@
           <a:lstStyle xmlns:a="http://schemas.openxmlformats.org/drawingml/2006/main"/>
           <a:p xmlns:a="http://schemas.openxmlformats.org/drawingml/2006/main">
             <a:pPr>
+              <a:buNone/>
               <a:defRPr sz="1350" b="0">
                 <a:solidFill>
                   <a:srgbClr val="B6C5CE"/>
@@ -24204,14 +24295,14 @@
       </p:sp>
       <p:pic>
         <p:nvPicPr>
-          <p:cNvPr id="26" name=""/>
+          <p:cNvPr id="28" name=""/>
           <p:cNvPicPr>
             <a:picLocks xmlns:a="http://schemas.openxmlformats.org/drawingml/2006/main" noChangeAspect="1"/>
           </p:cNvPicPr>
           <p:nvPr/>
         </p:nvPicPr>
         <p:blipFill>
-          <a:blip xmlns:r="http://schemas.openxmlformats.org/officeDocument/2006/relationships" xmlns:a="http://schemas.openxmlformats.org/drawingml/2006/main" r:embed="Rc8d13fb93b974a77"/>
+          <a:blip xmlns:r="http://schemas.openxmlformats.org/officeDocument/2006/relationships" xmlns:a="http://schemas.openxmlformats.org/drawingml/2006/main" r:embed="R1dfe96568c7e4884"/>
           <a:stretch xmlns:a="http://schemas.openxmlformats.org/drawingml/2006/main"/>
         </p:blipFill>
         <p:spPr>
@@ -24287,6 +24378,7 @@
           <a:lstStyle xmlns:a="http://schemas.openxmlformats.org/drawingml/2006/main"/>
           <a:p xmlns:a="http://schemas.openxmlformats.org/drawingml/2006/main">
             <a:pPr>
+              <a:buNone/>
               <a:defRPr sz="1350" b="1">
                 <a:solidFill>
                   <a:srgbClr val="5DCEF2"/>
@@ -24344,6 +24436,7 @@
           <a:lstStyle xmlns:a="http://schemas.openxmlformats.org/drawingml/2006/main"/>
           <a:p xmlns:a="http://schemas.openxmlformats.org/drawingml/2006/main">
             <a:pPr>
+              <a:buNone/>
               <a:defRPr sz="3600" b="1">
                 <a:solidFill>
                   <a:srgbClr val="F5F7F9"/>
@@ -24401,6 +24494,7 @@
           <a:lstStyle xmlns:a="http://schemas.openxmlformats.org/drawingml/2006/main"/>
           <a:p xmlns:a="http://schemas.openxmlformats.org/drawingml/2006/main">
             <a:pPr>
+              <a:buNone/>
               <a:defRPr sz="4800" b="1">
                 <a:solidFill>
                   <a:srgbClr val="5DCEF2"/>
@@ -24458,6 +24552,7 @@
           <a:lstStyle xmlns:a="http://schemas.openxmlformats.org/drawingml/2006/main"/>
           <a:p xmlns:a="http://schemas.openxmlformats.org/drawingml/2006/main">
             <a:pPr>
+              <a:buNone/>
               <a:defRPr sz="2325" b="0">
                 <a:solidFill>
                   <a:srgbClr val="F5F7F9"/>
@@ -24481,6 +24576,7 @@
           </a:p>
           <a:p xmlns:a="http://schemas.openxmlformats.org/drawingml/2006/main">
             <a:pPr>
+              <a:buNone/>
               <a:defRPr sz="2325" b="0">
                 <a:solidFill>
                   <a:srgbClr val="F5F7F9"/>
@@ -24504,6 +24600,7 @@
           </a:p>
           <a:p xmlns:a="http://schemas.openxmlformats.org/drawingml/2006/main">
             <a:pPr>
+              <a:buNone/>
               <a:defRPr sz="2325" b="0">
                 <a:solidFill>
                   <a:srgbClr val="F5F7F9"/>
@@ -24561,6 +24658,7 @@
           <a:lstStyle xmlns:a="http://schemas.openxmlformats.org/drawingml/2006/main"/>
           <a:p xmlns:a="http://schemas.openxmlformats.org/drawingml/2006/main">
             <a:pPr>
+              <a:buNone/>
               <a:defRPr sz="2100" b="0">
                 <a:solidFill>
                   <a:srgbClr val="B6C5CE"/>
@@ -24618,6 +24716,7 @@
           <a:lstStyle xmlns:a="http://schemas.openxmlformats.org/drawingml/2006/main"/>
           <a:p xmlns:a="http://schemas.openxmlformats.org/drawingml/2006/main">
             <a:pPr>
+              <a:buNone/>
               <a:defRPr sz="1350" b="0">
                 <a:solidFill>
                   <a:srgbClr val="B6C5CE"/>
@@ -24643,14 +24742,14 @@
       </p:sp>
       <p:pic>
         <p:nvPicPr>
-          <p:cNvPr id="14" name=""/>
+          <p:cNvPr id="16" name=""/>
           <p:cNvPicPr>
             <a:picLocks xmlns:a="http://schemas.openxmlformats.org/drawingml/2006/main" noChangeAspect="1"/>
           </p:cNvPicPr>
           <p:nvPr/>
         </p:nvPicPr>
         <p:blipFill>
-          <a:blip xmlns:r="http://schemas.openxmlformats.org/officeDocument/2006/relationships" xmlns:a="http://schemas.openxmlformats.org/drawingml/2006/main" r:embed="R313cc01891e84e22"/>
+          <a:blip xmlns:r="http://schemas.openxmlformats.org/officeDocument/2006/relationships" xmlns:a="http://schemas.openxmlformats.org/drawingml/2006/main" r:embed="Re1695202f3bc443f"/>
           <a:stretch xmlns:a="http://schemas.openxmlformats.org/drawingml/2006/main"/>
         </p:blipFill>
         <p:spPr>
@@ -24726,6 +24825,7 @@
           <a:lstStyle xmlns:a="http://schemas.openxmlformats.org/drawingml/2006/main"/>
           <a:p xmlns:a="http://schemas.openxmlformats.org/drawingml/2006/main">
             <a:pPr>
+              <a:buNone/>
               <a:defRPr sz="1350" b="1">
                 <a:solidFill>
                   <a:srgbClr val="5DCEF2"/>
@@ -24783,6 +24883,7 @@
           <a:lstStyle xmlns:a="http://schemas.openxmlformats.org/drawingml/2006/main"/>
           <a:p xmlns:a="http://schemas.openxmlformats.org/drawingml/2006/main">
             <a:pPr>
+              <a:buNone/>
               <a:defRPr sz="3600" b="1">
                 <a:solidFill>
                   <a:srgbClr val="F5F7F9"/>
@@ -24840,6 +24941,7 @@
           <a:lstStyle xmlns:a="http://schemas.openxmlformats.org/drawingml/2006/main"/>
           <a:p xmlns:a="http://schemas.openxmlformats.org/drawingml/2006/main">
             <a:pPr>
+              <a:buNone/>
               <a:defRPr sz="3900" b="1">
                 <a:solidFill>
                   <a:srgbClr val="5DCEF2"/>
@@ -24897,6 +24999,7 @@
           <a:lstStyle xmlns:a="http://schemas.openxmlformats.org/drawingml/2006/main"/>
           <a:p xmlns:a="http://schemas.openxmlformats.org/drawingml/2006/main">
             <a:pPr>
+              <a:buNone/>
               <a:defRPr sz="2400" b="1">
                 <a:solidFill>
                   <a:srgbClr val="5DCEF2"/>
@@ -24954,6 +25057,7 @@
           <a:lstStyle xmlns:a="http://schemas.openxmlformats.org/drawingml/2006/main"/>
           <a:p xmlns:a="http://schemas.openxmlformats.org/drawingml/2006/main">
             <a:pPr>
+              <a:buNone/>
               <a:defRPr sz="2550" b="0">
                 <a:solidFill>
                   <a:srgbClr val="F5F7F9"/>
@@ -25011,6 +25115,7 @@
           <a:lstStyle xmlns:a="http://schemas.openxmlformats.org/drawingml/2006/main"/>
           <a:p xmlns:a="http://schemas.openxmlformats.org/drawingml/2006/main">
             <a:pPr>
+              <a:buNone/>
               <a:defRPr sz="2400" b="1">
                 <a:solidFill>
                   <a:srgbClr val="5DCEF2"/>
@@ -25068,6 +25173,7 @@
           <a:lstStyle xmlns:a="http://schemas.openxmlformats.org/drawingml/2006/main"/>
           <a:p xmlns:a="http://schemas.openxmlformats.org/drawingml/2006/main">
             <a:pPr>
+              <a:buNone/>
               <a:defRPr sz="2550" b="0">
                 <a:solidFill>
                   <a:srgbClr val="F5F7F9"/>
@@ -25125,6 +25231,7 @@
           <a:lstStyle xmlns:a="http://schemas.openxmlformats.org/drawingml/2006/main"/>
           <a:p xmlns:a="http://schemas.openxmlformats.org/drawingml/2006/main">
             <a:pPr>
+              <a:buNone/>
               <a:defRPr sz="1950" b="0">
                 <a:solidFill>
                   <a:srgbClr val="B6C5CE"/>
@@ -25182,6 +25289,7 @@
           <a:lstStyle xmlns:a="http://schemas.openxmlformats.org/drawingml/2006/main"/>
           <a:p xmlns:a="http://schemas.openxmlformats.org/drawingml/2006/main">
             <a:pPr>
+              <a:buNone/>
               <a:defRPr sz="1350" b="0">
                 <a:solidFill>
                   <a:srgbClr val="B6C5CE"/>
@@ -25207,14 +25315,14 @@
       </p:sp>
       <p:pic>
         <p:nvPicPr>
-          <p:cNvPr id="20" name=""/>
+          <p:cNvPr id="22" name=""/>
           <p:cNvPicPr>
             <a:picLocks xmlns:a="http://schemas.openxmlformats.org/drawingml/2006/main" noChangeAspect="1"/>
           </p:cNvPicPr>
           <p:nvPr/>
         </p:nvPicPr>
         <p:blipFill>
-          <a:blip xmlns:r="http://schemas.openxmlformats.org/officeDocument/2006/relationships" xmlns:a="http://schemas.openxmlformats.org/drawingml/2006/main" r:embed="Rbacc376dffb34012"/>
+          <a:blip xmlns:r="http://schemas.openxmlformats.org/officeDocument/2006/relationships" xmlns:a="http://schemas.openxmlformats.org/drawingml/2006/main" r:embed="Rceb22c55c2b3415c"/>
           <a:stretch xmlns:a="http://schemas.openxmlformats.org/drawingml/2006/main"/>
         </p:blipFill>
         <p:spPr>

</xml_diff>